<commit_message>
Swap in the real BSCM plant photo and product-led title imagery
- Title slide now shows the retort pouch with the cooked rice it makes
  (BSCM catalogue key visual) instead of raw grain in a sack
- BSCM profile carries the actual BSCM Foods plant in Bangsue, sourced
  from the group's corporate site at 2400 px
- Japanese Style Rice card uses the group's own steamed-rice photography;
  the supplier publishes no pack shot for that SKU, noted in the footnote
- Trim the SKU footnote back to a single line

Co-Authored-By: Claude Opus 5 <noreply@anthropic.com>
Claude-Session: https://claude.ai/code/session_01NDFDM6HpP3f8QTd8UUPgQV
</commit_message>
<xml_diff>
--- a/RTE_Rice_Suppliers.pptx
+++ b/RTE_Rice_Suppliers.pptx
@@ -2741,7 +2741,7 @@
                 <a:ea typeface="Calibri" pitchFamily="34" charset="-122"/>
                 <a:cs typeface="Calibri" pitchFamily="34" charset="-120"/>
               </a:rPr>
-              <a:t>Джерело: каталог продукції BSCM Foods та комерційна пропозиція постачальника; сертифікати — за каталогом виробника.</a:t>
+              <a:t>Джерело: каталог продукції BSCM Foods, комерційна пропозиція постачальника та корпоративний сайт групи BSCM (bscm.co.th); сертифікати — за каталогом.</a:t>
             </a:r>
             <a:endParaRPr lang="en-US" sz="900" dirty="0"/>
           </a:p>
@@ -5472,7 +5472,7 @@
                 <a:ea typeface="Calibri" pitchFamily="34" charset="-122"/>
                 <a:cs typeface="Calibri" pitchFamily="34" charset="-120"/>
               </a:rPr>
-              <a:t>Фото — з офіційного каталогу BSCM Foods; для Japanese Style Rice каталог фото упаковки не містить. Собівартість включає мито 10%, ПДВ 20%, транспорт і кредитні гроші 2,5%.</a:t>
+              <a:t>Фото упаковки — з каталогу BSCM Foods; для Japanese Style Rice постачальник фото не надав. Собівартість: мито 10%, ПДВ 20%, транспорт, кредитні гроші 2,5%.</a:t>
             </a:r>
             <a:endParaRPr lang="en-US" sz="900" dirty="0"/>
           </a:p>

</xml_diff>

<commit_message>
Neutral cover photo and stronger company facts on both profiles
- Cover now carries an unbranded cooked-rice still life instead of a
  supplier-branded pack shot
- Drop the low-value rows (HS code, carton dimensions, lead time) and the
  "4 SKU" stat
- Rebuild both fact tables around what a buyer weighs: group history and
  export reach for BSCM; incorporation, capacity, sourcing network and
  export reach for CM Premium, sourced from cmp-rice.com
- Brighten and tighten the CM Premium mill photo

Co-Authored-By: Claude Opus 5 <noreply@anthropic.com>
Claude-Session: https://claude.ai/code/session_01NDFDM6HpP3f8QTd8UUPgQV
</commit_message>
<xml_diff>
--- a/RTE_Rice_Suppliers.pptx
+++ b/RTE_Rice_Suppliers.pptx
@@ -1707,7 +1707,7 @@
                 <a:ea typeface="Calibri" pitchFamily="34" charset="-122"/>
                 <a:cs typeface="Calibri" pitchFamily="34" charset="-120"/>
               </a:rPr>
-              <a:t>Бангкок, Таїланд</a:t>
+              <a:t>Бангкок (Bangsue), Таїланд</a:t>
             </a:r>
             <a:endParaRPr lang="en-US" sz="1150" dirty="0"/>
           </a:p>
@@ -1746,7 +1746,7 @@
                 <a:ea typeface="Calibri" pitchFamily="34" charset="-122"/>
                 <a:cs typeface="Calibri" pitchFamily="34" charset="-120"/>
               </a:rPr>
-              <a:t>Технологія</a:t>
+              <a:t>Група</a:t>
             </a:r>
             <a:endParaRPr lang="en-US" sz="1050" dirty="0"/>
           </a:p>
@@ -1785,7 +1785,7 @@
                 <a:ea typeface="Calibri" pitchFamily="34" charset="-122"/>
                 <a:cs typeface="Calibri" pitchFamily="34" charset="-120"/>
               </a:rPr>
-              <a:t>Ретортна стерилізація, без консервантів</a:t>
+              <a:t>Bangsue Chia Meng Rice Mill, з 1937</a:t>
             </a:r>
             <a:endParaRPr lang="en-US" sz="1150" dirty="0"/>
           </a:p>
@@ -1824,7 +1824,7 @@
                 <a:ea typeface="Calibri" pitchFamily="34" charset="-122"/>
                 <a:cs typeface="Calibri" pitchFamily="34" charset="-120"/>
               </a:rPr>
-              <a:t>Формат в офері</a:t>
+              <a:t>RTE-виробництво</a:t>
             </a:r>
             <a:endParaRPr lang="en-US" sz="1050" dirty="0"/>
           </a:p>
@@ -1863,7 +1863,7 @@
                 <a:ea typeface="Calibri" pitchFamily="34" charset="-122"/>
                 <a:cs typeface="Calibri" pitchFamily="34" charset="-120"/>
               </a:rPr>
-              <a:t>Пауч 240 г · 6 шт у коробі</a:t>
+              <a:t>власний завод BSCM Foods, з 2009</a:t>
             </a:r>
             <a:endParaRPr lang="en-US" sz="1150" dirty="0"/>
           </a:p>
@@ -1902,7 +1902,7 @@
                 <a:ea typeface="Calibri" pitchFamily="34" charset="-122"/>
                 <a:cs typeface="Calibri" pitchFamily="34" charset="-120"/>
               </a:rPr>
-              <a:t>Габарит короба</a:t>
+              <a:t>Технологія</a:t>
             </a:r>
             <a:endParaRPr lang="en-US" sz="1050" dirty="0"/>
           </a:p>
@@ -1941,7 +1941,7 @@
                 <a:ea typeface="Calibri" pitchFamily="34" charset="-122"/>
                 <a:cs typeface="Calibri" pitchFamily="34" charset="-120"/>
               </a:rPr>
-              <a:t>159 × 140 × 185 мм · 0,004118 м³</a:t>
+              <a:t>ретортна стерилізація, без консервантів</a:t>
             </a:r>
             <a:endParaRPr lang="en-US" sz="1150" dirty="0"/>
           </a:p>
@@ -2097,7 +2097,7 @@
                 <a:ea typeface="Calibri" pitchFamily="34" charset="-122"/>
                 <a:cs typeface="Calibri" pitchFamily="34" charset="-120"/>
               </a:rPr>
-              <a:t>Мікрохвильова піч, 60–90 сек</a:t>
+              <a:t>мікрохвильова піч, 60–90 сек</a:t>
             </a:r>
             <a:endParaRPr lang="en-US" sz="1150" dirty="0"/>
           </a:p>
@@ -2136,7 +2136,7 @@
                 <a:ea typeface="Calibri" pitchFamily="34" charset="-122"/>
                 <a:cs typeface="Calibri" pitchFamily="34" charset="-120"/>
               </a:rPr>
-              <a:t>Код УКТЗЕД / HS</a:t>
+              <a:t>Формат в офері</a:t>
             </a:r>
             <a:endParaRPr lang="en-US" sz="1050" dirty="0"/>
           </a:p>
@@ -2175,7 +2175,7 @@
                 <a:ea typeface="Calibri" pitchFamily="34" charset="-122"/>
                 <a:cs typeface="Calibri" pitchFamily="34" charset="-120"/>
               </a:rPr>
-              <a:t>1904 90 10</a:t>
+              <a:t>пауч 240 г · 6 шт у коробі</a:t>
             </a:r>
             <a:endParaRPr lang="en-US" sz="1150" dirty="0"/>
           </a:p>
@@ -2253,7 +2253,7 @@
                 <a:ea typeface="Calibri" pitchFamily="34" charset="-122"/>
                 <a:cs typeface="Calibri" pitchFamily="34" charset="-120"/>
               </a:rPr>
-              <a:t>BRCGS · HACCP · USDA/EU Organic · Halal</a:t>
+              <a:t>BRC · HACCP · ISO 22000 · GMP · Organic</a:t>
             </a:r>
             <a:endParaRPr lang="en-US" sz="1150" dirty="0"/>
           </a:p>
@@ -2652,7 +2652,7 @@
                 <a:ea typeface="Cambria" pitchFamily="34" charset="-122"/>
                 <a:cs typeface="Cambria" pitchFamily="34" charset="-120"/>
               </a:rPr>
-              <a:t>4</a:t>
+              <a:t>60+</a:t>
             </a:r>
             <a:r>
               <a:rPr lang="en-US" sz="1100" dirty="0">
@@ -2663,7 +2663,7 @@
                 <a:ea typeface="Cambria" pitchFamily="34" charset="-122"/>
                 <a:cs typeface="Cambria" pitchFamily="34" charset="-120"/>
               </a:rPr>
-              <a:t> SKU</a:t>
+              <a:t> країн</a:t>
             </a:r>
             <a:endParaRPr lang="en-US" sz="1900" dirty="0"/>
           </a:p>
@@ -2702,7 +2702,7 @@
                 <a:ea typeface="Calibri" pitchFamily="34" charset="-122"/>
                 <a:cs typeface="Calibri" pitchFamily="34" charset="-120"/>
               </a:rPr>
-              <a:t>у поточному офері</a:t>
+              <a:t>країн експорту групи</a:t>
             </a:r>
             <a:endParaRPr lang="en-US" sz="1050" dirty="0"/>
           </a:p>
@@ -5805,7 +5805,7 @@
         </p:nvSpPr>
         <p:spPr>
           <a:xfrm>
-            <a:off x="841248" y="3401568"/>
+            <a:off x="841248" y="3383280"/>
             <a:ext cx="2103120" cy="256032"/>
           </a:xfrm>
           <a:prstGeom prst="rect">
@@ -5844,7 +5844,7 @@
         </p:nvSpPr>
         <p:spPr>
           <a:xfrm>
-            <a:off x="2971800" y="3401568"/>
+            <a:off x="2971800" y="3383280"/>
             <a:ext cx="4023360" cy="256032"/>
           </a:xfrm>
           <a:prstGeom prst="rect">
@@ -5869,7 +5869,7 @@
                 <a:ea typeface="Calibri" pitchFamily="34" charset="-122"/>
                 <a:cs typeface="Calibri" pitchFamily="34" charset="-120"/>
               </a:rPr>
-              <a:t>Офіс Nonthaburi · завод Nakhon Ratchasima</a:t>
+              <a:t>офіс Nonthaburi · завод Nakhon Ratchasima</a:t>
             </a:r>
             <a:endParaRPr lang="en-US" sz="1150" dirty="0"/>
           </a:p>
@@ -5883,7 +5883,7 @@
         </p:nvSpPr>
         <p:spPr>
           <a:xfrm>
-            <a:off x="841248" y="3767328"/>
+            <a:off x="841248" y="3717036"/>
             <a:ext cx="2103120" cy="256032"/>
           </a:xfrm>
           <a:prstGeom prst="rect">
@@ -5908,7 +5908,7 @@
                 <a:ea typeface="Calibri" pitchFamily="34" charset="-122"/>
                 <a:cs typeface="Calibri" pitchFamily="34" charset="-120"/>
               </a:rPr>
-              <a:t>На ринку з</a:t>
+              <a:t>Заснована</a:t>
             </a:r>
             <a:endParaRPr lang="en-US" sz="1050" dirty="0"/>
           </a:p>
@@ -5922,7 +5922,7 @@
         </p:nvSpPr>
         <p:spPr>
           <a:xfrm>
-            <a:off x="2971800" y="3767328"/>
+            <a:off x="2971800" y="3717036"/>
             <a:ext cx="4023360" cy="256032"/>
           </a:xfrm>
           <a:prstGeom prst="rect">
@@ -5947,7 +5947,7 @@
                 <a:ea typeface="Calibri" pitchFamily="34" charset="-122"/>
                 <a:cs typeface="Calibri" pitchFamily="34" charset="-120"/>
               </a:rPr>
-              <a:t>2016 · останнє оновлення ліній 2024</a:t>
+              <a:t>6 липня 2016 · капітал 50 млн THB</a:t>
             </a:r>
             <a:endParaRPr lang="en-US" sz="1150" dirty="0"/>
           </a:p>
@@ -5961,7 +5961,7 @@
         </p:nvSpPr>
         <p:spPr>
           <a:xfrm>
-            <a:off x="841248" y="4133088"/>
+            <a:off x="841248" y="4050792"/>
             <a:ext cx="2103120" cy="256032"/>
           </a:xfrm>
           <a:prstGeom prst="rect">
@@ -5986,6 +5986,84 @@
                 <a:ea typeface="Calibri" pitchFamily="34" charset="-122"/>
                 <a:cs typeface="Calibri" pitchFamily="34" charset="-120"/>
               </a:rPr>
+              <a:t>Досвід групи</a:t>
+            </a:r>
+            <a:endParaRPr lang="en-US" sz="1050" dirty="0"/>
+          </a:p>
+        </p:txBody>
+      </p:sp>
+      <p:sp>
+        <p:nvSpPr>
+          <p:cNvPr id="14" name="Text 12"/>
+          <p:cNvSpPr/>
+          <p:nvPr/>
+        </p:nvSpPr>
+        <p:spPr>
+          <a:xfrm>
+            <a:off x="2971800" y="4050792"/>
+            <a:ext cx="4023360" cy="256032"/>
+          </a:xfrm>
+          <a:prstGeom prst="rect">
+            <a:avLst/>
+          </a:prstGeom>
+          <a:noFill/>
+          <a:ln/>
+        </p:spPr>
+        <p:txBody>
+          <a:bodyPr wrap="square" lIns="0" tIns="0" rIns="0" bIns="0" rtlCol="0" anchor="ctr"/>
+          <a:lstStyle/>
+          <a:p>
+            <a:pPr marL="0" indent="0">
+              <a:buNone/>
+            </a:pPr>
+            <a:r>
+              <a:rPr lang="en-US" sz="1150" b="1" dirty="0">
+                <a:solidFill>
+                  <a:srgbClr val="F5F0E2"/>
+                </a:solidFill>
+                <a:latin typeface="Calibri" pitchFamily="34" charset="0"/>
+                <a:ea typeface="Calibri" pitchFamily="34" charset="-122"/>
+                <a:cs typeface="Calibri" pitchFamily="34" charset="-120"/>
+              </a:rPr>
+              <a:t>понад 30 років у рисовому виробництві</a:t>
+            </a:r>
+            <a:endParaRPr lang="en-US" sz="1150" dirty="0"/>
+          </a:p>
+        </p:txBody>
+      </p:sp>
+      <p:sp>
+        <p:nvSpPr>
+          <p:cNvPr id="15" name="Text 13"/>
+          <p:cNvSpPr/>
+          <p:nvPr/>
+        </p:nvSpPr>
+        <p:spPr>
+          <a:xfrm>
+            <a:off x="841248" y="4384548"/>
+            <a:ext cx="2103120" cy="256032"/>
+          </a:xfrm>
+          <a:prstGeom prst="rect">
+            <a:avLst/>
+          </a:prstGeom>
+          <a:noFill/>
+          <a:ln/>
+        </p:spPr>
+        <p:txBody>
+          <a:bodyPr wrap="square" lIns="0" tIns="0" rIns="0" bIns="0" rtlCol="0" anchor="ctr"/>
+          <a:lstStyle/>
+          <a:p>
+            <a:pPr marL="0" indent="0">
+              <a:buNone/>
+            </a:pPr>
+            <a:r>
+              <a:rPr lang="en-US" sz="1050" dirty="0">
+                <a:solidFill>
+                  <a:srgbClr val="BFCFBB"/>
+                </a:solidFill>
+                <a:latin typeface="Calibri" pitchFamily="34" charset="0"/>
+                <a:ea typeface="Calibri" pitchFamily="34" charset="-122"/>
+                <a:cs typeface="Calibri" pitchFamily="34" charset="-120"/>
+              </a:rPr>
               <a:t>Потужність</a:t>
             </a:r>
             <a:endParaRPr lang="en-US" sz="1050" dirty="0"/>
@@ -5994,13 +6072,13 @@
       </p:sp>
       <p:sp>
         <p:nvSpPr>
-          <p:cNvPr id="14" name="Text 12"/>
-          <p:cNvSpPr/>
-          <p:nvPr/>
-        </p:nvSpPr>
-        <p:spPr>
-          <a:xfrm>
-            <a:off x="2971800" y="4133088"/>
+          <p:cNvPr id="16" name="Text 14"/>
+          <p:cNvSpPr/>
+          <p:nvPr/>
+        </p:nvSpPr>
+        <p:spPr>
+          <a:xfrm>
+            <a:off x="2971800" y="4384548"/>
             <a:ext cx="4023360" cy="256032"/>
           </a:xfrm>
           <a:prstGeom prst="rect">
@@ -6025,7 +6103,7 @@
                 <a:ea typeface="Calibri" pitchFamily="34" charset="-122"/>
                 <a:cs typeface="Calibri" pitchFamily="34" charset="-120"/>
               </a:rPr>
-              <a:t>10 000 тонн на місяць</a:t>
+              <a:t>120 000 тонн на рік · 10 000 т/міс</a:t>
             </a:r>
             <a:endParaRPr lang="en-US" sz="1150" dirty="0"/>
           </a:p>
@@ -6033,13 +6111,13 @@
       </p:sp>
       <p:sp>
         <p:nvSpPr>
-          <p:cNvPr id="15" name="Text 13"/>
-          <p:cNvSpPr/>
-          <p:nvPr/>
-        </p:nvSpPr>
-        <p:spPr>
-          <a:xfrm>
-            <a:off x="841248" y="4498848"/>
+          <p:cNvPr id="17" name="Text 15"/>
+          <p:cNvSpPr/>
+          <p:nvPr/>
+        </p:nvSpPr>
+        <p:spPr>
+          <a:xfrm>
+            <a:off x="841248" y="4718304"/>
             <a:ext cx="2103120" cy="256032"/>
           </a:xfrm>
           <a:prstGeom prst="rect">
@@ -6064,6 +6142,240 @@
                 <a:ea typeface="Calibri" pitchFamily="34" charset="-122"/>
                 <a:cs typeface="Calibri" pitchFamily="34" charset="-120"/>
               </a:rPr>
+              <a:t>Сировина</a:t>
+            </a:r>
+            <a:endParaRPr lang="en-US" sz="1050" dirty="0"/>
+          </a:p>
+        </p:txBody>
+      </p:sp>
+      <p:sp>
+        <p:nvSpPr>
+          <p:cNvPr id="18" name="Text 16"/>
+          <p:cNvSpPr/>
+          <p:nvPr/>
+        </p:nvSpPr>
+        <p:spPr>
+          <a:xfrm>
+            <a:off x="2971800" y="4718304"/>
+            <a:ext cx="4023360" cy="256032"/>
+          </a:xfrm>
+          <a:prstGeom prst="rect">
+            <a:avLst/>
+          </a:prstGeom>
+          <a:noFill/>
+          <a:ln/>
+        </p:spPr>
+        <p:txBody>
+          <a:bodyPr wrap="square" lIns="0" tIns="0" rIns="0" bIns="0" rtlCol="0" anchor="ctr"/>
+          <a:lstStyle/>
+          <a:p>
+            <a:pPr marL="0" indent="0">
+              <a:buNone/>
+            </a:pPr>
+            <a:r>
+              <a:rPr lang="en-US" sz="1150" b="1" dirty="0">
+                <a:solidFill>
+                  <a:srgbClr val="F5F0E2"/>
+                </a:solidFill>
+                <a:latin typeface="Calibri" pitchFamily="34" charset="0"/>
+                <a:ea typeface="Calibri" pitchFamily="34" charset="-122"/>
+                <a:cs typeface="Calibri" pitchFamily="34" charset="-120"/>
+              </a:rPr>
+              <a:t>99% Таїланд · 30+ партнерських рисозаводів</a:t>
+            </a:r>
+            <a:endParaRPr lang="en-US" sz="1150" dirty="0"/>
+          </a:p>
+        </p:txBody>
+      </p:sp>
+      <p:sp>
+        <p:nvSpPr>
+          <p:cNvPr id="19" name="Text 17"/>
+          <p:cNvSpPr/>
+          <p:nvPr/>
+        </p:nvSpPr>
+        <p:spPr>
+          <a:xfrm>
+            <a:off x="841248" y="5052060"/>
+            <a:ext cx="2103120" cy="256032"/>
+          </a:xfrm>
+          <a:prstGeom prst="rect">
+            <a:avLst/>
+          </a:prstGeom>
+          <a:noFill/>
+          <a:ln/>
+        </p:spPr>
+        <p:txBody>
+          <a:bodyPr wrap="square" lIns="0" tIns="0" rIns="0" bIns="0" rtlCol="0" anchor="ctr"/>
+          <a:lstStyle/>
+          <a:p>
+            <a:pPr marL="0" indent="0">
+              <a:buNone/>
+            </a:pPr>
+            <a:r>
+              <a:rPr lang="en-US" sz="1050" dirty="0">
+                <a:solidFill>
+                  <a:srgbClr val="BFCFBB"/>
+                </a:solidFill>
+                <a:latin typeface="Calibri" pitchFamily="34" charset="0"/>
+                <a:ea typeface="Calibri" pitchFamily="34" charset="-122"/>
+                <a:cs typeface="Calibri" pitchFamily="34" charset="-120"/>
+              </a:rPr>
+              <a:t>Експорт</a:t>
+            </a:r>
+            <a:endParaRPr lang="en-US" sz="1050" dirty="0"/>
+          </a:p>
+        </p:txBody>
+      </p:sp>
+      <p:sp>
+        <p:nvSpPr>
+          <p:cNvPr id="20" name="Text 18"/>
+          <p:cNvSpPr/>
+          <p:nvPr/>
+        </p:nvSpPr>
+        <p:spPr>
+          <a:xfrm>
+            <a:off x="2971800" y="5052060"/>
+            <a:ext cx="4023360" cy="256032"/>
+          </a:xfrm>
+          <a:prstGeom prst="rect">
+            <a:avLst/>
+          </a:prstGeom>
+          <a:noFill/>
+          <a:ln/>
+        </p:spPr>
+        <p:txBody>
+          <a:bodyPr wrap="square" lIns="0" tIns="0" rIns="0" bIns="0" rtlCol="0" anchor="ctr"/>
+          <a:lstStyle/>
+          <a:p>
+            <a:pPr marL="0" indent="0">
+              <a:buNone/>
+            </a:pPr>
+            <a:r>
+              <a:rPr lang="en-US" sz="1150" b="1" dirty="0">
+                <a:solidFill>
+                  <a:srgbClr val="F5F0E2"/>
+                </a:solidFill>
+                <a:latin typeface="Calibri" pitchFamily="34" charset="0"/>
+                <a:ea typeface="Calibri" pitchFamily="34" charset="-122"/>
+                <a:cs typeface="Calibri" pitchFamily="34" charset="-120"/>
+              </a:rPr>
+              <a:t>понад 20 країн світу</a:t>
+            </a:r>
+            <a:endParaRPr lang="en-US" sz="1150" dirty="0"/>
+          </a:p>
+        </p:txBody>
+      </p:sp>
+      <p:sp>
+        <p:nvSpPr>
+          <p:cNvPr id="21" name="Text 19"/>
+          <p:cNvSpPr/>
+          <p:nvPr/>
+        </p:nvSpPr>
+        <p:spPr>
+          <a:xfrm>
+            <a:off x="841248" y="5385816"/>
+            <a:ext cx="2103120" cy="256032"/>
+          </a:xfrm>
+          <a:prstGeom prst="rect">
+            <a:avLst/>
+          </a:prstGeom>
+          <a:noFill/>
+          <a:ln/>
+        </p:spPr>
+        <p:txBody>
+          <a:bodyPr wrap="square" lIns="0" tIns="0" rIns="0" bIns="0" rtlCol="0" anchor="ctr"/>
+          <a:lstStyle/>
+          <a:p>
+            <a:pPr marL="0" indent="0">
+              <a:buNone/>
+            </a:pPr>
+            <a:r>
+              <a:rPr lang="en-US" sz="1050" dirty="0">
+                <a:solidFill>
+                  <a:srgbClr val="BFCFBB"/>
+                </a:solidFill>
+                <a:latin typeface="Calibri" pitchFamily="34" charset="0"/>
+                <a:ea typeface="Calibri" pitchFamily="34" charset="-122"/>
+                <a:cs typeface="Calibri" pitchFamily="34" charset="-120"/>
+              </a:rPr>
+              <a:t>Формат в офері</a:t>
+            </a:r>
+            <a:endParaRPr lang="en-US" sz="1050" dirty="0"/>
+          </a:p>
+        </p:txBody>
+      </p:sp>
+      <p:sp>
+        <p:nvSpPr>
+          <p:cNvPr id="22" name="Text 20"/>
+          <p:cNvSpPr/>
+          <p:nvPr/>
+        </p:nvSpPr>
+        <p:spPr>
+          <a:xfrm>
+            <a:off x="2971800" y="5385816"/>
+            <a:ext cx="4023360" cy="256032"/>
+          </a:xfrm>
+          <a:prstGeom prst="rect">
+            <a:avLst/>
+          </a:prstGeom>
+          <a:noFill/>
+          <a:ln/>
+        </p:spPr>
+        <p:txBody>
+          <a:bodyPr wrap="square" lIns="0" tIns="0" rIns="0" bIns="0" rtlCol="0" anchor="ctr"/>
+          <a:lstStyle/>
+          <a:p>
+            <a:pPr marL="0" indent="0">
+              <a:buNone/>
+            </a:pPr>
+            <a:r>
+              <a:rPr lang="en-US" sz="1150" b="1" dirty="0">
+                <a:solidFill>
+                  <a:srgbClr val="F5F0E2"/>
+                </a:solidFill>
+                <a:latin typeface="Calibri" pitchFamily="34" charset="0"/>
+                <a:ea typeface="Calibri" pitchFamily="34" charset="-122"/>
+                <a:cs typeface="Calibri" pitchFamily="34" charset="-120"/>
+              </a:rPr>
+              <a:t>пауч 250 г · 24 шт у коробі</a:t>
+            </a:r>
+            <a:endParaRPr lang="en-US" sz="1150" dirty="0"/>
+          </a:p>
+        </p:txBody>
+      </p:sp>
+      <p:sp>
+        <p:nvSpPr>
+          <p:cNvPr id="21" name="Text 19"/>
+          <p:cNvSpPr/>
+          <p:nvPr/>
+        </p:nvSpPr>
+        <p:spPr>
+          <a:xfrm>
+            <a:off x="841248" y="5719572"/>
+            <a:ext cx="2103120" cy="256032"/>
+          </a:xfrm>
+          <a:prstGeom prst="rect">
+            <a:avLst/>
+          </a:prstGeom>
+          <a:noFill/>
+          <a:ln/>
+        </p:spPr>
+        <p:txBody>
+          <a:bodyPr wrap="square" lIns="0" tIns="0" rIns="0" bIns="0" rtlCol="0" anchor="ctr"/>
+          <a:lstStyle/>
+          <a:p>
+            <a:pPr marL="0" indent="0">
+              <a:buNone/>
+            </a:pPr>
+            <a:r>
+              <a:rPr lang="en-US" sz="1050" dirty="0">
+                <a:solidFill>
+                  <a:srgbClr val="BFCFBB"/>
+                </a:solidFill>
+                <a:latin typeface="Calibri" pitchFamily="34" charset="0"/>
+                <a:ea typeface="Calibri" pitchFamily="34" charset="-122"/>
+                <a:cs typeface="Calibri" pitchFamily="34" charset="-120"/>
+              </a:rPr>
               <a:t>Сертифікація</a:t>
             </a:r>
             <a:endParaRPr lang="en-US" sz="1050" dirty="0"/>
@@ -6072,13 +6384,13 @@
       </p:sp>
       <p:sp>
         <p:nvSpPr>
-          <p:cNvPr id="16" name="Text 14"/>
-          <p:cNvSpPr/>
-          <p:nvPr/>
-        </p:nvSpPr>
-        <p:spPr>
-          <a:xfrm>
-            <a:off x="2971800" y="4498848"/>
+          <p:cNvPr id="22" name="Text 20"/>
+          <p:cNvSpPr/>
+          <p:nvPr/>
+        </p:nvSpPr>
+        <p:spPr>
+          <a:xfrm>
+            <a:off x="2971800" y="5719572"/>
             <a:ext cx="4023360" cy="256032"/>
           </a:xfrm>
           <a:prstGeom prst="rect">
@@ -6103,241 +6415,7 @@
                 <a:ea typeface="Calibri" pitchFamily="34" charset="-122"/>
                 <a:cs typeface="Calibri" pitchFamily="34" charset="-120"/>
               </a:rPr>
-              <a:t>USDA Organic · EU Organic · BRCGS · HACCP</a:t>
-            </a:r>
-            <a:endParaRPr lang="en-US" sz="1150" dirty="0"/>
-          </a:p>
-        </p:txBody>
-      </p:sp>
-      <p:sp>
-        <p:nvSpPr>
-          <p:cNvPr id="17" name="Text 15"/>
-          <p:cNvSpPr/>
-          <p:nvPr/>
-        </p:nvSpPr>
-        <p:spPr>
-          <a:xfrm>
-            <a:off x="841248" y="4864608"/>
-            <a:ext cx="2103120" cy="256032"/>
-          </a:xfrm>
-          <a:prstGeom prst="rect">
-            <a:avLst/>
-          </a:prstGeom>
-          <a:noFill/>
-          <a:ln/>
-        </p:spPr>
-        <p:txBody>
-          <a:bodyPr wrap="square" lIns="0" tIns="0" rIns="0" bIns="0" rtlCol="0" anchor="ctr"/>
-          <a:lstStyle/>
-          <a:p>
-            <a:pPr marL="0" indent="0">
-              <a:buNone/>
-            </a:pPr>
-            <a:r>
-              <a:rPr lang="en-US" sz="1050" dirty="0">
-                <a:solidFill>
-                  <a:srgbClr val="BFCFBB"/>
-                </a:solidFill>
-                <a:latin typeface="Calibri" pitchFamily="34" charset="0"/>
-                <a:ea typeface="Calibri" pitchFamily="34" charset="-122"/>
-                <a:cs typeface="Calibri" pitchFamily="34" charset="-120"/>
-              </a:rPr>
-              <a:t>Формат в офері</a:t>
-            </a:r>
-            <a:endParaRPr lang="en-US" sz="1050" dirty="0"/>
-          </a:p>
-        </p:txBody>
-      </p:sp>
-      <p:sp>
-        <p:nvSpPr>
-          <p:cNvPr id="18" name="Text 16"/>
-          <p:cNvSpPr/>
-          <p:nvPr/>
-        </p:nvSpPr>
-        <p:spPr>
-          <a:xfrm>
-            <a:off x="2971800" y="4864608"/>
-            <a:ext cx="4023360" cy="256032"/>
-          </a:xfrm>
-          <a:prstGeom prst="rect">
-            <a:avLst/>
-          </a:prstGeom>
-          <a:noFill/>
-          <a:ln/>
-        </p:spPr>
-        <p:txBody>
-          <a:bodyPr wrap="square" lIns="0" tIns="0" rIns="0" bIns="0" rtlCol="0" anchor="ctr"/>
-          <a:lstStyle/>
-          <a:p>
-            <a:pPr marL="0" indent="0">
-              <a:buNone/>
-            </a:pPr>
-            <a:r>
-              <a:rPr lang="en-US" sz="1150" b="1" dirty="0">
-                <a:solidFill>
-                  <a:srgbClr val="F5F0E2"/>
-                </a:solidFill>
-                <a:latin typeface="Calibri" pitchFamily="34" charset="0"/>
-                <a:ea typeface="Calibri" pitchFamily="34" charset="-122"/>
-                <a:cs typeface="Calibri" pitchFamily="34" charset="-120"/>
-              </a:rPr>
-              <a:t>Пауч 250 г · 24 шт у коробі</a:t>
-            </a:r>
-            <a:endParaRPr lang="en-US" sz="1150" dirty="0"/>
-          </a:p>
-        </p:txBody>
-      </p:sp>
-      <p:sp>
-        <p:nvSpPr>
-          <p:cNvPr id="19" name="Text 17"/>
-          <p:cNvSpPr/>
-          <p:nvPr/>
-        </p:nvSpPr>
-        <p:spPr>
-          <a:xfrm>
-            <a:off x="841248" y="5230368"/>
-            <a:ext cx="2103120" cy="256032"/>
-          </a:xfrm>
-          <a:prstGeom prst="rect">
-            <a:avLst/>
-          </a:prstGeom>
-          <a:noFill/>
-          <a:ln/>
-        </p:spPr>
-        <p:txBody>
-          <a:bodyPr wrap="square" lIns="0" tIns="0" rIns="0" bIns="0" rtlCol="0" anchor="ctr"/>
-          <a:lstStyle/>
-          <a:p>
-            <a:pPr marL="0" indent="0">
-              <a:buNone/>
-            </a:pPr>
-            <a:r>
-              <a:rPr lang="en-US" sz="1050" dirty="0">
-                <a:solidFill>
-                  <a:srgbClr val="BFCFBB"/>
-                </a:solidFill>
-                <a:latin typeface="Calibri" pitchFamily="34" charset="0"/>
-                <a:ea typeface="Calibri" pitchFamily="34" charset="-122"/>
-                <a:cs typeface="Calibri" pitchFamily="34" charset="-120"/>
-              </a:rPr>
-              <a:t>Габарит короба</a:t>
-            </a:r>
-            <a:endParaRPr lang="en-US" sz="1050" dirty="0"/>
-          </a:p>
-        </p:txBody>
-      </p:sp>
-      <p:sp>
-        <p:nvSpPr>
-          <p:cNvPr id="20" name="Text 18"/>
-          <p:cNvSpPr/>
-          <p:nvPr/>
-        </p:nvSpPr>
-        <p:spPr>
-          <a:xfrm>
-            <a:off x="2971800" y="5230368"/>
-            <a:ext cx="4023360" cy="256032"/>
-          </a:xfrm>
-          <a:prstGeom prst="rect">
-            <a:avLst/>
-          </a:prstGeom>
-          <a:noFill/>
-          <a:ln/>
-        </p:spPr>
-        <p:txBody>
-          <a:bodyPr wrap="square" lIns="0" tIns="0" rIns="0" bIns="0" rtlCol="0" anchor="ctr"/>
-          <a:lstStyle/>
-          <a:p>
-            <a:pPr marL="0" indent="0">
-              <a:buNone/>
-            </a:pPr>
-            <a:r>
-              <a:rPr lang="en-US" sz="1150" b="1" dirty="0">
-                <a:solidFill>
-                  <a:srgbClr val="F5F0E2"/>
-                </a:solidFill>
-                <a:latin typeface="Calibri" pitchFamily="34" charset="0"/>
-                <a:ea typeface="Calibri" pitchFamily="34" charset="-122"/>
-                <a:cs typeface="Calibri" pitchFamily="34" charset="-120"/>
-              </a:rPr>
-              <a:t>200 × 400 × 200 мм · 0,016 м³</a:t>
-            </a:r>
-            <a:endParaRPr lang="en-US" sz="1150" dirty="0"/>
-          </a:p>
-        </p:txBody>
-      </p:sp>
-      <p:sp>
-        <p:nvSpPr>
-          <p:cNvPr id="21" name="Text 19"/>
-          <p:cNvSpPr/>
-          <p:nvPr/>
-        </p:nvSpPr>
-        <p:spPr>
-          <a:xfrm>
-            <a:off x="841248" y="5596128"/>
-            <a:ext cx="2103120" cy="256032"/>
-          </a:xfrm>
-          <a:prstGeom prst="rect">
-            <a:avLst/>
-          </a:prstGeom>
-          <a:noFill/>
-          <a:ln/>
-        </p:spPr>
-        <p:txBody>
-          <a:bodyPr wrap="square" lIns="0" tIns="0" rIns="0" bIns="0" rtlCol="0" anchor="ctr"/>
-          <a:lstStyle/>
-          <a:p>
-            <a:pPr marL="0" indent="0">
-              <a:buNone/>
-            </a:pPr>
-            <a:r>
-              <a:rPr lang="en-US" sz="1050" dirty="0">
-                <a:solidFill>
-                  <a:srgbClr val="BFCFBB"/>
-                </a:solidFill>
-                <a:latin typeface="Calibri" pitchFamily="34" charset="0"/>
-                <a:ea typeface="Calibri" pitchFamily="34" charset="-122"/>
-                <a:cs typeface="Calibri" pitchFamily="34" charset="-120"/>
-              </a:rPr>
-              <a:t>Термін виконання</a:t>
-            </a:r>
-            <a:endParaRPr lang="en-US" sz="1050" dirty="0"/>
-          </a:p>
-        </p:txBody>
-      </p:sp>
-      <p:sp>
-        <p:nvSpPr>
-          <p:cNvPr id="22" name="Text 20"/>
-          <p:cNvSpPr/>
-          <p:nvPr/>
-        </p:nvSpPr>
-        <p:spPr>
-          <a:xfrm>
-            <a:off x="2971800" y="5596128"/>
-            <a:ext cx="4023360" cy="256032"/>
-          </a:xfrm>
-          <a:prstGeom prst="rect">
-            <a:avLst/>
-          </a:prstGeom>
-          <a:noFill/>
-          <a:ln/>
-        </p:spPr>
-        <p:txBody>
-          <a:bodyPr wrap="square" lIns="0" tIns="0" rIns="0" bIns="0" rtlCol="0" anchor="ctr"/>
-          <a:lstStyle/>
-          <a:p>
-            <a:pPr marL="0" indent="0">
-              <a:buNone/>
-            </a:pPr>
-            <a:r>
-              <a:rPr lang="en-US" sz="1150" b="1" dirty="0">
-                <a:solidFill>
-                  <a:srgbClr val="F5F0E2"/>
-                </a:solidFill>
-                <a:latin typeface="Calibri" pitchFamily="34" charset="0"/>
-                <a:ea typeface="Calibri" pitchFamily="34" charset="-122"/>
-                <a:cs typeface="Calibri" pitchFamily="34" charset="-120"/>
-              </a:rPr>
-              <a:t>до 30 днів від контракту до ETD</a:t>
+              <a:t>BRC · HACCP · ISO 9001 · Halal · Organic</a:t>
             </a:r>
             <a:endParaRPr lang="en-US" sz="1150" dirty="0"/>
           </a:p>
@@ -6592,7 +6670,7 @@
                 <a:ea typeface="Cambria" pitchFamily="34" charset="-122"/>
                 <a:cs typeface="Cambria" pitchFamily="34" charset="-120"/>
               </a:rPr>
-              <a:t>10 000</a:t>
+              <a:t>120 000</a:t>
             </a:r>
             <a:r>
               <a:rPr lang="en-US" sz="1100" dirty="0">
@@ -6603,7 +6681,7 @@
                 <a:ea typeface="Cambria" pitchFamily="34" charset="-122"/>
                 <a:cs typeface="Cambria" pitchFamily="34" charset="-120"/>
               </a:rPr>
-              <a:t> т/міс</a:t>
+              <a:t> т/рік</a:t>
             </a:r>
             <a:endParaRPr lang="en-US" sz="1900" dirty="0"/>
           </a:p>
@@ -6813,7 +6891,7 @@
                 <a:ea typeface="Calibri" pitchFamily="34" charset="-122"/>
                 <a:cs typeface="Calibri" pitchFamily="34" charset="-120"/>
               </a:rPr>
-              <a:t>Джерело: корпоративна презентація CM Premium Rice Co., Ltd. та прайс-лист Chefrey.</a:t>
+              <a:t>Джерело: корпоративна презентація CM Premium Rice Co., Ltd., сайт cmp-rice.com та прайс-лист Chefrey.</a:t>
             </a:r>
             <a:endParaRPr lang="en-US" sz="900" dirty="0"/>
           </a:p>

</xml_diff>

<commit_message>
Switch the deck to a bright light theme and stop hiding the cover photo
- Cover: the paddy photo runs sharp and unretouched at full frame, with a
  single compact white card holding the copy instead of a blur-and-darken wash
- Content slides: white cards on a warm ivory page, replacing the dark
  photo background that made every slide read black
- Colour-code the suppliers: BSCM amber, CM Premium green, applied to
  headers, rules, outlines and stat tiles
- Japanese Style Rice card states plainly that the pack shot is pending
  rather than showing a stand-in photo as if it were the product

Co-Authored-By: Claude Opus 5 <noreply@anthropic.com>
Claude-Session: https://claude.ai/code/session_01NDFDM6HpP3f8QTd8UUPgQV
</commit_message>
<xml_diff>
--- a/RTE_Rice_Suppliers.pptx
+++ b/RTE_Rice_Suppliers.pptx
@@ -1012,8 +1012,8 @@
         </p:nvSpPr>
         <p:spPr>
           <a:xfrm>
-            <a:off x="640080" y="1417320"/>
-            <a:ext cx="5852160" cy="4023360"/>
+            <a:off x="640080" y="1691640"/>
+            <a:ext cx="5349240" cy="3474720"/>
           </a:xfrm>
           <a:prstGeom prst="roundRect">
             <a:avLst>
@@ -1021,8 +1021,8 @@
             </a:avLst>
           </a:prstGeom>
           <a:solidFill>
-            <a:srgbClr val="0A2214">
-              <a:alpha val="92000"/>
+            <a:srgbClr val="FFFFFF">
+              <a:alpha val="100000"/>
             </a:srgbClr>
           </a:solidFill>
           <a:ln w="15875">
@@ -1055,8 +1055,8 @@
         </p:nvSpPr>
         <p:spPr>
           <a:xfrm>
-            <a:off x="1143000" y="2276856"/>
-            <a:ext cx="4846320" cy="685800"/>
+            <a:off x="1097280" y="2322576"/>
+            <a:ext cx="4434840" cy="685800"/>
           </a:xfrm>
           <a:prstGeom prst="rect">
             <a:avLst/>
@@ -1072,9 +1072,9 @@
               <a:buNone/>
             </a:pPr>
             <a:r>
-              <a:rPr lang="en-US" sz="3000" b="1" kern="0" spc="150" dirty="0">
-                <a:solidFill>
-                  <a:srgbClr val="E0B252"/>
+              <a:rPr lang="en-US" sz="2700" b="1" kern="0" spc="150" dirty="0">
+                <a:solidFill>
+                  <a:srgbClr val="A5730F"/>
                 </a:solidFill>
                 <a:latin typeface="Cambria" pitchFamily="34" charset="0"/>
                 <a:ea typeface="Cambria" pitchFamily="34" charset="-122"/>
@@ -1094,8 +1094,8 @@
         </p:nvSpPr>
         <p:spPr>
           <a:xfrm>
-            <a:off x="1143000" y="3099816"/>
-            <a:ext cx="2011680" cy="0"/>
+            <a:off x="1097280" y="3081528"/>
+            <a:ext cx="1828800" cy="0"/>
           </a:xfrm>
           <a:prstGeom prst="line">
             <a:avLst/>
@@ -1124,7 +1124,7 @@
         </p:nvSpPr>
         <p:spPr>
           <a:xfrm>
-            <a:off x="2098548" y="3054096"/>
+            <a:off x="1961388" y="3035808"/>
             <a:ext cx="100584" cy="100584"/>
           </a:xfrm>
           <a:prstGeom prst="diamond">
@@ -1156,8 +1156,8 @@
         </p:nvSpPr>
         <p:spPr>
           <a:xfrm>
-            <a:off x="1143000" y="3282696"/>
-            <a:ext cx="4846320" cy="384048"/>
+            <a:off x="1097280" y="3264408"/>
+            <a:ext cx="4434840" cy="384048"/>
           </a:xfrm>
           <a:prstGeom prst="rect">
             <a:avLst/>
@@ -1175,7 +1175,7 @@
             <a:r>
               <a:rPr lang="en-US" sz="1700" dirty="0">
                 <a:solidFill>
-                  <a:srgbClr val="F5F0E2"/>
+                  <a:srgbClr val="241C10"/>
                 </a:solidFill>
                 <a:latin typeface="Calibri" pitchFamily="34" charset="0"/>
                 <a:ea typeface="Calibri" pitchFamily="34" charset="-122"/>
@@ -1195,8 +1195,8 @@
         </p:nvSpPr>
         <p:spPr>
           <a:xfrm>
-            <a:off x="1143000" y="3831336"/>
-            <a:ext cx="4983480" cy="329184"/>
+            <a:off x="1097280" y="3785616"/>
+            <a:ext cx="4434840" cy="329184"/>
           </a:xfrm>
           <a:prstGeom prst="rect">
             <a:avLst/>
@@ -1212,9 +1212,9 @@
               <a:buNone/>
             </a:pPr>
             <a:r>
-              <a:rPr lang="en-US" sz="1200" b="1" dirty="0">
-                <a:solidFill>
-                  <a:srgbClr val="FFFFFF"/>
+              <a:rPr lang="en-US" sz="1150" b="1" dirty="0">
+                <a:solidFill>
+                  <a:srgbClr val="241C10"/>
                 </a:solidFill>
                 <a:latin typeface="Calibri" pitchFamily="34" charset="0"/>
                 <a:ea typeface="Calibri" pitchFamily="34" charset="-122"/>
@@ -1223,9 +1223,9 @@
               <a:t>BSCM Foods Co., Ltd.</a:t>
             </a:r>
             <a:r>
-              <a:rPr lang="en-US" sz="1200" dirty="0">
-                <a:solidFill>
-                  <a:srgbClr val="A87C2A"/>
+              <a:rPr lang="en-US" sz="1150" dirty="0">
+                <a:solidFill>
+                  <a:srgbClr val="A5730F"/>
                 </a:solidFill>
                 <a:latin typeface="Calibri" pitchFamily="34" charset="0"/>
                 <a:ea typeface="Calibri" pitchFamily="34" charset="-122"/>
@@ -1234,9 +1234,9 @@
               <a:t>   ·   </a:t>
             </a:r>
             <a:r>
-              <a:rPr lang="en-US" sz="1200" b="1" dirty="0">
-                <a:solidFill>
-                  <a:srgbClr val="FFFFFF"/>
+              <a:rPr lang="en-US" sz="1150" b="1" dirty="0">
+                <a:solidFill>
+                  <a:srgbClr val="241C10"/>
                 </a:solidFill>
                 <a:latin typeface="Calibri" pitchFamily="34" charset="0"/>
                 <a:ea typeface="Calibri" pitchFamily="34" charset="-122"/>
@@ -1256,8 +1256,8 @@
         </p:nvSpPr>
         <p:spPr>
           <a:xfrm>
-            <a:off x="1143000" y="4288536"/>
-            <a:ext cx="4846320" cy="292608"/>
+            <a:off x="1097280" y="4242816"/>
+            <a:ext cx="4434840" cy="292608"/>
           </a:xfrm>
           <a:prstGeom prst="rect">
             <a:avLst/>
@@ -1275,7 +1275,7 @@
             <a:r>
               <a:rPr lang="en-US" sz="1150" dirty="0">
                 <a:solidFill>
-                  <a:srgbClr val="BFCFBB"/>
+                  <a:srgbClr val="8A7457"/>
                 </a:solidFill>
                 <a:latin typeface="Calibri" pitchFamily="34" charset="0"/>
                 <a:ea typeface="Calibri" pitchFamily="34" charset="-122"/>
@@ -1287,35 +1287,6 @@
           </a:p>
         </p:txBody>
       </p:sp>
-      <p:pic>
-        <p:nvPicPr>
-          <p:cNvPr id="9" name="Picture 8" descr="hero_rice.jpg"/>
-          <p:cNvPicPr>
-            <a:picLocks noChangeAspect="1"/>
-          </p:cNvPicPr>
-          <p:nvPr/>
-        </p:nvPicPr>
-        <p:blipFill>
-          <a:blip r:embed="rId4"/>
-          <a:stretch>
-            <a:fillRect/>
-          </a:stretch>
-        </p:blipFill>
-        <p:spPr>
-          <a:xfrm>
-            <a:off x="6949440" y="1417320"/>
-            <a:ext cx="4599432" cy="4023360"/>
-          </a:xfrm>
-          <a:prstGeom prst="roundRect">
-            <a:avLst/>
-          </a:prstGeom>
-          <a:ln w="15875">
-            <a:solidFill>
-              <a:srgbClr val="A87C2A"/>
-            </a:solidFill>
-          </a:ln>
-        </p:spPr>
-      </p:pic>
     </p:spTree>
   </p:cSld>
   <p:clrMapOvr>
@@ -1382,7 +1353,7 @@
             <a:r>
               <a:rPr lang="en-US" sz="1100" b="1" kern="0" spc="260" dirty="0">
                 <a:solidFill>
-                  <a:srgbClr val="D08A3C"/>
+                  <a:srgbClr val="B8721E"/>
                 </a:solidFill>
                 <a:latin typeface="Calibri" pitchFamily="34" charset="0"/>
                 <a:ea typeface="Calibri" pitchFamily="34" charset="-122"/>
@@ -1421,7 +1392,7 @@
             <a:r>
               <a:rPr lang="en-US" sz="3100" b="1" dirty="0">
                 <a:solidFill>
-                  <a:srgbClr val="FFFFFF"/>
+                  <a:srgbClr val="241C10"/>
                 </a:solidFill>
                 <a:latin typeface="Cambria" pitchFamily="34" charset="0"/>
                 <a:ea typeface="Cambria" pitchFamily="34" charset="-122"/>
@@ -1460,7 +1431,7 @@
             <a:r>
               <a:rPr lang="en-US" sz="1250" i="1" dirty="0">
                 <a:solidFill>
-                  <a:srgbClr val="BFCFBB"/>
+                  <a:srgbClr val="8A7457"/>
                 </a:solidFill>
                 <a:latin typeface="Calibri" pitchFamily="34" charset="0"/>
                 <a:ea typeface="Calibri" pitchFamily="34" charset="-122"/>
@@ -1489,7 +1460,7 @@
             </a:avLst>
           </a:prstGeom>
           <a:solidFill>
-            <a:srgbClr val="0A2214">
+            <a:srgbClr val="FFFFFF">
               <a:alpha val="90000"/>
             </a:srgbClr>
           </a:solidFill>
@@ -1542,7 +1513,7 @@
             <a:r>
               <a:rPr lang="en-US" sz="1700" b="1" dirty="0">
                 <a:solidFill>
-                  <a:srgbClr val="E0B252"/>
+                  <a:srgbClr val="A5730F"/>
                 </a:solidFill>
                 <a:latin typeface="Cambria" pitchFamily="34" charset="0"/>
                 <a:ea typeface="Cambria" pitchFamily="34" charset="-122"/>
@@ -1584,7 +1555,7 @@
             <a:r>
               <a:rPr lang="en-US" sz="1200" dirty="0">
                 <a:solidFill>
-                  <a:srgbClr val="F5F0E2"/>
+                  <a:srgbClr val="3A2F1F"/>
                 </a:solidFill>
                 <a:latin typeface="Calibri" pitchFamily="34" charset="0"/>
                 <a:ea typeface="Calibri" pitchFamily="34" charset="-122"/>
@@ -1623,7 +1594,7 @@
             <a:r>
               <a:rPr lang="en-US" sz="1700" b="1" dirty="0">
                 <a:solidFill>
-                  <a:srgbClr val="E0B252"/>
+                  <a:srgbClr val="A5730F"/>
                 </a:solidFill>
                 <a:latin typeface="Cambria" pitchFamily="34" charset="0"/>
                 <a:ea typeface="Cambria" pitchFamily="34" charset="-122"/>
@@ -1662,7 +1633,7 @@
             <a:r>
               <a:rPr lang="en-US" sz="1050" dirty="0">
                 <a:solidFill>
-                  <a:srgbClr val="BFCFBB"/>
+                  <a:srgbClr val="8A7457"/>
                 </a:solidFill>
                 <a:latin typeface="Calibri" pitchFamily="34" charset="0"/>
                 <a:ea typeface="Calibri" pitchFamily="34" charset="-122"/>
@@ -1701,7 +1672,7 @@
             <a:r>
               <a:rPr lang="en-US" sz="1150" b="1" dirty="0">
                 <a:solidFill>
-                  <a:srgbClr val="F5F0E2"/>
+                  <a:srgbClr val="3A2F1F"/>
                 </a:solidFill>
                 <a:latin typeface="Calibri" pitchFamily="34" charset="0"/>
                 <a:ea typeface="Calibri" pitchFamily="34" charset="-122"/>
@@ -1740,7 +1711,7 @@
             <a:r>
               <a:rPr lang="en-US" sz="1050" dirty="0">
                 <a:solidFill>
-                  <a:srgbClr val="BFCFBB"/>
+                  <a:srgbClr val="8A7457"/>
                 </a:solidFill>
                 <a:latin typeface="Calibri" pitchFamily="34" charset="0"/>
                 <a:ea typeface="Calibri" pitchFamily="34" charset="-122"/>
@@ -1779,7 +1750,7 @@
             <a:r>
               <a:rPr lang="en-US" sz="1150" b="1" dirty="0">
                 <a:solidFill>
-                  <a:srgbClr val="F5F0E2"/>
+                  <a:srgbClr val="3A2F1F"/>
                 </a:solidFill>
                 <a:latin typeface="Calibri" pitchFamily="34" charset="0"/>
                 <a:ea typeface="Calibri" pitchFamily="34" charset="-122"/>
@@ -1818,7 +1789,7 @@
             <a:r>
               <a:rPr lang="en-US" sz="1050" dirty="0">
                 <a:solidFill>
-                  <a:srgbClr val="BFCFBB"/>
+                  <a:srgbClr val="8A7457"/>
                 </a:solidFill>
                 <a:latin typeface="Calibri" pitchFamily="34" charset="0"/>
                 <a:ea typeface="Calibri" pitchFamily="34" charset="-122"/>
@@ -1857,7 +1828,7 @@
             <a:r>
               <a:rPr lang="en-US" sz="1150" b="1" dirty="0">
                 <a:solidFill>
-                  <a:srgbClr val="F5F0E2"/>
+                  <a:srgbClr val="3A2F1F"/>
                 </a:solidFill>
                 <a:latin typeface="Calibri" pitchFamily="34" charset="0"/>
                 <a:ea typeface="Calibri" pitchFamily="34" charset="-122"/>
@@ -1896,7 +1867,7 @@
             <a:r>
               <a:rPr lang="en-US" sz="1050" dirty="0">
                 <a:solidFill>
-                  <a:srgbClr val="BFCFBB"/>
+                  <a:srgbClr val="8A7457"/>
                 </a:solidFill>
                 <a:latin typeface="Calibri" pitchFamily="34" charset="0"/>
                 <a:ea typeface="Calibri" pitchFamily="34" charset="-122"/>
@@ -1935,7 +1906,7 @@
             <a:r>
               <a:rPr lang="en-US" sz="1150" b="1" dirty="0">
                 <a:solidFill>
-                  <a:srgbClr val="F5F0E2"/>
+                  <a:srgbClr val="3A2F1F"/>
                 </a:solidFill>
                 <a:latin typeface="Calibri" pitchFamily="34" charset="0"/>
                 <a:ea typeface="Calibri" pitchFamily="34" charset="-122"/>
@@ -1974,7 +1945,7 @@
             <a:r>
               <a:rPr lang="en-US" sz="1050" dirty="0">
                 <a:solidFill>
-                  <a:srgbClr val="BFCFBB"/>
+                  <a:srgbClr val="8A7457"/>
                 </a:solidFill>
                 <a:latin typeface="Calibri" pitchFamily="34" charset="0"/>
                 <a:ea typeface="Calibri" pitchFamily="34" charset="-122"/>
@@ -2013,7 +1984,7 @@
             <a:r>
               <a:rPr lang="en-US" sz="1150" b="1" dirty="0">
                 <a:solidFill>
-                  <a:srgbClr val="F5F0E2"/>
+                  <a:srgbClr val="3A2F1F"/>
                 </a:solidFill>
                 <a:latin typeface="Calibri" pitchFamily="34" charset="0"/>
                 <a:ea typeface="Calibri" pitchFamily="34" charset="-122"/>
@@ -2052,7 +2023,7 @@
             <a:r>
               <a:rPr lang="en-US" sz="1050" dirty="0">
                 <a:solidFill>
-                  <a:srgbClr val="BFCFBB"/>
+                  <a:srgbClr val="8A7457"/>
                 </a:solidFill>
                 <a:latin typeface="Calibri" pitchFamily="34" charset="0"/>
                 <a:ea typeface="Calibri" pitchFamily="34" charset="-122"/>
@@ -2091,7 +2062,7 @@
             <a:r>
               <a:rPr lang="en-US" sz="1150" b="1" dirty="0">
                 <a:solidFill>
-                  <a:srgbClr val="F5F0E2"/>
+                  <a:srgbClr val="3A2F1F"/>
                 </a:solidFill>
                 <a:latin typeface="Calibri" pitchFamily="34" charset="0"/>
                 <a:ea typeface="Calibri" pitchFamily="34" charset="-122"/>
@@ -2130,7 +2101,7 @@
             <a:r>
               <a:rPr lang="en-US" sz="1050" dirty="0">
                 <a:solidFill>
-                  <a:srgbClr val="BFCFBB"/>
+                  <a:srgbClr val="8A7457"/>
                 </a:solidFill>
                 <a:latin typeface="Calibri" pitchFamily="34" charset="0"/>
                 <a:ea typeface="Calibri" pitchFamily="34" charset="-122"/>
@@ -2169,7 +2140,7 @@
             <a:r>
               <a:rPr lang="en-US" sz="1150" b="1" dirty="0">
                 <a:solidFill>
-                  <a:srgbClr val="F5F0E2"/>
+                  <a:srgbClr val="3A2F1F"/>
                 </a:solidFill>
                 <a:latin typeface="Calibri" pitchFamily="34" charset="0"/>
                 <a:ea typeface="Calibri" pitchFamily="34" charset="-122"/>
@@ -2208,7 +2179,7 @@
             <a:r>
               <a:rPr lang="en-US" sz="1050" dirty="0">
                 <a:solidFill>
-                  <a:srgbClr val="BFCFBB"/>
+                  <a:srgbClr val="8A7457"/>
                 </a:solidFill>
                 <a:latin typeface="Calibri" pitchFamily="34" charset="0"/>
                 <a:ea typeface="Calibri" pitchFamily="34" charset="-122"/>
@@ -2247,7 +2218,7 @@
             <a:r>
               <a:rPr lang="en-US" sz="1150" b="1" dirty="0">
                 <a:solidFill>
-                  <a:srgbClr val="F5F0E2"/>
+                  <a:srgbClr val="3A2F1F"/>
                 </a:solidFill>
                 <a:latin typeface="Calibri" pitchFamily="34" charset="0"/>
                 <a:ea typeface="Calibri" pitchFamily="34" charset="-122"/>
@@ -2329,8 +2300,8 @@
             </a:avLst>
           </a:prstGeom>
           <a:solidFill>
-            <a:srgbClr val="0A2214">
-              <a:alpha val="90000"/>
+            <a:srgbClr val="9C5A16">
+              <a:alpha val="100000"/>
             </a:srgbClr>
           </a:solidFill>
           <a:ln w="15875">
@@ -2382,7 +2353,7 @@
             <a:r>
               <a:rPr lang="en-US" sz="1900" b="1" dirty="0">
                 <a:solidFill>
-                  <a:srgbClr val="E0B252"/>
+                  <a:srgbClr val="FBF1DC"/>
                 </a:solidFill>
                 <a:latin typeface="Cambria" pitchFamily="34" charset="0"/>
                 <a:ea typeface="Cambria" pitchFamily="34" charset="-122"/>
@@ -2393,7 +2364,7 @@
             <a:r>
               <a:rPr lang="en-US" sz="1100" dirty="0">
                 <a:solidFill>
-                  <a:srgbClr val="E0B252"/>
+                  <a:srgbClr val="FBF1DC"/>
                 </a:solidFill>
                 <a:latin typeface="Cambria" pitchFamily="34" charset="0"/>
                 <a:ea typeface="Cambria" pitchFamily="34" charset="-122"/>
@@ -2432,7 +2403,7 @@
             <a:r>
               <a:rPr lang="en-US" sz="1050" dirty="0">
                 <a:solidFill>
-                  <a:srgbClr val="F5F0E2"/>
+                  <a:srgbClr val="FBF1DC"/>
                 </a:solidFill>
                 <a:latin typeface="Calibri" pitchFamily="34" charset="0"/>
                 <a:ea typeface="Calibri" pitchFamily="34" charset="-122"/>
@@ -2461,8 +2432,8 @@
             </a:avLst>
           </a:prstGeom>
           <a:solidFill>
-            <a:srgbClr val="0A2214">
-              <a:alpha val="90000"/>
+            <a:srgbClr val="9C5A16">
+              <a:alpha val="100000"/>
             </a:srgbClr>
           </a:solidFill>
           <a:ln w="15875">
@@ -2514,7 +2485,7 @@
             <a:r>
               <a:rPr lang="en-US" sz="1900" b="1" dirty="0">
                 <a:solidFill>
-                  <a:srgbClr val="E0B252"/>
+                  <a:srgbClr val="FBF1DC"/>
                 </a:solidFill>
                 <a:latin typeface="Cambria" pitchFamily="34" charset="0"/>
                 <a:ea typeface="Cambria" pitchFamily="34" charset="-122"/>
@@ -2525,7 +2496,7 @@
             <a:r>
               <a:rPr lang="en-US" sz="1100" dirty="0">
                 <a:solidFill>
-                  <a:srgbClr val="E0B252"/>
+                  <a:srgbClr val="FBF1DC"/>
                 </a:solidFill>
                 <a:latin typeface="Cambria" pitchFamily="34" charset="0"/>
                 <a:ea typeface="Cambria" pitchFamily="34" charset="-122"/>
@@ -2564,7 +2535,7 @@
             <a:r>
               <a:rPr lang="en-US" sz="1050" dirty="0">
                 <a:solidFill>
-                  <a:srgbClr val="F5F0E2"/>
+                  <a:srgbClr val="FBF1DC"/>
                 </a:solidFill>
                 <a:latin typeface="Calibri" pitchFamily="34" charset="0"/>
                 <a:ea typeface="Calibri" pitchFamily="34" charset="-122"/>
@@ -2593,8 +2564,8 @@
             </a:avLst>
           </a:prstGeom>
           <a:solidFill>
-            <a:srgbClr val="0A2214">
-              <a:alpha val="90000"/>
+            <a:srgbClr val="9C5A16">
+              <a:alpha val="100000"/>
             </a:srgbClr>
           </a:solidFill>
           <a:ln w="15875">
@@ -2646,7 +2617,7 @@
             <a:r>
               <a:rPr lang="en-US" sz="1900" b="1" dirty="0">
                 <a:solidFill>
-                  <a:srgbClr val="E0B252"/>
+                  <a:srgbClr val="FBF1DC"/>
                 </a:solidFill>
                 <a:latin typeface="Cambria" pitchFamily="34" charset="0"/>
                 <a:ea typeface="Cambria" pitchFamily="34" charset="-122"/>
@@ -2657,7 +2628,7 @@
             <a:r>
               <a:rPr lang="en-US" sz="1100" dirty="0">
                 <a:solidFill>
-                  <a:srgbClr val="E0B252"/>
+                  <a:srgbClr val="FBF1DC"/>
                 </a:solidFill>
                 <a:latin typeface="Cambria" pitchFamily="34" charset="0"/>
                 <a:ea typeface="Cambria" pitchFamily="34" charset="-122"/>
@@ -2696,7 +2667,7 @@
             <a:r>
               <a:rPr lang="en-US" sz="1050" dirty="0">
                 <a:solidFill>
-                  <a:srgbClr val="F5F0E2"/>
+                  <a:srgbClr val="FBF1DC"/>
                 </a:solidFill>
                 <a:latin typeface="Calibri" pitchFamily="34" charset="0"/>
                 <a:ea typeface="Calibri" pitchFamily="34" charset="-122"/>
@@ -2735,7 +2706,7 @@
             <a:r>
               <a:rPr lang="en-US" sz="900" dirty="0">
                 <a:solidFill>
-                  <a:srgbClr val="C2D2BD"/>
+                  <a:srgbClr val="9C8B6E"/>
                 </a:solidFill>
                 <a:latin typeface="Calibri" pitchFamily="34" charset="0"/>
                 <a:ea typeface="Calibri" pitchFamily="34" charset="-122"/>
@@ -2813,7 +2784,7 @@
             <a:r>
               <a:rPr lang="en-US" sz="1100" b="1" kern="0" spc="260" dirty="0">
                 <a:solidFill>
-                  <a:srgbClr val="D08A3C"/>
+                  <a:srgbClr val="B8721E"/>
                 </a:solidFill>
                 <a:latin typeface="Calibri" pitchFamily="34" charset="0"/>
                 <a:ea typeface="Calibri" pitchFamily="34" charset="-122"/>
@@ -2852,7 +2823,7 @@
             <a:r>
               <a:rPr lang="en-US" sz="3100" b="1" dirty="0">
                 <a:solidFill>
-                  <a:srgbClr val="FFFFFF"/>
+                  <a:srgbClr val="241C10"/>
                 </a:solidFill>
                 <a:latin typeface="Cambria" pitchFamily="34" charset="0"/>
                 <a:ea typeface="Cambria" pitchFamily="34" charset="-122"/>
@@ -2891,7 +2862,7 @@
             <a:r>
               <a:rPr lang="en-US" sz="1250" i="1" dirty="0">
                 <a:solidFill>
-                  <a:srgbClr val="BFCFBB"/>
+                  <a:srgbClr val="8A7457"/>
                 </a:solidFill>
                 <a:latin typeface="Calibri" pitchFamily="34" charset="0"/>
                 <a:ea typeface="Calibri" pitchFamily="34" charset="-122"/>
@@ -2920,7 +2891,7 @@
             </a:avLst>
           </a:prstGeom>
           <a:solidFill>
-            <a:srgbClr val="0A2214">
+            <a:srgbClr val="FFFFFF">
               <a:alpha val="90000"/>
             </a:srgbClr>
           </a:solidFill>
@@ -3099,7 +3070,7 @@
             <a:r>
               <a:rPr lang="en-US" sz="1450" b="1" dirty="0">
                 <a:solidFill>
-                  <a:srgbClr val="FFFFFF"/>
+                  <a:srgbClr val="241C10"/>
                 </a:solidFill>
                 <a:latin typeface="Cambria" pitchFamily="34" charset="0"/>
                 <a:ea typeface="Cambria" pitchFamily="34" charset="-122"/>
@@ -3138,7 +3109,7 @@
             <a:r>
               <a:rPr lang="en-US" sz="1000" dirty="0">
                 <a:solidFill>
-                  <a:srgbClr val="BFCFBB"/>
+                  <a:srgbClr val="8A7457"/>
                 </a:solidFill>
                 <a:latin typeface="Calibri" pitchFamily="34" charset="0"/>
                 <a:ea typeface="Calibri" pitchFamily="34" charset="-122"/>
@@ -3167,7 +3138,7 @@
             </a:avLst>
           </a:prstGeom>
           <a:solidFill>
-            <a:srgbClr val="16391F">
+            <a:srgbClr val="FBF1DC">
               <a:alpha val="92000"/>
             </a:srgbClr>
           </a:solidFill>
@@ -3213,7 +3184,7 @@
             <a:r>
               <a:rPr lang="en-US" sz="750" b="1" kern="0" spc="100" dirty="0">
                 <a:solidFill>
-                  <a:srgbClr val="E0B252"/>
+                  <a:srgbClr val="A5730F"/>
                 </a:solidFill>
                 <a:latin typeface="Calibri" pitchFamily="34" charset="0"/>
                 <a:ea typeface="Calibri" pitchFamily="34" charset="-122"/>
@@ -3252,7 +3223,7 @@
             <a:r>
               <a:rPr lang="en-US" sz="900" dirty="0">
                 <a:solidFill>
-                  <a:srgbClr val="BFCFBB"/>
+                  <a:srgbClr val="8A7457"/>
                 </a:solidFill>
                 <a:latin typeface="Calibri" pitchFamily="34" charset="0"/>
                 <a:ea typeface="Calibri" pitchFamily="34" charset="-122"/>
@@ -3291,7 +3262,7 @@
             <a:r>
               <a:rPr lang="en-US" sz="950" dirty="0">
                 <a:solidFill>
-                  <a:srgbClr val="F5F0E2"/>
+                  <a:srgbClr val="3A2F1F"/>
                 </a:solidFill>
                 <a:latin typeface="Calibri" pitchFamily="34" charset="0"/>
                 <a:ea typeface="Calibri" pitchFamily="34" charset="-122"/>
@@ -3330,7 +3301,7 @@
             <a:r>
               <a:rPr lang="en-US" sz="900" b="1" dirty="0">
                 <a:solidFill>
-                  <a:srgbClr val="E0B252"/>
+                  <a:srgbClr val="A5730F"/>
                 </a:solidFill>
                 <a:latin typeface="Calibri" pitchFamily="34" charset="0"/>
                 <a:ea typeface="Calibri" pitchFamily="34" charset="-122"/>
@@ -3369,7 +3340,7 @@
             <a:r>
               <a:rPr lang="en-US" sz="950" b="1" dirty="0">
                 <a:solidFill>
-                  <a:srgbClr val="E0B252"/>
+                  <a:srgbClr val="A5730F"/>
                 </a:solidFill>
                 <a:latin typeface="Calibri" pitchFamily="34" charset="0"/>
                 <a:ea typeface="Calibri" pitchFamily="34" charset="-122"/>
@@ -3408,7 +3379,7 @@
             <a:r>
               <a:rPr lang="en-US" sz="900" dirty="0">
                 <a:solidFill>
-                  <a:srgbClr val="BFCFBB"/>
+                  <a:srgbClr val="8A7457"/>
                 </a:solidFill>
                 <a:latin typeface="Calibri" pitchFamily="34" charset="0"/>
                 <a:ea typeface="Calibri" pitchFamily="34" charset="-122"/>
@@ -3447,7 +3418,7 @@
             <a:r>
               <a:rPr lang="en-US" sz="950" dirty="0">
                 <a:solidFill>
-                  <a:srgbClr val="F5F0E2"/>
+                  <a:srgbClr val="3A2F1F"/>
                 </a:solidFill>
                 <a:latin typeface="Calibri" pitchFamily="34" charset="0"/>
                 <a:ea typeface="Calibri" pitchFamily="34" charset="-122"/>
@@ -3486,7 +3457,7 @@
             <a:r>
               <a:rPr lang="en-US" sz="900" dirty="0">
                 <a:solidFill>
-                  <a:srgbClr val="BFCFBB"/>
+                  <a:srgbClr val="8A7457"/>
                 </a:solidFill>
                 <a:latin typeface="Calibri" pitchFamily="34" charset="0"/>
                 <a:ea typeface="Calibri" pitchFamily="34" charset="-122"/>
@@ -3525,7 +3496,7 @@
             <a:r>
               <a:rPr lang="en-US" sz="950" dirty="0">
                 <a:solidFill>
-                  <a:srgbClr val="F5F0E2"/>
+                  <a:srgbClr val="3A2F1F"/>
                 </a:solidFill>
                 <a:latin typeface="Calibri" pitchFamily="34" charset="0"/>
                 <a:ea typeface="Calibri" pitchFamily="34" charset="-122"/>
@@ -3554,7 +3525,7 @@
             </a:avLst>
           </a:prstGeom>
           <a:solidFill>
-            <a:srgbClr val="0A2214">
+            <a:srgbClr val="FFFFFF">
               <a:alpha val="90000"/>
             </a:srgbClr>
           </a:solidFill>
@@ -3733,7 +3704,7 @@
             <a:r>
               <a:rPr lang="en-US" sz="1450" b="1" dirty="0">
                 <a:solidFill>
-                  <a:srgbClr val="FFFFFF"/>
+                  <a:srgbClr val="241C10"/>
                 </a:solidFill>
                 <a:latin typeface="Cambria" pitchFamily="34" charset="0"/>
                 <a:ea typeface="Cambria" pitchFamily="34" charset="-122"/>
@@ -3772,7 +3743,7 @@
             <a:r>
               <a:rPr lang="en-US" sz="1000" dirty="0">
                 <a:solidFill>
-                  <a:srgbClr val="BFCFBB"/>
+                  <a:srgbClr val="8A7457"/>
                 </a:solidFill>
                 <a:latin typeface="Calibri" pitchFamily="34" charset="0"/>
                 <a:ea typeface="Calibri" pitchFamily="34" charset="-122"/>
@@ -3801,7 +3772,7 @@
             </a:avLst>
           </a:prstGeom>
           <a:solidFill>
-            <a:srgbClr val="16391F">
+            <a:srgbClr val="FBF1DC">
               <a:alpha val="92000"/>
             </a:srgbClr>
           </a:solidFill>
@@ -3847,7 +3818,7 @@
             <a:r>
               <a:rPr lang="en-US" sz="750" b="1" kern="0" spc="100" dirty="0">
                 <a:solidFill>
-                  <a:srgbClr val="E0B252"/>
+                  <a:srgbClr val="A5730F"/>
                 </a:solidFill>
                 <a:latin typeface="Calibri" pitchFamily="34" charset="0"/>
                 <a:ea typeface="Calibri" pitchFamily="34" charset="-122"/>
@@ -3886,7 +3857,7 @@
             <a:r>
               <a:rPr lang="en-US" sz="900" dirty="0">
                 <a:solidFill>
-                  <a:srgbClr val="BFCFBB"/>
+                  <a:srgbClr val="8A7457"/>
                 </a:solidFill>
                 <a:latin typeface="Calibri" pitchFamily="34" charset="0"/>
                 <a:ea typeface="Calibri" pitchFamily="34" charset="-122"/>
@@ -3925,7 +3896,7 @@
             <a:r>
               <a:rPr lang="en-US" sz="950" dirty="0">
                 <a:solidFill>
-                  <a:srgbClr val="F5F0E2"/>
+                  <a:srgbClr val="3A2F1F"/>
                 </a:solidFill>
                 <a:latin typeface="Calibri" pitchFamily="34" charset="0"/>
                 <a:ea typeface="Calibri" pitchFamily="34" charset="-122"/>
@@ -3964,7 +3935,7 @@
             <a:r>
               <a:rPr lang="en-US" sz="900" b="1" dirty="0">
                 <a:solidFill>
-                  <a:srgbClr val="E0B252"/>
+                  <a:srgbClr val="A5730F"/>
                 </a:solidFill>
                 <a:latin typeface="Calibri" pitchFamily="34" charset="0"/>
                 <a:ea typeface="Calibri" pitchFamily="34" charset="-122"/>
@@ -4003,7 +3974,7 @@
             <a:r>
               <a:rPr lang="en-US" sz="950" b="1" dirty="0">
                 <a:solidFill>
-                  <a:srgbClr val="E0B252"/>
+                  <a:srgbClr val="A5730F"/>
                 </a:solidFill>
                 <a:latin typeface="Calibri" pitchFamily="34" charset="0"/>
                 <a:ea typeface="Calibri" pitchFamily="34" charset="-122"/>
@@ -4042,7 +4013,7 @@
             <a:r>
               <a:rPr lang="en-US" sz="900" dirty="0">
                 <a:solidFill>
-                  <a:srgbClr val="BFCFBB"/>
+                  <a:srgbClr val="8A7457"/>
                 </a:solidFill>
                 <a:latin typeface="Calibri" pitchFamily="34" charset="0"/>
                 <a:ea typeface="Calibri" pitchFamily="34" charset="-122"/>
@@ -4081,7 +4052,7 @@
             <a:r>
               <a:rPr lang="en-US" sz="950" dirty="0">
                 <a:solidFill>
-                  <a:srgbClr val="F5F0E2"/>
+                  <a:srgbClr val="3A2F1F"/>
                 </a:solidFill>
                 <a:latin typeface="Calibri" pitchFamily="34" charset="0"/>
                 <a:ea typeface="Calibri" pitchFamily="34" charset="-122"/>
@@ -4120,7 +4091,7 @@
             <a:r>
               <a:rPr lang="en-US" sz="900" dirty="0">
                 <a:solidFill>
-                  <a:srgbClr val="BFCFBB"/>
+                  <a:srgbClr val="8A7457"/>
                 </a:solidFill>
                 <a:latin typeface="Calibri" pitchFamily="34" charset="0"/>
                 <a:ea typeface="Calibri" pitchFamily="34" charset="-122"/>
@@ -4159,7 +4130,7 @@
             <a:r>
               <a:rPr lang="en-US" sz="950" dirty="0">
                 <a:solidFill>
-                  <a:srgbClr val="F5F0E2"/>
+                  <a:srgbClr val="3A2F1F"/>
                 </a:solidFill>
                 <a:latin typeface="Calibri" pitchFamily="34" charset="0"/>
                 <a:ea typeface="Calibri" pitchFamily="34" charset="-122"/>
@@ -4188,7 +4159,7 @@
             </a:avLst>
           </a:prstGeom>
           <a:solidFill>
-            <a:srgbClr val="0A2214">
+            <a:srgbClr val="FFFFFF">
               <a:alpha val="90000"/>
             </a:srgbClr>
           </a:solidFill>
@@ -4367,7 +4338,7 @@
             <a:r>
               <a:rPr lang="en-US" sz="1450" b="1" dirty="0">
                 <a:solidFill>
-                  <a:srgbClr val="FFFFFF"/>
+                  <a:srgbClr val="241C10"/>
                 </a:solidFill>
                 <a:latin typeface="Cambria" pitchFamily="34" charset="0"/>
                 <a:ea typeface="Cambria" pitchFamily="34" charset="-122"/>
@@ -4406,7 +4377,7 @@
             <a:r>
               <a:rPr lang="en-US" sz="1000" dirty="0">
                 <a:solidFill>
-                  <a:srgbClr val="BFCFBB"/>
+                  <a:srgbClr val="8A7457"/>
                 </a:solidFill>
                 <a:latin typeface="Calibri" pitchFamily="34" charset="0"/>
                 <a:ea typeface="Calibri" pitchFamily="34" charset="-122"/>
@@ -4435,7 +4406,7 @@
             </a:avLst>
           </a:prstGeom>
           <a:solidFill>
-            <a:srgbClr val="16391F">
+            <a:srgbClr val="FBF1DC">
               <a:alpha val="92000"/>
             </a:srgbClr>
           </a:solidFill>
@@ -4481,7 +4452,7 @@
             <a:r>
               <a:rPr lang="en-US" sz="750" b="1" kern="0" spc="100" dirty="0">
                 <a:solidFill>
-                  <a:srgbClr val="E0B252"/>
+                  <a:srgbClr val="A5730F"/>
                 </a:solidFill>
                 <a:latin typeface="Calibri" pitchFamily="34" charset="0"/>
                 <a:ea typeface="Calibri" pitchFamily="34" charset="-122"/>
@@ -4520,7 +4491,7 @@
             <a:r>
               <a:rPr lang="en-US" sz="900" dirty="0">
                 <a:solidFill>
-                  <a:srgbClr val="BFCFBB"/>
+                  <a:srgbClr val="8A7457"/>
                 </a:solidFill>
                 <a:latin typeface="Calibri" pitchFamily="34" charset="0"/>
                 <a:ea typeface="Calibri" pitchFamily="34" charset="-122"/>
@@ -4559,7 +4530,7 @@
             <a:r>
               <a:rPr lang="en-US" sz="950" dirty="0">
                 <a:solidFill>
-                  <a:srgbClr val="F5F0E2"/>
+                  <a:srgbClr val="3A2F1F"/>
                 </a:solidFill>
                 <a:latin typeface="Calibri" pitchFamily="34" charset="0"/>
                 <a:ea typeface="Calibri" pitchFamily="34" charset="-122"/>
@@ -4598,7 +4569,7 @@
             <a:r>
               <a:rPr lang="en-US" sz="900" b="1" dirty="0">
                 <a:solidFill>
-                  <a:srgbClr val="E0B252"/>
+                  <a:srgbClr val="A5730F"/>
                 </a:solidFill>
                 <a:latin typeface="Calibri" pitchFamily="34" charset="0"/>
                 <a:ea typeface="Calibri" pitchFamily="34" charset="-122"/>
@@ -4637,7 +4608,7 @@
             <a:r>
               <a:rPr lang="en-US" sz="950" b="1" dirty="0">
                 <a:solidFill>
-                  <a:srgbClr val="E0B252"/>
+                  <a:srgbClr val="A5730F"/>
                 </a:solidFill>
                 <a:latin typeface="Calibri" pitchFamily="34" charset="0"/>
                 <a:ea typeface="Calibri" pitchFamily="34" charset="-122"/>
@@ -4676,7 +4647,7 @@
             <a:r>
               <a:rPr lang="en-US" sz="900" dirty="0">
                 <a:solidFill>
-                  <a:srgbClr val="BFCFBB"/>
+                  <a:srgbClr val="8A7457"/>
                 </a:solidFill>
                 <a:latin typeface="Calibri" pitchFamily="34" charset="0"/>
                 <a:ea typeface="Calibri" pitchFamily="34" charset="-122"/>
@@ -4715,7 +4686,7 @@
             <a:r>
               <a:rPr lang="en-US" sz="950" dirty="0">
                 <a:solidFill>
-                  <a:srgbClr val="F5F0E2"/>
+                  <a:srgbClr val="3A2F1F"/>
                 </a:solidFill>
                 <a:latin typeface="Calibri" pitchFamily="34" charset="0"/>
                 <a:ea typeface="Calibri" pitchFamily="34" charset="-122"/>
@@ -4754,7 +4725,7 @@
             <a:r>
               <a:rPr lang="en-US" sz="900" dirty="0">
                 <a:solidFill>
-                  <a:srgbClr val="BFCFBB"/>
+                  <a:srgbClr val="8A7457"/>
                 </a:solidFill>
                 <a:latin typeface="Calibri" pitchFamily="34" charset="0"/>
                 <a:ea typeface="Calibri" pitchFamily="34" charset="-122"/>
@@ -4793,7 +4764,7 @@
             <a:r>
               <a:rPr lang="en-US" sz="950" dirty="0">
                 <a:solidFill>
-                  <a:srgbClr val="F5F0E2"/>
+                  <a:srgbClr val="3A2F1F"/>
                 </a:solidFill>
                 <a:latin typeface="Calibri" pitchFamily="34" charset="0"/>
                 <a:ea typeface="Calibri" pitchFamily="34" charset="-122"/>
@@ -4822,7 +4793,7 @@
             </a:avLst>
           </a:prstGeom>
           <a:solidFill>
-            <a:srgbClr val="0A2214">
+            <a:srgbClr val="FFFFFF">
               <a:alpha val="90000"/>
             </a:srgbClr>
           </a:solidFill>
@@ -5001,7 +4972,7 @@
             <a:r>
               <a:rPr lang="en-US" sz="1450" b="1" dirty="0">
                 <a:solidFill>
-                  <a:srgbClr val="FFFFFF"/>
+                  <a:srgbClr val="241C10"/>
                 </a:solidFill>
                 <a:latin typeface="Cambria" pitchFamily="34" charset="0"/>
                 <a:ea typeface="Cambria" pitchFamily="34" charset="-122"/>
@@ -5040,7 +5011,7 @@
             <a:r>
               <a:rPr lang="en-US" sz="1000" dirty="0">
                 <a:solidFill>
-                  <a:srgbClr val="BFCFBB"/>
+                  <a:srgbClr val="8A7457"/>
                 </a:solidFill>
                 <a:latin typeface="Calibri" pitchFamily="34" charset="0"/>
                 <a:ea typeface="Calibri" pitchFamily="34" charset="-122"/>
@@ -5069,7 +5040,7 @@
             </a:avLst>
           </a:prstGeom>
           <a:solidFill>
-            <a:srgbClr val="16391F">
+            <a:srgbClr val="FBF1DC">
               <a:alpha val="92000"/>
             </a:srgbClr>
           </a:solidFill>
@@ -5115,7 +5086,7 @@
             <a:r>
               <a:rPr lang="en-US" sz="750" b="1" kern="0" spc="100" dirty="0">
                 <a:solidFill>
-                  <a:srgbClr val="E0B252"/>
+                  <a:srgbClr val="A5730F"/>
                 </a:solidFill>
                 <a:latin typeface="Calibri" pitchFamily="34" charset="0"/>
                 <a:ea typeface="Calibri" pitchFamily="34" charset="-122"/>
@@ -5154,7 +5125,7 @@
             <a:r>
               <a:rPr lang="en-US" sz="900" dirty="0">
                 <a:solidFill>
-                  <a:srgbClr val="BFCFBB"/>
+                  <a:srgbClr val="8A7457"/>
                 </a:solidFill>
                 <a:latin typeface="Calibri" pitchFamily="34" charset="0"/>
                 <a:ea typeface="Calibri" pitchFamily="34" charset="-122"/>
@@ -5193,7 +5164,7 @@
             <a:r>
               <a:rPr lang="en-US" sz="950" dirty="0">
                 <a:solidFill>
-                  <a:srgbClr val="F5F0E2"/>
+                  <a:srgbClr val="3A2F1F"/>
                 </a:solidFill>
                 <a:latin typeface="Calibri" pitchFamily="34" charset="0"/>
                 <a:ea typeface="Calibri" pitchFamily="34" charset="-122"/>
@@ -5232,7 +5203,7 @@
             <a:r>
               <a:rPr lang="en-US" sz="900" b="1" dirty="0">
                 <a:solidFill>
-                  <a:srgbClr val="E0B252"/>
+                  <a:srgbClr val="A5730F"/>
                 </a:solidFill>
                 <a:latin typeface="Calibri" pitchFamily="34" charset="0"/>
                 <a:ea typeface="Calibri" pitchFamily="34" charset="-122"/>
@@ -5271,7 +5242,7 @@
             <a:r>
               <a:rPr lang="en-US" sz="950" b="1" dirty="0">
                 <a:solidFill>
-                  <a:srgbClr val="E0B252"/>
+                  <a:srgbClr val="A5730F"/>
                 </a:solidFill>
                 <a:latin typeface="Calibri" pitchFamily="34" charset="0"/>
                 <a:ea typeface="Calibri" pitchFamily="34" charset="-122"/>
@@ -5310,7 +5281,7 @@
             <a:r>
               <a:rPr lang="en-US" sz="900" dirty="0">
                 <a:solidFill>
-                  <a:srgbClr val="BFCFBB"/>
+                  <a:srgbClr val="8A7457"/>
                 </a:solidFill>
                 <a:latin typeface="Calibri" pitchFamily="34" charset="0"/>
                 <a:ea typeface="Calibri" pitchFamily="34" charset="-122"/>
@@ -5349,7 +5320,7 @@
             <a:r>
               <a:rPr lang="en-US" sz="950" dirty="0">
                 <a:solidFill>
-                  <a:srgbClr val="F5F0E2"/>
+                  <a:srgbClr val="3A2F1F"/>
                 </a:solidFill>
                 <a:latin typeface="Calibri" pitchFamily="34" charset="0"/>
                 <a:ea typeface="Calibri" pitchFamily="34" charset="-122"/>
@@ -5388,7 +5359,7 @@
             <a:r>
               <a:rPr lang="en-US" sz="900" dirty="0">
                 <a:solidFill>
-                  <a:srgbClr val="BFCFBB"/>
+                  <a:srgbClr val="8A7457"/>
                 </a:solidFill>
                 <a:latin typeface="Calibri" pitchFamily="34" charset="0"/>
                 <a:ea typeface="Calibri" pitchFamily="34" charset="-122"/>
@@ -5427,7 +5398,7 @@
             <a:r>
               <a:rPr lang="en-US" sz="950" dirty="0">
                 <a:solidFill>
-                  <a:srgbClr val="F5F0E2"/>
+                  <a:srgbClr val="3A2F1F"/>
                 </a:solidFill>
                 <a:latin typeface="Calibri" pitchFamily="34" charset="0"/>
                 <a:ea typeface="Calibri" pitchFamily="34" charset="-122"/>
@@ -5466,7 +5437,7 @@
             <a:r>
               <a:rPr lang="en-US" sz="900" dirty="0">
                 <a:solidFill>
-                  <a:srgbClr val="C2D2BD"/>
+                  <a:srgbClr val="9C8B6E"/>
                 </a:solidFill>
                 <a:latin typeface="Calibri" pitchFamily="34" charset="0"/>
                 <a:ea typeface="Calibri" pitchFamily="34" charset="-122"/>
@@ -5544,7 +5515,7 @@
             <a:r>
               <a:rPr lang="en-US" sz="1100" b="1" kern="0" spc="260" dirty="0">
                 <a:solidFill>
-                  <a:srgbClr val="6FA84B"/>
+                  <a:srgbClr val="2E7D3C"/>
                 </a:solidFill>
                 <a:latin typeface="Calibri" pitchFamily="34" charset="0"/>
                 <a:ea typeface="Calibri" pitchFamily="34" charset="-122"/>
@@ -5583,7 +5554,7 @@
             <a:r>
               <a:rPr lang="en-US" sz="3100" b="1" dirty="0">
                 <a:solidFill>
-                  <a:srgbClr val="FFFFFF"/>
+                  <a:srgbClr val="241C10"/>
                 </a:solidFill>
                 <a:latin typeface="Cambria" pitchFamily="34" charset="0"/>
                 <a:ea typeface="Cambria" pitchFamily="34" charset="-122"/>
@@ -5622,7 +5593,7 @@
             <a:r>
               <a:rPr lang="en-US" sz="1250" i="1" dirty="0">
                 <a:solidFill>
-                  <a:srgbClr val="BFCFBB"/>
+                  <a:srgbClr val="8A7457"/>
                 </a:solidFill>
                 <a:latin typeface="Calibri" pitchFamily="34" charset="0"/>
                 <a:ea typeface="Calibri" pitchFamily="34" charset="-122"/>
@@ -5651,13 +5622,13 @@
             </a:avLst>
           </a:prstGeom>
           <a:solidFill>
-            <a:srgbClr val="0A2214">
+            <a:srgbClr val="FFFFFF">
               <a:alpha val="90000"/>
             </a:srgbClr>
           </a:solidFill>
           <a:ln w="15875">
             <a:solidFill>
-              <a:srgbClr val="A87C2A"/>
+              <a:srgbClr val="2E7D3C"/>
             </a:solidFill>
             <a:prstDash val="solid"/>
           </a:ln>
@@ -5704,7 +5675,7 @@
             <a:r>
               <a:rPr lang="en-US" sz="1700" b="1" dirty="0">
                 <a:solidFill>
-                  <a:srgbClr val="E0B252"/>
+                  <a:srgbClr val="1F5C3A"/>
                 </a:solidFill>
                 <a:latin typeface="Cambria" pitchFamily="34" charset="0"/>
                 <a:ea typeface="Cambria" pitchFamily="34" charset="-122"/>
@@ -5746,7 +5717,7 @@
             <a:r>
               <a:rPr lang="en-US" sz="1200" dirty="0">
                 <a:solidFill>
-                  <a:srgbClr val="F5F0E2"/>
+                  <a:srgbClr val="3A2F1F"/>
                 </a:solidFill>
                 <a:latin typeface="Calibri" pitchFamily="34" charset="0"/>
                 <a:ea typeface="Calibri" pitchFamily="34" charset="-122"/>
@@ -5785,7 +5756,7 @@
             <a:r>
               <a:rPr lang="en-US" sz="1700" b="1" dirty="0">
                 <a:solidFill>
-                  <a:srgbClr val="E0B252"/>
+                  <a:srgbClr val="1F5C3A"/>
                 </a:solidFill>
                 <a:latin typeface="Cambria" pitchFamily="34" charset="0"/>
                 <a:ea typeface="Cambria" pitchFamily="34" charset="-122"/>
@@ -5824,7 +5795,7 @@
             <a:r>
               <a:rPr lang="en-US" sz="1050" dirty="0">
                 <a:solidFill>
-                  <a:srgbClr val="BFCFBB"/>
+                  <a:srgbClr val="8A7457"/>
                 </a:solidFill>
                 <a:latin typeface="Calibri" pitchFamily="34" charset="0"/>
                 <a:ea typeface="Calibri" pitchFamily="34" charset="-122"/>
@@ -5863,7 +5834,7 @@
             <a:r>
               <a:rPr lang="en-US" sz="1150" b="1" dirty="0">
                 <a:solidFill>
-                  <a:srgbClr val="F5F0E2"/>
+                  <a:srgbClr val="3A2F1F"/>
                 </a:solidFill>
                 <a:latin typeface="Calibri" pitchFamily="34" charset="0"/>
                 <a:ea typeface="Calibri" pitchFamily="34" charset="-122"/>
@@ -5902,7 +5873,7 @@
             <a:r>
               <a:rPr lang="en-US" sz="1050" dirty="0">
                 <a:solidFill>
-                  <a:srgbClr val="BFCFBB"/>
+                  <a:srgbClr val="8A7457"/>
                 </a:solidFill>
                 <a:latin typeface="Calibri" pitchFamily="34" charset="0"/>
                 <a:ea typeface="Calibri" pitchFamily="34" charset="-122"/>
@@ -5941,7 +5912,7 @@
             <a:r>
               <a:rPr lang="en-US" sz="1150" b="1" dirty="0">
                 <a:solidFill>
-                  <a:srgbClr val="F5F0E2"/>
+                  <a:srgbClr val="3A2F1F"/>
                 </a:solidFill>
                 <a:latin typeface="Calibri" pitchFamily="34" charset="0"/>
                 <a:ea typeface="Calibri" pitchFamily="34" charset="-122"/>
@@ -5980,7 +5951,7 @@
             <a:r>
               <a:rPr lang="en-US" sz="1050" dirty="0">
                 <a:solidFill>
-                  <a:srgbClr val="BFCFBB"/>
+                  <a:srgbClr val="8A7457"/>
                 </a:solidFill>
                 <a:latin typeface="Calibri" pitchFamily="34" charset="0"/>
                 <a:ea typeface="Calibri" pitchFamily="34" charset="-122"/>
@@ -6019,7 +5990,7 @@
             <a:r>
               <a:rPr lang="en-US" sz="1150" b="1" dirty="0">
                 <a:solidFill>
-                  <a:srgbClr val="F5F0E2"/>
+                  <a:srgbClr val="3A2F1F"/>
                 </a:solidFill>
                 <a:latin typeface="Calibri" pitchFamily="34" charset="0"/>
                 <a:ea typeface="Calibri" pitchFamily="34" charset="-122"/>
@@ -6058,7 +6029,7 @@
             <a:r>
               <a:rPr lang="en-US" sz="1050" dirty="0">
                 <a:solidFill>
-                  <a:srgbClr val="BFCFBB"/>
+                  <a:srgbClr val="8A7457"/>
                 </a:solidFill>
                 <a:latin typeface="Calibri" pitchFamily="34" charset="0"/>
                 <a:ea typeface="Calibri" pitchFamily="34" charset="-122"/>
@@ -6097,7 +6068,7 @@
             <a:r>
               <a:rPr lang="en-US" sz="1150" b="1" dirty="0">
                 <a:solidFill>
-                  <a:srgbClr val="F5F0E2"/>
+                  <a:srgbClr val="3A2F1F"/>
                 </a:solidFill>
                 <a:latin typeface="Calibri" pitchFamily="34" charset="0"/>
                 <a:ea typeface="Calibri" pitchFamily="34" charset="-122"/>
@@ -6136,7 +6107,7 @@
             <a:r>
               <a:rPr lang="en-US" sz="1050" dirty="0">
                 <a:solidFill>
-                  <a:srgbClr val="BFCFBB"/>
+                  <a:srgbClr val="8A7457"/>
                 </a:solidFill>
                 <a:latin typeface="Calibri" pitchFamily="34" charset="0"/>
                 <a:ea typeface="Calibri" pitchFamily="34" charset="-122"/>
@@ -6175,7 +6146,7 @@
             <a:r>
               <a:rPr lang="en-US" sz="1150" b="1" dirty="0">
                 <a:solidFill>
-                  <a:srgbClr val="F5F0E2"/>
+                  <a:srgbClr val="3A2F1F"/>
                 </a:solidFill>
                 <a:latin typeface="Calibri" pitchFamily="34" charset="0"/>
                 <a:ea typeface="Calibri" pitchFamily="34" charset="-122"/>
@@ -6214,7 +6185,7 @@
             <a:r>
               <a:rPr lang="en-US" sz="1050" dirty="0">
                 <a:solidFill>
-                  <a:srgbClr val="BFCFBB"/>
+                  <a:srgbClr val="8A7457"/>
                 </a:solidFill>
                 <a:latin typeface="Calibri" pitchFamily="34" charset="0"/>
                 <a:ea typeface="Calibri" pitchFamily="34" charset="-122"/>
@@ -6253,7 +6224,7 @@
             <a:r>
               <a:rPr lang="en-US" sz="1150" b="1" dirty="0">
                 <a:solidFill>
-                  <a:srgbClr val="F5F0E2"/>
+                  <a:srgbClr val="3A2F1F"/>
                 </a:solidFill>
                 <a:latin typeface="Calibri" pitchFamily="34" charset="0"/>
                 <a:ea typeface="Calibri" pitchFamily="34" charset="-122"/>
@@ -6292,7 +6263,7 @@
             <a:r>
               <a:rPr lang="en-US" sz="1050" dirty="0">
                 <a:solidFill>
-                  <a:srgbClr val="BFCFBB"/>
+                  <a:srgbClr val="8A7457"/>
                 </a:solidFill>
                 <a:latin typeface="Calibri" pitchFamily="34" charset="0"/>
                 <a:ea typeface="Calibri" pitchFamily="34" charset="-122"/>
@@ -6331,7 +6302,7 @@
             <a:r>
               <a:rPr lang="en-US" sz="1150" b="1" dirty="0">
                 <a:solidFill>
-                  <a:srgbClr val="F5F0E2"/>
+                  <a:srgbClr val="3A2F1F"/>
                 </a:solidFill>
                 <a:latin typeface="Calibri" pitchFamily="34" charset="0"/>
                 <a:ea typeface="Calibri" pitchFamily="34" charset="-122"/>
@@ -6370,7 +6341,7 @@
             <a:r>
               <a:rPr lang="en-US" sz="1050" dirty="0">
                 <a:solidFill>
-                  <a:srgbClr val="BFCFBB"/>
+                  <a:srgbClr val="8A7457"/>
                 </a:solidFill>
                 <a:latin typeface="Calibri" pitchFamily="34" charset="0"/>
                 <a:ea typeface="Calibri" pitchFamily="34" charset="-122"/>
@@ -6409,7 +6380,7 @@
             <a:r>
               <a:rPr lang="en-US" sz="1150" b="1" dirty="0">
                 <a:solidFill>
-                  <a:srgbClr val="F5F0E2"/>
+                  <a:srgbClr val="3A2F1F"/>
                 </a:solidFill>
                 <a:latin typeface="Calibri" pitchFamily="34" charset="0"/>
                 <a:ea typeface="Calibri" pitchFamily="34" charset="-122"/>
@@ -6460,7 +6431,7 @@
           </a:prstGeom>
           <a:ln w="15875">
             <a:solidFill>
-              <a:srgbClr val="A87C2A"/>
+              <a:srgbClr val="2E7D3C"/>
             </a:solidFill>
             <a:prstDash val="solid"/>
           </a:ln>
@@ -6490,13 +6461,13 @@
             </a:avLst>
           </a:prstGeom>
           <a:solidFill>
-            <a:srgbClr val="0A2214">
-              <a:alpha val="90000"/>
+            <a:srgbClr val="1F5C3A">
+              <a:alpha val="100000"/>
             </a:srgbClr>
           </a:solidFill>
           <a:ln w="15875">
             <a:solidFill>
-              <a:srgbClr val="A87C2A"/>
+              <a:srgbClr val="2E7D3C"/>
             </a:solidFill>
             <a:prstDash val="solid"/>
           </a:ln>
@@ -6543,7 +6514,7 @@
             <a:r>
               <a:rPr lang="en-US" sz="1900" b="1" dirty="0">
                 <a:solidFill>
-                  <a:srgbClr val="E0B252"/>
+                  <a:srgbClr val="EAF3EA"/>
                 </a:solidFill>
                 <a:latin typeface="Cambria" pitchFamily="34" charset="0"/>
                 <a:ea typeface="Cambria" pitchFamily="34" charset="-122"/>
@@ -6582,7 +6553,7 @@
             <a:r>
               <a:rPr lang="en-US" sz="1050" dirty="0">
                 <a:solidFill>
-                  <a:srgbClr val="F5F0E2"/>
+                  <a:srgbClr val="EAF3EA"/>
                 </a:solidFill>
                 <a:latin typeface="Calibri" pitchFamily="34" charset="0"/>
                 <a:ea typeface="Calibri" pitchFamily="34" charset="-122"/>
@@ -6611,13 +6582,13 @@
             </a:avLst>
           </a:prstGeom>
           <a:solidFill>
-            <a:srgbClr val="0A2214">
-              <a:alpha val="90000"/>
+            <a:srgbClr val="1F5C3A">
+              <a:alpha val="100000"/>
             </a:srgbClr>
           </a:solidFill>
           <a:ln w="15875">
             <a:solidFill>
-              <a:srgbClr val="A87C2A"/>
+              <a:srgbClr val="2E7D3C"/>
             </a:solidFill>
             <a:prstDash val="solid"/>
           </a:ln>
@@ -6664,7 +6635,7 @@
             <a:r>
               <a:rPr lang="en-US" sz="1900" b="1" dirty="0">
                 <a:solidFill>
-                  <a:srgbClr val="E0B252"/>
+                  <a:srgbClr val="EAF3EA"/>
                 </a:solidFill>
                 <a:latin typeface="Cambria" pitchFamily="34" charset="0"/>
                 <a:ea typeface="Cambria" pitchFamily="34" charset="-122"/>
@@ -6675,7 +6646,7 @@
             <a:r>
               <a:rPr lang="en-US" sz="1100" dirty="0">
                 <a:solidFill>
-                  <a:srgbClr val="E0B252"/>
+                  <a:srgbClr val="EAF3EA"/>
                 </a:solidFill>
                 <a:latin typeface="Cambria" pitchFamily="34" charset="0"/>
                 <a:ea typeface="Cambria" pitchFamily="34" charset="-122"/>
@@ -6714,7 +6685,7 @@
             <a:r>
               <a:rPr lang="en-US" sz="1050" dirty="0">
                 <a:solidFill>
-                  <a:srgbClr val="F5F0E2"/>
+                  <a:srgbClr val="EAF3EA"/>
                 </a:solidFill>
                 <a:latin typeface="Calibri" pitchFamily="34" charset="0"/>
                 <a:ea typeface="Calibri" pitchFamily="34" charset="-122"/>
@@ -6743,13 +6714,13 @@
             </a:avLst>
           </a:prstGeom>
           <a:solidFill>
-            <a:srgbClr val="0A2214">
-              <a:alpha val="90000"/>
+            <a:srgbClr val="1F5C3A">
+              <a:alpha val="100000"/>
             </a:srgbClr>
           </a:solidFill>
           <a:ln w="15875">
             <a:solidFill>
-              <a:srgbClr val="A87C2A"/>
+              <a:srgbClr val="2E7D3C"/>
             </a:solidFill>
             <a:prstDash val="solid"/>
           </a:ln>
@@ -6796,7 +6767,7 @@
             <a:r>
               <a:rPr lang="en-US" sz="1900" b="1" dirty="0">
                 <a:solidFill>
-                  <a:srgbClr val="E0B252"/>
+                  <a:srgbClr val="EAF3EA"/>
                 </a:solidFill>
                 <a:latin typeface="Cambria" pitchFamily="34" charset="0"/>
                 <a:ea typeface="Cambria" pitchFamily="34" charset="-122"/>
@@ -6807,7 +6778,7 @@
             <a:r>
               <a:rPr lang="en-US" sz="1100" dirty="0">
                 <a:solidFill>
-                  <a:srgbClr val="E0B252"/>
+                  <a:srgbClr val="EAF3EA"/>
                 </a:solidFill>
                 <a:latin typeface="Cambria" pitchFamily="34" charset="0"/>
                 <a:ea typeface="Cambria" pitchFamily="34" charset="-122"/>
@@ -6846,7 +6817,7 @@
             <a:r>
               <a:rPr lang="en-US" sz="1050" dirty="0">
                 <a:solidFill>
-                  <a:srgbClr val="F5F0E2"/>
+                  <a:srgbClr val="EAF3EA"/>
                 </a:solidFill>
                 <a:latin typeface="Calibri" pitchFamily="34" charset="0"/>
                 <a:ea typeface="Calibri" pitchFamily="34" charset="-122"/>
@@ -6885,7 +6856,7 @@
             <a:r>
               <a:rPr lang="en-US" sz="900" dirty="0">
                 <a:solidFill>
-                  <a:srgbClr val="C2D2BD"/>
+                  <a:srgbClr val="9C8B6E"/>
                 </a:solidFill>
                 <a:latin typeface="Calibri" pitchFamily="34" charset="0"/>
                 <a:ea typeface="Calibri" pitchFamily="34" charset="-122"/>
@@ -6963,7 +6934,7 @@
             <a:r>
               <a:rPr lang="en-US" sz="1100" b="1" kern="0" spc="260" dirty="0">
                 <a:solidFill>
-                  <a:srgbClr val="6FA84B"/>
+                  <a:srgbClr val="2E7D3C"/>
                 </a:solidFill>
                 <a:latin typeface="Calibri" pitchFamily="34" charset="0"/>
                 <a:ea typeface="Calibri" pitchFamily="34" charset="-122"/>
@@ -7002,7 +6973,7 @@
             <a:r>
               <a:rPr lang="en-US" sz="3100" b="1" dirty="0">
                 <a:solidFill>
-                  <a:srgbClr val="FFFFFF"/>
+                  <a:srgbClr val="241C10"/>
                 </a:solidFill>
                 <a:latin typeface="Cambria" pitchFamily="34" charset="0"/>
                 <a:ea typeface="Cambria" pitchFamily="34" charset="-122"/>
@@ -7041,7 +7012,7 @@
             <a:r>
               <a:rPr lang="en-US" sz="1250" i="1" dirty="0">
                 <a:solidFill>
-                  <a:srgbClr val="BFCFBB"/>
+                  <a:srgbClr val="8A7457"/>
                 </a:solidFill>
                 <a:latin typeface="Calibri" pitchFamily="34" charset="0"/>
                 <a:ea typeface="Calibri" pitchFamily="34" charset="-122"/>
@@ -7070,13 +7041,13 @@
             </a:avLst>
           </a:prstGeom>
           <a:solidFill>
-            <a:srgbClr val="0A2214">
+            <a:srgbClr val="FFFFFF">
               <a:alpha val="90000"/>
             </a:srgbClr>
           </a:solidFill>
           <a:ln w="15875">
             <a:solidFill>
-              <a:srgbClr val="A87C2A"/>
+              <a:srgbClr val="2E7D3C"/>
             </a:solidFill>
             <a:prstDash val="solid"/>
           </a:ln>
@@ -7135,7 +7106,7 @@
           </a:prstGeom>
           <a:ln w="12700">
             <a:solidFill>
-              <a:srgbClr val="A87C2A"/>
+              <a:srgbClr val="2E7D3C"/>
             </a:solidFill>
             <a:prstDash val="solid"/>
           </a:ln>
@@ -7169,7 +7140,7 @@
           </a:solidFill>
           <a:ln w="6350">
             <a:solidFill>
-              <a:srgbClr val="A87C2A"/>
+              <a:srgbClr val="2E7D3C"/>
             </a:solidFill>
             <a:prstDash val="solid"/>
           </a:ln>
@@ -7248,7 +7219,7 @@
             <a:r>
               <a:rPr lang="en-US" sz="1450" b="1" dirty="0">
                 <a:solidFill>
-                  <a:srgbClr val="FFFFFF"/>
+                  <a:srgbClr val="241C10"/>
                 </a:solidFill>
                 <a:latin typeface="Cambria" pitchFamily="34" charset="0"/>
                 <a:ea typeface="Cambria" pitchFamily="34" charset="-122"/>
@@ -7265,7 +7236,7 @@
             <a:r>
               <a:rPr lang="en-US" sz="1450" b="1" dirty="0">
                 <a:solidFill>
-                  <a:srgbClr val="FFFFFF"/>
+                  <a:srgbClr val="241C10"/>
                 </a:solidFill>
                 <a:latin typeface="Cambria" pitchFamily="34" charset="0"/>
                 <a:ea typeface="Cambria" pitchFamily="34" charset="-122"/>
@@ -7304,7 +7275,7 @@
             <a:r>
               <a:rPr lang="en-US" sz="1000" dirty="0">
                 <a:solidFill>
-                  <a:srgbClr val="BFCFBB"/>
+                  <a:srgbClr val="8A7457"/>
                 </a:solidFill>
                 <a:latin typeface="Calibri" pitchFamily="34" charset="0"/>
                 <a:ea typeface="Calibri" pitchFamily="34" charset="-122"/>
@@ -7333,13 +7304,13 @@
             </a:avLst>
           </a:prstGeom>
           <a:solidFill>
-            <a:srgbClr val="16391F">
+            <a:srgbClr val="EAF3EA">
               <a:alpha val="92000"/>
             </a:srgbClr>
           </a:solidFill>
           <a:ln w="9525">
             <a:solidFill>
-              <a:srgbClr val="A87C2A"/>
+              <a:srgbClr val="2E7D3C"/>
             </a:solidFill>
             <a:prstDash val="solid"/>
           </a:ln>
@@ -7379,7 +7350,7 @@
             <a:r>
               <a:rPr lang="en-US" sz="750" b="1" kern="0" spc="100" dirty="0">
                 <a:solidFill>
-                  <a:srgbClr val="E0B252"/>
+                  <a:srgbClr val="1F5C3A"/>
                 </a:solidFill>
                 <a:latin typeface="Calibri" pitchFamily="34" charset="0"/>
                 <a:ea typeface="Calibri" pitchFamily="34" charset="-122"/>
@@ -7418,7 +7389,7 @@
             <a:r>
               <a:rPr lang="en-US" sz="900" dirty="0">
                 <a:solidFill>
-                  <a:srgbClr val="BFCFBB"/>
+                  <a:srgbClr val="8A7457"/>
                 </a:solidFill>
                 <a:latin typeface="Calibri" pitchFamily="34" charset="0"/>
                 <a:ea typeface="Calibri" pitchFamily="34" charset="-122"/>
@@ -7457,7 +7428,7 @@
             <a:r>
               <a:rPr lang="en-US" sz="950" dirty="0">
                 <a:solidFill>
-                  <a:srgbClr val="F5F0E2"/>
+                  <a:srgbClr val="3A2F1F"/>
                 </a:solidFill>
                 <a:latin typeface="Calibri" pitchFamily="34" charset="0"/>
                 <a:ea typeface="Calibri" pitchFamily="34" charset="-122"/>
@@ -7496,7 +7467,7 @@
             <a:r>
               <a:rPr lang="en-US" sz="900" b="1" dirty="0">
                 <a:solidFill>
-                  <a:srgbClr val="E0B252"/>
+                  <a:srgbClr val="1F5C3A"/>
                 </a:solidFill>
                 <a:latin typeface="Calibri" pitchFamily="34" charset="0"/>
                 <a:ea typeface="Calibri" pitchFamily="34" charset="-122"/>
@@ -7535,7 +7506,7 @@
             <a:r>
               <a:rPr lang="en-US" sz="950" b="1" dirty="0">
                 <a:solidFill>
-                  <a:srgbClr val="E0B252"/>
+                  <a:srgbClr val="1F5C3A"/>
                 </a:solidFill>
                 <a:latin typeface="Calibri" pitchFamily="34" charset="0"/>
                 <a:ea typeface="Calibri" pitchFamily="34" charset="-122"/>
@@ -7574,7 +7545,7 @@
             <a:r>
               <a:rPr lang="en-US" sz="900" dirty="0">
                 <a:solidFill>
-                  <a:srgbClr val="BFCFBB"/>
+                  <a:srgbClr val="8A7457"/>
                 </a:solidFill>
                 <a:latin typeface="Calibri" pitchFamily="34" charset="0"/>
                 <a:ea typeface="Calibri" pitchFamily="34" charset="-122"/>
@@ -7613,7 +7584,7 @@
             <a:r>
               <a:rPr lang="en-US" sz="950" dirty="0">
                 <a:solidFill>
-                  <a:srgbClr val="F5F0E2"/>
+                  <a:srgbClr val="3A2F1F"/>
                 </a:solidFill>
                 <a:latin typeface="Calibri" pitchFamily="34" charset="0"/>
                 <a:ea typeface="Calibri" pitchFamily="34" charset="-122"/>
@@ -7652,7 +7623,7 @@
             <a:r>
               <a:rPr lang="en-US" sz="900" dirty="0">
                 <a:solidFill>
-                  <a:srgbClr val="BFCFBB"/>
+                  <a:srgbClr val="8A7457"/>
                 </a:solidFill>
                 <a:latin typeface="Calibri" pitchFamily="34" charset="0"/>
                 <a:ea typeface="Calibri" pitchFamily="34" charset="-122"/>
@@ -7691,7 +7662,7 @@
             <a:r>
               <a:rPr lang="en-US" sz="950" dirty="0">
                 <a:solidFill>
-                  <a:srgbClr val="F5F0E2"/>
+                  <a:srgbClr val="3A2F1F"/>
                 </a:solidFill>
                 <a:latin typeface="Calibri" pitchFamily="34" charset="0"/>
                 <a:ea typeface="Calibri" pitchFamily="34" charset="-122"/>
@@ -7720,13 +7691,13 @@
             </a:avLst>
           </a:prstGeom>
           <a:solidFill>
-            <a:srgbClr val="0A2214">
+            <a:srgbClr val="FFFFFF">
               <a:alpha val="90000"/>
             </a:srgbClr>
           </a:solidFill>
           <a:ln w="15875">
             <a:solidFill>
-              <a:srgbClr val="A87C2A"/>
+              <a:srgbClr val="2E7D3C"/>
             </a:solidFill>
             <a:prstDash val="solid"/>
           </a:ln>
@@ -7785,7 +7756,7 @@
           </a:prstGeom>
           <a:ln w="12700">
             <a:solidFill>
-              <a:srgbClr val="A87C2A"/>
+              <a:srgbClr val="2E7D3C"/>
             </a:solidFill>
             <a:prstDash val="solid"/>
           </a:ln>
@@ -7819,7 +7790,7 @@
           </a:solidFill>
           <a:ln w="6350">
             <a:solidFill>
-              <a:srgbClr val="A87C2A"/>
+              <a:srgbClr val="2E7D3C"/>
             </a:solidFill>
             <a:prstDash val="solid"/>
           </a:ln>
@@ -7898,7 +7869,7 @@
             <a:r>
               <a:rPr lang="en-US" sz="1450" b="1" dirty="0">
                 <a:solidFill>
-                  <a:srgbClr val="FFFFFF"/>
+                  <a:srgbClr val="241C10"/>
                 </a:solidFill>
                 <a:latin typeface="Cambria" pitchFamily="34" charset="0"/>
                 <a:ea typeface="Cambria" pitchFamily="34" charset="-122"/>
@@ -7937,7 +7908,7 @@
             <a:r>
               <a:rPr lang="en-US" sz="1000" dirty="0">
                 <a:solidFill>
-                  <a:srgbClr val="BFCFBB"/>
+                  <a:srgbClr val="8A7457"/>
                 </a:solidFill>
                 <a:latin typeface="Calibri" pitchFamily="34" charset="0"/>
                 <a:ea typeface="Calibri" pitchFamily="34" charset="-122"/>
@@ -7966,13 +7937,13 @@
             </a:avLst>
           </a:prstGeom>
           <a:solidFill>
-            <a:srgbClr val="16391F">
+            <a:srgbClr val="EAF3EA">
               <a:alpha val="92000"/>
             </a:srgbClr>
           </a:solidFill>
           <a:ln w="9525">
             <a:solidFill>
-              <a:srgbClr val="A87C2A"/>
+              <a:srgbClr val="2E7D3C"/>
             </a:solidFill>
             <a:prstDash val="solid"/>
           </a:ln>
@@ -8012,7 +7983,7 @@
             <a:r>
               <a:rPr lang="en-US" sz="750" b="1" kern="0" spc="100" dirty="0">
                 <a:solidFill>
-                  <a:srgbClr val="E0B252"/>
+                  <a:srgbClr val="1F5C3A"/>
                 </a:solidFill>
                 <a:latin typeface="Calibri" pitchFamily="34" charset="0"/>
                 <a:ea typeface="Calibri" pitchFamily="34" charset="-122"/>
@@ -8051,7 +8022,7 @@
             <a:r>
               <a:rPr lang="en-US" sz="900" dirty="0">
                 <a:solidFill>
-                  <a:srgbClr val="BFCFBB"/>
+                  <a:srgbClr val="8A7457"/>
                 </a:solidFill>
                 <a:latin typeface="Calibri" pitchFamily="34" charset="0"/>
                 <a:ea typeface="Calibri" pitchFamily="34" charset="-122"/>
@@ -8090,7 +8061,7 @@
             <a:r>
               <a:rPr lang="en-US" sz="950" dirty="0">
                 <a:solidFill>
-                  <a:srgbClr val="F5F0E2"/>
+                  <a:srgbClr val="3A2F1F"/>
                 </a:solidFill>
                 <a:latin typeface="Calibri" pitchFamily="34" charset="0"/>
                 <a:ea typeface="Calibri" pitchFamily="34" charset="-122"/>
@@ -8129,7 +8100,7 @@
             <a:r>
               <a:rPr lang="en-US" sz="900" b="1" dirty="0">
                 <a:solidFill>
-                  <a:srgbClr val="E0B252"/>
+                  <a:srgbClr val="1F5C3A"/>
                 </a:solidFill>
                 <a:latin typeface="Calibri" pitchFamily="34" charset="0"/>
                 <a:ea typeface="Calibri" pitchFamily="34" charset="-122"/>
@@ -8168,7 +8139,7 @@
             <a:r>
               <a:rPr lang="en-US" sz="950" b="1" dirty="0">
                 <a:solidFill>
-                  <a:srgbClr val="E0B252"/>
+                  <a:srgbClr val="1F5C3A"/>
                 </a:solidFill>
                 <a:latin typeface="Calibri" pitchFamily="34" charset="0"/>
                 <a:ea typeface="Calibri" pitchFamily="34" charset="-122"/>
@@ -8207,7 +8178,7 @@
             <a:r>
               <a:rPr lang="en-US" sz="900" dirty="0">
                 <a:solidFill>
-                  <a:srgbClr val="BFCFBB"/>
+                  <a:srgbClr val="8A7457"/>
                 </a:solidFill>
                 <a:latin typeface="Calibri" pitchFamily="34" charset="0"/>
                 <a:ea typeface="Calibri" pitchFamily="34" charset="-122"/>
@@ -8246,7 +8217,7 @@
             <a:r>
               <a:rPr lang="en-US" sz="950" dirty="0">
                 <a:solidFill>
-                  <a:srgbClr val="F5F0E2"/>
+                  <a:srgbClr val="3A2F1F"/>
                 </a:solidFill>
                 <a:latin typeface="Calibri" pitchFamily="34" charset="0"/>
                 <a:ea typeface="Calibri" pitchFamily="34" charset="-122"/>
@@ -8285,7 +8256,7 @@
             <a:r>
               <a:rPr lang="en-US" sz="900" dirty="0">
                 <a:solidFill>
-                  <a:srgbClr val="BFCFBB"/>
+                  <a:srgbClr val="8A7457"/>
                 </a:solidFill>
                 <a:latin typeface="Calibri" pitchFamily="34" charset="0"/>
                 <a:ea typeface="Calibri" pitchFamily="34" charset="-122"/>
@@ -8324,7 +8295,7 @@
             <a:r>
               <a:rPr lang="en-US" sz="950" dirty="0">
                 <a:solidFill>
-                  <a:srgbClr val="F5F0E2"/>
+                  <a:srgbClr val="3A2F1F"/>
                 </a:solidFill>
                 <a:latin typeface="Calibri" pitchFamily="34" charset="0"/>
                 <a:ea typeface="Calibri" pitchFamily="34" charset="-122"/>
@@ -8353,13 +8324,13 @@
             </a:avLst>
           </a:prstGeom>
           <a:solidFill>
-            <a:srgbClr val="0A2214">
+            <a:srgbClr val="FFFFFF">
               <a:alpha val="90000"/>
             </a:srgbClr>
           </a:solidFill>
           <a:ln w="15875">
             <a:solidFill>
-              <a:srgbClr val="A87C2A"/>
+              <a:srgbClr val="2E7D3C"/>
             </a:solidFill>
             <a:prstDash val="solid"/>
           </a:ln>
@@ -8418,7 +8389,7 @@
           </a:prstGeom>
           <a:ln w="12700">
             <a:solidFill>
-              <a:srgbClr val="A87C2A"/>
+              <a:srgbClr val="2E7D3C"/>
             </a:solidFill>
             <a:prstDash val="solid"/>
           </a:ln>
@@ -8452,7 +8423,7 @@
           </a:solidFill>
           <a:ln w="6350">
             <a:solidFill>
-              <a:srgbClr val="A87C2A"/>
+              <a:srgbClr val="2E7D3C"/>
             </a:solidFill>
             <a:prstDash val="solid"/>
           </a:ln>
@@ -8531,7 +8502,7 @@
             <a:r>
               <a:rPr lang="en-US" sz="1450" b="1" dirty="0">
                 <a:solidFill>
-                  <a:srgbClr val="FFFFFF"/>
+                  <a:srgbClr val="241C10"/>
                 </a:solidFill>
                 <a:latin typeface="Cambria" pitchFamily="34" charset="0"/>
                 <a:ea typeface="Cambria" pitchFamily="34" charset="-122"/>
@@ -8570,7 +8541,7 @@
             <a:r>
               <a:rPr lang="en-US" sz="1000" dirty="0">
                 <a:solidFill>
-                  <a:srgbClr val="BFCFBB"/>
+                  <a:srgbClr val="8A7457"/>
                 </a:solidFill>
                 <a:latin typeface="Calibri" pitchFamily="34" charset="0"/>
                 <a:ea typeface="Calibri" pitchFamily="34" charset="-122"/>
@@ -8599,13 +8570,13 @@
             </a:avLst>
           </a:prstGeom>
           <a:solidFill>
-            <a:srgbClr val="16391F">
+            <a:srgbClr val="EAF3EA">
               <a:alpha val="92000"/>
             </a:srgbClr>
           </a:solidFill>
           <a:ln w="9525">
             <a:solidFill>
-              <a:srgbClr val="A87C2A"/>
+              <a:srgbClr val="2E7D3C"/>
             </a:solidFill>
             <a:prstDash val="solid"/>
           </a:ln>
@@ -8645,7 +8616,7 @@
             <a:r>
               <a:rPr lang="en-US" sz="750" b="1" kern="0" spc="100" dirty="0">
                 <a:solidFill>
-                  <a:srgbClr val="E0B252"/>
+                  <a:srgbClr val="1F5C3A"/>
                 </a:solidFill>
                 <a:latin typeface="Calibri" pitchFamily="34" charset="0"/>
                 <a:ea typeface="Calibri" pitchFamily="34" charset="-122"/>
@@ -8684,7 +8655,7 @@
             <a:r>
               <a:rPr lang="en-US" sz="900" dirty="0">
                 <a:solidFill>
-                  <a:srgbClr val="BFCFBB"/>
+                  <a:srgbClr val="8A7457"/>
                 </a:solidFill>
                 <a:latin typeface="Calibri" pitchFamily="34" charset="0"/>
                 <a:ea typeface="Calibri" pitchFamily="34" charset="-122"/>
@@ -8723,7 +8694,7 @@
             <a:r>
               <a:rPr lang="en-US" sz="950" dirty="0">
                 <a:solidFill>
-                  <a:srgbClr val="F5F0E2"/>
+                  <a:srgbClr val="3A2F1F"/>
                 </a:solidFill>
                 <a:latin typeface="Calibri" pitchFamily="34" charset="0"/>
                 <a:ea typeface="Calibri" pitchFamily="34" charset="-122"/>
@@ -8762,7 +8733,7 @@
             <a:r>
               <a:rPr lang="en-US" sz="900" b="1" dirty="0">
                 <a:solidFill>
-                  <a:srgbClr val="E0B252"/>
+                  <a:srgbClr val="1F5C3A"/>
                 </a:solidFill>
                 <a:latin typeface="Calibri" pitchFamily="34" charset="0"/>
                 <a:ea typeface="Calibri" pitchFamily="34" charset="-122"/>
@@ -8801,7 +8772,7 @@
             <a:r>
               <a:rPr lang="en-US" sz="950" b="1" dirty="0">
                 <a:solidFill>
-                  <a:srgbClr val="E0B252"/>
+                  <a:srgbClr val="1F5C3A"/>
                 </a:solidFill>
                 <a:latin typeface="Calibri" pitchFamily="34" charset="0"/>
                 <a:ea typeface="Calibri" pitchFamily="34" charset="-122"/>
@@ -8840,7 +8811,7 @@
             <a:r>
               <a:rPr lang="en-US" sz="900" dirty="0">
                 <a:solidFill>
-                  <a:srgbClr val="BFCFBB"/>
+                  <a:srgbClr val="8A7457"/>
                 </a:solidFill>
                 <a:latin typeface="Calibri" pitchFamily="34" charset="0"/>
                 <a:ea typeface="Calibri" pitchFamily="34" charset="-122"/>
@@ -8879,7 +8850,7 @@
             <a:r>
               <a:rPr lang="en-US" sz="950" dirty="0">
                 <a:solidFill>
-                  <a:srgbClr val="F5F0E2"/>
+                  <a:srgbClr val="3A2F1F"/>
                 </a:solidFill>
                 <a:latin typeface="Calibri" pitchFamily="34" charset="0"/>
                 <a:ea typeface="Calibri" pitchFamily="34" charset="-122"/>
@@ -8918,7 +8889,7 @@
             <a:r>
               <a:rPr lang="en-US" sz="900" dirty="0">
                 <a:solidFill>
-                  <a:srgbClr val="BFCFBB"/>
+                  <a:srgbClr val="8A7457"/>
                 </a:solidFill>
                 <a:latin typeface="Calibri" pitchFamily="34" charset="0"/>
                 <a:ea typeface="Calibri" pitchFamily="34" charset="-122"/>
@@ -8957,7 +8928,7 @@
             <a:r>
               <a:rPr lang="en-US" sz="950" dirty="0">
                 <a:solidFill>
-                  <a:srgbClr val="F5F0E2"/>
+                  <a:srgbClr val="3A2F1F"/>
                 </a:solidFill>
                 <a:latin typeface="Calibri" pitchFamily="34" charset="0"/>
                 <a:ea typeface="Calibri" pitchFamily="34" charset="-122"/>
@@ -8986,13 +8957,13 @@
             </a:avLst>
           </a:prstGeom>
           <a:solidFill>
-            <a:srgbClr val="0A2214">
+            <a:srgbClr val="FFFFFF">
               <a:alpha val="90000"/>
             </a:srgbClr>
           </a:solidFill>
           <a:ln w="15875">
             <a:solidFill>
-              <a:srgbClr val="A87C2A"/>
+              <a:srgbClr val="2E7D3C"/>
             </a:solidFill>
             <a:prstDash val="solid"/>
           </a:ln>
@@ -9051,7 +9022,7 @@
           </a:prstGeom>
           <a:ln w="12700">
             <a:solidFill>
-              <a:srgbClr val="A87C2A"/>
+              <a:srgbClr val="2E7D3C"/>
             </a:solidFill>
             <a:prstDash val="solid"/>
           </a:ln>
@@ -9085,7 +9056,7 @@
           </a:solidFill>
           <a:ln w="6350">
             <a:solidFill>
-              <a:srgbClr val="A87C2A"/>
+              <a:srgbClr val="2E7D3C"/>
             </a:solidFill>
             <a:prstDash val="solid"/>
           </a:ln>
@@ -9164,7 +9135,7 @@
             <a:r>
               <a:rPr lang="en-US" sz="1450" b="1" dirty="0">
                 <a:solidFill>
-                  <a:srgbClr val="FFFFFF"/>
+                  <a:srgbClr val="241C10"/>
                 </a:solidFill>
                 <a:latin typeface="Cambria" pitchFamily="34" charset="0"/>
                 <a:ea typeface="Cambria" pitchFamily="34" charset="-122"/>
@@ -9203,7 +9174,7 @@
             <a:r>
               <a:rPr lang="en-US" sz="1000" dirty="0">
                 <a:solidFill>
-                  <a:srgbClr val="BFCFBB"/>
+                  <a:srgbClr val="8A7457"/>
                 </a:solidFill>
                 <a:latin typeface="Calibri" pitchFamily="34" charset="0"/>
                 <a:ea typeface="Calibri" pitchFamily="34" charset="-122"/>
@@ -9232,13 +9203,13 @@
             </a:avLst>
           </a:prstGeom>
           <a:solidFill>
-            <a:srgbClr val="16391F">
+            <a:srgbClr val="EAF3EA">
               <a:alpha val="92000"/>
             </a:srgbClr>
           </a:solidFill>
           <a:ln w="9525">
             <a:solidFill>
-              <a:srgbClr val="A87C2A"/>
+              <a:srgbClr val="2E7D3C"/>
             </a:solidFill>
             <a:prstDash val="solid"/>
           </a:ln>
@@ -9278,7 +9249,7 @@
             <a:r>
               <a:rPr lang="en-US" sz="750" b="1" kern="0" spc="100" dirty="0">
                 <a:solidFill>
-                  <a:srgbClr val="E0B252"/>
+                  <a:srgbClr val="1F5C3A"/>
                 </a:solidFill>
                 <a:latin typeface="Calibri" pitchFamily="34" charset="0"/>
                 <a:ea typeface="Calibri" pitchFamily="34" charset="-122"/>
@@ -9317,7 +9288,7 @@
             <a:r>
               <a:rPr lang="en-US" sz="900" dirty="0">
                 <a:solidFill>
-                  <a:srgbClr val="BFCFBB"/>
+                  <a:srgbClr val="8A7457"/>
                 </a:solidFill>
                 <a:latin typeface="Calibri" pitchFamily="34" charset="0"/>
                 <a:ea typeface="Calibri" pitchFamily="34" charset="-122"/>
@@ -9356,7 +9327,7 @@
             <a:r>
               <a:rPr lang="en-US" sz="950" dirty="0">
                 <a:solidFill>
-                  <a:srgbClr val="F5F0E2"/>
+                  <a:srgbClr val="3A2F1F"/>
                 </a:solidFill>
                 <a:latin typeface="Calibri" pitchFamily="34" charset="0"/>
                 <a:ea typeface="Calibri" pitchFamily="34" charset="-122"/>
@@ -9395,7 +9366,7 @@
             <a:r>
               <a:rPr lang="en-US" sz="900" b="1" dirty="0">
                 <a:solidFill>
-                  <a:srgbClr val="E0B252"/>
+                  <a:srgbClr val="1F5C3A"/>
                 </a:solidFill>
                 <a:latin typeface="Calibri" pitchFamily="34" charset="0"/>
                 <a:ea typeface="Calibri" pitchFamily="34" charset="-122"/>
@@ -9434,7 +9405,7 @@
             <a:r>
               <a:rPr lang="en-US" sz="950" b="1" dirty="0">
                 <a:solidFill>
-                  <a:srgbClr val="E0B252"/>
+                  <a:srgbClr val="1F5C3A"/>
                 </a:solidFill>
                 <a:latin typeface="Calibri" pitchFamily="34" charset="0"/>
                 <a:ea typeface="Calibri" pitchFamily="34" charset="-122"/>
@@ -9473,7 +9444,7 @@
             <a:r>
               <a:rPr lang="en-US" sz="900" dirty="0">
                 <a:solidFill>
-                  <a:srgbClr val="BFCFBB"/>
+                  <a:srgbClr val="8A7457"/>
                 </a:solidFill>
                 <a:latin typeface="Calibri" pitchFamily="34" charset="0"/>
                 <a:ea typeface="Calibri" pitchFamily="34" charset="-122"/>
@@ -9512,7 +9483,7 @@
             <a:r>
               <a:rPr lang="en-US" sz="950" dirty="0">
                 <a:solidFill>
-                  <a:srgbClr val="F5F0E2"/>
+                  <a:srgbClr val="3A2F1F"/>
                 </a:solidFill>
                 <a:latin typeface="Calibri" pitchFamily="34" charset="0"/>
                 <a:ea typeface="Calibri" pitchFamily="34" charset="-122"/>
@@ -9551,7 +9522,7 @@
             <a:r>
               <a:rPr lang="en-US" sz="900" dirty="0">
                 <a:solidFill>
-                  <a:srgbClr val="BFCFBB"/>
+                  <a:srgbClr val="8A7457"/>
                 </a:solidFill>
                 <a:latin typeface="Calibri" pitchFamily="34" charset="0"/>
                 <a:ea typeface="Calibri" pitchFamily="34" charset="-122"/>
@@ -9590,7 +9561,7 @@
             <a:r>
               <a:rPr lang="en-US" sz="950" dirty="0">
                 <a:solidFill>
-                  <a:srgbClr val="F5F0E2"/>
+                  <a:srgbClr val="3A2F1F"/>
                 </a:solidFill>
                 <a:latin typeface="Calibri" pitchFamily="34" charset="0"/>
                 <a:ea typeface="Calibri" pitchFamily="34" charset="-122"/>
@@ -9629,7 +9600,7 @@
             <a:r>
               <a:rPr lang="en-US" sz="900" dirty="0">
                 <a:solidFill>
-                  <a:srgbClr val="C2D2BD"/>
+                  <a:srgbClr val="9C8B6E"/>
                 </a:solidFill>
                 <a:latin typeface="Calibri" pitchFamily="34" charset="0"/>
                 <a:ea typeface="Calibri" pitchFamily="34" charset="-122"/>

</xml_diff>

<commit_message>
Restore the emerald card design on slides 2-5, lifted a full step
The white-card treatment went too far: bring back the green cards with gold
hairlines, but richer than the original near-black version.

- Background is a visible emerald paddy scene again - lifted, saturated,
  with a warm glow top-right and a vignette so the cards still separate
- Card bodies move from charcoal-green to a true green; price boxes follow
- Gold hairlines, accent headers and figures all brightened a step
- Cover keeps the light treatment: sharp photo, single white copy card

Co-Authored-By: Claude Opus 5 <noreply@anthropic.com>
Claude-Session: https://claude.ai/code/session_01NDFDM6HpP3f8QTd8UUPgQV
</commit_message>
<xml_diff>
--- a/RTE_Rice_Suppliers.pptx
+++ b/RTE_Rice_Suppliers.pptx
@@ -1353,7 +1353,7 @@
             <a:r>
               <a:rPr lang="en-US" sz="1100" b="1" kern="0" spc="260" dirty="0">
                 <a:solidFill>
-                  <a:srgbClr val="B8721E"/>
+                  <a:srgbClr val="F0AC58"/>
                 </a:solidFill>
                 <a:latin typeface="Calibri" pitchFamily="34" charset="0"/>
                 <a:ea typeface="Calibri" pitchFamily="34" charset="-122"/>
@@ -1392,7 +1392,7 @@
             <a:r>
               <a:rPr lang="en-US" sz="3100" b="1" dirty="0">
                 <a:solidFill>
-                  <a:srgbClr val="241C10"/>
+                  <a:srgbClr val="FFFFFF"/>
                 </a:solidFill>
                 <a:latin typeface="Cambria" pitchFamily="34" charset="0"/>
                 <a:ea typeface="Cambria" pitchFamily="34" charset="-122"/>
@@ -1431,7 +1431,7 @@
             <a:r>
               <a:rPr lang="en-US" sz="1250" i="1" dirty="0">
                 <a:solidFill>
-                  <a:srgbClr val="8A7457"/>
+                  <a:srgbClr val="D2E4CE"/>
                 </a:solidFill>
                 <a:latin typeface="Calibri" pitchFamily="34" charset="0"/>
                 <a:ea typeface="Calibri" pitchFamily="34" charset="-122"/>
@@ -1460,13 +1460,13 @@
             </a:avLst>
           </a:prstGeom>
           <a:solidFill>
-            <a:srgbClr val="FFFFFF">
+            <a:srgbClr val="12452B">
               <a:alpha val="90000"/>
             </a:srgbClr>
           </a:solidFill>
           <a:ln w="15875">
             <a:solidFill>
-              <a:srgbClr val="A87C2A"/>
+              <a:srgbClr val="C89C40"/>
             </a:solidFill>
             <a:prstDash val="solid"/>
           </a:ln>
@@ -1513,7 +1513,7 @@
             <a:r>
               <a:rPr lang="en-US" sz="1700" b="1" dirty="0">
                 <a:solidFill>
-                  <a:srgbClr val="A5730F"/>
+                  <a:srgbClr val="F5CE76"/>
                 </a:solidFill>
                 <a:latin typeface="Cambria" pitchFamily="34" charset="0"/>
                 <a:ea typeface="Cambria" pitchFamily="34" charset="-122"/>
@@ -1555,7 +1555,7 @@
             <a:r>
               <a:rPr lang="en-US" sz="1200" dirty="0">
                 <a:solidFill>
-                  <a:srgbClr val="3A2F1F"/>
+                  <a:srgbClr val="FCF9F0"/>
                 </a:solidFill>
                 <a:latin typeface="Calibri" pitchFamily="34" charset="0"/>
                 <a:ea typeface="Calibri" pitchFamily="34" charset="-122"/>
@@ -1594,7 +1594,7 @@
             <a:r>
               <a:rPr lang="en-US" sz="1700" b="1" dirty="0">
                 <a:solidFill>
-                  <a:srgbClr val="A5730F"/>
+                  <a:srgbClr val="F5CE76"/>
                 </a:solidFill>
                 <a:latin typeface="Cambria" pitchFamily="34" charset="0"/>
                 <a:ea typeface="Cambria" pitchFamily="34" charset="-122"/>
@@ -1633,7 +1633,7 @@
             <a:r>
               <a:rPr lang="en-US" sz="1050" dirty="0">
                 <a:solidFill>
-                  <a:srgbClr val="8A7457"/>
+                  <a:srgbClr val="D2E4CE"/>
                 </a:solidFill>
                 <a:latin typeface="Calibri" pitchFamily="34" charset="0"/>
                 <a:ea typeface="Calibri" pitchFamily="34" charset="-122"/>
@@ -1672,7 +1672,7 @@
             <a:r>
               <a:rPr lang="en-US" sz="1150" b="1" dirty="0">
                 <a:solidFill>
-                  <a:srgbClr val="3A2F1F"/>
+                  <a:srgbClr val="FCF9F0"/>
                 </a:solidFill>
                 <a:latin typeface="Calibri" pitchFamily="34" charset="0"/>
                 <a:ea typeface="Calibri" pitchFamily="34" charset="-122"/>
@@ -1711,7 +1711,7 @@
             <a:r>
               <a:rPr lang="en-US" sz="1050" dirty="0">
                 <a:solidFill>
-                  <a:srgbClr val="8A7457"/>
+                  <a:srgbClr val="D2E4CE"/>
                 </a:solidFill>
                 <a:latin typeface="Calibri" pitchFamily="34" charset="0"/>
                 <a:ea typeface="Calibri" pitchFamily="34" charset="-122"/>
@@ -1750,7 +1750,7 @@
             <a:r>
               <a:rPr lang="en-US" sz="1150" b="1" dirty="0">
                 <a:solidFill>
-                  <a:srgbClr val="3A2F1F"/>
+                  <a:srgbClr val="FCF9F0"/>
                 </a:solidFill>
                 <a:latin typeface="Calibri" pitchFamily="34" charset="0"/>
                 <a:ea typeface="Calibri" pitchFamily="34" charset="-122"/>
@@ -1789,7 +1789,7 @@
             <a:r>
               <a:rPr lang="en-US" sz="1050" dirty="0">
                 <a:solidFill>
-                  <a:srgbClr val="8A7457"/>
+                  <a:srgbClr val="D2E4CE"/>
                 </a:solidFill>
                 <a:latin typeface="Calibri" pitchFamily="34" charset="0"/>
                 <a:ea typeface="Calibri" pitchFamily="34" charset="-122"/>
@@ -1828,7 +1828,7 @@
             <a:r>
               <a:rPr lang="en-US" sz="1150" b="1" dirty="0">
                 <a:solidFill>
-                  <a:srgbClr val="3A2F1F"/>
+                  <a:srgbClr val="FCF9F0"/>
                 </a:solidFill>
                 <a:latin typeface="Calibri" pitchFamily="34" charset="0"/>
                 <a:ea typeface="Calibri" pitchFamily="34" charset="-122"/>
@@ -1867,7 +1867,7 @@
             <a:r>
               <a:rPr lang="en-US" sz="1050" dirty="0">
                 <a:solidFill>
-                  <a:srgbClr val="8A7457"/>
+                  <a:srgbClr val="D2E4CE"/>
                 </a:solidFill>
                 <a:latin typeface="Calibri" pitchFamily="34" charset="0"/>
                 <a:ea typeface="Calibri" pitchFamily="34" charset="-122"/>
@@ -1906,7 +1906,7 @@
             <a:r>
               <a:rPr lang="en-US" sz="1150" b="1" dirty="0">
                 <a:solidFill>
-                  <a:srgbClr val="3A2F1F"/>
+                  <a:srgbClr val="FCF9F0"/>
                 </a:solidFill>
                 <a:latin typeface="Calibri" pitchFamily="34" charset="0"/>
                 <a:ea typeface="Calibri" pitchFamily="34" charset="-122"/>
@@ -1945,7 +1945,7 @@
             <a:r>
               <a:rPr lang="en-US" sz="1050" dirty="0">
                 <a:solidFill>
-                  <a:srgbClr val="8A7457"/>
+                  <a:srgbClr val="D2E4CE"/>
                 </a:solidFill>
                 <a:latin typeface="Calibri" pitchFamily="34" charset="0"/>
                 <a:ea typeface="Calibri" pitchFamily="34" charset="-122"/>
@@ -1984,7 +1984,7 @@
             <a:r>
               <a:rPr lang="en-US" sz="1150" b="1" dirty="0">
                 <a:solidFill>
-                  <a:srgbClr val="3A2F1F"/>
+                  <a:srgbClr val="FCF9F0"/>
                 </a:solidFill>
                 <a:latin typeface="Calibri" pitchFamily="34" charset="0"/>
                 <a:ea typeface="Calibri" pitchFamily="34" charset="-122"/>
@@ -2023,7 +2023,7 @@
             <a:r>
               <a:rPr lang="en-US" sz="1050" dirty="0">
                 <a:solidFill>
-                  <a:srgbClr val="8A7457"/>
+                  <a:srgbClr val="D2E4CE"/>
                 </a:solidFill>
                 <a:latin typeface="Calibri" pitchFamily="34" charset="0"/>
                 <a:ea typeface="Calibri" pitchFamily="34" charset="-122"/>
@@ -2062,7 +2062,7 @@
             <a:r>
               <a:rPr lang="en-US" sz="1150" b="1" dirty="0">
                 <a:solidFill>
-                  <a:srgbClr val="3A2F1F"/>
+                  <a:srgbClr val="FCF9F0"/>
                 </a:solidFill>
                 <a:latin typeface="Calibri" pitchFamily="34" charset="0"/>
                 <a:ea typeface="Calibri" pitchFamily="34" charset="-122"/>
@@ -2101,7 +2101,7 @@
             <a:r>
               <a:rPr lang="en-US" sz="1050" dirty="0">
                 <a:solidFill>
-                  <a:srgbClr val="8A7457"/>
+                  <a:srgbClr val="D2E4CE"/>
                 </a:solidFill>
                 <a:latin typeface="Calibri" pitchFamily="34" charset="0"/>
                 <a:ea typeface="Calibri" pitchFamily="34" charset="-122"/>
@@ -2140,7 +2140,7 @@
             <a:r>
               <a:rPr lang="en-US" sz="1150" b="1" dirty="0">
                 <a:solidFill>
-                  <a:srgbClr val="3A2F1F"/>
+                  <a:srgbClr val="FCF9F0"/>
                 </a:solidFill>
                 <a:latin typeface="Calibri" pitchFamily="34" charset="0"/>
                 <a:ea typeface="Calibri" pitchFamily="34" charset="-122"/>
@@ -2179,7 +2179,7 @@
             <a:r>
               <a:rPr lang="en-US" sz="1050" dirty="0">
                 <a:solidFill>
-                  <a:srgbClr val="8A7457"/>
+                  <a:srgbClr val="D2E4CE"/>
                 </a:solidFill>
                 <a:latin typeface="Calibri" pitchFamily="34" charset="0"/>
                 <a:ea typeface="Calibri" pitchFamily="34" charset="-122"/>
@@ -2218,7 +2218,7 @@
             <a:r>
               <a:rPr lang="en-US" sz="1150" b="1" dirty="0">
                 <a:solidFill>
-                  <a:srgbClr val="3A2F1F"/>
+                  <a:srgbClr val="FCF9F0"/>
                 </a:solidFill>
                 <a:latin typeface="Calibri" pitchFamily="34" charset="0"/>
                 <a:ea typeface="Calibri" pitchFamily="34" charset="-122"/>
@@ -2270,7 +2270,7 @@
           </a:prstGeom>
           <a:ln w="15875">
             <a:solidFill>
-              <a:srgbClr val="A87C2A"/>
+              <a:srgbClr val="C89C40"/>
             </a:solidFill>
             <a:prstDash val="solid"/>
           </a:ln>
@@ -2300,13 +2300,13 @@
             </a:avLst>
           </a:prstGeom>
           <a:solidFill>
-            <a:srgbClr val="9C5A16">
-              <a:alpha val="100000"/>
+            <a:srgbClr val="12452B">
+              <a:alpha val="90000"/>
             </a:srgbClr>
           </a:solidFill>
           <a:ln w="15875">
             <a:solidFill>
-              <a:srgbClr val="A87C2A"/>
+              <a:srgbClr val="C89C40"/>
             </a:solidFill>
             <a:prstDash val="solid"/>
           </a:ln>
@@ -2353,7 +2353,7 @@
             <a:r>
               <a:rPr lang="en-US" sz="1900" b="1" dirty="0">
                 <a:solidFill>
-                  <a:srgbClr val="FBF1DC"/>
+                  <a:srgbClr val="F5CE76"/>
                 </a:solidFill>
                 <a:latin typeface="Cambria" pitchFamily="34" charset="0"/>
                 <a:ea typeface="Cambria" pitchFamily="34" charset="-122"/>
@@ -2364,7 +2364,7 @@
             <a:r>
               <a:rPr lang="en-US" sz="1100" dirty="0">
                 <a:solidFill>
-                  <a:srgbClr val="FBF1DC"/>
+                  <a:srgbClr val="F5CE76"/>
                 </a:solidFill>
                 <a:latin typeface="Cambria" pitchFamily="34" charset="0"/>
                 <a:ea typeface="Cambria" pitchFamily="34" charset="-122"/>
@@ -2403,7 +2403,7 @@
             <a:r>
               <a:rPr lang="en-US" sz="1050" dirty="0">
                 <a:solidFill>
-                  <a:srgbClr val="FBF1DC"/>
+                  <a:srgbClr val="FCF9F0"/>
                 </a:solidFill>
                 <a:latin typeface="Calibri" pitchFamily="34" charset="0"/>
                 <a:ea typeface="Calibri" pitchFamily="34" charset="-122"/>
@@ -2432,13 +2432,13 @@
             </a:avLst>
           </a:prstGeom>
           <a:solidFill>
-            <a:srgbClr val="9C5A16">
-              <a:alpha val="100000"/>
+            <a:srgbClr val="12452B">
+              <a:alpha val="90000"/>
             </a:srgbClr>
           </a:solidFill>
           <a:ln w="15875">
             <a:solidFill>
-              <a:srgbClr val="A87C2A"/>
+              <a:srgbClr val="C89C40"/>
             </a:solidFill>
             <a:prstDash val="solid"/>
           </a:ln>
@@ -2485,7 +2485,7 @@
             <a:r>
               <a:rPr lang="en-US" sz="1900" b="1" dirty="0">
                 <a:solidFill>
-                  <a:srgbClr val="FBF1DC"/>
+                  <a:srgbClr val="F5CE76"/>
                 </a:solidFill>
                 <a:latin typeface="Cambria" pitchFamily="34" charset="0"/>
                 <a:ea typeface="Cambria" pitchFamily="34" charset="-122"/>
@@ -2496,7 +2496,7 @@
             <a:r>
               <a:rPr lang="en-US" sz="1100" dirty="0">
                 <a:solidFill>
-                  <a:srgbClr val="FBF1DC"/>
+                  <a:srgbClr val="F5CE76"/>
                 </a:solidFill>
                 <a:latin typeface="Cambria" pitchFamily="34" charset="0"/>
                 <a:ea typeface="Cambria" pitchFamily="34" charset="-122"/>
@@ -2535,7 +2535,7 @@
             <a:r>
               <a:rPr lang="en-US" sz="1050" dirty="0">
                 <a:solidFill>
-                  <a:srgbClr val="FBF1DC"/>
+                  <a:srgbClr val="FCF9F0"/>
                 </a:solidFill>
                 <a:latin typeface="Calibri" pitchFamily="34" charset="0"/>
                 <a:ea typeface="Calibri" pitchFamily="34" charset="-122"/>
@@ -2564,13 +2564,13 @@
             </a:avLst>
           </a:prstGeom>
           <a:solidFill>
-            <a:srgbClr val="9C5A16">
-              <a:alpha val="100000"/>
+            <a:srgbClr val="12452B">
+              <a:alpha val="90000"/>
             </a:srgbClr>
           </a:solidFill>
           <a:ln w="15875">
             <a:solidFill>
-              <a:srgbClr val="A87C2A"/>
+              <a:srgbClr val="C89C40"/>
             </a:solidFill>
             <a:prstDash val="solid"/>
           </a:ln>
@@ -2617,7 +2617,7 @@
             <a:r>
               <a:rPr lang="en-US" sz="1900" b="1" dirty="0">
                 <a:solidFill>
-                  <a:srgbClr val="FBF1DC"/>
+                  <a:srgbClr val="F5CE76"/>
                 </a:solidFill>
                 <a:latin typeface="Cambria" pitchFamily="34" charset="0"/>
                 <a:ea typeface="Cambria" pitchFamily="34" charset="-122"/>
@@ -2628,7 +2628,7 @@
             <a:r>
               <a:rPr lang="en-US" sz="1100" dirty="0">
                 <a:solidFill>
-                  <a:srgbClr val="FBF1DC"/>
+                  <a:srgbClr val="F5CE76"/>
                 </a:solidFill>
                 <a:latin typeface="Cambria" pitchFamily="34" charset="0"/>
                 <a:ea typeface="Cambria" pitchFamily="34" charset="-122"/>
@@ -2667,7 +2667,7 @@
             <a:r>
               <a:rPr lang="en-US" sz="1050" dirty="0">
                 <a:solidFill>
-                  <a:srgbClr val="FBF1DC"/>
+                  <a:srgbClr val="FCF9F0"/>
                 </a:solidFill>
                 <a:latin typeface="Calibri" pitchFamily="34" charset="0"/>
                 <a:ea typeface="Calibri" pitchFamily="34" charset="-122"/>
@@ -2706,7 +2706,7 @@
             <a:r>
               <a:rPr lang="en-US" sz="900" dirty="0">
                 <a:solidFill>
-                  <a:srgbClr val="9C8B6E"/>
+                  <a:srgbClr val="C3D7BF"/>
                 </a:solidFill>
                 <a:latin typeface="Calibri" pitchFamily="34" charset="0"/>
                 <a:ea typeface="Calibri" pitchFamily="34" charset="-122"/>
@@ -2784,7 +2784,7 @@
             <a:r>
               <a:rPr lang="en-US" sz="1100" b="1" kern="0" spc="260" dirty="0">
                 <a:solidFill>
-                  <a:srgbClr val="B8721E"/>
+                  <a:srgbClr val="F0AC58"/>
                 </a:solidFill>
                 <a:latin typeface="Calibri" pitchFamily="34" charset="0"/>
                 <a:ea typeface="Calibri" pitchFamily="34" charset="-122"/>
@@ -2823,7 +2823,7 @@
             <a:r>
               <a:rPr lang="en-US" sz="3100" b="1" dirty="0">
                 <a:solidFill>
-                  <a:srgbClr val="241C10"/>
+                  <a:srgbClr val="FFFFFF"/>
                 </a:solidFill>
                 <a:latin typeface="Cambria" pitchFamily="34" charset="0"/>
                 <a:ea typeface="Cambria" pitchFamily="34" charset="-122"/>
@@ -2862,7 +2862,7 @@
             <a:r>
               <a:rPr lang="en-US" sz="1250" i="1" dirty="0">
                 <a:solidFill>
-                  <a:srgbClr val="8A7457"/>
+                  <a:srgbClr val="D2E4CE"/>
                 </a:solidFill>
                 <a:latin typeface="Calibri" pitchFamily="34" charset="0"/>
                 <a:ea typeface="Calibri" pitchFamily="34" charset="-122"/>
@@ -2891,13 +2891,13 @@
             </a:avLst>
           </a:prstGeom>
           <a:solidFill>
-            <a:srgbClr val="FFFFFF">
+            <a:srgbClr val="12452B">
               <a:alpha val="90000"/>
             </a:srgbClr>
           </a:solidFill>
           <a:ln w="15875">
             <a:solidFill>
-              <a:srgbClr val="A87C2A"/>
+              <a:srgbClr val="C89C40"/>
             </a:solidFill>
             <a:prstDash val="solid"/>
           </a:ln>
@@ -2957,7 +2957,7 @@
           </a:prstGeom>
           <a:ln w="12700">
             <a:solidFill>
-              <a:srgbClr val="A87C2A"/>
+              <a:srgbClr val="C89C40"/>
             </a:solidFill>
             <a:prstDash val="solid"/>
           </a:ln>
@@ -2987,11 +2987,11 @@
             </a:avLst>
           </a:prstGeom>
           <a:solidFill>
-            <a:srgbClr val="8A5A20"/>
+            <a:srgbClr val="B0762A"/>
           </a:solidFill>
           <a:ln w="6350">
             <a:solidFill>
-              <a:srgbClr val="A87C2A"/>
+              <a:srgbClr val="C89C40"/>
             </a:solidFill>
             <a:prstDash val="solid"/>
           </a:ln>
@@ -3070,7 +3070,7 @@
             <a:r>
               <a:rPr lang="en-US" sz="1450" b="1" dirty="0">
                 <a:solidFill>
-                  <a:srgbClr val="241C10"/>
+                  <a:srgbClr val="FFFFFF"/>
                 </a:solidFill>
                 <a:latin typeface="Cambria" pitchFamily="34" charset="0"/>
                 <a:ea typeface="Cambria" pitchFamily="34" charset="-122"/>
@@ -3109,7 +3109,7 @@
             <a:r>
               <a:rPr lang="en-US" sz="1000" dirty="0">
                 <a:solidFill>
-                  <a:srgbClr val="8A7457"/>
+                  <a:srgbClr val="D2E4CE"/>
                 </a:solidFill>
                 <a:latin typeface="Calibri" pitchFamily="34" charset="0"/>
                 <a:ea typeface="Calibri" pitchFamily="34" charset="-122"/>
@@ -3138,13 +3138,13 @@
             </a:avLst>
           </a:prstGeom>
           <a:solidFill>
-            <a:srgbClr val="FBF1DC">
+            <a:srgbClr val="1A5433">
               <a:alpha val="92000"/>
             </a:srgbClr>
           </a:solidFill>
           <a:ln w="9525">
             <a:solidFill>
-              <a:srgbClr val="A87C2A"/>
+              <a:srgbClr val="C89C40"/>
             </a:solidFill>
             <a:prstDash val="solid"/>
           </a:ln>
@@ -3184,7 +3184,7 @@
             <a:r>
               <a:rPr lang="en-US" sz="750" b="1" kern="0" spc="100" dirty="0">
                 <a:solidFill>
-                  <a:srgbClr val="A5730F"/>
+                  <a:srgbClr val="F5CE76"/>
                 </a:solidFill>
                 <a:latin typeface="Calibri" pitchFamily="34" charset="0"/>
                 <a:ea typeface="Calibri" pitchFamily="34" charset="-122"/>
@@ -3223,7 +3223,7 @@
             <a:r>
               <a:rPr lang="en-US" sz="900" dirty="0">
                 <a:solidFill>
-                  <a:srgbClr val="8A7457"/>
+                  <a:srgbClr val="D2E4CE"/>
                 </a:solidFill>
                 <a:latin typeface="Calibri" pitchFamily="34" charset="0"/>
                 <a:ea typeface="Calibri" pitchFamily="34" charset="-122"/>
@@ -3262,7 +3262,7 @@
             <a:r>
               <a:rPr lang="en-US" sz="950" dirty="0">
                 <a:solidFill>
-                  <a:srgbClr val="3A2F1F"/>
+                  <a:srgbClr val="FCF9F0"/>
                 </a:solidFill>
                 <a:latin typeface="Calibri" pitchFamily="34" charset="0"/>
                 <a:ea typeface="Calibri" pitchFamily="34" charset="-122"/>
@@ -3301,7 +3301,7 @@
             <a:r>
               <a:rPr lang="en-US" sz="900" b="1" dirty="0">
                 <a:solidFill>
-                  <a:srgbClr val="A5730F"/>
+                  <a:srgbClr val="F5CE76"/>
                 </a:solidFill>
                 <a:latin typeface="Calibri" pitchFamily="34" charset="0"/>
                 <a:ea typeface="Calibri" pitchFamily="34" charset="-122"/>
@@ -3340,7 +3340,7 @@
             <a:r>
               <a:rPr lang="en-US" sz="950" b="1" dirty="0">
                 <a:solidFill>
-                  <a:srgbClr val="A5730F"/>
+                  <a:srgbClr val="F5CE76"/>
                 </a:solidFill>
                 <a:latin typeface="Calibri" pitchFamily="34" charset="0"/>
                 <a:ea typeface="Calibri" pitchFamily="34" charset="-122"/>
@@ -3379,7 +3379,7 @@
             <a:r>
               <a:rPr lang="en-US" sz="900" dirty="0">
                 <a:solidFill>
-                  <a:srgbClr val="8A7457"/>
+                  <a:srgbClr val="D2E4CE"/>
                 </a:solidFill>
                 <a:latin typeface="Calibri" pitchFamily="34" charset="0"/>
                 <a:ea typeface="Calibri" pitchFamily="34" charset="-122"/>
@@ -3418,7 +3418,7 @@
             <a:r>
               <a:rPr lang="en-US" sz="950" dirty="0">
                 <a:solidFill>
-                  <a:srgbClr val="3A2F1F"/>
+                  <a:srgbClr val="FCF9F0"/>
                 </a:solidFill>
                 <a:latin typeface="Calibri" pitchFamily="34" charset="0"/>
                 <a:ea typeface="Calibri" pitchFamily="34" charset="-122"/>
@@ -3457,7 +3457,7 @@
             <a:r>
               <a:rPr lang="en-US" sz="900" dirty="0">
                 <a:solidFill>
-                  <a:srgbClr val="8A7457"/>
+                  <a:srgbClr val="D2E4CE"/>
                 </a:solidFill>
                 <a:latin typeface="Calibri" pitchFamily="34" charset="0"/>
                 <a:ea typeface="Calibri" pitchFamily="34" charset="-122"/>
@@ -3496,7 +3496,7 @@
             <a:r>
               <a:rPr lang="en-US" sz="950" dirty="0">
                 <a:solidFill>
-                  <a:srgbClr val="3A2F1F"/>
+                  <a:srgbClr val="FCF9F0"/>
                 </a:solidFill>
                 <a:latin typeface="Calibri" pitchFamily="34" charset="0"/>
                 <a:ea typeface="Calibri" pitchFamily="34" charset="-122"/>
@@ -3525,13 +3525,13 @@
             </a:avLst>
           </a:prstGeom>
           <a:solidFill>
-            <a:srgbClr val="FFFFFF">
+            <a:srgbClr val="12452B">
               <a:alpha val="90000"/>
             </a:srgbClr>
           </a:solidFill>
           <a:ln w="15875">
             <a:solidFill>
-              <a:srgbClr val="A87C2A"/>
+              <a:srgbClr val="C89C40"/>
             </a:solidFill>
             <a:prstDash val="solid"/>
           </a:ln>
@@ -3591,7 +3591,7 @@
           </a:prstGeom>
           <a:ln w="12700">
             <a:solidFill>
-              <a:srgbClr val="A87C2A"/>
+              <a:srgbClr val="C89C40"/>
             </a:solidFill>
             <a:prstDash val="solid"/>
           </a:ln>
@@ -3621,11 +3621,11 @@
             </a:avLst>
           </a:prstGeom>
           <a:solidFill>
-            <a:srgbClr val="8A5A20"/>
+            <a:srgbClr val="B0762A"/>
           </a:solidFill>
           <a:ln w="6350">
             <a:solidFill>
-              <a:srgbClr val="A87C2A"/>
+              <a:srgbClr val="C89C40"/>
             </a:solidFill>
             <a:prstDash val="solid"/>
           </a:ln>
@@ -3704,7 +3704,7 @@
             <a:r>
               <a:rPr lang="en-US" sz="1450" b="1" dirty="0">
                 <a:solidFill>
-                  <a:srgbClr val="241C10"/>
+                  <a:srgbClr val="FFFFFF"/>
                 </a:solidFill>
                 <a:latin typeface="Cambria" pitchFamily="34" charset="0"/>
                 <a:ea typeface="Cambria" pitchFamily="34" charset="-122"/>
@@ -3743,7 +3743,7 @@
             <a:r>
               <a:rPr lang="en-US" sz="1000" dirty="0">
                 <a:solidFill>
-                  <a:srgbClr val="8A7457"/>
+                  <a:srgbClr val="D2E4CE"/>
                 </a:solidFill>
                 <a:latin typeface="Calibri" pitchFamily="34" charset="0"/>
                 <a:ea typeface="Calibri" pitchFamily="34" charset="-122"/>
@@ -3772,13 +3772,13 @@
             </a:avLst>
           </a:prstGeom>
           <a:solidFill>
-            <a:srgbClr val="FBF1DC">
+            <a:srgbClr val="1A5433">
               <a:alpha val="92000"/>
             </a:srgbClr>
           </a:solidFill>
           <a:ln w="9525">
             <a:solidFill>
-              <a:srgbClr val="A87C2A"/>
+              <a:srgbClr val="C89C40"/>
             </a:solidFill>
             <a:prstDash val="solid"/>
           </a:ln>
@@ -3818,7 +3818,7 @@
             <a:r>
               <a:rPr lang="en-US" sz="750" b="1" kern="0" spc="100" dirty="0">
                 <a:solidFill>
-                  <a:srgbClr val="A5730F"/>
+                  <a:srgbClr val="F5CE76"/>
                 </a:solidFill>
                 <a:latin typeface="Calibri" pitchFamily="34" charset="0"/>
                 <a:ea typeface="Calibri" pitchFamily="34" charset="-122"/>
@@ -3857,7 +3857,7 @@
             <a:r>
               <a:rPr lang="en-US" sz="900" dirty="0">
                 <a:solidFill>
-                  <a:srgbClr val="8A7457"/>
+                  <a:srgbClr val="D2E4CE"/>
                 </a:solidFill>
                 <a:latin typeface="Calibri" pitchFamily="34" charset="0"/>
                 <a:ea typeface="Calibri" pitchFamily="34" charset="-122"/>
@@ -3896,7 +3896,7 @@
             <a:r>
               <a:rPr lang="en-US" sz="950" dirty="0">
                 <a:solidFill>
-                  <a:srgbClr val="3A2F1F"/>
+                  <a:srgbClr val="FCF9F0"/>
                 </a:solidFill>
                 <a:latin typeface="Calibri" pitchFamily="34" charset="0"/>
                 <a:ea typeface="Calibri" pitchFamily="34" charset="-122"/>
@@ -3935,7 +3935,7 @@
             <a:r>
               <a:rPr lang="en-US" sz="900" b="1" dirty="0">
                 <a:solidFill>
-                  <a:srgbClr val="A5730F"/>
+                  <a:srgbClr val="F5CE76"/>
                 </a:solidFill>
                 <a:latin typeface="Calibri" pitchFamily="34" charset="0"/>
                 <a:ea typeface="Calibri" pitchFamily="34" charset="-122"/>
@@ -3974,7 +3974,7 @@
             <a:r>
               <a:rPr lang="en-US" sz="950" b="1" dirty="0">
                 <a:solidFill>
-                  <a:srgbClr val="A5730F"/>
+                  <a:srgbClr val="F5CE76"/>
                 </a:solidFill>
                 <a:latin typeface="Calibri" pitchFamily="34" charset="0"/>
                 <a:ea typeface="Calibri" pitchFamily="34" charset="-122"/>
@@ -4013,7 +4013,7 @@
             <a:r>
               <a:rPr lang="en-US" sz="900" dirty="0">
                 <a:solidFill>
-                  <a:srgbClr val="8A7457"/>
+                  <a:srgbClr val="D2E4CE"/>
                 </a:solidFill>
                 <a:latin typeface="Calibri" pitchFamily="34" charset="0"/>
                 <a:ea typeface="Calibri" pitchFamily="34" charset="-122"/>
@@ -4052,7 +4052,7 @@
             <a:r>
               <a:rPr lang="en-US" sz="950" dirty="0">
                 <a:solidFill>
-                  <a:srgbClr val="3A2F1F"/>
+                  <a:srgbClr val="FCF9F0"/>
                 </a:solidFill>
                 <a:latin typeface="Calibri" pitchFamily="34" charset="0"/>
                 <a:ea typeface="Calibri" pitchFamily="34" charset="-122"/>
@@ -4091,7 +4091,7 @@
             <a:r>
               <a:rPr lang="en-US" sz="900" dirty="0">
                 <a:solidFill>
-                  <a:srgbClr val="8A7457"/>
+                  <a:srgbClr val="D2E4CE"/>
                 </a:solidFill>
                 <a:latin typeface="Calibri" pitchFamily="34" charset="0"/>
                 <a:ea typeface="Calibri" pitchFamily="34" charset="-122"/>
@@ -4130,7 +4130,7 @@
             <a:r>
               <a:rPr lang="en-US" sz="950" dirty="0">
                 <a:solidFill>
-                  <a:srgbClr val="3A2F1F"/>
+                  <a:srgbClr val="FCF9F0"/>
                 </a:solidFill>
                 <a:latin typeface="Calibri" pitchFamily="34" charset="0"/>
                 <a:ea typeface="Calibri" pitchFamily="34" charset="-122"/>
@@ -4159,13 +4159,13 @@
             </a:avLst>
           </a:prstGeom>
           <a:solidFill>
-            <a:srgbClr val="FFFFFF">
+            <a:srgbClr val="12452B">
               <a:alpha val="90000"/>
             </a:srgbClr>
           </a:solidFill>
           <a:ln w="15875">
             <a:solidFill>
-              <a:srgbClr val="A87C2A"/>
+              <a:srgbClr val="C89C40"/>
             </a:solidFill>
             <a:prstDash val="solid"/>
           </a:ln>
@@ -4225,7 +4225,7 @@
           </a:prstGeom>
           <a:ln w="12700">
             <a:solidFill>
-              <a:srgbClr val="A87C2A"/>
+              <a:srgbClr val="C89C40"/>
             </a:solidFill>
             <a:prstDash val="solid"/>
           </a:ln>
@@ -4255,11 +4255,11 @@
             </a:avLst>
           </a:prstGeom>
           <a:solidFill>
-            <a:srgbClr val="8A5A20"/>
+            <a:srgbClr val="B0762A"/>
           </a:solidFill>
           <a:ln w="6350">
             <a:solidFill>
-              <a:srgbClr val="A87C2A"/>
+              <a:srgbClr val="C89C40"/>
             </a:solidFill>
             <a:prstDash val="solid"/>
           </a:ln>
@@ -4338,7 +4338,7 @@
             <a:r>
               <a:rPr lang="en-US" sz="1450" b="1" dirty="0">
                 <a:solidFill>
-                  <a:srgbClr val="241C10"/>
+                  <a:srgbClr val="FFFFFF"/>
                 </a:solidFill>
                 <a:latin typeface="Cambria" pitchFamily="34" charset="0"/>
                 <a:ea typeface="Cambria" pitchFamily="34" charset="-122"/>
@@ -4377,7 +4377,7 @@
             <a:r>
               <a:rPr lang="en-US" sz="1000" dirty="0">
                 <a:solidFill>
-                  <a:srgbClr val="8A7457"/>
+                  <a:srgbClr val="D2E4CE"/>
                 </a:solidFill>
                 <a:latin typeface="Calibri" pitchFamily="34" charset="0"/>
                 <a:ea typeface="Calibri" pitchFamily="34" charset="-122"/>
@@ -4406,13 +4406,13 @@
             </a:avLst>
           </a:prstGeom>
           <a:solidFill>
-            <a:srgbClr val="FBF1DC">
+            <a:srgbClr val="1A5433">
               <a:alpha val="92000"/>
             </a:srgbClr>
           </a:solidFill>
           <a:ln w="9525">
             <a:solidFill>
-              <a:srgbClr val="A87C2A"/>
+              <a:srgbClr val="C89C40"/>
             </a:solidFill>
             <a:prstDash val="solid"/>
           </a:ln>
@@ -4452,7 +4452,7 @@
             <a:r>
               <a:rPr lang="en-US" sz="750" b="1" kern="0" spc="100" dirty="0">
                 <a:solidFill>
-                  <a:srgbClr val="A5730F"/>
+                  <a:srgbClr val="F5CE76"/>
                 </a:solidFill>
                 <a:latin typeface="Calibri" pitchFamily="34" charset="0"/>
                 <a:ea typeface="Calibri" pitchFamily="34" charset="-122"/>
@@ -4491,7 +4491,7 @@
             <a:r>
               <a:rPr lang="en-US" sz="900" dirty="0">
                 <a:solidFill>
-                  <a:srgbClr val="8A7457"/>
+                  <a:srgbClr val="D2E4CE"/>
                 </a:solidFill>
                 <a:latin typeface="Calibri" pitchFamily="34" charset="0"/>
                 <a:ea typeface="Calibri" pitchFamily="34" charset="-122"/>
@@ -4530,7 +4530,7 @@
             <a:r>
               <a:rPr lang="en-US" sz="950" dirty="0">
                 <a:solidFill>
-                  <a:srgbClr val="3A2F1F"/>
+                  <a:srgbClr val="FCF9F0"/>
                 </a:solidFill>
                 <a:latin typeface="Calibri" pitchFamily="34" charset="0"/>
                 <a:ea typeface="Calibri" pitchFamily="34" charset="-122"/>
@@ -4569,7 +4569,7 @@
             <a:r>
               <a:rPr lang="en-US" sz="900" b="1" dirty="0">
                 <a:solidFill>
-                  <a:srgbClr val="A5730F"/>
+                  <a:srgbClr val="F5CE76"/>
                 </a:solidFill>
                 <a:latin typeface="Calibri" pitchFamily="34" charset="0"/>
                 <a:ea typeface="Calibri" pitchFamily="34" charset="-122"/>
@@ -4608,7 +4608,7 @@
             <a:r>
               <a:rPr lang="en-US" sz="950" b="1" dirty="0">
                 <a:solidFill>
-                  <a:srgbClr val="A5730F"/>
+                  <a:srgbClr val="F5CE76"/>
                 </a:solidFill>
                 <a:latin typeface="Calibri" pitchFamily="34" charset="0"/>
                 <a:ea typeface="Calibri" pitchFamily="34" charset="-122"/>
@@ -4647,7 +4647,7 @@
             <a:r>
               <a:rPr lang="en-US" sz="900" dirty="0">
                 <a:solidFill>
-                  <a:srgbClr val="8A7457"/>
+                  <a:srgbClr val="D2E4CE"/>
                 </a:solidFill>
                 <a:latin typeface="Calibri" pitchFamily="34" charset="0"/>
                 <a:ea typeface="Calibri" pitchFamily="34" charset="-122"/>
@@ -4686,7 +4686,7 @@
             <a:r>
               <a:rPr lang="en-US" sz="950" dirty="0">
                 <a:solidFill>
-                  <a:srgbClr val="3A2F1F"/>
+                  <a:srgbClr val="FCF9F0"/>
                 </a:solidFill>
                 <a:latin typeface="Calibri" pitchFamily="34" charset="0"/>
                 <a:ea typeface="Calibri" pitchFamily="34" charset="-122"/>
@@ -4725,7 +4725,7 @@
             <a:r>
               <a:rPr lang="en-US" sz="900" dirty="0">
                 <a:solidFill>
-                  <a:srgbClr val="8A7457"/>
+                  <a:srgbClr val="D2E4CE"/>
                 </a:solidFill>
                 <a:latin typeface="Calibri" pitchFamily="34" charset="0"/>
                 <a:ea typeface="Calibri" pitchFamily="34" charset="-122"/>
@@ -4764,7 +4764,7 @@
             <a:r>
               <a:rPr lang="en-US" sz="950" dirty="0">
                 <a:solidFill>
-                  <a:srgbClr val="3A2F1F"/>
+                  <a:srgbClr val="FCF9F0"/>
                 </a:solidFill>
                 <a:latin typeface="Calibri" pitchFamily="34" charset="0"/>
                 <a:ea typeface="Calibri" pitchFamily="34" charset="-122"/>
@@ -4793,13 +4793,13 @@
             </a:avLst>
           </a:prstGeom>
           <a:solidFill>
-            <a:srgbClr val="FFFFFF">
+            <a:srgbClr val="12452B">
               <a:alpha val="90000"/>
             </a:srgbClr>
           </a:solidFill>
           <a:ln w="15875">
             <a:solidFill>
-              <a:srgbClr val="A87C2A"/>
+              <a:srgbClr val="C89C40"/>
             </a:solidFill>
             <a:prstDash val="solid"/>
           </a:ln>
@@ -4859,7 +4859,7 @@
           </a:prstGeom>
           <a:ln w="12700">
             <a:solidFill>
-              <a:srgbClr val="A87C2A"/>
+              <a:srgbClr val="C89C40"/>
             </a:solidFill>
             <a:prstDash val="solid"/>
           </a:ln>
@@ -4889,11 +4889,11 @@
             </a:avLst>
           </a:prstGeom>
           <a:solidFill>
-            <a:srgbClr val="8A5A20"/>
+            <a:srgbClr val="B0762A"/>
           </a:solidFill>
           <a:ln w="6350">
             <a:solidFill>
-              <a:srgbClr val="A87C2A"/>
+              <a:srgbClr val="C89C40"/>
             </a:solidFill>
             <a:prstDash val="solid"/>
           </a:ln>
@@ -4972,7 +4972,7 @@
             <a:r>
               <a:rPr lang="en-US" sz="1450" b="1" dirty="0">
                 <a:solidFill>
-                  <a:srgbClr val="241C10"/>
+                  <a:srgbClr val="FFFFFF"/>
                 </a:solidFill>
                 <a:latin typeface="Cambria" pitchFamily="34" charset="0"/>
                 <a:ea typeface="Cambria" pitchFamily="34" charset="-122"/>
@@ -5011,7 +5011,7 @@
             <a:r>
               <a:rPr lang="en-US" sz="1000" dirty="0">
                 <a:solidFill>
-                  <a:srgbClr val="8A7457"/>
+                  <a:srgbClr val="D2E4CE"/>
                 </a:solidFill>
                 <a:latin typeface="Calibri" pitchFamily="34" charset="0"/>
                 <a:ea typeface="Calibri" pitchFamily="34" charset="-122"/>
@@ -5040,13 +5040,13 @@
             </a:avLst>
           </a:prstGeom>
           <a:solidFill>
-            <a:srgbClr val="FBF1DC">
+            <a:srgbClr val="1A5433">
               <a:alpha val="92000"/>
             </a:srgbClr>
           </a:solidFill>
           <a:ln w="9525">
             <a:solidFill>
-              <a:srgbClr val="A87C2A"/>
+              <a:srgbClr val="C89C40"/>
             </a:solidFill>
             <a:prstDash val="solid"/>
           </a:ln>
@@ -5086,7 +5086,7 @@
             <a:r>
               <a:rPr lang="en-US" sz="750" b="1" kern="0" spc="100" dirty="0">
                 <a:solidFill>
-                  <a:srgbClr val="A5730F"/>
+                  <a:srgbClr val="F5CE76"/>
                 </a:solidFill>
                 <a:latin typeface="Calibri" pitchFamily="34" charset="0"/>
                 <a:ea typeface="Calibri" pitchFamily="34" charset="-122"/>
@@ -5125,7 +5125,7 @@
             <a:r>
               <a:rPr lang="en-US" sz="900" dirty="0">
                 <a:solidFill>
-                  <a:srgbClr val="8A7457"/>
+                  <a:srgbClr val="D2E4CE"/>
                 </a:solidFill>
                 <a:latin typeface="Calibri" pitchFamily="34" charset="0"/>
                 <a:ea typeface="Calibri" pitchFamily="34" charset="-122"/>
@@ -5164,7 +5164,7 @@
             <a:r>
               <a:rPr lang="en-US" sz="950" dirty="0">
                 <a:solidFill>
-                  <a:srgbClr val="3A2F1F"/>
+                  <a:srgbClr val="FCF9F0"/>
                 </a:solidFill>
                 <a:latin typeface="Calibri" pitchFamily="34" charset="0"/>
                 <a:ea typeface="Calibri" pitchFamily="34" charset="-122"/>
@@ -5203,7 +5203,7 @@
             <a:r>
               <a:rPr lang="en-US" sz="900" b="1" dirty="0">
                 <a:solidFill>
-                  <a:srgbClr val="A5730F"/>
+                  <a:srgbClr val="F5CE76"/>
                 </a:solidFill>
                 <a:latin typeface="Calibri" pitchFamily="34" charset="0"/>
                 <a:ea typeface="Calibri" pitchFamily="34" charset="-122"/>
@@ -5242,7 +5242,7 @@
             <a:r>
               <a:rPr lang="en-US" sz="950" b="1" dirty="0">
                 <a:solidFill>
-                  <a:srgbClr val="A5730F"/>
+                  <a:srgbClr val="F5CE76"/>
                 </a:solidFill>
                 <a:latin typeface="Calibri" pitchFamily="34" charset="0"/>
                 <a:ea typeface="Calibri" pitchFamily="34" charset="-122"/>
@@ -5281,7 +5281,7 @@
             <a:r>
               <a:rPr lang="en-US" sz="900" dirty="0">
                 <a:solidFill>
-                  <a:srgbClr val="8A7457"/>
+                  <a:srgbClr val="D2E4CE"/>
                 </a:solidFill>
                 <a:latin typeface="Calibri" pitchFamily="34" charset="0"/>
                 <a:ea typeface="Calibri" pitchFamily="34" charset="-122"/>
@@ -5320,7 +5320,7 @@
             <a:r>
               <a:rPr lang="en-US" sz="950" dirty="0">
                 <a:solidFill>
-                  <a:srgbClr val="3A2F1F"/>
+                  <a:srgbClr val="FCF9F0"/>
                 </a:solidFill>
                 <a:latin typeface="Calibri" pitchFamily="34" charset="0"/>
                 <a:ea typeface="Calibri" pitchFamily="34" charset="-122"/>
@@ -5359,7 +5359,7 @@
             <a:r>
               <a:rPr lang="en-US" sz="900" dirty="0">
                 <a:solidFill>
-                  <a:srgbClr val="8A7457"/>
+                  <a:srgbClr val="D2E4CE"/>
                 </a:solidFill>
                 <a:latin typeface="Calibri" pitchFamily="34" charset="0"/>
                 <a:ea typeface="Calibri" pitchFamily="34" charset="-122"/>
@@ -5398,7 +5398,7 @@
             <a:r>
               <a:rPr lang="en-US" sz="950" dirty="0">
                 <a:solidFill>
-                  <a:srgbClr val="3A2F1F"/>
+                  <a:srgbClr val="FCF9F0"/>
                 </a:solidFill>
                 <a:latin typeface="Calibri" pitchFamily="34" charset="0"/>
                 <a:ea typeface="Calibri" pitchFamily="34" charset="-122"/>
@@ -5437,7 +5437,7 @@
             <a:r>
               <a:rPr lang="en-US" sz="900" dirty="0">
                 <a:solidFill>
-                  <a:srgbClr val="9C8B6E"/>
+                  <a:srgbClr val="C3D7BF"/>
                 </a:solidFill>
                 <a:latin typeface="Calibri" pitchFamily="34" charset="0"/>
                 <a:ea typeface="Calibri" pitchFamily="34" charset="-122"/>
@@ -5515,7 +5515,7 @@
             <a:r>
               <a:rPr lang="en-US" sz="1100" b="1" kern="0" spc="260" dirty="0">
                 <a:solidFill>
-                  <a:srgbClr val="2E7D3C"/>
+                  <a:srgbClr val="9BD473"/>
                 </a:solidFill>
                 <a:latin typeface="Calibri" pitchFamily="34" charset="0"/>
                 <a:ea typeface="Calibri" pitchFamily="34" charset="-122"/>
@@ -5554,7 +5554,7 @@
             <a:r>
               <a:rPr lang="en-US" sz="3100" b="1" dirty="0">
                 <a:solidFill>
-                  <a:srgbClr val="241C10"/>
+                  <a:srgbClr val="FFFFFF"/>
                 </a:solidFill>
                 <a:latin typeface="Cambria" pitchFamily="34" charset="0"/>
                 <a:ea typeface="Cambria" pitchFamily="34" charset="-122"/>
@@ -5593,7 +5593,7 @@
             <a:r>
               <a:rPr lang="en-US" sz="1250" i="1" dirty="0">
                 <a:solidFill>
-                  <a:srgbClr val="8A7457"/>
+                  <a:srgbClr val="D2E4CE"/>
                 </a:solidFill>
                 <a:latin typeface="Calibri" pitchFamily="34" charset="0"/>
                 <a:ea typeface="Calibri" pitchFamily="34" charset="-122"/>
@@ -5622,13 +5622,13 @@
             </a:avLst>
           </a:prstGeom>
           <a:solidFill>
-            <a:srgbClr val="FFFFFF">
+            <a:srgbClr val="12452B">
               <a:alpha val="90000"/>
             </a:srgbClr>
           </a:solidFill>
           <a:ln w="15875">
             <a:solidFill>
-              <a:srgbClr val="2E7D3C"/>
+              <a:srgbClr val="C89C40"/>
             </a:solidFill>
             <a:prstDash val="solid"/>
           </a:ln>
@@ -5675,7 +5675,7 @@
             <a:r>
               <a:rPr lang="en-US" sz="1700" b="1" dirty="0">
                 <a:solidFill>
-                  <a:srgbClr val="1F5C3A"/>
+                  <a:srgbClr val="F5CE76"/>
                 </a:solidFill>
                 <a:latin typeface="Cambria" pitchFamily="34" charset="0"/>
                 <a:ea typeface="Cambria" pitchFamily="34" charset="-122"/>
@@ -5717,7 +5717,7 @@
             <a:r>
               <a:rPr lang="en-US" sz="1200" dirty="0">
                 <a:solidFill>
-                  <a:srgbClr val="3A2F1F"/>
+                  <a:srgbClr val="FCF9F0"/>
                 </a:solidFill>
                 <a:latin typeface="Calibri" pitchFamily="34" charset="0"/>
                 <a:ea typeface="Calibri" pitchFamily="34" charset="-122"/>
@@ -5756,7 +5756,7 @@
             <a:r>
               <a:rPr lang="en-US" sz="1700" b="1" dirty="0">
                 <a:solidFill>
-                  <a:srgbClr val="1F5C3A"/>
+                  <a:srgbClr val="F5CE76"/>
                 </a:solidFill>
                 <a:latin typeface="Cambria" pitchFamily="34" charset="0"/>
                 <a:ea typeface="Cambria" pitchFamily="34" charset="-122"/>
@@ -5795,7 +5795,7 @@
             <a:r>
               <a:rPr lang="en-US" sz="1050" dirty="0">
                 <a:solidFill>
-                  <a:srgbClr val="8A7457"/>
+                  <a:srgbClr val="D2E4CE"/>
                 </a:solidFill>
                 <a:latin typeface="Calibri" pitchFamily="34" charset="0"/>
                 <a:ea typeface="Calibri" pitchFamily="34" charset="-122"/>
@@ -5834,7 +5834,7 @@
             <a:r>
               <a:rPr lang="en-US" sz="1150" b="1" dirty="0">
                 <a:solidFill>
-                  <a:srgbClr val="3A2F1F"/>
+                  <a:srgbClr val="FCF9F0"/>
                 </a:solidFill>
                 <a:latin typeface="Calibri" pitchFamily="34" charset="0"/>
                 <a:ea typeface="Calibri" pitchFamily="34" charset="-122"/>
@@ -5873,7 +5873,7 @@
             <a:r>
               <a:rPr lang="en-US" sz="1050" dirty="0">
                 <a:solidFill>
-                  <a:srgbClr val="8A7457"/>
+                  <a:srgbClr val="D2E4CE"/>
                 </a:solidFill>
                 <a:latin typeface="Calibri" pitchFamily="34" charset="0"/>
                 <a:ea typeface="Calibri" pitchFamily="34" charset="-122"/>
@@ -5912,7 +5912,7 @@
             <a:r>
               <a:rPr lang="en-US" sz="1150" b="1" dirty="0">
                 <a:solidFill>
-                  <a:srgbClr val="3A2F1F"/>
+                  <a:srgbClr val="FCF9F0"/>
                 </a:solidFill>
                 <a:latin typeface="Calibri" pitchFamily="34" charset="0"/>
                 <a:ea typeface="Calibri" pitchFamily="34" charset="-122"/>
@@ -5951,7 +5951,7 @@
             <a:r>
               <a:rPr lang="en-US" sz="1050" dirty="0">
                 <a:solidFill>
-                  <a:srgbClr val="8A7457"/>
+                  <a:srgbClr val="D2E4CE"/>
                 </a:solidFill>
                 <a:latin typeface="Calibri" pitchFamily="34" charset="0"/>
                 <a:ea typeface="Calibri" pitchFamily="34" charset="-122"/>
@@ -5990,7 +5990,7 @@
             <a:r>
               <a:rPr lang="en-US" sz="1150" b="1" dirty="0">
                 <a:solidFill>
-                  <a:srgbClr val="3A2F1F"/>
+                  <a:srgbClr val="FCF9F0"/>
                 </a:solidFill>
                 <a:latin typeface="Calibri" pitchFamily="34" charset="0"/>
                 <a:ea typeface="Calibri" pitchFamily="34" charset="-122"/>
@@ -6029,7 +6029,7 @@
             <a:r>
               <a:rPr lang="en-US" sz="1050" dirty="0">
                 <a:solidFill>
-                  <a:srgbClr val="8A7457"/>
+                  <a:srgbClr val="D2E4CE"/>
                 </a:solidFill>
                 <a:latin typeface="Calibri" pitchFamily="34" charset="0"/>
                 <a:ea typeface="Calibri" pitchFamily="34" charset="-122"/>
@@ -6068,7 +6068,7 @@
             <a:r>
               <a:rPr lang="en-US" sz="1150" b="1" dirty="0">
                 <a:solidFill>
-                  <a:srgbClr val="3A2F1F"/>
+                  <a:srgbClr val="FCF9F0"/>
                 </a:solidFill>
                 <a:latin typeface="Calibri" pitchFamily="34" charset="0"/>
                 <a:ea typeface="Calibri" pitchFamily="34" charset="-122"/>
@@ -6107,7 +6107,7 @@
             <a:r>
               <a:rPr lang="en-US" sz="1050" dirty="0">
                 <a:solidFill>
-                  <a:srgbClr val="8A7457"/>
+                  <a:srgbClr val="D2E4CE"/>
                 </a:solidFill>
                 <a:latin typeface="Calibri" pitchFamily="34" charset="0"/>
                 <a:ea typeface="Calibri" pitchFamily="34" charset="-122"/>
@@ -6146,7 +6146,7 @@
             <a:r>
               <a:rPr lang="en-US" sz="1150" b="1" dirty="0">
                 <a:solidFill>
-                  <a:srgbClr val="3A2F1F"/>
+                  <a:srgbClr val="FCF9F0"/>
                 </a:solidFill>
                 <a:latin typeface="Calibri" pitchFamily="34" charset="0"/>
                 <a:ea typeface="Calibri" pitchFamily="34" charset="-122"/>
@@ -6185,7 +6185,7 @@
             <a:r>
               <a:rPr lang="en-US" sz="1050" dirty="0">
                 <a:solidFill>
-                  <a:srgbClr val="8A7457"/>
+                  <a:srgbClr val="D2E4CE"/>
                 </a:solidFill>
                 <a:latin typeface="Calibri" pitchFamily="34" charset="0"/>
                 <a:ea typeface="Calibri" pitchFamily="34" charset="-122"/>
@@ -6224,7 +6224,7 @@
             <a:r>
               <a:rPr lang="en-US" sz="1150" b="1" dirty="0">
                 <a:solidFill>
-                  <a:srgbClr val="3A2F1F"/>
+                  <a:srgbClr val="FCF9F0"/>
                 </a:solidFill>
                 <a:latin typeface="Calibri" pitchFamily="34" charset="0"/>
                 <a:ea typeface="Calibri" pitchFamily="34" charset="-122"/>
@@ -6263,7 +6263,7 @@
             <a:r>
               <a:rPr lang="en-US" sz="1050" dirty="0">
                 <a:solidFill>
-                  <a:srgbClr val="8A7457"/>
+                  <a:srgbClr val="D2E4CE"/>
                 </a:solidFill>
                 <a:latin typeface="Calibri" pitchFamily="34" charset="0"/>
                 <a:ea typeface="Calibri" pitchFamily="34" charset="-122"/>
@@ -6302,7 +6302,7 @@
             <a:r>
               <a:rPr lang="en-US" sz="1150" b="1" dirty="0">
                 <a:solidFill>
-                  <a:srgbClr val="3A2F1F"/>
+                  <a:srgbClr val="FCF9F0"/>
                 </a:solidFill>
                 <a:latin typeface="Calibri" pitchFamily="34" charset="0"/>
                 <a:ea typeface="Calibri" pitchFamily="34" charset="-122"/>
@@ -6341,7 +6341,7 @@
             <a:r>
               <a:rPr lang="en-US" sz="1050" dirty="0">
                 <a:solidFill>
-                  <a:srgbClr val="8A7457"/>
+                  <a:srgbClr val="D2E4CE"/>
                 </a:solidFill>
                 <a:latin typeface="Calibri" pitchFamily="34" charset="0"/>
                 <a:ea typeface="Calibri" pitchFamily="34" charset="-122"/>
@@ -6380,7 +6380,7 @@
             <a:r>
               <a:rPr lang="en-US" sz="1150" b="1" dirty="0">
                 <a:solidFill>
-                  <a:srgbClr val="3A2F1F"/>
+                  <a:srgbClr val="FCF9F0"/>
                 </a:solidFill>
                 <a:latin typeface="Calibri" pitchFamily="34" charset="0"/>
                 <a:ea typeface="Calibri" pitchFamily="34" charset="-122"/>
@@ -6431,7 +6431,7 @@
           </a:prstGeom>
           <a:ln w="15875">
             <a:solidFill>
-              <a:srgbClr val="2E7D3C"/>
+              <a:srgbClr val="C89C40"/>
             </a:solidFill>
             <a:prstDash val="solid"/>
           </a:ln>
@@ -6461,13 +6461,13 @@
             </a:avLst>
           </a:prstGeom>
           <a:solidFill>
-            <a:srgbClr val="1F5C3A">
-              <a:alpha val="100000"/>
+            <a:srgbClr val="12452B">
+              <a:alpha val="90000"/>
             </a:srgbClr>
           </a:solidFill>
           <a:ln w="15875">
             <a:solidFill>
-              <a:srgbClr val="2E7D3C"/>
+              <a:srgbClr val="C89C40"/>
             </a:solidFill>
             <a:prstDash val="solid"/>
           </a:ln>
@@ -6514,7 +6514,7 @@
             <a:r>
               <a:rPr lang="en-US" sz="1900" b="1" dirty="0">
                 <a:solidFill>
-                  <a:srgbClr val="EAF3EA"/>
+                  <a:srgbClr val="F5CE76"/>
                 </a:solidFill>
                 <a:latin typeface="Cambria" pitchFamily="34" charset="0"/>
                 <a:ea typeface="Cambria" pitchFamily="34" charset="-122"/>
@@ -6553,7 +6553,7 @@
             <a:r>
               <a:rPr lang="en-US" sz="1050" dirty="0">
                 <a:solidFill>
-                  <a:srgbClr val="EAF3EA"/>
+                  <a:srgbClr val="FCF9F0"/>
                 </a:solidFill>
                 <a:latin typeface="Calibri" pitchFamily="34" charset="0"/>
                 <a:ea typeface="Calibri" pitchFamily="34" charset="-122"/>
@@ -6582,13 +6582,13 @@
             </a:avLst>
           </a:prstGeom>
           <a:solidFill>
-            <a:srgbClr val="1F5C3A">
-              <a:alpha val="100000"/>
+            <a:srgbClr val="12452B">
+              <a:alpha val="90000"/>
             </a:srgbClr>
           </a:solidFill>
           <a:ln w="15875">
             <a:solidFill>
-              <a:srgbClr val="2E7D3C"/>
+              <a:srgbClr val="C89C40"/>
             </a:solidFill>
             <a:prstDash val="solid"/>
           </a:ln>
@@ -6635,7 +6635,7 @@
             <a:r>
               <a:rPr lang="en-US" sz="1900" b="1" dirty="0">
                 <a:solidFill>
-                  <a:srgbClr val="EAF3EA"/>
+                  <a:srgbClr val="F5CE76"/>
                 </a:solidFill>
                 <a:latin typeface="Cambria" pitchFamily="34" charset="0"/>
                 <a:ea typeface="Cambria" pitchFamily="34" charset="-122"/>
@@ -6646,7 +6646,7 @@
             <a:r>
               <a:rPr lang="en-US" sz="1100" dirty="0">
                 <a:solidFill>
-                  <a:srgbClr val="EAF3EA"/>
+                  <a:srgbClr val="F5CE76"/>
                 </a:solidFill>
                 <a:latin typeface="Cambria" pitchFamily="34" charset="0"/>
                 <a:ea typeface="Cambria" pitchFamily="34" charset="-122"/>
@@ -6685,7 +6685,7 @@
             <a:r>
               <a:rPr lang="en-US" sz="1050" dirty="0">
                 <a:solidFill>
-                  <a:srgbClr val="EAF3EA"/>
+                  <a:srgbClr val="FCF9F0"/>
                 </a:solidFill>
                 <a:latin typeface="Calibri" pitchFamily="34" charset="0"/>
                 <a:ea typeface="Calibri" pitchFamily="34" charset="-122"/>
@@ -6714,13 +6714,13 @@
             </a:avLst>
           </a:prstGeom>
           <a:solidFill>
-            <a:srgbClr val="1F5C3A">
-              <a:alpha val="100000"/>
+            <a:srgbClr val="12452B">
+              <a:alpha val="90000"/>
             </a:srgbClr>
           </a:solidFill>
           <a:ln w="15875">
             <a:solidFill>
-              <a:srgbClr val="2E7D3C"/>
+              <a:srgbClr val="C89C40"/>
             </a:solidFill>
             <a:prstDash val="solid"/>
           </a:ln>
@@ -6767,7 +6767,7 @@
             <a:r>
               <a:rPr lang="en-US" sz="1900" b="1" dirty="0">
                 <a:solidFill>
-                  <a:srgbClr val="EAF3EA"/>
+                  <a:srgbClr val="F5CE76"/>
                 </a:solidFill>
                 <a:latin typeface="Cambria" pitchFamily="34" charset="0"/>
                 <a:ea typeface="Cambria" pitchFamily="34" charset="-122"/>
@@ -6778,7 +6778,7 @@
             <a:r>
               <a:rPr lang="en-US" sz="1100" dirty="0">
                 <a:solidFill>
-                  <a:srgbClr val="EAF3EA"/>
+                  <a:srgbClr val="F5CE76"/>
                 </a:solidFill>
                 <a:latin typeface="Cambria" pitchFamily="34" charset="0"/>
                 <a:ea typeface="Cambria" pitchFamily="34" charset="-122"/>
@@ -6817,7 +6817,7 @@
             <a:r>
               <a:rPr lang="en-US" sz="1050" dirty="0">
                 <a:solidFill>
-                  <a:srgbClr val="EAF3EA"/>
+                  <a:srgbClr val="FCF9F0"/>
                 </a:solidFill>
                 <a:latin typeface="Calibri" pitchFamily="34" charset="0"/>
                 <a:ea typeface="Calibri" pitchFamily="34" charset="-122"/>
@@ -6856,7 +6856,7 @@
             <a:r>
               <a:rPr lang="en-US" sz="900" dirty="0">
                 <a:solidFill>
-                  <a:srgbClr val="9C8B6E"/>
+                  <a:srgbClr val="C3D7BF"/>
                 </a:solidFill>
                 <a:latin typeface="Calibri" pitchFamily="34" charset="0"/>
                 <a:ea typeface="Calibri" pitchFamily="34" charset="-122"/>
@@ -6934,7 +6934,7 @@
             <a:r>
               <a:rPr lang="en-US" sz="1100" b="1" kern="0" spc="260" dirty="0">
                 <a:solidFill>
-                  <a:srgbClr val="2E7D3C"/>
+                  <a:srgbClr val="9BD473"/>
                 </a:solidFill>
                 <a:latin typeface="Calibri" pitchFamily="34" charset="0"/>
                 <a:ea typeface="Calibri" pitchFamily="34" charset="-122"/>
@@ -6973,7 +6973,7 @@
             <a:r>
               <a:rPr lang="en-US" sz="3100" b="1" dirty="0">
                 <a:solidFill>
-                  <a:srgbClr val="241C10"/>
+                  <a:srgbClr val="FFFFFF"/>
                 </a:solidFill>
                 <a:latin typeface="Cambria" pitchFamily="34" charset="0"/>
                 <a:ea typeface="Cambria" pitchFamily="34" charset="-122"/>
@@ -7012,7 +7012,7 @@
             <a:r>
               <a:rPr lang="en-US" sz="1250" i="1" dirty="0">
                 <a:solidFill>
-                  <a:srgbClr val="8A7457"/>
+                  <a:srgbClr val="D2E4CE"/>
                 </a:solidFill>
                 <a:latin typeface="Calibri" pitchFamily="34" charset="0"/>
                 <a:ea typeface="Calibri" pitchFamily="34" charset="-122"/>
@@ -7041,13 +7041,13 @@
             </a:avLst>
           </a:prstGeom>
           <a:solidFill>
-            <a:srgbClr val="FFFFFF">
+            <a:srgbClr val="12452B">
               <a:alpha val="90000"/>
             </a:srgbClr>
           </a:solidFill>
           <a:ln w="15875">
             <a:solidFill>
-              <a:srgbClr val="2E7D3C"/>
+              <a:srgbClr val="C89C40"/>
             </a:solidFill>
             <a:prstDash val="solid"/>
           </a:ln>
@@ -7106,7 +7106,7 @@
           </a:prstGeom>
           <a:ln w="12700">
             <a:solidFill>
-              <a:srgbClr val="2E7D3C"/>
+              <a:srgbClr val="C89C40"/>
             </a:solidFill>
             <a:prstDash val="solid"/>
           </a:ln>
@@ -7136,11 +7136,11 @@
             </a:avLst>
           </a:prstGeom>
           <a:solidFill>
-            <a:srgbClr val="2E6B3A"/>
+            <a:srgbClr val="358A48"/>
           </a:solidFill>
           <a:ln w="6350">
             <a:solidFill>
-              <a:srgbClr val="2E7D3C"/>
+              <a:srgbClr val="C89C40"/>
             </a:solidFill>
             <a:prstDash val="solid"/>
           </a:ln>
@@ -7219,7 +7219,7 @@
             <a:r>
               <a:rPr lang="en-US" sz="1450" b="1" dirty="0">
                 <a:solidFill>
-                  <a:srgbClr val="241C10"/>
+                  <a:srgbClr val="FFFFFF"/>
                 </a:solidFill>
                 <a:latin typeface="Cambria" pitchFamily="34" charset="0"/>
                 <a:ea typeface="Cambria" pitchFamily="34" charset="-122"/>
@@ -7236,7 +7236,7 @@
             <a:r>
               <a:rPr lang="en-US" sz="1450" b="1" dirty="0">
                 <a:solidFill>
-                  <a:srgbClr val="241C10"/>
+                  <a:srgbClr val="FFFFFF"/>
                 </a:solidFill>
                 <a:latin typeface="Cambria" pitchFamily="34" charset="0"/>
                 <a:ea typeface="Cambria" pitchFamily="34" charset="-122"/>
@@ -7275,7 +7275,7 @@
             <a:r>
               <a:rPr lang="en-US" sz="1000" dirty="0">
                 <a:solidFill>
-                  <a:srgbClr val="8A7457"/>
+                  <a:srgbClr val="D2E4CE"/>
                 </a:solidFill>
                 <a:latin typeface="Calibri" pitchFamily="34" charset="0"/>
                 <a:ea typeface="Calibri" pitchFamily="34" charset="-122"/>
@@ -7304,13 +7304,13 @@
             </a:avLst>
           </a:prstGeom>
           <a:solidFill>
-            <a:srgbClr val="EAF3EA">
+            <a:srgbClr val="1A5433">
               <a:alpha val="92000"/>
             </a:srgbClr>
           </a:solidFill>
           <a:ln w="9525">
             <a:solidFill>
-              <a:srgbClr val="2E7D3C"/>
+              <a:srgbClr val="C89C40"/>
             </a:solidFill>
             <a:prstDash val="solid"/>
           </a:ln>
@@ -7350,7 +7350,7 @@
             <a:r>
               <a:rPr lang="en-US" sz="750" b="1" kern="0" spc="100" dirty="0">
                 <a:solidFill>
-                  <a:srgbClr val="1F5C3A"/>
+                  <a:srgbClr val="F5CE76"/>
                 </a:solidFill>
                 <a:latin typeface="Calibri" pitchFamily="34" charset="0"/>
                 <a:ea typeface="Calibri" pitchFamily="34" charset="-122"/>
@@ -7389,7 +7389,7 @@
             <a:r>
               <a:rPr lang="en-US" sz="900" dirty="0">
                 <a:solidFill>
-                  <a:srgbClr val="8A7457"/>
+                  <a:srgbClr val="D2E4CE"/>
                 </a:solidFill>
                 <a:latin typeface="Calibri" pitchFamily="34" charset="0"/>
                 <a:ea typeface="Calibri" pitchFamily="34" charset="-122"/>
@@ -7428,7 +7428,7 @@
             <a:r>
               <a:rPr lang="en-US" sz="950" dirty="0">
                 <a:solidFill>
-                  <a:srgbClr val="3A2F1F"/>
+                  <a:srgbClr val="FCF9F0"/>
                 </a:solidFill>
                 <a:latin typeface="Calibri" pitchFamily="34" charset="0"/>
                 <a:ea typeface="Calibri" pitchFamily="34" charset="-122"/>
@@ -7467,7 +7467,7 @@
             <a:r>
               <a:rPr lang="en-US" sz="900" b="1" dirty="0">
                 <a:solidFill>
-                  <a:srgbClr val="1F5C3A"/>
+                  <a:srgbClr val="F5CE76"/>
                 </a:solidFill>
                 <a:latin typeface="Calibri" pitchFamily="34" charset="0"/>
                 <a:ea typeface="Calibri" pitchFamily="34" charset="-122"/>
@@ -7506,7 +7506,7 @@
             <a:r>
               <a:rPr lang="en-US" sz="950" b="1" dirty="0">
                 <a:solidFill>
-                  <a:srgbClr val="1F5C3A"/>
+                  <a:srgbClr val="F5CE76"/>
                 </a:solidFill>
                 <a:latin typeface="Calibri" pitchFamily="34" charset="0"/>
                 <a:ea typeface="Calibri" pitchFamily="34" charset="-122"/>
@@ -7545,7 +7545,7 @@
             <a:r>
               <a:rPr lang="en-US" sz="900" dirty="0">
                 <a:solidFill>
-                  <a:srgbClr val="8A7457"/>
+                  <a:srgbClr val="D2E4CE"/>
                 </a:solidFill>
                 <a:latin typeface="Calibri" pitchFamily="34" charset="0"/>
                 <a:ea typeface="Calibri" pitchFamily="34" charset="-122"/>
@@ -7584,7 +7584,7 @@
             <a:r>
               <a:rPr lang="en-US" sz="950" dirty="0">
                 <a:solidFill>
-                  <a:srgbClr val="3A2F1F"/>
+                  <a:srgbClr val="FCF9F0"/>
                 </a:solidFill>
                 <a:latin typeface="Calibri" pitchFamily="34" charset="0"/>
                 <a:ea typeface="Calibri" pitchFamily="34" charset="-122"/>
@@ -7623,7 +7623,7 @@
             <a:r>
               <a:rPr lang="en-US" sz="900" dirty="0">
                 <a:solidFill>
-                  <a:srgbClr val="8A7457"/>
+                  <a:srgbClr val="D2E4CE"/>
                 </a:solidFill>
                 <a:latin typeface="Calibri" pitchFamily="34" charset="0"/>
                 <a:ea typeface="Calibri" pitchFamily="34" charset="-122"/>
@@ -7662,7 +7662,7 @@
             <a:r>
               <a:rPr lang="en-US" sz="950" dirty="0">
                 <a:solidFill>
-                  <a:srgbClr val="3A2F1F"/>
+                  <a:srgbClr val="FCF9F0"/>
                 </a:solidFill>
                 <a:latin typeface="Calibri" pitchFamily="34" charset="0"/>
                 <a:ea typeface="Calibri" pitchFamily="34" charset="-122"/>
@@ -7691,13 +7691,13 @@
             </a:avLst>
           </a:prstGeom>
           <a:solidFill>
-            <a:srgbClr val="FFFFFF">
+            <a:srgbClr val="12452B">
               <a:alpha val="90000"/>
             </a:srgbClr>
           </a:solidFill>
           <a:ln w="15875">
             <a:solidFill>
-              <a:srgbClr val="2E7D3C"/>
+              <a:srgbClr val="C89C40"/>
             </a:solidFill>
             <a:prstDash val="solid"/>
           </a:ln>
@@ -7756,7 +7756,7 @@
           </a:prstGeom>
           <a:ln w="12700">
             <a:solidFill>
-              <a:srgbClr val="2E7D3C"/>
+              <a:srgbClr val="C89C40"/>
             </a:solidFill>
             <a:prstDash val="solid"/>
           </a:ln>
@@ -7786,11 +7786,11 @@
             </a:avLst>
           </a:prstGeom>
           <a:solidFill>
-            <a:srgbClr val="2E6B3A"/>
+            <a:srgbClr val="358A48"/>
           </a:solidFill>
           <a:ln w="6350">
             <a:solidFill>
-              <a:srgbClr val="2E7D3C"/>
+              <a:srgbClr val="C89C40"/>
             </a:solidFill>
             <a:prstDash val="solid"/>
           </a:ln>
@@ -7869,7 +7869,7 @@
             <a:r>
               <a:rPr lang="en-US" sz="1450" b="1" dirty="0">
                 <a:solidFill>
-                  <a:srgbClr val="241C10"/>
+                  <a:srgbClr val="FFFFFF"/>
                 </a:solidFill>
                 <a:latin typeface="Cambria" pitchFamily="34" charset="0"/>
                 <a:ea typeface="Cambria" pitchFamily="34" charset="-122"/>
@@ -7908,7 +7908,7 @@
             <a:r>
               <a:rPr lang="en-US" sz="1000" dirty="0">
                 <a:solidFill>
-                  <a:srgbClr val="8A7457"/>
+                  <a:srgbClr val="D2E4CE"/>
                 </a:solidFill>
                 <a:latin typeface="Calibri" pitchFamily="34" charset="0"/>
                 <a:ea typeface="Calibri" pitchFamily="34" charset="-122"/>
@@ -7937,13 +7937,13 @@
             </a:avLst>
           </a:prstGeom>
           <a:solidFill>
-            <a:srgbClr val="EAF3EA">
+            <a:srgbClr val="1A5433">
               <a:alpha val="92000"/>
             </a:srgbClr>
           </a:solidFill>
           <a:ln w="9525">
             <a:solidFill>
-              <a:srgbClr val="2E7D3C"/>
+              <a:srgbClr val="C89C40"/>
             </a:solidFill>
             <a:prstDash val="solid"/>
           </a:ln>
@@ -7983,7 +7983,7 @@
             <a:r>
               <a:rPr lang="en-US" sz="750" b="1" kern="0" spc="100" dirty="0">
                 <a:solidFill>
-                  <a:srgbClr val="1F5C3A"/>
+                  <a:srgbClr val="F5CE76"/>
                 </a:solidFill>
                 <a:latin typeface="Calibri" pitchFamily="34" charset="0"/>
                 <a:ea typeface="Calibri" pitchFamily="34" charset="-122"/>
@@ -8022,7 +8022,7 @@
             <a:r>
               <a:rPr lang="en-US" sz="900" dirty="0">
                 <a:solidFill>
-                  <a:srgbClr val="8A7457"/>
+                  <a:srgbClr val="D2E4CE"/>
                 </a:solidFill>
                 <a:latin typeface="Calibri" pitchFamily="34" charset="0"/>
                 <a:ea typeface="Calibri" pitchFamily="34" charset="-122"/>
@@ -8061,7 +8061,7 @@
             <a:r>
               <a:rPr lang="en-US" sz="950" dirty="0">
                 <a:solidFill>
-                  <a:srgbClr val="3A2F1F"/>
+                  <a:srgbClr val="FCF9F0"/>
                 </a:solidFill>
                 <a:latin typeface="Calibri" pitchFamily="34" charset="0"/>
                 <a:ea typeface="Calibri" pitchFamily="34" charset="-122"/>
@@ -8100,7 +8100,7 @@
             <a:r>
               <a:rPr lang="en-US" sz="900" b="1" dirty="0">
                 <a:solidFill>
-                  <a:srgbClr val="1F5C3A"/>
+                  <a:srgbClr val="F5CE76"/>
                 </a:solidFill>
                 <a:latin typeface="Calibri" pitchFamily="34" charset="0"/>
                 <a:ea typeface="Calibri" pitchFamily="34" charset="-122"/>
@@ -8139,7 +8139,7 @@
             <a:r>
               <a:rPr lang="en-US" sz="950" b="1" dirty="0">
                 <a:solidFill>
-                  <a:srgbClr val="1F5C3A"/>
+                  <a:srgbClr val="F5CE76"/>
                 </a:solidFill>
                 <a:latin typeface="Calibri" pitchFamily="34" charset="0"/>
                 <a:ea typeface="Calibri" pitchFamily="34" charset="-122"/>
@@ -8178,7 +8178,7 @@
             <a:r>
               <a:rPr lang="en-US" sz="900" dirty="0">
                 <a:solidFill>
-                  <a:srgbClr val="8A7457"/>
+                  <a:srgbClr val="D2E4CE"/>
                 </a:solidFill>
                 <a:latin typeface="Calibri" pitchFamily="34" charset="0"/>
                 <a:ea typeface="Calibri" pitchFamily="34" charset="-122"/>
@@ -8217,7 +8217,7 @@
             <a:r>
               <a:rPr lang="en-US" sz="950" dirty="0">
                 <a:solidFill>
-                  <a:srgbClr val="3A2F1F"/>
+                  <a:srgbClr val="FCF9F0"/>
                 </a:solidFill>
                 <a:latin typeface="Calibri" pitchFamily="34" charset="0"/>
                 <a:ea typeface="Calibri" pitchFamily="34" charset="-122"/>
@@ -8256,7 +8256,7 @@
             <a:r>
               <a:rPr lang="en-US" sz="900" dirty="0">
                 <a:solidFill>
-                  <a:srgbClr val="8A7457"/>
+                  <a:srgbClr val="D2E4CE"/>
                 </a:solidFill>
                 <a:latin typeface="Calibri" pitchFamily="34" charset="0"/>
                 <a:ea typeface="Calibri" pitchFamily="34" charset="-122"/>
@@ -8295,7 +8295,7 @@
             <a:r>
               <a:rPr lang="en-US" sz="950" dirty="0">
                 <a:solidFill>
-                  <a:srgbClr val="3A2F1F"/>
+                  <a:srgbClr val="FCF9F0"/>
                 </a:solidFill>
                 <a:latin typeface="Calibri" pitchFamily="34" charset="0"/>
                 <a:ea typeface="Calibri" pitchFamily="34" charset="-122"/>
@@ -8324,13 +8324,13 @@
             </a:avLst>
           </a:prstGeom>
           <a:solidFill>
-            <a:srgbClr val="FFFFFF">
+            <a:srgbClr val="12452B">
               <a:alpha val="90000"/>
             </a:srgbClr>
           </a:solidFill>
           <a:ln w="15875">
             <a:solidFill>
-              <a:srgbClr val="2E7D3C"/>
+              <a:srgbClr val="C89C40"/>
             </a:solidFill>
             <a:prstDash val="solid"/>
           </a:ln>
@@ -8389,7 +8389,7 @@
           </a:prstGeom>
           <a:ln w="12700">
             <a:solidFill>
-              <a:srgbClr val="2E7D3C"/>
+              <a:srgbClr val="C89C40"/>
             </a:solidFill>
             <a:prstDash val="solid"/>
           </a:ln>
@@ -8419,11 +8419,11 @@
             </a:avLst>
           </a:prstGeom>
           <a:solidFill>
-            <a:srgbClr val="2E6B3A"/>
+            <a:srgbClr val="358A48"/>
           </a:solidFill>
           <a:ln w="6350">
             <a:solidFill>
-              <a:srgbClr val="2E7D3C"/>
+              <a:srgbClr val="C89C40"/>
             </a:solidFill>
             <a:prstDash val="solid"/>
           </a:ln>
@@ -8502,7 +8502,7 @@
             <a:r>
               <a:rPr lang="en-US" sz="1450" b="1" dirty="0">
                 <a:solidFill>
-                  <a:srgbClr val="241C10"/>
+                  <a:srgbClr val="FFFFFF"/>
                 </a:solidFill>
                 <a:latin typeface="Cambria" pitchFamily="34" charset="0"/>
                 <a:ea typeface="Cambria" pitchFamily="34" charset="-122"/>
@@ -8541,7 +8541,7 @@
             <a:r>
               <a:rPr lang="en-US" sz="1000" dirty="0">
                 <a:solidFill>
-                  <a:srgbClr val="8A7457"/>
+                  <a:srgbClr val="D2E4CE"/>
                 </a:solidFill>
                 <a:latin typeface="Calibri" pitchFamily="34" charset="0"/>
                 <a:ea typeface="Calibri" pitchFamily="34" charset="-122"/>
@@ -8570,13 +8570,13 @@
             </a:avLst>
           </a:prstGeom>
           <a:solidFill>
-            <a:srgbClr val="EAF3EA">
+            <a:srgbClr val="1A5433">
               <a:alpha val="92000"/>
             </a:srgbClr>
           </a:solidFill>
           <a:ln w="9525">
             <a:solidFill>
-              <a:srgbClr val="2E7D3C"/>
+              <a:srgbClr val="C89C40"/>
             </a:solidFill>
             <a:prstDash val="solid"/>
           </a:ln>
@@ -8616,7 +8616,7 @@
             <a:r>
               <a:rPr lang="en-US" sz="750" b="1" kern="0" spc="100" dirty="0">
                 <a:solidFill>
-                  <a:srgbClr val="1F5C3A"/>
+                  <a:srgbClr val="F5CE76"/>
                 </a:solidFill>
                 <a:latin typeface="Calibri" pitchFamily="34" charset="0"/>
                 <a:ea typeface="Calibri" pitchFamily="34" charset="-122"/>
@@ -8655,7 +8655,7 @@
             <a:r>
               <a:rPr lang="en-US" sz="900" dirty="0">
                 <a:solidFill>
-                  <a:srgbClr val="8A7457"/>
+                  <a:srgbClr val="D2E4CE"/>
                 </a:solidFill>
                 <a:latin typeface="Calibri" pitchFamily="34" charset="0"/>
                 <a:ea typeface="Calibri" pitchFamily="34" charset="-122"/>
@@ -8694,7 +8694,7 @@
             <a:r>
               <a:rPr lang="en-US" sz="950" dirty="0">
                 <a:solidFill>
-                  <a:srgbClr val="3A2F1F"/>
+                  <a:srgbClr val="FCF9F0"/>
                 </a:solidFill>
                 <a:latin typeface="Calibri" pitchFamily="34" charset="0"/>
                 <a:ea typeface="Calibri" pitchFamily="34" charset="-122"/>
@@ -8733,7 +8733,7 @@
             <a:r>
               <a:rPr lang="en-US" sz="900" b="1" dirty="0">
                 <a:solidFill>
-                  <a:srgbClr val="1F5C3A"/>
+                  <a:srgbClr val="F5CE76"/>
                 </a:solidFill>
                 <a:latin typeface="Calibri" pitchFamily="34" charset="0"/>
                 <a:ea typeface="Calibri" pitchFamily="34" charset="-122"/>
@@ -8772,7 +8772,7 @@
             <a:r>
               <a:rPr lang="en-US" sz="950" b="1" dirty="0">
                 <a:solidFill>
-                  <a:srgbClr val="1F5C3A"/>
+                  <a:srgbClr val="F5CE76"/>
                 </a:solidFill>
                 <a:latin typeface="Calibri" pitchFamily="34" charset="0"/>
                 <a:ea typeface="Calibri" pitchFamily="34" charset="-122"/>
@@ -8811,7 +8811,7 @@
             <a:r>
               <a:rPr lang="en-US" sz="900" dirty="0">
                 <a:solidFill>
-                  <a:srgbClr val="8A7457"/>
+                  <a:srgbClr val="D2E4CE"/>
                 </a:solidFill>
                 <a:latin typeface="Calibri" pitchFamily="34" charset="0"/>
                 <a:ea typeface="Calibri" pitchFamily="34" charset="-122"/>
@@ -8850,7 +8850,7 @@
             <a:r>
               <a:rPr lang="en-US" sz="950" dirty="0">
                 <a:solidFill>
-                  <a:srgbClr val="3A2F1F"/>
+                  <a:srgbClr val="FCF9F0"/>
                 </a:solidFill>
                 <a:latin typeface="Calibri" pitchFamily="34" charset="0"/>
                 <a:ea typeface="Calibri" pitchFamily="34" charset="-122"/>
@@ -8889,7 +8889,7 @@
             <a:r>
               <a:rPr lang="en-US" sz="900" dirty="0">
                 <a:solidFill>
-                  <a:srgbClr val="8A7457"/>
+                  <a:srgbClr val="D2E4CE"/>
                 </a:solidFill>
                 <a:latin typeface="Calibri" pitchFamily="34" charset="0"/>
                 <a:ea typeface="Calibri" pitchFamily="34" charset="-122"/>
@@ -8928,7 +8928,7 @@
             <a:r>
               <a:rPr lang="en-US" sz="950" dirty="0">
                 <a:solidFill>
-                  <a:srgbClr val="3A2F1F"/>
+                  <a:srgbClr val="FCF9F0"/>
                 </a:solidFill>
                 <a:latin typeface="Calibri" pitchFamily="34" charset="0"/>
                 <a:ea typeface="Calibri" pitchFamily="34" charset="-122"/>
@@ -8957,13 +8957,13 @@
             </a:avLst>
           </a:prstGeom>
           <a:solidFill>
-            <a:srgbClr val="FFFFFF">
+            <a:srgbClr val="12452B">
               <a:alpha val="90000"/>
             </a:srgbClr>
           </a:solidFill>
           <a:ln w="15875">
             <a:solidFill>
-              <a:srgbClr val="2E7D3C"/>
+              <a:srgbClr val="C89C40"/>
             </a:solidFill>
             <a:prstDash val="solid"/>
           </a:ln>
@@ -9022,7 +9022,7 @@
           </a:prstGeom>
           <a:ln w="12700">
             <a:solidFill>
-              <a:srgbClr val="2E7D3C"/>
+              <a:srgbClr val="C89C40"/>
             </a:solidFill>
             <a:prstDash val="solid"/>
           </a:ln>
@@ -9052,11 +9052,11 @@
             </a:avLst>
           </a:prstGeom>
           <a:solidFill>
-            <a:srgbClr val="2E6B3A"/>
+            <a:srgbClr val="358A48"/>
           </a:solidFill>
           <a:ln w="6350">
             <a:solidFill>
-              <a:srgbClr val="2E7D3C"/>
+              <a:srgbClr val="C89C40"/>
             </a:solidFill>
             <a:prstDash val="solid"/>
           </a:ln>
@@ -9135,7 +9135,7 @@
             <a:r>
               <a:rPr lang="en-US" sz="1450" b="1" dirty="0">
                 <a:solidFill>
-                  <a:srgbClr val="241C10"/>
+                  <a:srgbClr val="FFFFFF"/>
                 </a:solidFill>
                 <a:latin typeface="Cambria" pitchFamily="34" charset="0"/>
                 <a:ea typeface="Cambria" pitchFamily="34" charset="-122"/>
@@ -9174,7 +9174,7 @@
             <a:r>
               <a:rPr lang="en-US" sz="1000" dirty="0">
                 <a:solidFill>
-                  <a:srgbClr val="8A7457"/>
+                  <a:srgbClr val="D2E4CE"/>
                 </a:solidFill>
                 <a:latin typeface="Calibri" pitchFamily="34" charset="0"/>
                 <a:ea typeface="Calibri" pitchFamily="34" charset="-122"/>
@@ -9203,13 +9203,13 @@
             </a:avLst>
           </a:prstGeom>
           <a:solidFill>
-            <a:srgbClr val="EAF3EA">
+            <a:srgbClr val="1A5433">
               <a:alpha val="92000"/>
             </a:srgbClr>
           </a:solidFill>
           <a:ln w="9525">
             <a:solidFill>
-              <a:srgbClr val="2E7D3C"/>
+              <a:srgbClr val="C89C40"/>
             </a:solidFill>
             <a:prstDash val="solid"/>
           </a:ln>
@@ -9249,7 +9249,7 @@
             <a:r>
               <a:rPr lang="en-US" sz="750" b="1" kern="0" spc="100" dirty="0">
                 <a:solidFill>
-                  <a:srgbClr val="1F5C3A"/>
+                  <a:srgbClr val="F5CE76"/>
                 </a:solidFill>
                 <a:latin typeface="Calibri" pitchFamily="34" charset="0"/>
                 <a:ea typeface="Calibri" pitchFamily="34" charset="-122"/>
@@ -9288,7 +9288,7 @@
             <a:r>
               <a:rPr lang="en-US" sz="900" dirty="0">
                 <a:solidFill>
-                  <a:srgbClr val="8A7457"/>
+                  <a:srgbClr val="D2E4CE"/>
                 </a:solidFill>
                 <a:latin typeface="Calibri" pitchFamily="34" charset="0"/>
                 <a:ea typeface="Calibri" pitchFamily="34" charset="-122"/>
@@ -9327,7 +9327,7 @@
             <a:r>
               <a:rPr lang="en-US" sz="950" dirty="0">
                 <a:solidFill>
-                  <a:srgbClr val="3A2F1F"/>
+                  <a:srgbClr val="FCF9F0"/>
                 </a:solidFill>
                 <a:latin typeface="Calibri" pitchFamily="34" charset="0"/>
                 <a:ea typeface="Calibri" pitchFamily="34" charset="-122"/>
@@ -9366,7 +9366,7 @@
             <a:r>
               <a:rPr lang="en-US" sz="900" b="1" dirty="0">
                 <a:solidFill>
-                  <a:srgbClr val="1F5C3A"/>
+                  <a:srgbClr val="F5CE76"/>
                 </a:solidFill>
                 <a:latin typeface="Calibri" pitchFamily="34" charset="0"/>
                 <a:ea typeface="Calibri" pitchFamily="34" charset="-122"/>
@@ -9405,7 +9405,7 @@
             <a:r>
               <a:rPr lang="en-US" sz="950" b="1" dirty="0">
                 <a:solidFill>
-                  <a:srgbClr val="1F5C3A"/>
+                  <a:srgbClr val="F5CE76"/>
                 </a:solidFill>
                 <a:latin typeface="Calibri" pitchFamily="34" charset="0"/>
                 <a:ea typeface="Calibri" pitchFamily="34" charset="-122"/>
@@ -9444,7 +9444,7 @@
             <a:r>
               <a:rPr lang="en-US" sz="900" dirty="0">
                 <a:solidFill>
-                  <a:srgbClr val="8A7457"/>
+                  <a:srgbClr val="D2E4CE"/>
                 </a:solidFill>
                 <a:latin typeface="Calibri" pitchFamily="34" charset="0"/>
                 <a:ea typeface="Calibri" pitchFamily="34" charset="-122"/>
@@ -9483,7 +9483,7 @@
             <a:r>
               <a:rPr lang="en-US" sz="950" dirty="0">
                 <a:solidFill>
-                  <a:srgbClr val="3A2F1F"/>
+                  <a:srgbClr val="FCF9F0"/>
                 </a:solidFill>
                 <a:latin typeface="Calibri" pitchFamily="34" charset="0"/>
                 <a:ea typeface="Calibri" pitchFamily="34" charset="-122"/>
@@ -9522,7 +9522,7 @@
             <a:r>
               <a:rPr lang="en-US" sz="900" dirty="0">
                 <a:solidFill>
-                  <a:srgbClr val="8A7457"/>
+                  <a:srgbClr val="D2E4CE"/>
                 </a:solidFill>
                 <a:latin typeface="Calibri" pitchFamily="34" charset="0"/>
                 <a:ea typeface="Calibri" pitchFamily="34" charset="-122"/>
@@ -9561,7 +9561,7 @@
             <a:r>
               <a:rPr lang="en-US" sz="950" dirty="0">
                 <a:solidFill>
-                  <a:srgbClr val="3A2F1F"/>
+                  <a:srgbClr val="FCF9F0"/>
                 </a:solidFill>
                 <a:latin typeface="Calibri" pitchFamily="34" charset="0"/>
                 <a:ea typeface="Calibri" pitchFamily="34" charset="-122"/>
@@ -9600,7 +9600,7 @@
             <a:r>
               <a:rPr lang="en-US" sz="900" dirty="0">
                 <a:solidFill>
-                  <a:srgbClr val="9C8B6E"/>
+                  <a:srgbClr val="C3D7BF"/>
                 </a:solidFill>
                 <a:latin typeface="Calibri" pitchFamily="34" charset="0"/>
                 <a:ea typeface="Calibri" pitchFamily="34" charset="-122"/>

</xml_diff>

<commit_message>
Match the title card to the emerald design used on every other slide
The cover's white copy card broke the deck's visual system. It now uses the
same green card + gold hairline + gold headline treatment as slides 2-5,
so all 5 slides read as one deck. The paddy photo stays sharp and full-frame
behind it.

Co-Authored-By: Claude Opus 5 <noreply@anthropic.com>
Claude-Session: https://claude.ai/code/session_01NDFDM6HpP3f8QTd8UUPgQV
</commit_message>
<xml_diff>
--- a/RTE_Rice_Suppliers.pptx
+++ b/RTE_Rice_Suppliers.pptx
@@ -1021,13 +1021,13 @@
             </a:avLst>
           </a:prstGeom>
           <a:solidFill>
-            <a:srgbClr val="FFFFFF">
-              <a:alpha val="100000"/>
+            <a:srgbClr val="12452B">
+              <a:alpha val="92000"/>
             </a:srgbClr>
           </a:solidFill>
           <a:ln w="15875">
             <a:solidFill>
-              <a:srgbClr val="A87C2A"/>
+              <a:srgbClr val="C89C40"/>
             </a:solidFill>
             <a:prstDash val="solid"/>
           </a:ln>
@@ -1074,7 +1074,7 @@
             <a:r>
               <a:rPr lang="en-US" sz="2700" b="1" kern="0" spc="150" dirty="0">
                 <a:solidFill>
-                  <a:srgbClr val="A5730F"/>
+                  <a:srgbClr val="F5CE76"/>
                 </a:solidFill>
                 <a:latin typeface="Cambria" pitchFamily="34" charset="0"/>
                 <a:ea typeface="Cambria" pitchFamily="34" charset="-122"/>
@@ -1103,7 +1103,7 @@
           <a:noFill/>
           <a:ln w="12700">
             <a:solidFill>
-              <a:srgbClr val="A87C2A"/>
+              <a:srgbClr val="C89C40"/>
             </a:solidFill>
             <a:prstDash val="solid"/>
           </a:ln>
@@ -1131,7 +1131,7 @@
             <a:avLst/>
           </a:prstGeom>
           <a:solidFill>
-            <a:srgbClr val="E0B252"/>
+            <a:srgbClr val="F5CE76"/>
           </a:solidFill>
           <a:ln w="6350">
             <a:solidFill>
@@ -1175,7 +1175,7 @@
             <a:r>
               <a:rPr lang="en-US" sz="1700" dirty="0">
                 <a:solidFill>
-                  <a:srgbClr val="241C10"/>
+                  <a:srgbClr val="FCF9F0"/>
                 </a:solidFill>
                 <a:latin typeface="Calibri" pitchFamily="34" charset="0"/>
                 <a:ea typeface="Calibri" pitchFamily="34" charset="-122"/>
@@ -1214,7 +1214,7 @@
             <a:r>
               <a:rPr lang="en-US" sz="1150" b="1" dirty="0">
                 <a:solidFill>
-                  <a:srgbClr val="241C10"/>
+                  <a:srgbClr val="FFFFFF"/>
                 </a:solidFill>
                 <a:latin typeface="Calibri" pitchFamily="34" charset="0"/>
                 <a:ea typeface="Calibri" pitchFamily="34" charset="-122"/>
@@ -1225,7 +1225,7 @@
             <a:r>
               <a:rPr lang="en-US" sz="1150" dirty="0">
                 <a:solidFill>
-                  <a:srgbClr val="A5730F"/>
+                  <a:srgbClr val="C89C40"/>
                 </a:solidFill>
                 <a:latin typeface="Calibri" pitchFamily="34" charset="0"/>
                 <a:ea typeface="Calibri" pitchFamily="34" charset="-122"/>
@@ -1236,7 +1236,7 @@
             <a:r>
               <a:rPr lang="en-US" sz="1150" b="1" dirty="0">
                 <a:solidFill>
-                  <a:srgbClr val="241C10"/>
+                  <a:srgbClr val="FFFFFF"/>
                 </a:solidFill>
                 <a:latin typeface="Calibri" pitchFamily="34" charset="0"/>
                 <a:ea typeface="Calibri" pitchFamily="34" charset="-122"/>
@@ -1275,7 +1275,7 @@
             <a:r>
               <a:rPr lang="en-US" sz="1150" dirty="0">
                 <a:solidFill>
-                  <a:srgbClr val="8A7457"/>
+                  <a:srgbClr val="D2E4CE"/>
                 </a:solidFill>
                 <a:latin typeface="Calibri" pitchFamily="34" charset="0"/>
                 <a:ea typeface="Calibri" pitchFamily="34" charset="-122"/>

</xml_diff>

<commit_message>
Rebuild the Double Cup slide as a Private-Label-only page
Slide 6 (Single Cup 12x150g) already matched the 4 confirmed SKUs
(Jasmine, Brown Jasmine, Red Jasmine, Rice Berry) - left untouched.

Slide 7 previously mixed two leftover single-cup cards in with a Double
Cup example; replaced it with a dedicated Double Cup 6x(2x125g) page:
- States plainly BSCM has no own-brand double cup - Private Label only
- Lists all 7 flavours from the source sheet, flagging "Jasmine Rice,
  no oil" as unavailable per BSCM's own note (the rest are "w oil")
- Real SPAR Jasmine Rice Cups photo as the private-label reference,
  cropped tighter to read as a clean product shot

Co-Authored-By: Claude Sonnet 5 <noreply@anthropic.com>
Claude-Session: https://claude.ai/code/session_01NDFDM6HpP3f8QTd8UUPgQV
</commit_message>
<xml_diff>
--- a/RTE_Rice_Suppliers.pptx
+++ b/RTE_Rice_Suppliers.pptx
@@ -14,7 +14,7 @@
     <p:sldId xmlns:r="http://schemas.openxmlformats.org/officeDocument/2006/relationships" id="259" r:id="Rfbb40df39bce476e"/>
     <p:sldId xmlns:r="http://schemas.openxmlformats.org/officeDocument/2006/relationships" id="260" r:id="Rbce01309253b447d"/>
     <p:sldId xmlns:r="http://schemas.openxmlformats.org/officeDocument/2006/relationships" id="261" r:id="Rd02b738b12d84961"/>
-    <p:sldId xmlns:r="http://schemas.openxmlformats.org/officeDocument/2006/relationships" id="262" r:id="R0eb9f675fbe54556"/>
+    <p:sldId xmlns:r="http://schemas.openxmlformats.org/officeDocument/2006/relationships" id="263" r:id="rId1"/>
   </p:sldIdLst>
   <p:sldSz cx="12192000" cy="6858000"/>
   <p:notesSz cx="6858000" cy="9144000"/>
@@ -841,95 +841,6 @@
           <a:p xmlns:a="http://schemas.openxmlformats.org/drawingml/2006/main">
             <a:r>
               <a:t>- User instruction — BSCM launched new cup production; cost is intentionally omitted.</a:t>
-            </a:r>
-            <a:endParaRPr/>
-          </a:p>
-        </p:txBody>
-      </p:sp>
-      <p:sp>
-        <p:nvSpPr>
-          <p:cNvPr id="4" name="Slide Number Placeholder 3"/>
-          <p:cNvSpPr>
-            <a:spLocks xmlns:a="http://schemas.openxmlformats.org/drawingml/2006/main" noGrp="1"/>
-          </p:cNvSpPr>
-          <p:nvPr>
-            <p:ph type="sldNum" idx="5"/>
-          </p:nvPr>
-        </p:nvSpPr>
-        <p:spPr/>
-        <p:txBody>
-          <a:bodyPr xmlns:a="http://schemas.openxmlformats.org/drawingml/2006/main"/>
-          <a:lstStyle xmlns:a="http://schemas.openxmlformats.org/drawingml/2006/main"/>
-          <a:p xmlns:a="http://schemas.openxmlformats.org/drawingml/2006/main"/>
-        </p:txBody>
-      </p:sp>
-    </p:spTree>
-  </p:cSld>
-  <p:clrMapOvr>
-    <a:masterClrMapping xmlns:a="http://schemas.openxmlformats.org/drawingml/2006/main"/>
-  </p:clrMapOvr>
-</p:notes>
-</file>
-
-<file path=ppt/notesSlides/notesSlide7.xml><?xml version="1.0" encoding="utf-8"?>
-<p:notes xmlns:p="http://schemas.openxmlformats.org/presentationml/2006/main">
-  <p:cSld>
-    <p:spTree>
-      <p:nvGrpSpPr>
-        <p:cNvPr id="1" name=""/>
-        <p:cNvGrpSpPr/>
-        <p:nvPr/>
-      </p:nvGrpSpPr>
-      <p:grpSpPr>
-        <a:xfrm xmlns:a="http://schemas.openxmlformats.org/drawingml/2006/main"/>
-      </p:grpSpPr>
-      <p:sp>
-        <p:nvSpPr>
-          <p:cNvPr id="2" name="Slide Image Placeholder 1"/>
-          <p:cNvSpPr>
-            <a:spLocks xmlns:a="http://schemas.openxmlformats.org/drawingml/2006/main" noGrp="1"/>
-          </p:cNvSpPr>
-          <p:nvPr>
-            <p:ph type="sldImg" idx="0"/>
-          </p:nvPr>
-        </p:nvSpPr>
-        <p:spPr/>
-      </p:sp>
-      <p:sp>
-        <p:nvSpPr>
-          <p:cNvPr id="3" name="Notes Placeholder 2"/>
-          <p:cNvSpPr>
-            <a:spLocks xmlns:a="http://schemas.openxmlformats.org/drawingml/2006/main" noGrp="1"/>
-          </p:cNvSpPr>
-          <p:nvPr>
-            <p:ph type="body" idx="1"/>
-          </p:nvPr>
-        </p:nvSpPr>
-        <p:spPr/>
-        <p:txBody>
-          <a:bodyPr xmlns:a="http://schemas.openxmlformats.org/drawingml/2006/main"/>
-          <a:lstStyle xmlns:a="http://schemas.openxmlformats.org/drawingml/2006/main"/>
-          <a:p xmlns:a="http://schemas.openxmlformats.org/drawingml/2006/main">
-            <a:r>
-              <a:t>[Sources]</a:t>
-            </a:r>
-            <a:endParaRPr/>
-          </a:p>
-          <a:p xmlns:a="http://schemas.openxmlformats.org/drawingml/2006/main">
-            <a:r>
-              <a:t>- Cup-Photo of Products.pdf — remaining Single Cup products and Double Cup configuration; supplied by the user.</a:t>
-            </a:r>
-            <a:endParaRPr/>
-          </a:p>
-          <a:p xmlns:a="http://schemas.openxmlformats.org/drawingml/2006/main">
-            <a:r>
-              <a:t>- ca90073a-6936-4878-b5fd-b76099408938.png — SPAR Private Label example; supplied by the user.</a:t>
-            </a:r>
-            <a:endParaRPr/>
-          </a:p>
-          <a:p xmlns:a="http://schemas.openxmlformats.org/drawingml/2006/main">
-            <a:r>
-              <a:t>- User instruction — cup and prior pouch assortment may be mixed in one container.</a:t>
             </a:r>
             <a:endParaRPr/>
           </a:p>
@@ -14870,7 +14781,7 @@
     <p:bg>
       <p:bgPr>
         <a:blipFill xmlns:a="http://schemas.openxmlformats.org/drawingml/2006/main" rotWithShape="1">
-          <a:blip xmlns:r="http://schemas.openxmlformats.org/officeDocument/2006/relationships" r:embed="R9794f7d478994cec">
+          <a:blip xmlns:r="http://schemas.openxmlformats.org/officeDocument/2006/relationships" r:embed="R835cd8b4bbcb4311">
             <a:lum/>
           </a:blip>
           <a:srcRect l="0" t="0" r="0" b="0"/>
@@ -14894,7 +14805,7 @@
           <p:cNvPr id="2" name="Text 0">
             <a:extLst xmlns:a="http://schemas.openxmlformats.org/drawingml/2006/main">
               <a:ext uri="{FF2B5EF4-FFF2-40B4-BE49-F238E27FC236}">
-                <a16:creationId xmlns:a16="http://schemas.microsoft.com/office/drawing/2014/main" id="{318C5BA4-D3A1-44C2-B745-30F83BBCCF97}"/>
+                <a16:creationId xmlns:a16="http://schemas.microsoft.com/office/drawing/2014/main" id="{BF77CD9A-0EFB-41E4-BB91-158CD8B97E51}"/>
               </a:ext>
             </a:extLst>
           </p:cNvPr>
@@ -14929,7 +14840,7 @@
                 <a:ea typeface="Calibri"/>
                 <a:cs typeface="Calibri"/>
               </a:rPr>
-              <a:t>BSCM FOODS · CUP / PRIVATE LABEL</a:t>
+              <a:t>BSCM FOODS  ·  DOUBLE CUP</a:t>
             </a:r>
             <a:endParaRPr sz="1100"/>
           </a:p>
@@ -14940,7 +14851,7 @@
           <p:cNvPr id="3" name="Text 1">
             <a:extLst xmlns:a="http://schemas.openxmlformats.org/drawingml/2006/main">
               <a:ext uri="{FF2B5EF4-FFF2-40B4-BE49-F238E27FC236}">
-                <a16:creationId xmlns:a16="http://schemas.microsoft.com/office/drawing/2014/main" id="{380CCB68-F07E-4088-8869-8D3DB6C90508}"/>
+                <a16:creationId xmlns:a16="http://schemas.microsoft.com/office/drawing/2014/main" id="{9496C762-5C3C-4C5E-AE52-4FCFDC0031FD}"/>
               </a:ext>
             </a:extLst>
           </p:cNvPr>
@@ -14975,7 +14886,7 @@
                 <a:ea typeface="Cambria"/>
                 <a:cs typeface="Cambria"/>
               </a:rPr>
-              <a:t>Ready Rice in Plastic Cup — продовження</a:t>
+              <a:t>Ready Rice in Plastic Cup 6 × (2 × 125 г)</a:t>
             </a:r>
             <a:endParaRPr sz="3100"/>
           </a:p>
@@ -14986,7 +14897,7 @@
           <p:cNvPr id="4" name="Text 2">
             <a:extLst xmlns:a="http://schemas.openxmlformats.org/drawingml/2006/main">
               <a:ext uri="{FF2B5EF4-FFF2-40B4-BE49-F238E27FC236}">
-                <a16:creationId xmlns:a16="http://schemas.microsoft.com/office/drawing/2014/main" id="{8EA601D2-50AF-4274-98C3-4894B277423C}"/>
+                <a16:creationId xmlns:a16="http://schemas.microsoft.com/office/drawing/2014/main" id="{477A47AF-CA07-4AD7-9441-ED43883C2405}"/>
               </a:ext>
             </a:extLst>
           </p:cNvPr>
@@ -15021,7 +14932,7 @@
                 <a:ea typeface="Calibri"/>
                 <a:cs typeface="Calibri"/>
               </a:rPr>
-              <a:t>Single Cup 12 × 150 г · Double Cup 6 × (2 × 125 г) · mixed container</a:t>
+              <a:t>Double cup зі sleeve-боксом · доступно тільки як Private Label</a:t>
             </a:r>
             <a:endParaRPr sz="1250"/>
           </a:p>
@@ -15032,7 +14943,7 @@
           <p:cNvPr id="5" name="Shape 3">
             <a:extLst xmlns:a="http://schemas.openxmlformats.org/drawingml/2006/main">
               <a:ext uri="{FF2B5EF4-FFF2-40B4-BE49-F238E27FC236}">
-                <a16:creationId xmlns:a16="http://schemas.microsoft.com/office/drawing/2014/main" id="{760E89EB-DA37-42CB-AC69-91A6CA0EA8B6}"/>
+                <a16:creationId xmlns:a16="http://schemas.microsoft.com/office/drawing/2014/main" id="{F1C3D159-6BBB-4F8D-B9ED-F6496F44B44F}"/>
               </a:ext>
             </a:extLst>
           </p:cNvPr>
@@ -15044,11 +14955,11 @@
         <p:spPr>
           <a:xfrm xmlns:a="http://schemas.openxmlformats.org/drawingml/2006/main">
             <a:off x="566928" y="1536192"/>
-            <a:ext cx="2706624" cy="4626864"/>
+            <a:ext cx="6675120" cy="4626864"/>
           </a:xfrm>
           <a:prstGeom xmlns:a="http://schemas.openxmlformats.org/drawingml/2006/main" prst="roundRect">
             <a:avLst>
-              <a:gd name="adj" fmla="val 4054"/>
+              <a:gd name="adj" fmla="val 2372"/>
             </a:avLst>
           </a:prstGeom>
           <a:solidFill xmlns:a="http://schemas.openxmlformats.org/drawingml/2006/main">
@@ -15080,27 +14991,837 @@
       </p:sp>
       <p:sp>
         <p:nvSpPr>
-          <p:cNvPr id="7" name="Shape 4">
-            <a:extLst xmlns:a="http://schemas.openxmlformats.org/drawingml/2006/main">
-              <a:ext uri="{FF2B5EF4-FFF2-40B4-BE49-F238E27FC236}">
-                <a16:creationId xmlns:a16="http://schemas.microsoft.com/office/drawing/2014/main" id="{030FCABB-62B5-4CCC-AA9F-B4C4F1FAE801}"/>
-              </a:ext>
-            </a:extLst>
-          </p:cNvPr>
-          <p:cNvSpPr>
-            <a:spLocks xmlns:a="http://schemas.openxmlformats.org/drawingml/2006/main" noGrp="1"/>
-          </p:cNvSpPr>
-          <p:nvPr/>
-        </p:nvSpPr>
-        <p:spPr>
-          <a:xfrm xmlns:a="http://schemas.openxmlformats.org/drawingml/2006/main">
-            <a:off x="749808" y="1700784"/>
-            <a:ext cx="2340864" cy="1810512"/>
-          </a:xfrm>
-          <a:prstGeom xmlns:a="http://schemas.openxmlformats.org/drawingml/2006/main" prst="rect">
-            <a:avLst/>
-          </a:prstGeom>
-          <a:ln xmlns:a="http://schemas.openxmlformats.org/drawingml/2006/main" w="12700">
+          <p:cNvPr id="6" name="Text 4">
+            <a:extLst xmlns:a="http://schemas.openxmlformats.org/drawingml/2006/main">
+              <a:ext uri="{FF2B5EF4-FFF2-40B4-BE49-F238E27FC236}">
+                <a16:creationId xmlns:a16="http://schemas.microsoft.com/office/drawing/2014/main" id="{ABB6272E-A3D6-4F20-AF34-CF17DAB68835}"/>
+              </a:ext>
+            </a:extLst>
+          </p:cNvPr>
+          <p:cNvSpPr>
+            <a:spLocks xmlns:a="http://schemas.openxmlformats.org/drawingml/2006/main" noGrp="1"/>
+          </p:cNvSpPr>
+          <p:nvPr/>
+        </p:nvSpPr>
+        <p:spPr>
+          <a:xfrm xmlns:a="http://schemas.openxmlformats.org/drawingml/2006/main">
+            <a:off x="841248" y="1737360"/>
+            <a:ext cx="6126480" cy="310896"/>
+          </a:xfrm>
+          <a:prstGeom xmlns:a="http://schemas.openxmlformats.org/drawingml/2006/main" prst="rect">
+            <a:avLst/>
+          </a:prstGeom>
+          <a:noFill xmlns:a="http://schemas.openxmlformats.org/drawingml/2006/main"/>
+        </p:spPr>
+        <p:txBody>
+          <a:bodyPr xmlns:a="http://schemas.openxmlformats.org/drawingml/2006/main" wrap="square" lIns="0" tIns="0" rIns="0" bIns="0" anchor="ctr"/>
+          <a:lstStyle xmlns:a="http://schemas.openxmlformats.org/drawingml/2006/main"/>
+          <a:p xmlns:a="http://schemas.openxmlformats.org/drawingml/2006/main">
+            <a:pPr marL="0" indent="0">
+              <a:buNone/>
+            </a:pPr>
+            <a:r>
+              <a:rPr sz="1700" b="1">
+                <a:solidFill>
+                  <a:srgbClr val="F5CE76"/>
+                </a:solidFill>
+                <a:latin typeface="Cambria"/>
+                <a:ea typeface="Cambria"/>
+                <a:cs typeface="Cambria"/>
+              </a:rPr>
+              <a:t>Про формат</a:t>
+            </a:r>
+            <a:endParaRPr sz="1700"/>
+          </a:p>
+        </p:txBody>
+      </p:sp>
+      <p:sp>
+        <p:nvSpPr>
+          <p:cNvPr id="7" name="Text 5">
+            <a:extLst xmlns:a="http://schemas.openxmlformats.org/drawingml/2006/main">
+              <a:ext uri="{FF2B5EF4-FFF2-40B4-BE49-F238E27FC236}">
+                <a16:creationId xmlns:a16="http://schemas.microsoft.com/office/drawing/2014/main" id="{F27C41B4-C39E-4BB3-87E3-96451AFDB1CC}"/>
+              </a:ext>
+            </a:extLst>
+          </p:cNvPr>
+          <p:cNvSpPr>
+            <a:spLocks xmlns:a="http://schemas.openxmlformats.org/drawingml/2006/main" noGrp="1"/>
+          </p:cNvSpPr>
+          <p:nvPr/>
+        </p:nvSpPr>
+        <p:spPr>
+          <a:xfrm xmlns:a="http://schemas.openxmlformats.org/drawingml/2006/main">
+            <a:off x="841248" y="2103120"/>
+            <a:ext cx="6126480" cy="868680"/>
+          </a:xfrm>
+          <a:prstGeom xmlns:a="http://schemas.openxmlformats.org/drawingml/2006/main" prst="rect">
+            <a:avLst/>
+          </a:prstGeom>
+          <a:noFill xmlns:a="http://schemas.openxmlformats.org/drawingml/2006/main"/>
+        </p:spPr>
+        <p:txBody>
+          <a:bodyPr xmlns:a="http://schemas.openxmlformats.org/drawingml/2006/main" wrap="square" lIns="0" tIns="0" rIns="0" bIns="0" anchor="ctr"/>
+          <a:lstStyle xmlns:a="http://schemas.openxmlformats.org/drawingml/2006/main"/>
+          <a:p xmlns:a="http://schemas.openxmlformats.org/drawingml/2006/main">
+            <a:pPr marL="0" indent="0">
+              <a:lnSpc>
+                <a:spcPts val="1700"/>
+              </a:lnSpc>
+              <a:buNone/>
+            </a:pPr>
+            <a:r>
+              <a:rPr sz="1200">
+                <a:solidFill>
+                  <a:srgbClr val="FCF9F0"/>
+                </a:solidFill>
+                <a:latin typeface="Calibri"/>
+                <a:ea typeface="Calibri"/>
+                <a:cs typeface="Calibri"/>
+              </a:rPr>
+              <a:t>Власного бренду BSCM у форматі double cup немає — цей формат постачальник випускає виключно під приватною маркою замовника. Sleeve-бокс друкується під дизайн клієнта; приклад нижче — Jasmine Rice Cups для мережі SPAR.</a:t>
+            </a:r>
+            <a:endParaRPr sz="1200"/>
+          </a:p>
+        </p:txBody>
+      </p:sp>
+      <p:sp>
+        <p:nvSpPr>
+          <p:cNvPr id="8" name="Text 6">
+            <a:extLst xmlns:a="http://schemas.openxmlformats.org/drawingml/2006/main">
+              <a:ext uri="{FF2B5EF4-FFF2-40B4-BE49-F238E27FC236}">
+                <a16:creationId xmlns:a16="http://schemas.microsoft.com/office/drawing/2014/main" id="{650D0EC9-3F48-4B23-B62F-2DC20F4CB1E3}"/>
+              </a:ext>
+            </a:extLst>
+          </p:cNvPr>
+          <p:cNvSpPr>
+            <a:spLocks xmlns:a="http://schemas.openxmlformats.org/drawingml/2006/main" noGrp="1"/>
+          </p:cNvSpPr>
+          <p:nvPr/>
+        </p:nvSpPr>
+        <p:spPr>
+          <a:xfrm xmlns:a="http://schemas.openxmlformats.org/drawingml/2006/main">
+            <a:off x="841248" y="3017520"/>
+            <a:ext cx="6126480" cy="310896"/>
+          </a:xfrm>
+          <a:prstGeom xmlns:a="http://schemas.openxmlformats.org/drawingml/2006/main" prst="rect">
+            <a:avLst/>
+          </a:prstGeom>
+          <a:noFill xmlns:a="http://schemas.openxmlformats.org/drawingml/2006/main"/>
+        </p:spPr>
+        <p:txBody>
+          <a:bodyPr xmlns:a="http://schemas.openxmlformats.org/drawingml/2006/main" wrap="square" lIns="0" tIns="0" rIns="0" bIns="0" anchor="ctr"/>
+          <a:lstStyle xmlns:a="http://schemas.openxmlformats.org/drawingml/2006/main"/>
+          <a:p xmlns:a="http://schemas.openxmlformats.org/drawingml/2006/main">
+            <a:pPr marL="0" indent="0">
+              <a:buNone/>
+            </a:pPr>
+            <a:r>
+              <a:rPr sz="1700" b="1">
+                <a:solidFill>
+                  <a:srgbClr val="F5CE76"/>
+                </a:solidFill>
+                <a:latin typeface="Cambria"/>
+                <a:ea typeface="Cambria"/>
+                <a:cs typeface="Cambria"/>
+              </a:rPr>
+              <a:t>Смаки в офері</a:t>
+            </a:r>
+            <a:endParaRPr sz="1700"/>
+          </a:p>
+        </p:txBody>
+      </p:sp>
+      <p:sp>
+        <p:nvSpPr>
+          <p:cNvPr id="9" name="Text 7">
+            <a:extLst xmlns:a="http://schemas.openxmlformats.org/drawingml/2006/main">
+              <a:ext uri="{FF2B5EF4-FFF2-40B4-BE49-F238E27FC236}">
+                <a16:creationId xmlns:a16="http://schemas.microsoft.com/office/drawing/2014/main" id="{7A91FA7F-CF81-4499-8A50-A7DEE4346D83}"/>
+              </a:ext>
+            </a:extLst>
+          </p:cNvPr>
+          <p:cNvSpPr>
+            <a:spLocks xmlns:a="http://schemas.openxmlformats.org/drawingml/2006/main" noGrp="1"/>
+          </p:cNvSpPr>
+          <p:nvPr/>
+        </p:nvSpPr>
+        <p:spPr>
+          <a:xfrm xmlns:a="http://schemas.openxmlformats.org/drawingml/2006/main">
+            <a:off x="841248" y="3383280"/>
+            <a:ext cx="2103120" cy="256032"/>
+          </a:xfrm>
+          <a:prstGeom xmlns:a="http://schemas.openxmlformats.org/drawingml/2006/main" prst="rect">
+            <a:avLst/>
+          </a:prstGeom>
+          <a:noFill xmlns:a="http://schemas.openxmlformats.org/drawingml/2006/main"/>
+        </p:spPr>
+        <p:txBody>
+          <a:bodyPr xmlns:a="http://schemas.openxmlformats.org/drawingml/2006/main" wrap="square" lIns="0" tIns="0" rIns="0" bIns="0" anchor="ctr"/>
+          <a:lstStyle xmlns:a="http://schemas.openxmlformats.org/drawingml/2006/main"/>
+          <a:p xmlns:a="http://schemas.openxmlformats.org/drawingml/2006/main">
+            <a:pPr marL="0" indent="0">
+              <a:buNone/>
+            </a:pPr>
+            <a:r>
+              <a:rPr sz="1050">
+                <a:solidFill>
+                  <a:srgbClr val="D2E4CE"/>
+                </a:solidFill>
+                <a:latin typeface="Calibri"/>
+                <a:ea typeface="Calibri"/>
+                <a:cs typeface="Calibri"/>
+              </a:rPr>
+              <a:t>Jasmine Rice, no oil</a:t>
+            </a:r>
+            <a:endParaRPr sz="1050"/>
+          </a:p>
+        </p:txBody>
+      </p:sp>
+      <p:sp>
+        <p:nvSpPr>
+          <p:cNvPr id="10" name="Text 8">
+            <a:extLst xmlns:a="http://schemas.openxmlformats.org/drawingml/2006/main">
+              <a:ext uri="{FF2B5EF4-FFF2-40B4-BE49-F238E27FC236}">
+                <a16:creationId xmlns:a16="http://schemas.microsoft.com/office/drawing/2014/main" id="{BE8A5288-4469-45DA-BAD0-F665517C1E65}"/>
+              </a:ext>
+            </a:extLst>
+          </p:cNvPr>
+          <p:cNvSpPr>
+            <a:spLocks xmlns:a="http://schemas.openxmlformats.org/drawingml/2006/main" noGrp="1"/>
+          </p:cNvSpPr>
+          <p:nvPr/>
+        </p:nvSpPr>
+        <p:spPr>
+          <a:xfrm xmlns:a="http://schemas.openxmlformats.org/drawingml/2006/main">
+            <a:off x="2971800" y="3383280"/>
+            <a:ext cx="4023360" cy="256032"/>
+          </a:xfrm>
+          <a:prstGeom xmlns:a="http://schemas.openxmlformats.org/drawingml/2006/main" prst="rect">
+            <a:avLst/>
+          </a:prstGeom>
+          <a:noFill xmlns:a="http://schemas.openxmlformats.org/drawingml/2006/main"/>
+        </p:spPr>
+        <p:txBody>
+          <a:bodyPr xmlns:a="http://schemas.openxmlformats.org/drawingml/2006/main" wrap="square" lIns="0" tIns="0" rIns="0" bIns="0" anchor="ctr"/>
+          <a:lstStyle xmlns:a="http://schemas.openxmlformats.org/drawingml/2006/main"/>
+          <a:p xmlns:a="http://schemas.openxmlformats.org/drawingml/2006/main">
+            <a:pPr marL="0" indent="0">
+              <a:buNone/>
+            </a:pPr>
+            <a:r>
+              <a:rPr sz="1150" b="1">
+                <a:solidFill>
+                  <a:srgbClr val="FCF9F0"/>
+                </a:solidFill>
+                <a:latin typeface="Calibri"/>
+                <a:ea typeface="Calibri"/>
+                <a:cs typeface="Calibri"/>
+              </a:rPr>
+              <a:t>немає в PL</a:t>
+            </a:r>
+            <a:endParaRPr sz="1150"/>
+          </a:p>
+        </p:txBody>
+      </p:sp>
+      <p:sp>
+        <p:nvSpPr>
+          <p:cNvPr id="11" name="Text 9">
+            <a:extLst xmlns:a="http://schemas.openxmlformats.org/drawingml/2006/main">
+              <a:ext uri="{FF2B5EF4-FFF2-40B4-BE49-F238E27FC236}">
+                <a16:creationId xmlns:a16="http://schemas.microsoft.com/office/drawing/2014/main" id="{FCACD5D8-D338-4EA5-B23F-C319A9D0F23D}"/>
+              </a:ext>
+            </a:extLst>
+          </p:cNvPr>
+          <p:cNvSpPr>
+            <a:spLocks xmlns:a="http://schemas.openxmlformats.org/drawingml/2006/main" noGrp="1"/>
+          </p:cNvSpPr>
+          <p:nvPr/>
+        </p:nvSpPr>
+        <p:spPr>
+          <a:xfrm xmlns:a="http://schemas.openxmlformats.org/drawingml/2006/main">
+            <a:off x="841248" y="3717036"/>
+            <a:ext cx="2103120" cy="256032"/>
+          </a:xfrm>
+          <a:prstGeom xmlns:a="http://schemas.openxmlformats.org/drawingml/2006/main" prst="rect">
+            <a:avLst/>
+          </a:prstGeom>
+          <a:noFill xmlns:a="http://schemas.openxmlformats.org/drawingml/2006/main"/>
+        </p:spPr>
+        <p:txBody>
+          <a:bodyPr xmlns:a="http://schemas.openxmlformats.org/drawingml/2006/main" wrap="square" lIns="0" tIns="0" rIns="0" bIns="0" anchor="ctr"/>
+          <a:lstStyle xmlns:a="http://schemas.openxmlformats.org/drawingml/2006/main"/>
+          <a:p xmlns:a="http://schemas.openxmlformats.org/drawingml/2006/main">
+            <a:pPr marL="0" indent="0">
+              <a:buNone/>
+            </a:pPr>
+            <a:r>
+              <a:rPr sz="1050">
+                <a:solidFill>
+                  <a:srgbClr val="D2E4CE"/>
+                </a:solidFill>
+                <a:latin typeface="Calibri"/>
+                <a:ea typeface="Calibri"/>
+                <a:cs typeface="Calibri"/>
+              </a:rPr>
+              <a:t>Jasmine Rice, w oil</a:t>
+            </a:r>
+            <a:endParaRPr sz="1050"/>
+          </a:p>
+        </p:txBody>
+      </p:sp>
+      <p:sp>
+        <p:nvSpPr>
+          <p:cNvPr id="12" name="Text 10">
+            <a:extLst xmlns:a="http://schemas.openxmlformats.org/drawingml/2006/main">
+              <a:ext uri="{FF2B5EF4-FFF2-40B4-BE49-F238E27FC236}">
+                <a16:creationId xmlns:a16="http://schemas.microsoft.com/office/drawing/2014/main" id="{818D73A6-5619-40CD-864C-164E337887CE}"/>
+              </a:ext>
+            </a:extLst>
+          </p:cNvPr>
+          <p:cNvSpPr>
+            <a:spLocks xmlns:a="http://schemas.openxmlformats.org/drawingml/2006/main" noGrp="1"/>
+          </p:cNvSpPr>
+          <p:nvPr/>
+        </p:nvSpPr>
+        <p:spPr>
+          <a:xfrm xmlns:a="http://schemas.openxmlformats.org/drawingml/2006/main">
+            <a:off x="2971800" y="3717036"/>
+            <a:ext cx="4023360" cy="256032"/>
+          </a:xfrm>
+          <a:prstGeom xmlns:a="http://schemas.openxmlformats.org/drawingml/2006/main" prst="rect">
+            <a:avLst/>
+          </a:prstGeom>
+          <a:noFill xmlns:a="http://schemas.openxmlformats.org/drawingml/2006/main"/>
+        </p:spPr>
+        <p:txBody>
+          <a:bodyPr xmlns:a="http://schemas.openxmlformats.org/drawingml/2006/main" wrap="square" lIns="0" tIns="0" rIns="0" bIns="0" anchor="ctr"/>
+          <a:lstStyle xmlns:a="http://schemas.openxmlformats.org/drawingml/2006/main"/>
+          <a:p xmlns:a="http://schemas.openxmlformats.org/drawingml/2006/main">
+            <a:pPr marL="0" indent="0">
+              <a:buNone/>
+            </a:pPr>
+            <a:r>
+              <a:rPr sz="1150" b="1">
+                <a:solidFill>
+                  <a:srgbClr val="FCF9F0"/>
+                </a:solidFill>
+                <a:latin typeface="Calibri"/>
+                <a:ea typeface="Calibri"/>
+                <a:cs typeface="Calibri"/>
+              </a:rPr>
+              <a:t>доступно</a:t>
+            </a:r>
+            <a:endParaRPr sz="1150"/>
+          </a:p>
+        </p:txBody>
+      </p:sp>
+      <p:sp>
+        <p:nvSpPr>
+          <p:cNvPr id="13" name="Text 11">
+            <a:extLst xmlns:a="http://schemas.openxmlformats.org/drawingml/2006/main">
+              <a:ext uri="{FF2B5EF4-FFF2-40B4-BE49-F238E27FC236}">
+                <a16:creationId xmlns:a16="http://schemas.microsoft.com/office/drawing/2014/main" id="{1B17E25C-EAC6-44DA-BED1-8DA3C384AB1F}"/>
+              </a:ext>
+            </a:extLst>
+          </p:cNvPr>
+          <p:cNvSpPr>
+            <a:spLocks xmlns:a="http://schemas.openxmlformats.org/drawingml/2006/main" noGrp="1"/>
+          </p:cNvSpPr>
+          <p:nvPr/>
+        </p:nvSpPr>
+        <p:spPr>
+          <a:xfrm xmlns:a="http://schemas.openxmlformats.org/drawingml/2006/main">
+            <a:off x="841248" y="4050792"/>
+            <a:ext cx="2103120" cy="256032"/>
+          </a:xfrm>
+          <a:prstGeom xmlns:a="http://schemas.openxmlformats.org/drawingml/2006/main" prst="rect">
+            <a:avLst/>
+          </a:prstGeom>
+          <a:noFill xmlns:a="http://schemas.openxmlformats.org/drawingml/2006/main"/>
+        </p:spPr>
+        <p:txBody>
+          <a:bodyPr xmlns:a="http://schemas.openxmlformats.org/drawingml/2006/main" wrap="square" lIns="0" tIns="0" rIns="0" bIns="0" anchor="ctr"/>
+          <a:lstStyle xmlns:a="http://schemas.openxmlformats.org/drawingml/2006/main"/>
+          <a:p xmlns:a="http://schemas.openxmlformats.org/drawingml/2006/main">
+            <a:pPr marL="0" indent="0">
+              <a:buNone/>
+            </a:pPr>
+            <a:r>
+              <a:rPr sz="1050">
+                <a:solidFill>
+                  <a:srgbClr val="D2E4CE"/>
+                </a:solidFill>
+                <a:latin typeface="Calibri"/>
+                <a:ea typeface="Calibri"/>
+                <a:cs typeface="Calibri"/>
+              </a:rPr>
+              <a:t>Jasmine Rice (Pathum), w oil</a:t>
+            </a:r>
+            <a:endParaRPr sz="1050"/>
+          </a:p>
+        </p:txBody>
+      </p:sp>
+      <p:sp>
+        <p:nvSpPr>
+          <p:cNvPr id="14" name="Text 12">
+            <a:extLst xmlns:a="http://schemas.openxmlformats.org/drawingml/2006/main">
+              <a:ext uri="{FF2B5EF4-FFF2-40B4-BE49-F238E27FC236}">
+                <a16:creationId xmlns:a16="http://schemas.microsoft.com/office/drawing/2014/main" id="{1ACB90C5-BF37-41D9-8DC3-D21E41BC119E}"/>
+              </a:ext>
+            </a:extLst>
+          </p:cNvPr>
+          <p:cNvSpPr>
+            <a:spLocks xmlns:a="http://schemas.openxmlformats.org/drawingml/2006/main" noGrp="1"/>
+          </p:cNvSpPr>
+          <p:nvPr/>
+        </p:nvSpPr>
+        <p:spPr>
+          <a:xfrm xmlns:a="http://schemas.openxmlformats.org/drawingml/2006/main">
+            <a:off x="2971800" y="4050792"/>
+            <a:ext cx="4023360" cy="256032"/>
+          </a:xfrm>
+          <a:prstGeom xmlns:a="http://schemas.openxmlformats.org/drawingml/2006/main" prst="rect">
+            <a:avLst/>
+          </a:prstGeom>
+          <a:noFill xmlns:a="http://schemas.openxmlformats.org/drawingml/2006/main"/>
+        </p:spPr>
+        <p:txBody>
+          <a:bodyPr xmlns:a="http://schemas.openxmlformats.org/drawingml/2006/main" wrap="square" lIns="0" tIns="0" rIns="0" bIns="0" anchor="ctr"/>
+          <a:lstStyle xmlns:a="http://schemas.openxmlformats.org/drawingml/2006/main"/>
+          <a:p xmlns:a="http://schemas.openxmlformats.org/drawingml/2006/main">
+            <a:pPr marL="0" indent="0">
+              <a:buNone/>
+            </a:pPr>
+            <a:r>
+              <a:rPr sz="1150" b="1">
+                <a:solidFill>
+                  <a:srgbClr val="FCF9F0"/>
+                </a:solidFill>
+                <a:latin typeface="Calibri"/>
+                <a:ea typeface="Calibri"/>
+                <a:cs typeface="Calibri"/>
+              </a:rPr>
+              <a:t>доступно</a:t>
+            </a:r>
+            <a:endParaRPr sz="1150"/>
+          </a:p>
+        </p:txBody>
+      </p:sp>
+      <p:sp>
+        <p:nvSpPr>
+          <p:cNvPr id="15" name="Text 13">
+            <a:extLst xmlns:a="http://schemas.openxmlformats.org/drawingml/2006/main">
+              <a:ext uri="{FF2B5EF4-FFF2-40B4-BE49-F238E27FC236}">
+                <a16:creationId xmlns:a16="http://schemas.microsoft.com/office/drawing/2014/main" id="{61BC70C4-0C92-435A-9487-D75013A4A699}"/>
+              </a:ext>
+            </a:extLst>
+          </p:cNvPr>
+          <p:cNvSpPr>
+            <a:spLocks xmlns:a="http://schemas.openxmlformats.org/drawingml/2006/main" noGrp="1"/>
+          </p:cNvSpPr>
+          <p:nvPr/>
+        </p:nvSpPr>
+        <p:spPr>
+          <a:xfrm xmlns:a="http://schemas.openxmlformats.org/drawingml/2006/main">
+            <a:off x="841248" y="4384548"/>
+            <a:ext cx="2103120" cy="256032"/>
+          </a:xfrm>
+          <a:prstGeom xmlns:a="http://schemas.openxmlformats.org/drawingml/2006/main" prst="rect">
+            <a:avLst/>
+          </a:prstGeom>
+          <a:noFill xmlns:a="http://schemas.openxmlformats.org/drawingml/2006/main"/>
+        </p:spPr>
+        <p:txBody>
+          <a:bodyPr xmlns:a="http://schemas.openxmlformats.org/drawingml/2006/main" wrap="square" lIns="0" tIns="0" rIns="0" bIns="0" anchor="ctr"/>
+          <a:lstStyle xmlns:a="http://schemas.openxmlformats.org/drawingml/2006/main"/>
+          <a:p xmlns:a="http://schemas.openxmlformats.org/drawingml/2006/main">
+            <a:pPr marL="0" indent="0">
+              <a:buNone/>
+            </a:pPr>
+            <a:r>
+              <a:rPr sz="1050">
+                <a:solidFill>
+                  <a:srgbClr val="D2E4CE"/>
+                </a:solidFill>
+                <a:latin typeface="Calibri"/>
+                <a:ea typeface="Calibri"/>
+                <a:cs typeface="Calibri"/>
+              </a:rPr>
+              <a:t>Brown Jasmine Rice, w oil</a:t>
+            </a:r>
+            <a:endParaRPr sz="1050"/>
+          </a:p>
+        </p:txBody>
+      </p:sp>
+      <p:sp>
+        <p:nvSpPr>
+          <p:cNvPr id="16" name="Text 14">
+            <a:extLst xmlns:a="http://schemas.openxmlformats.org/drawingml/2006/main">
+              <a:ext uri="{FF2B5EF4-FFF2-40B4-BE49-F238E27FC236}">
+                <a16:creationId xmlns:a16="http://schemas.microsoft.com/office/drawing/2014/main" id="{3F159060-DCDF-44CC-8B6D-02E8ED33BA8F}"/>
+              </a:ext>
+            </a:extLst>
+          </p:cNvPr>
+          <p:cNvSpPr>
+            <a:spLocks xmlns:a="http://schemas.openxmlformats.org/drawingml/2006/main" noGrp="1"/>
+          </p:cNvSpPr>
+          <p:nvPr/>
+        </p:nvSpPr>
+        <p:spPr>
+          <a:xfrm xmlns:a="http://schemas.openxmlformats.org/drawingml/2006/main">
+            <a:off x="2971800" y="4384548"/>
+            <a:ext cx="4023360" cy="256032"/>
+          </a:xfrm>
+          <a:prstGeom xmlns:a="http://schemas.openxmlformats.org/drawingml/2006/main" prst="rect">
+            <a:avLst/>
+          </a:prstGeom>
+          <a:noFill xmlns:a="http://schemas.openxmlformats.org/drawingml/2006/main"/>
+        </p:spPr>
+        <p:txBody>
+          <a:bodyPr xmlns:a="http://schemas.openxmlformats.org/drawingml/2006/main" wrap="square" lIns="0" tIns="0" rIns="0" bIns="0" anchor="ctr"/>
+          <a:lstStyle xmlns:a="http://schemas.openxmlformats.org/drawingml/2006/main"/>
+          <a:p xmlns:a="http://schemas.openxmlformats.org/drawingml/2006/main">
+            <a:pPr marL="0" indent="0">
+              <a:buNone/>
+            </a:pPr>
+            <a:r>
+              <a:rPr sz="1150" b="1">
+                <a:solidFill>
+                  <a:srgbClr val="FCF9F0"/>
+                </a:solidFill>
+                <a:latin typeface="Calibri"/>
+                <a:ea typeface="Calibri"/>
+                <a:cs typeface="Calibri"/>
+              </a:rPr>
+              <a:t>доступно</a:t>
+            </a:r>
+            <a:endParaRPr sz="1150"/>
+          </a:p>
+        </p:txBody>
+      </p:sp>
+      <p:sp>
+        <p:nvSpPr>
+          <p:cNvPr id="17" name="Text 15">
+            <a:extLst xmlns:a="http://schemas.openxmlformats.org/drawingml/2006/main">
+              <a:ext uri="{FF2B5EF4-FFF2-40B4-BE49-F238E27FC236}">
+                <a16:creationId xmlns:a16="http://schemas.microsoft.com/office/drawing/2014/main" id="{387B55C1-5453-4641-8FEE-2A2600E80415}"/>
+              </a:ext>
+            </a:extLst>
+          </p:cNvPr>
+          <p:cNvSpPr>
+            <a:spLocks xmlns:a="http://schemas.openxmlformats.org/drawingml/2006/main" noGrp="1"/>
+          </p:cNvSpPr>
+          <p:nvPr/>
+        </p:nvSpPr>
+        <p:spPr>
+          <a:xfrm xmlns:a="http://schemas.openxmlformats.org/drawingml/2006/main">
+            <a:off x="841248" y="4718304"/>
+            <a:ext cx="2103120" cy="256032"/>
+          </a:xfrm>
+          <a:prstGeom xmlns:a="http://schemas.openxmlformats.org/drawingml/2006/main" prst="rect">
+            <a:avLst/>
+          </a:prstGeom>
+          <a:noFill xmlns:a="http://schemas.openxmlformats.org/drawingml/2006/main"/>
+        </p:spPr>
+        <p:txBody>
+          <a:bodyPr xmlns:a="http://schemas.openxmlformats.org/drawingml/2006/main" wrap="square" lIns="0" tIns="0" rIns="0" bIns="0" anchor="ctr"/>
+          <a:lstStyle xmlns:a="http://schemas.openxmlformats.org/drawingml/2006/main"/>
+          <a:p xmlns:a="http://schemas.openxmlformats.org/drawingml/2006/main">
+            <a:pPr marL="0" indent="0">
+              <a:buNone/>
+            </a:pPr>
+            <a:r>
+              <a:rPr sz="1050">
+                <a:solidFill>
+                  <a:srgbClr val="D2E4CE"/>
+                </a:solidFill>
+                <a:latin typeface="Calibri"/>
+                <a:ea typeface="Calibri"/>
+                <a:cs typeface="Calibri"/>
+              </a:rPr>
+              <a:t>Brown Rice, w oil</a:t>
+            </a:r>
+            <a:endParaRPr sz="1050"/>
+          </a:p>
+        </p:txBody>
+      </p:sp>
+      <p:sp>
+        <p:nvSpPr>
+          <p:cNvPr id="18" name="Text 16">
+            <a:extLst xmlns:a="http://schemas.openxmlformats.org/drawingml/2006/main">
+              <a:ext uri="{FF2B5EF4-FFF2-40B4-BE49-F238E27FC236}">
+                <a16:creationId xmlns:a16="http://schemas.microsoft.com/office/drawing/2014/main" id="{E5BCD84D-F4E9-40F7-AA7D-85E5A9A7C865}"/>
+              </a:ext>
+            </a:extLst>
+          </p:cNvPr>
+          <p:cNvSpPr>
+            <a:spLocks xmlns:a="http://schemas.openxmlformats.org/drawingml/2006/main" noGrp="1"/>
+          </p:cNvSpPr>
+          <p:nvPr/>
+        </p:nvSpPr>
+        <p:spPr>
+          <a:xfrm xmlns:a="http://schemas.openxmlformats.org/drawingml/2006/main">
+            <a:off x="2971800" y="4718304"/>
+            <a:ext cx="4023360" cy="256032"/>
+          </a:xfrm>
+          <a:prstGeom xmlns:a="http://schemas.openxmlformats.org/drawingml/2006/main" prst="rect">
+            <a:avLst/>
+          </a:prstGeom>
+          <a:noFill xmlns:a="http://schemas.openxmlformats.org/drawingml/2006/main"/>
+        </p:spPr>
+        <p:txBody>
+          <a:bodyPr xmlns:a="http://schemas.openxmlformats.org/drawingml/2006/main" wrap="square" lIns="0" tIns="0" rIns="0" bIns="0" anchor="ctr"/>
+          <a:lstStyle xmlns:a="http://schemas.openxmlformats.org/drawingml/2006/main"/>
+          <a:p xmlns:a="http://schemas.openxmlformats.org/drawingml/2006/main">
+            <a:pPr marL="0" indent="0">
+              <a:buNone/>
+            </a:pPr>
+            <a:r>
+              <a:rPr sz="1150" b="1">
+                <a:solidFill>
+                  <a:srgbClr val="FCF9F0"/>
+                </a:solidFill>
+                <a:latin typeface="Calibri"/>
+                <a:ea typeface="Calibri"/>
+                <a:cs typeface="Calibri"/>
+              </a:rPr>
+              <a:t>доступно</a:t>
+            </a:r>
+            <a:endParaRPr sz="1150"/>
+          </a:p>
+        </p:txBody>
+      </p:sp>
+      <p:sp>
+        <p:nvSpPr>
+          <p:cNvPr id="19" name="Text 17">
+            <a:extLst xmlns:a="http://schemas.openxmlformats.org/drawingml/2006/main">
+              <a:ext uri="{FF2B5EF4-FFF2-40B4-BE49-F238E27FC236}">
+                <a16:creationId xmlns:a16="http://schemas.microsoft.com/office/drawing/2014/main" id="{9CD79870-7EED-40F1-B03F-865D47193057}"/>
+              </a:ext>
+            </a:extLst>
+          </p:cNvPr>
+          <p:cNvSpPr>
+            <a:spLocks xmlns:a="http://schemas.openxmlformats.org/drawingml/2006/main" noGrp="1"/>
+          </p:cNvSpPr>
+          <p:nvPr/>
+        </p:nvSpPr>
+        <p:spPr>
+          <a:xfrm xmlns:a="http://schemas.openxmlformats.org/drawingml/2006/main">
+            <a:off x="841248" y="5052060"/>
+            <a:ext cx="2103120" cy="256032"/>
+          </a:xfrm>
+          <a:prstGeom xmlns:a="http://schemas.openxmlformats.org/drawingml/2006/main" prst="rect">
+            <a:avLst/>
+          </a:prstGeom>
+          <a:noFill xmlns:a="http://schemas.openxmlformats.org/drawingml/2006/main"/>
+        </p:spPr>
+        <p:txBody>
+          <a:bodyPr xmlns:a="http://schemas.openxmlformats.org/drawingml/2006/main" wrap="square" lIns="0" tIns="0" rIns="0" bIns="0" anchor="ctr"/>
+          <a:lstStyle xmlns:a="http://schemas.openxmlformats.org/drawingml/2006/main"/>
+          <a:p xmlns:a="http://schemas.openxmlformats.org/drawingml/2006/main">
+            <a:pPr marL="0" indent="0">
+              <a:buNone/>
+            </a:pPr>
+            <a:r>
+              <a:rPr sz="1050">
+                <a:solidFill>
+                  <a:srgbClr val="D2E4CE"/>
+                </a:solidFill>
+                <a:latin typeface="Calibri"/>
+                <a:ea typeface="Calibri"/>
+                <a:cs typeface="Calibri"/>
+              </a:rPr>
+              <a:t>Basmati Rice*, w oil</a:t>
+            </a:r>
+            <a:endParaRPr sz="1050"/>
+          </a:p>
+        </p:txBody>
+      </p:sp>
+      <p:sp>
+        <p:nvSpPr>
+          <p:cNvPr id="20" name="Text 18">
+            <a:extLst xmlns:a="http://schemas.openxmlformats.org/drawingml/2006/main">
+              <a:ext uri="{FF2B5EF4-FFF2-40B4-BE49-F238E27FC236}">
+                <a16:creationId xmlns:a16="http://schemas.microsoft.com/office/drawing/2014/main" id="{9696F0F8-6388-458A-9A6E-BD09F3ACBA30}"/>
+              </a:ext>
+            </a:extLst>
+          </p:cNvPr>
+          <p:cNvSpPr>
+            <a:spLocks xmlns:a="http://schemas.openxmlformats.org/drawingml/2006/main" noGrp="1"/>
+          </p:cNvSpPr>
+          <p:nvPr/>
+        </p:nvSpPr>
+        <p:spPr>
+          <a:xfrm xmlns:a="http://schemas.openxmlformats.org/drawingml/2006/main">
+            <a:off x="2971800" y="5052060"/>
+            <a:ext cx="4023360" cy="256032"/>
+          </a:xfrm>
+          <a:prstGeom xmlns:a="http://schemas.openxmlformats.org/drawingml/2006/main" prst="rect">
+            <a:avLst/>
+          </a:prstGeom>
+          <a:noFill xmlns:a="http://schemas.openxmlformats.org/drawingml/2006/main"/>
+        </p:spPr>
+        <p:txBody>
+          <a:bodyPr xmlns:a="http://schemas.openxmlformats.org/drawingml/2006/main" wrap="square" lIns="0" tIns="0" rIns="0" bIns="0" anchor="ctr"/>
+          <a:lstStyle xmlns:a="http://schemas.openxmlformats.org/drawingml/2006/main"/>
+          <a:p xmlns:a="http://schemas.openxmlformats.org/drawingml/2006/main">
+            <a:pPr marL="0" indent="0">
+              <a:buNone/>
+            </a:pPr>
+            <a:r>
+              <a:rPr sz="1150" b="1">
+                <a:solidFill>
+                  <a:srgbClr val="FCF9F0"/>
+                </a:solidFill>
+                <a:latin typeface="Calibri"/>
+                <a:ea typeface="Calibri"/>
+                <a:cs typeface="Calibri"/>
+              </a:rPr>
+              <a:t>доступно</a:t>
+            </a:r>
+            <a:endParaRPr sz="1150"/>
+          </a:p>
+        </p:txBody>
+      </p:sp>
+      <p:sp>
+        <p:nvSpPr>
+          <p:cNvPr id="21" name="Text 19">
+            <a:extLst xmlns:a="http://schemas.openxmlformats.org/drawingml/2006/main">
+              <a:ext uri="{FF2B5EF4-FFF2-40B4-BE49-F238E27FC236}">
+                <a16:creationId xmlns:a16="http://schemas.microsoft.com/office/drawing/2014/main" id="{13A8E69A-5D22-455F-8007-BE2ECE9342F0}"/>
+              </a:ext>
+            </a:extLst>
+          </p:cNvPr>
+          <p:cNvSpPr>
+            <a:spLocks xmlns:a="http://schemas.openxmlformats.org/drawingml/2006/main" noGrp="1"/>
+          </p:cNvSpPr>
+          <p:nvPr/>
+        </p:nvSpPr>
+        <p:spPr>
+          <a:xfrm xmlns:a="http://schemas.openxmlformats.org/drawingml/2006/main">
+            <a:off x="841248" y="5385816"/>
+            <a:ext cx="2103120" cy="256032"/>
+          </a:xfrm>
+          <a:prstGeom xmlns:a="http://schemas.openxmlformats.org/drawingml/2006/main" prst="rect">
+            <a:avLst/>
+          </a:prstGeom>
+          <a:noFill xmlns:a="http://schemas.openxmlformats.org/drawingml/2006/main"/>
+        </p:spPr>
+        <p:txBody>
+          <a:bodyPr xmlns:a="http://schemas.openxmlformats.org/drawingml/2006/main" wrap="square" lIns="0" tIns="0" rIns="0" bIns="0" anchor="ctr"/>
+          <a:lstStyle xmlns:a="http://schemas.openxmlformats.org/drawingml/2006/main"/>
+          <a:p xmlns:a="http://schemas.openxmlformats.org/drawingml/2006/main">
+            <a:pPr marL="0" indent="0">
+              <a:buNone/>
+            </a:pPr>
+            <a:r>
+              <a:rPr sz="1050">
+                <a:solidFill>
+                  <a:srgbClr val="D2E4CE"/>
+                </a:solidFill>
+                <a:latin typeface="Calibri"/>
+                <a:ea typeface="Calibri"/>
+                <a:cs typeface="Calibri"/>
+              </a:rPr>
+              <a:t>Long Grain, w oil</a:t>
+            </a:r>
+            <a:endParaRPr sz="1050"/>
+          </a:p>
+        </p:txBody>
+      </p:sp>
+      <p:sp>
+        <p:nvSpPr>
+          <p:cNvPr id="22" name="Text 20">
+            <a:extLst xmlns:a="http://schemas.openxmlformats.org/drawingml/2006/main">
+              <a:ext uri="{FF2B5EF4-FFF2-40B4-BE49-F238E27FC236}">
+                <a16:creationId xmlns:a16="http://schemas.microsoft.com/office/drawing/2014/main" id="{0F71CE83-5380-4313-A831-A097BEC1C816}"/>
+              </a:ext>
+            </a:extLst>
+          </p:cNvPr>
+          <p:cNvSpPr>
+            <a:spLocks xmlns:a="http://schemas.openxmlformats.org/drawingml/2006/main" noGrp="1"/>
+          </p:cNvSpPr>
+          <p:nvPr/>
+        </p:nvSpPr>
+        <p:spPr>
+          <a:xfrm xmlns:a="http://schemas.openxmlformats.org/drawingml/2006/main">
+            <a:off x="2971800" y="5385816"/>
+            <a:ext cx="4023360" cy="256032"/>
+          </a:xfrm>
+          <a:prstGeom xmlns:a="http://schemas.openxmlformats.org/drawingml/2006/main" prst="rect">
+            <a:avLst/>
+          </a:prstGeom>
+          <a:noFill xmlns:a="http://schemas.openxmlformats.org/drawingml/2006/main"/>
+        </p:spPr>
+        <p:txBody>
+          <a:bodyPr xmlns:a="http://schemas.openxmlformats.org/drawingml/2006/main" wrap="square" lIns="0" tIns="0" rIns="0" bIns="0" anchor="ctr"/>
+          <a:lstStyle xmlns:a="http://schemas.openxmlformats.org/drawingml/2006/main"/>
+          <a:p xmlns:a="http://schemas.openxmlformats.org/drawingml/2006/main">
+            <a:pPr marL="0" indent="0">
+              <a:buNone/>
+            </a:pPr>
+            <a:r>
+              <a:rPr sz="1150" b="1">
+                <a:solidFill>
+                  <a:srgbClr val="FCF9F0"/>
+                </a:solidFill>
+                <a:latin typeface="Calibri"/>
+                <a:ea typeface="Calibri"/>
+                <a:cs typeface="Calibri"/>
+              </a:rPr>
+              <a:t>доступно</a:t>
+            </a:r>
+            <a:endParaRPr sz="1150"/>
+          </a:p>
+        </p:txBody>
+      </p:sp>
+      <p:pic>
+        <p:nvPicPr>
+          <p:cNvPr id="61" name="Picture 34"/>
+          <p:cNvPicPr>
+            <a:picLocks xmlns:a="http://schemas.openxmlformats.org/drawingml/2006/main" noChangeAspect="1"/>
+          </p:cNvPicPr>
+          <p:nvPr/>
+        </p:nvPicPr>
+        <p:blipFill>
+          <a:blip xmlns:r="http://schemas.openxmlformats.org/officeDocument/2006/relationships" xmlns:a="http://schemas.openxmlformats.org/drawingml/2006/main" r:embed="R5f5ac99bb7944fca"/>
+          <a:srcRect xmlns:a="http://schemas.openxmlformats.org/drawingml/2006/main"/>
+          <a:stretch xmlns:a="http://schemas.openxmlformats.org/drawingml/2006/main">
+            <a:fillRect l="0" t="0" r="0" b="0"/>
+          </a:stretch>
+        </p:blipFill>
+        <p:spPr>
+          <a:xfrm xmlns:a="http://schemas.openxmlformats.org/drawingml/2006/main">
+            <a:off x="7534656" y="1536192"/>
+            <a:ext cx="4096512" cy="2834640"/>
+          </a:xfrm>
+          <a:prstGeom xmlns:a="http://schemas.openxmlformats.org/drawingml/2006/main" prst="roundRect">
+            <a:avLst/>
+          </a:prstGeom>
+        </p:spPr>
+      </p:pic>
+      <p:sp>
+        <p:nvSpPr>
+          <p:cNvPr id="24" name="Shape 21">
+            <a:extLst xmlns:a="http://schemas.openxmlformats.org/drawingml/2006/main">
+              <a:ext uri="{FF2B5EF4-FFF2-40B4-BE49-F238E27FC236}">
+                <a16:creationId xmlns:a16="http://schemas.microsoft.com/office/drawing/2014/main" id="{7366CF28-1B6D-49C3-946A-65C3FD0C8631}"/>
+              </a:ext>
+            </a:extLst>
+          </p:cNvPr>
+          <p:cNvSpPr>
+            <a:spLocks xmlns:a="http://schemas.openxmlformats.org/drawingml/2006/main" noGrp="1"/>
+          </p:cNvSpPr>
+          <p:nvPr/>
+        </p:nvSpPr>
+        <p:spPr>
+          <a:xfrm xmlns:a="http://schemas.openxmlformats.org/drawingml/2006/main">
+            <a:off x="7534656" y="1536192"/>
+            <a:ext cx="4096512" cy="2834640"/>
+          </a:xfrm>
+          <a:prstGeom xmlns:a="http://schemas.openxmlformats.org/drawingml/2006/main" prst="rect">
+            <a:avLst/>
+          </a:prstGeom>
+          <a:ln xmlns:a="http://schemas.openxmlformats.org/drawingml/2006/main" w="15875">
             <a:solidFill>
               <a:srgbClr val="C89C40"/>
             </a:solidFill>
@@ -15117,665 +15838,26 @@
       </p:sp>
       <p:sp>
         <p:nvSpPr>
-          <p:cNvPr id="8" name="Shape 5">
-            <a:extLst xmlns:a="http://schemas.openxmlformats.org/drawingml/2006/main">
-              <a:ext uri="{FF2B5EF4-FFF2-40B4-BE49-F238E27FC236}">
-                <a16:creationId xmlns:a16="http://schemas.microsoft.com/office/drawing/2014/main" id="{30459869-F0AC-4806-A6A5-9985DB86A96E}"/>
-              </a:ext>
-            </a:extLst>
-          </p:cNvPr>
-          <p:cNvSpPr>
-            <a:spLocks xmlns:a="http://schemas.openxmlformats.org/drawingml/2006/main" noGrp="1"/>
-          </p:cNvSpPr>
-          <p:nvPr/>
-        </p:nvSpPr>
-        <p:spPr>
-          <a:xfrm xmlns:a="http://schemas.openxmlformats.org/drawingml/2006/main">
-            <a:off x="749808" y="3611880"/>
-            <a:ext cx="1417320" cy="237744"/>
+          <p:cNvPr id="25" name="Shape 22">
+            <a:extLst xmlns:a="http://schemas.openxmlformats.org/drawingml/2006/main">
+              <a:ext uri="{FF2B5EF4-FFF2-40B4-BE49-F238E27FC236}">
+                <a16:creationId xmlns:a16="http://schemas.microsoft.com/office/drawing/2014/main" id="{831A629E-B7E5-4A9F-8D0C-CEFC366EAB2E}"/>
+              </a:ext>
+            </a:extLst>
+          </p:cNvPr>
+          <p:cNvSpPr>
+            <a:spLocks xmlns:a="http://schemas.openxmlformats.org/drawingml/2006/main" noGrp="1"/>
+          </p:cNvSpPr>
+          <p:nvPr/>
+        </p:nvSpPr>
+        <p:spPr>
+          <a:xfrm xmlns:a="http://schemas.openxmlformats.org/drawingml/2006/main">
+            <a:off x="7534656" y="4526280"/>
+            <a:ext cx="4096512" cy="484632"/>
           </a:xfrm>
           <a:prstGeom xmlns:a="http://schemas.openxmlformats.org/drawingml/2006/main" prst="roundRect">
             <a:avLst>
-              <a:gd name="adj" fmla="val 23077"/>
-            </a:avLst>
-          </a:prstGeom>
-          <a:solidFill xmlns:a="http://schemas.openxmlformats.org/drawingml/2006/main">
-            <a:srgbClr val="B0762A"/>
-          </a:solidFill>
-          <a:ln xmlns:a="http://schemas.openxmlformats.org/drawingml/2006/main" w="6350">
-            <a:solidFill>
-              <a:srgbClr val="C89C40"/>
-            </a:solidFill>
-            <a:prstDash val="solid"/>
-          </a:ln>
-        </p:spPr>
-        <p:txBody>
-          <a:bodyPr xmlns:a="http://schemas.openxmlformats.org/drawingml/2006/main"/>
-          <a:lstStyle xmlns:a="http://schemas.openxmlformats.org/drawingml/2006/main"/>
-          <a:p xmlns:a="http://schemas.openxmlformats.org/drawingml/2006/main">
-            <a:endParaRPr/>
-          </a:p>
-        </p:txBody>
-      </p:sp>
-      <p:sp>
-        <p:nvSpPr>
-          <p:cNvPr id="9" name="Text 6">
-            <a:extLst xmlns:a="http://schemas.openxmlformats.org/drawingml/2006/main">
-              <a:ext uri="{FF2B5EF4-FFF2-40B4-BE49-F238E27FC236}">
-                <a16:creationId xmlns:a16="http://schemas.microsoft.com/office/drawing/2014/main" id="{740FE40E-3AFF-44AA-822A-DF0305CB94F6}"/>
-              </a:ext>
-            </a:extLst>
-          </p:cNvPr>
-          <p:cNvSpPr>
-            <a:spLocks xmlns:a="http://schemas.openxmlformats.org/drawingml/2006/main" noGrp="1"/>
-          </p:cNvSpPr>
-          <p:nvPr/>
-        </p:nvSpPr>
-        <p:spPr>
-          <a:xfrm xmlns:a="http://schemas.openxmlformats.org/drawingml/2006/main">
-            <a:off x="749808" y="3621024"/>
-            <a:ext cx="1417320" cy="219456"/>
-          </a:xfrm>
-          <a:prstGeom xmlns:a="http://schemas.openxmlformats.org/drawingml/2006/main" prst="rect">
-            <a:avLst/>
-          </a:prstGeom>
-          <a:noFill xmlns:a="http://schemas.openxmlformats.org/drawingml/2006/main"/>
-        </p:spPr>
-        <p:txBody>
-          <a:bodyPr xmlns:a="http://schemas.openxmlformats.org/drawingml/2006/main" wrap="square" lIns="0" tIns="0" rIns="0" bIns="0" anchor="ctr"/>
-          <a:lstStyle xmlns:a="http://schemas.openxmlformats.org/drawingml/2006/main"/>
-          <a:p xmlns:a="http://schemas.openxmlformats.org/drawingml/2006/main">
-            <a:pPr marL="0" indent="0" algn="ctr">
-              <a:buNone/>
-            </a:pPr>
-            <a:r>
-              <a:rPr sz="850" b="1" spc="60">
-                <a:solidFill>
-                  <a:srgbClr val="FFFFFF"/>
-                </a:solidFill>
-                <a:latin typeface="Calibri"/>
-                <a:ea typeface="Calibri"/>
-                <a:cs typeface="Calibri"/>
-              </a:rPr>
-              <a:t>CUP 150 Г · W/O OIL</a:t>
-            </a:r>
-            <a:endParaRPr sz="850"/>
-          </a:p>
-        </p:txBody>
-      </p:sp>
-      <p:sp>
-        <p:nvSpPr>
-          <p:cNvPr id="10" name="Text 7">
-            <a:extLst xmlns:a="http://schemas.openxmlformats.org/drawingml/2006/main">
-              <a:ext uri="{FF2B5EF4-FFF2-40B4-BE49-F238E27FC236}">
-                <a16:creationId xmlns:a16="http://schemas.microsoft.com/office/drawing/2014/main" id="{3634DF81-CF5A-42FF-B295-D79E46794514}"/>
-              </a:ext>
-            </a:extLst>
-          </p:cNvPr>
-          <p:cNvSpPr>
-            <a:spLocks xmlns:a="http://schemas.openxmlformats.org/drawingml/2006/main" noGrp="1"/>
-          </p:cNvSpPr>
-          <p:nvPr/>
-        </p:nvSpPr>
-        <p:spPr>
-          <a:xfrm xmlns:a="http://schemas.openxmlformats.org/drawingml/2006/main">
-            <a:off x="749808" y="3931920"/>
-            <a:ext cx="2340864" cy="548640"/>
-          </a:xfrm>
-          <a:prstGeom xmlns:a="http://schemas.openxmlformats.org/drawingml/2006/main" prst="rect">
-            <a:avLst/>
-          </a:prstGeom>
-          <a:noFill xmlns:a="http://schemas.openxmlformats.org/drawingml/2006/main"/>
-        </p:spPr>
-        <p:txBody>
-          <a:bodyPr xmlns:a="http://schemas.openxmlformats.org/drawingml/2006/main" wrap="square" lIns="0" tIns="0" rIns="0" bIns="0" anchor="t"/>
-          <a:lstStyle xmlns:a="http://schemas.openxmlformats.org/drawingml/2006/main"/>
-          <a:p xmlns:a="http://schemas.openxmlformats.org/drawingml/2006/main">
-            <a:pPr marL="0" indent="0">
-              <a:buNone/>
-            </a:pPr>
-            <a:r>
-              <a:rPr sz="1450" b="1">
-                <a:solidFill>
-                  <a:srgbClr val="FFFFFF"/>
-                </a:solidFill>
-                <a:latin typeface="Cambria"/>
-                <a:ea typeface="Cambria"/>
-                <a:cs typeface="Cambria"/>
-              </a:rPr>
-              <a:t>Brown Jasmine Rice
-with Red Quinoa</a:t>
-            </a:r>
-            <a:endParaRPr sz="1450"/>
-          </a:p>
-        </p:txBody>
-      </p:sp>
-      <p:sp>
-        <p:nvSpPr>
-          <p:cNvPr id="11" name="Text 8">
-            <a:extLst xmlns:a="http://schemas.openxmlformats.org/drawingml/2006/main">
-              <a:ext uri="{FF2B5EF4-FFF2-40B4-BE49-F238E27FC236}">
-                <a16:creationId xmlns:a16="http://schemas.microsoft.com/office/drawing/2014/main" id="{25EE9D78-55FB-4825-A4EC-1CE5288481C3}"/>
-              </a:ext>
-            </a:extLst>
-          </p:cNvPr>
-          <p:cNvSpPr>
-            <a:spLocks xmlns:a="http://schemas.openxmlformats.org/drawingml/2006/main" noGrp="1"/>
-          </p:cNvSpPr>
-          <p:nvPr/>
-        </p:nvSpPr>
-        <p:spPr>
-          <a:xfrm xmlns:a="http://schemas.openxmlformats.org/drawingml/2006/main">
-            <a:off x="749808" y="4498848"/>
-            <a:ext cx="2340864" cy="237744"/>
-          </a:xfrm>
-          <a:prstGeom xmlns:a="http://schemas.openxmlformats.org/drawingml/2006/main" prst="rect">
-            <a:avLst/>
-          </a:prstGeom>
-          <a:noFill xmlns:a="http://schemas.openxmlformats.org/drawingml/2006/main"/>
-        </p:spPr>
-        <p:txBody>
-          <a:bodyPr xmlns:a="http://schemas.openxmlformats.org/drawingml/2006/main" wrap="square" lIns="0" tIns="0" rIns="0" bIns="0" anchor="ctr"/>
-          <a:lstStyle xmlns:a="http://schemas.openxmlformats.org/drawingml/2006/main"/>
-          <a:p xmlns:a="http://schemas.openxmlformats.org/drawingml/2006/main">
-            <a:pPr marL="0" indent="0">
-              <a:buNone/>
-            </a:pPr>
-            <a:r>
-              <a:rPr sz="1000">
-                <a:solidFill>
-                  <a:srgbClr val="D2E4CE"/>
-                </a:solidFill>
-                <a:latin typeface="Calibri"/>
-                <a:ea typeface="Calibri"/>
-                <a:cs typeface="Calibri"/>
-              </a:rPr>
-              <a:t>Single Cup · Sleeve Box</a:t>
-            </a:r>
-            <a:endParaRPr sz="1000"/>
-          </a:p>
-        </p:txBody>
-      </p:sp>
-      <p:sp>
-        <p:nvSpPr>
-          <p:cNvPr id="12" name="Shape 9">
-            <a:extLst xmlns:a="http://schemas.openxmlformats.org/drawingml/2006/main">
-              <a:ext uri="{FF2B5EF4-FFF2-40B4-BE49-F238E27FC236}">
-                <a16:creationId xmlns:a16="http://schemas.microsoft.com/office/drawing/2014/main" id="{B8161C34-47AF-4A98-91ED-6E1E141D9701}"/>
-              </a:ext>
-            </a:extLst>
-          </p:cNvPr>
-          <p:cNvSpPr>
-            <a:spLocks xmlns:a="http://schemas.openxmlformats.org/drawingml/2006/main" noGrp="1"/>
-          </p:cNvSpPr>
-          <p:nvPr/>
-        </p:nvSpPr>
-        <p:spPr>
-          <a:xfrm xmlns:a="http://schemas.openxmlformats.org/drawingml/2006/main">
-            <a:off x="749808" y="4791456"/>
-            <a:ext cx="2340864" cy="1170432"/>
-          </a:xfrm>
-          <a:prstGeom xmlns:a="http://schemas.openxmlformats.org/drawingml/2006/main" prst="roundRect">
-            <a:avLst>
-              <a:gd name="adj" fmla="val 5469"/>
-            </a:avLst>
-          </a:prstGeom>
-          <a:solidFill xmlns:a="http://schemas.openxmlformats.org/drawingml/2006/main">
-            <a:srgbClr val="1A5433">
-              <a:alpha val="92000"/>
-            </a:srgbClr>
-          </a:solidFill>
-          <a:ln xmlns:a="http://schemas.openxmlformats.org/drawingml/2006/main" w="9525">
-            <a:solidFill>
-              <a:srgbClr val="C89C40"/>
-            </a:solidFill>
-            <a:prstDash val="solid"/>
-          </a:ln>
-        </p:spPr>
-        <p:txBody>
-          <a:bodyPr xmlns:a="http://schemas.openxmlformats.org/drawingml/2006/main"/>
-          <a:lstStyle xmlns:a="http://schemas.openxmlformats.org/drawingml/2006/main"/>
-          <a:p xmlns:a="http://schemas.openxmlformats.org/drawingml/2006/main">
-            <a:endParaRPr/>
-          </a:p>
-        </p:txBody>
-      </p:sp>
-      <p:sp>
-        <p:nvSpPr>
-          <p:cNvPr id="13" name="Text 10">
-            <a:extLst xmlns:a="http://schemas.openxmlformats.org/drawingml/2006/main">
-              <a:ext uri="{FF2B5EF4-FFF2-40B4-BE49-F238E27FC236}">
-                <a16:creationId xmlns:a16="http://schemas.microsoft.com/office/drawing/2014/main" id="{6D3A29BD-427F-41DD-A67A-208B5804CF15}"/>
-              </a:ext>
-            </a:extLst>
-          </p:cNvPr>
-          <p:cNvSpPr>
-            <a:spLocks xmlns:a="http://schemas.openxmlformats.org/drawingml/2006/main" noGrp="1"/>
-          </p:cNvSpPr>
-          <p:nvPr/>
-        </p:nvSpPr>
-        <p:spPr>
-          <a:xfrm xmlns:a="http://schemas.openxmlformats.org/drawingml/2006/main">
-            <a:off x="859536" y="4855464"/>
-            <a:ext cx="2148840" cy="182880"/>
-          </a:xfrm>
-          <a:prstGeom xmlns:a="http://schemas.openxmlformats.org/drawingml/2006/main" prst="rect">
-            <a:avLst/>
-          </a:prstGeom>
-          <a:noFill xmlns:a="http://schemas.openxmlformats.org/drawingml/2006/main"/>
-        </p:spPr>
-        <p:txBody>
-          <a:bodyPr xmlns:a="http://schemas.openxmlformats.org/drawingml/2006/main" wrap="square" lIns="0" tIns="0" rIns="0" bIns="0" anchor="ctr"/>
-          <a:lstStyle xmlns:a="http://schemas.openxmlformats.org/drawingml/2006/main"/>
-          <a:p xmlns:a="http://schemas.openxmlformats.org/drawingml/2006/main">
-            <a:pPr marL="0" indent="0">
-              <a:buNone/>
-            </a:pPr>
-            <a:r>
-              <a:rPr sz="750" b="1" spc="100">
-                <a:solidFill>
-                  <a:srgbClr val="F5CE76"/>
-                </a:solidFill>
-                <a:latin typeface="Calibri"/>
-                <a:ea typeface="Calibri"/>
-                <a:cs typeface="Calibri"/>
-              </a:rPr>
-              <a:t>ПАРАМЕТРИ УПАКОВКИ</a:t>
-            </a:r>
-            <a:endParaRPr sz="750"/>
-          </a:p>
-        </p:txBody>
-      </p:sp>
-      <p:sp>
-        <p:nvSpPr>
-          <p:cNvPr id="14" name="Text 11">
-            <a:extLst xmlns:a="http://schemas.openxmlformats.org/drawingml/2006/main">
-              <a:ext uri="{FF2B5EF4-FFF2-40B4-BE49-F238E27FC236}">
-                <a16:creationId xmlns:a16="http://schemas.microsoft.com/office/drawing/2014/main" id="{DF225FD2-5DF4-4E27-A0C2-ED5225E2FD54}"/>
-              </a:ext>
-            </a:extLst>
-          </p:cNvPr>
-          <p:cNvSpPr>
-            <a:spLocks xmlns:a="http://schemas.openxmlformats.org/drawingml/2006/main" noGrp="1"/>
-          </p:cNvSpPr>
-          <p:nvPr/>
-        </p:nvSpPr>
-        <p:spPr>
-          <a:xfrm xmlns:a="http://schemas.openxmlformats.org/drawingml/2006/main">
-            <a:off x="859536" y="5056632"/>
-            <a:ext cx="658368" cy="192024"/>
-          </a:xfrm>
-          <a:prstGeom xmlns:a="http://schemas.openxmlformats.org/drawingml/2006/main" prst="rect">
-            <a:avLst/>
-          </a:prstGeom>
-          <a:noFill xmlns:a="http://schemas.openxmlformats.org/drawingml/2006/main"/>
-        </p:spPr>
-        <p:txBody>
-          <a:bodyPr xmlns:a="http://schemas.openxmlformats.org/drawingml/2006/main" wrap="square" lIns="0" tIns="0" rIns="0" bIns="0" anchor="ctr"/>
-          <a:lstStyle xmlns:a="http://schemas.openxmlformats.org/drawingml/2006/main"/>
-          <a:p xmlns:a="http://schemas.openxmlformats.org/drawingml/2006/main">
-            <a:pPr marL="0" indent="0">
-              <a:buNone/>
-            </a:pPr>
-            <a:r>
-              <a:rPr sz="900">
-                <a:solidFill>
-                  <a:srgbClr val="D2E4CE"/>
-                </a:solidFill>
-                <a:latin typeface="Calibri"/>
-                <a:ea typeface="Calibri"/>
-                <a:cs typeface="Calibri"/>
-              </a:rPr>
-              <a:t>Формат</a:t>
-            </a:r>
-            <a:endParaRPr sz="900"/>
-          </a:p>
-        </p:txBody>
-      </p:sp>
-      <p:sp>
-        <p:nvSpPr>
-          <p:cNvPr id="15" name="Text 12">
-            <a:extLst xmlns:a="http://schemas.openxmlformats.org/drawingml/2006/main">
-              <a:ext uri="{FF2B5EF4-FFF2-40B4-BE49-F238E27FC236}">
-                <a16:creationId xmlns:a16="http://schemas.microsoft.com/office/drawing/2014/main" id="{CBAEDDDF-B30B-44A8-84D8-1F1351720E53}"/>
-              </a:ext>
-            </a:extLst>
-          </p:cNvPr>
-          <p:cNvSpPr>
-            <a:spLocks xmlns:a="http://schemas.openxmlformats.org/drawingml/2006/main" noGrp="1"/>
-          </p:cNvSpPr>
-          <p:nvPr/>
-        </p:nvSpPr>
-        <p:spPr>
-          <a:xfrm xmlns:a="http://schemas.openxmlformats.org/drawingml/2006/main">
-            <a:off x="1499616" y="5056632"/>
-            <a:ext cx="1508760" cy="192024"/>
-          </a:xfrm>
-          <a:prstGeom xmlns:a="http://schemas.openxmlformats.org/drawingml/2006/main" prst="rect">
-            <a:avLst/>
-          </a:prstGeom>
-          <a:noFill xmlns:a="http://schemas.openxmlformats.org/drawingml/2006/main"/>
-        </p:spPr>
-        <p:txBody>
-          <a:bodyPr xmlns:a="http://schemas.openxmlformats.org/drawingml/2006/main" wrap="square" lIns="0" tIns="0" rIns="0" bIns="0" anchor="ctr"/>
-          <a:lstStyle xmlns:a="http://schemas.openxmlformats.org/drawingml/2006/main"/>
-          <a:p xmlns:a="http://schemas.openxmlformats.org/drawingml/2006/main">
-            <a:pPr marL="0" indent="0" algn="r">
-              <a:buNone/>
-            </a:pPr>
-            <a:r>
-              <a:rPr sz="950">
-                <a:solidFill>
-                  <a:srgbClr val="FCF9F0"/>
-                </a:solidFill>
-                <a:latin typeface="Calibri"/>
-                <a:ea typeface="Calibri"/>
-                <a:cs typeface="Calibri"/>
-              </a:rPr>
-              <a:t>Single Cup</a:t>
-            </a:r>
-            <a:endParaRPr sz="950"/>
-          </a:p>
-        </p:txBody>
-      </p:sp>
-      <p:sp>
-        <p:nvSpPr>
-          <p:cNvPr id="16" name="Text 13">
-            <a:extLst xmlns:a="http://schemas.openxmlformats.org/drawingml/2006/main">
-              <a:ext uri="{FF2B5EF4-FFF2-40B4-BE49-F238E27FC236}">
-                <a16:creationId xmlns:a16="http://schemas.microsoft.com/office/drawing/2014/main" id="{6D2FA2E5-E055-4EED-B764-D8C358F13040}"/>
-              </a:ext>
-            </a:extLst>
-          </p:cNvPr>
-          <p:cNvSpPr>
-            <a:spLocks xmlns:a="http://schemas.openxmlformats.org/drawingml/2006/main" noGrp="1"/>
-          </p:cNvSpPr>
-          <p:nvPr/>
-        </p:nvSpPr>
-        <p:spPr>
-          <a:xfrm xmlns:a="http://schemas.openxmlformats.org/drawingml/2006/main">
-            <a:off x="859536" y="5262372"/>
-            <a:ext cx="658368" cy="192024"/>
-          </a:xfrm>
-          <a:prstGeom xmlns:a="http://schemas.openxmlformats.org/drawingml/2006/main" prst="rect">
-            <a:avLst/>
-          </a:prstGeom>
-          <a:noFill xmlns:a="http://schemas.openxmlformats.org/drawingml/2006/main"/>
-        </p:spPr>
-        <p:txBody>
-          <a:bodyPr xmlns:a="http://schemas.openxmlformats.org/drawingml/2006/main" wrap="square" lIns="0" tIns="0" rIns="0" bIns="0" anchor="ctr"/>
-          <a:lstStyle xmlns:a="http://schemas.openxmlformats.org/drawingml/2006/main"/>
-          <a:p xmlns:a="http://schemas.openxmlformats.org/drawingml/2006/main">
-            <a:pPr marL="0" indent="0">
-              <a:buNone/>
-            </a:pPr>
-            <a:r>
-              <a:rPr sz="900" b="1">
-                <a:solidFill>
-                  <a:srgbClr val="F5CE76"/>
-                </a:solidFill>
-                <a:latin typeface="Calibri"/>
-                <a:ea typeface="Calibri"/>
-                <a:cs typeface="Calibri"/>
-              </a:rPr>
-              <a:t>Вага</a:t>
-            </a:r>
-            <a:endParaRPr sz="900"/>
-          </a:p>
-        </p:txBody>
-      </p:sp>
-      <p:sp>
-        <p:nvSpPr>
-          <p:cNvPr id="17" name="Text 14">
-            <a:extLst xmlns:a="http://schemas.openxmlformats.org/drawingml/2006/main">
-              <a:ext uri="{FF2B5EF4-FFF2-40B4-BE49-F238E27FC236}">
-                <a16:creationId xmlns:a16="http://schemas.microsoft.com/office/drawing/2014/main" id="{3EFA949F-A8B8-4BD8-BEA2-862EF1E9F3A7}"/>
-              </a:ext>
-            </a:extLst>
-          </p:cNvPr>
-          <p:cNvSpPr>
-            <a:spLocks xmlns:a="http://schemas.openxmlformats.org/drawingml/2006/main" noGrp="1"/>
-          </p:cNvSpPr>
-          <p:nvPr/>
-        </p:nvSpPr>
-        <p:spPr>
-          <a:xfrm xmlns:a="http://schemas.openxmlformats.org/drawingml/2006/main">
-            <a:off x="1499616" y="5262372"/>
-            <a:ext cx="1508760" cy="192024"/>
-          </a:xfrm>
-          <a:prstGeom xmlns:a="http://schemas.openxmlformats.org/drawingml/2006/main" prst="rect">
-            <a:avLst/>
-          </a:prstGeom>
-          <a:noFill xmlns:a="http://schemas.openxmlformats.org/drawingml/2006/main"/>
-        </p:spPr>
-        <p:txBody>
-          <a:bodyPr xmlns:a="http://schemas.openxmlformats.org/drawingml/2006/main" wrap="square" lIns="0" tIns="0" rIns="0" bIns="0" anchor="ctr"/>
-          <a:lstStyle xmlns:a="http://schemas.openxmlformats.org/drawingml/2006/main"/>
-          <a:p xmlns:a="http://schemas.openxmlformats.org/drawingml/2006/main">
-            <a:pPr marL="0" indent="0" algn="r">
-              <a:buNone/>
-            </a:pPr>
-            <a:r>
-              <a:rPr sz="950" b="1">
-                <a:solidFill>
-                  <a:srgbClr val="F5CE76"/>
-                </a:solidFill>
-                <a:latin typeface="Calibri"/>
-                <a:ea typeface="Calibri"/>
-                <a:cs typeface="Calibri"/>
-              </a:rPr>
-              <a:t>150 г</a:t>
-            </a:r>
-            <a:endParaRPr sz="950"/>
-          </a:p>
-        </p:txBody>
-      </p:sp>
-      <p:sp>
-        <p:nvSpPr>
-          <p:cNvPr id="18" name="Text 15">
-            <a:extLst xmlns:a="http://schemas.openxmlformats.org/drawingml/2006/main">
-              <a:ext uri="{FF2B5EF4-FFF2-40B4-BE49-F238E27FC236}">
-                <a16:creationId xmlns:a16="http://schemas.microsoft.com/office/drawing/2014/main" id="{9F4E7F66-E648-45BF-B645-840EB5CD86B3}"/>
-              </a:ext>
-            </a:extLst>
-          </p:cNvPr>
-          <p:cNvSpPr>
-            <a:spLocks xmlns:a="http://schemas.openxmlformats.org/drawingml/2006/main" noGrp="1"/>
-          </p:cNvSpPr>
-          <p:nvPr/>
-        </p:nvSpPr>
-        <p:spPr>
-          <a:xfrm xmlns:a="http://schemas.openxmlformats.org/drawingml/2006/main">
-            <a:off x="859536" y="5468112"/>
-            <a:ext cx="658368" cy="192024"/>
-          </a:xfrm>
-          <a:prstGeom xmlns:a="http://schemas.openxmlformats.org/drawingml/2006/main" prst="rect">
-            <a:avLst/>
-          </a:prstGeom>
-          <a:noFill xmlns:a="http://schemas.openxmlformats.org/drawingml/2006/main"/>
-        </p:spPr>
-        <p:txBody>
-          <a:bodyPr xmlns:a="http://schemas.openxmlformats.org/drawingml/2006/main" wrap="square" lIns="0" tIns="0" rIns="0" bIns="0" anchor="ctr"/>
-          <a:lstStyle xmlns:a="http://schemas.openxmlformats.org/drawingml/2006/main"/>
-          <a:p xmlns:a="http://schemas.openxmlformats.org/drawingml/2006/main">
-            <a:pPr marL="0" indent="0">
-              <a:buNone/>
-            </a:pPr>
-            <a:r>
-              <a:rPr sz="900">
-                <a:solidFill>
-                  <a:srgbClr val="D2E4CE"/>
-                </a:solidFill>
-                <a:latin typeface="Calibri"/>
-                <a:ea typeface="Calibri"/>
-                <a:cs typeface="Calibri"/>
-              </a:rPr>
-              <a:t>Короб</a:t>
-            </a:r>
-            <a:endParaRPr sz="900"/>
-          </a:p>
-        </p:txBody>
-      </p:sp>
-      <p:sp>
-        <p:nvSpPr>
-          <p:cNvPr id="19" name="Text 16">
-            <a:extLst xmlns:a="http://schemas.openxmlformats.org/drawingml/2006/main">
-              <a:ext uri="{FF2B5EF4-FFF2-40B4-BE49-F238E27FC236}">
-                <a16:creationId xmlns:a16="http://schemas.microsoft.com/office/drawing/2014/main" id="{03FA87CF-3F1F-407C-97E5-CE3B0D83E714}"/>
-              </a:ext>
-            </a:extLst>
-          </p:cNvPr>
-          <p:cNvSpPr>
-            <a:spLocks xmlns:a="http://schemas.openxmlformats.org/drawingml/2006/main" noGrp="1"/>
-          </p:cNvSpPr>
-          <p:nvPr/>
-        </p:nvSpPr>
-        <p:spPr>
-          <a:xfrm xmlns:a="http://schemas.openxmlformats.org/drawingml/2006/main">
-            <a:off x="1499616" y="5468112"/>
-            <a:ext cx="1508760" cy="192024"/>
-          </a:xfrm>
-          <a:prstGeom xmlns:a="http://schemas.openxmlformats.org/drawingml/2006/main" prst="rect">
-            <a:avLst/>
-          </a:prstGeom>
-          <a:noFill xmlns:a="http://schemas.openxmlformats.org/drawingml/2006/main"/>
-        </p:spPr>
-        <p:txBody>
-          <a:bodyPr xmlns:a="http://schemas.openxmlformats.org/drawingml/2006/main" wrap="square" lIns="0" tIns="0" rIns="0" bIns="0" anchor="ctr"/>
-          <a:lstStyle xmlns:a="http://schemas.openxmlformats.org/drawingml/2006/main"/>
-          <a:p xmlns:a="http://schemas.openxmlformats.org/drawingml/2006/main">
-            <a:pPr marL="0" indent="0" algn="r">
-              <a:buNone/>
-            </a:pPr>
-            <a:r>
-              <a:rPr sz="950">
-                <a:solidFill>
-                  <a:srgbClr val="FCF9F0"/>
-                </a:solidFill>
-                <a:latin typeface="Calibri"/>
-                <a:ea typeface="Calibri"/>
-                <a:cs typeface="Calibri"/>
-              </a:rPr>
-              <a:t>12 шт.</a:t>
-            </a:r>
-            <a:endParaRPr sz="950"/>
-          </a:p>
-        </p:txBody>
-      </p:sp>
-      <p:sp>
-        <p:nvSpPr>
-          <p:cNvPr id="20" name="Text 17">
-            <a:extLst xmlns:a="http://schemas.openxmlformats.org/drawingml/2006/main">
-              <a:ext uri="{FF2B5EF4-FFF2-40B4-BE49-F238E27FC236}">
-                <a16:creationId xmlns:a16="http://schemas.microsoft.com/office/drawing/2014/main" id="{ED686B9D-4A4D-4002-9CDE-77BA53EB1911}"/>
-              </a:ext>
-            </a:extLst>
-          </p:cNvPr>
-          <p:cNvSpPr>
-            <a:spLocks xmlns:a="http://schemas.openxmlformats.org/drawingml/2006/main" noGrp="1"/>
-          </p:cNvSpPr>
-          <p:nvPr/>
-        </p:nvSpPr>
-        <p:spPr>
-          <a:xfrm xmlns:a="http://schemas.openxmlformats.org/drawingml/2006/main">
-            <a:off x="859536" y="5673852"/>
-            <a:ext cx="658368" cy="192024"/>
-          </a:xfrm>
-          <a:prstGeom xmlns:a="http://schemas.openxmlformats.org/drawingml/2006/main" prst="rect">
-            <a:avLst/>
-          </a:prstGeom>
-          <a:noFill xmlns:a="http://schemas.openxmlformats.org/drawingml/2006/main"/>
-        </p:spPr>
-        <p:txBody>
-          <a:bodyPr xmlns:a="http://schemas.openxmlformats.org/drawingml/2006/main" wrap="square" lIns="0" tIns="0" rIns="0" bIns="0" anchor="ctr"/>
-          <a:lstStyle xmlns:a="http://schemas.openxmlformats.org/drawingml/2006/main"/>
-          <a:p xmlns:a="http://schemas.openxmlformats.org/drawingml/2006/main">
-            <a:pPr marL="0" indent="0">
-              <a:buNone/>
-            </a:pPr>
-            <a:r>
-              <a:rPr sz="900">
-                <a:solidFill>
-                  <a:srgbClr val="D2E4CE"/>
-                </a:solidFill>
-                <a:latin typeface="Calibri"/>
-                <a:ea typeface="Calibri"/>
-                <a:cs typeface="Calibri"/>
-              </a:rPr>
-              <a:t>Sleeve</a:t>
-            </a:r>
-            <a:endParaRPr sz="900"/>
-          </a:p>
-        </p:txBody>
-      </p:sp>
-      <p:sp>
-        <p:nvSpPr>
-          <p:cNvPr id="21" name="Text 18">
-            <a:extLst xmlns:a="http://schemas.openxmlformats.org/drawingml/2006/main">
-              <a:ext uri="{FF2B5EF4-FFF2-40B4-BE49-F238E27FC236}">
-                <a16:creationId xmlns:a16="http://schemas.microsoft.com/office/drawing/2014/main" id="{5F1395A1-2F78-48B0-8C30-47BF1137A35B}"/>
-              </a:ext>
-            </a:extLst>
-          </p:cNvPr>
-          <p:cNvSpPr>
-            <a:spLocks xmlns:a="http://schemas.openxmlformats.org/drawingml/2006/main" noGrp="1"/>
-          </p:cNvSpPr>
-          <p:nvPr/>
-        </p:nvSpPr>
-        <p:spPr>
-          <a:xfrm xmlns:a="http://schemas.openxmlformats.org/drawingml/2006/main">
-            <a:off x="1499616" y="5673852"/>
-            <a:ext cx="1508760" cy="192024"/>
-          </a:xfrm>
-          <a:prstGeom xmlns:a="http://schemas.openxmlformats.org/drawingml/2006/main" prst="rect">
-            <a:avLst/>
-          </a:prstGeom>
-          <a:noFill xmlns:a="http://schemas.openxmlformats.org/drawingml/2006/main"/>
-        </p:spPr>
-        <p:txBody>
-          <a:bodyPr xmlns:a="http://schemas.openxmlformats.org/drawingml/2006/main" wrap="square" lIns="0" tIns="0" rIns="0" bIns="0" anchor="ctr"/>
-          <a:lstStyle xmlns:a="http://schemas.openxmlformats.org/drawingml/2006/main"/>
-          <a:p xmlns:a="http://schemas.openxmlformats.org/drawingml/2006/main">
-            <a:pPr marL="0" indent="0" algn="r">
-              <a:buNone/>
-            </a:pPr>
-            <a:r>
-              <a:rPr sz="950">
-                <a:solidFill>
-                  <a:srgbClr val="FCF9F0"/>
-                </a:solidFill>
-                <a:latin typeface="Calibri"/>
-                <a:ea typeface="Calibri"/>
-                <a:cs typeface="Calibri"/>
-              </a:rPr>
-              <a:t>коробка</a:t>
-            </a:r>
-            <a:endParaRPr sz="950"/>
-          </a:p>
-        </p:txBody>
-      </p:sp>
-      <p:sp>
-        <p:nvSpPr>
-          <p:cNvPr id="22" name="Shape 19">
-            <a:extLst xmlns:a="http://schemas.openxmlformats.org/drawingml/2006/main">
-              <a:ext uri="{FF2B5EF4-FFF2-40B4-BE49-F238E27FC236}">
-                <a16:creationId xmlns:a16="http://schemas.microsoft.com/office/drawing/2014/main" id="{AFCD23EF-4833-427F-B74B-6E405E3069ED}"/>
-              </a:ext>
-            </a:extLst>
-          </p:cNvPr>
-          <p:cNvSpPr>
-            <a:spLocks xmlns:a="http://schemas.openxmlformats.org/drawingml/2006/main" noGrp="1"/>
-          </p:cNvSpPr>
-          <p:nvPr/>
-        </p:nvSpPr>
-        <p:spPr>
-          <a:xfrm xmlns:a="http://schemas.openxmlformats.org/drawingml/2006/main">
-            <a:off x="3383280" y="1536192"/>
-            <a:ext cx="2706624" cy="4626864"/>
-          </a:xfrm>
-          <a:prstGeom xmlns:a="http://schemas.openxmlformats.org/drawingml/2006/main" prst="roundRect">
-            <a:avLst>
-              <a:gd name="adj" fmla="val 4054"/>
+              <a:gd name="adj" fmla="val 15094"/>
             </a:avLst>
           </a:prstGeom>
           <a:solidFill xmlns:a="http://schemas.openxmlformats.org/drawingml/2006/main">
@@ -15807,701 +15889,129 @@
       </p:sp>
       <p:sp>
         <p:nvSpPr>
-          <p:cNvPr id="24" name="Shape 20">
-            <a:extLst xmlns:a="http://schemas.openxmlformats.org/drawingml/2006/main">
-              <a:ext uri="{FF2B5EF4-FFF2-40B4-BE49-F238E27FC236}">
-                <a16:creationId xmlns:a16="http://schemas.microsoft.com/office/drawing/2014/main" id="{CC510ACE-6515-4BC0-B50D-985970D330BD}"/>
-              </a:ext>
-            </a:extLst>
-          </p:cNvPr>
-          <p:cNvSpPr>
-            <a:spLocks xmlns:a="http://schemas.openxmlformats.org/drawingml/2006/main" noGrp="1"/>
-          </p:cNvSpPr>
-          <p:nvPr/>
-        </p:nvSpPr>
-        <p:spPr>
-          <a:xfrm xmlns:a="http://schemas.openxmlformats.org/drawingml/2006/main">
-            <a:off x="3566160" y="1700784"/>
-            <a:ext cx="2340864" cy="1810512"/>
-          </a:xfrm>
-          <a:prstGeom xmlns:a="http://schemas.openxmlformats.org/drawingml/2006/main" prst="rect">
-            <a:avLst/>
-          </a:prstGeom>
-          <a:ln xmlns:a="http://schemas.openxmlformats.org/drawingml/2006/main" w="12700">
-            <a:solidFill>
-              <a:srgbClr val="C89C40"/>
-            </a:solidFill>
-            <a:prstDash val="solid"/>
-          </a:ln>
-        </p:spPr>
-        <p:txBody>
-          <a:bodyPr xmlns:a="http://schemas.openxmlformats.org/drawingml/2006/main"/>
-          <a:lstStyle xmlns:a="http://schemas.openxmlformats.org/drawingml/2006/main"/>
-          <a:p xmlns:a="http://schemas.openxmlformats.org/drawingml/2006/main">
-            <a:endParaRPr/>
-          </a:p>
-        </p:txBody>
-      </p:sp>
-      <p:sp>
-        <p:nvSpPr>
-          <p:cNvPr id="25" name="Shape 21">
-            <a:extLst xmlns:a="http://schemas.openxmlformats.org/drawingml/2006/main">
-              <a:ext uri="{FF2B5EF4-FFF2-40B4-BE49-F238E27FC236}">
-                <a16:creationId xmlns:a16="http://schemas.microsoft.com/office/drawing/2014/main" id="{6F360826-A308-4AC3-BAA1-7446672F8749}"/>
-              </a:ext>
-            </a:extLst>
-          </p:cNvPr>
-          <p:cNvSpPr>
-            <a:spLocks xmlns:a="http://schemas.openxmlformats.org/drawingml/2006/main" noGrp="1"/>
-          </p:cNvSpPr>
-          <p:nvPr/>
-        </p:nvSpPr>
-        <p:spPr>
-          <a:xfrm xmlns:a="http://schemas.openxmlformats.org/drawingml/2006/main">
-            <a:off x="3566160" y="3611880"/>
-            <a:ext cx="1417320" cy="237744"/>
-          </a:xfrm>
-          <a:prstGeom xmlns:a="http://schemas.openxmlformats.org/drawingml/2006/main" prst="roundRect">
-            <a:avLst>
-              <a:gd name="adj" fmla="val 23077"/>
-            </a:avLst>
-          </a:prstGeom>
-          <a:solidFill xmlns:a="http://schemas.openxmlformats.org/drawingml/2006/main">
-            <a:srgbClr val="B0762A"/>
-          </a:solidFill>
-          <a:ln xmlns:a="http://schemas.openxmlformats.org/drawingml/2006/main" w="6350">
-            <a:solidFill>
-              <a:srgbClr val="C89C40"/>
-            </a:solidFill>
-            <a:prstDash val="solid"/>
-          </a:ln>
-        </p:spPr>
-        <p:txBody>
-          <a:bodyPr xmlns:a="http://schemas.openxmlformats.org/drawingml/2006/main"/>
-          <a:lstStyle xmlns:a="http://schemas.openxmlformats.org/drawingml/2006/main"/>
-          <a:p xmlns:a="http://schemas.openxmlformats.org/drawingml/2006/main">
-            <a:endParaRPr/>
-          </a:p>
-        </p:txBody>
-      </p:sp>
-      <p:sp>
-        <p:nvSpPr>
-          <p:cNvPr id="26" name="Text 22">
-            <a:extLst xmlns:a="http://schemas.openxmlformats.org/drawingml/2006/main">
-              <a:ext uri="{FF2B5EF4-FFF2-40B4-BE49-F238E27FC236}">
-                <a16:creationId xmlns:a16="http://schemas.microsoft.com/office/drawing/2014/main" id="{7036F6EF-F813-4855-BBAB-E834036C4733}"/>
-              </a:ext>
-            </a:extLst>
-          </p:cNvPr>
-          <p:cNvSpPr>
-            <a:spLocks xmlns:a="http://schemas.openxmlformats.org/drawingml/2006/main" noGrp="1"/>
-          </p:cNvSpPr>
-          <p:nvPr/>
-        </p:nvSpPr>
-        <p:spPr>
-          <a:xfrm xmlns:a="http://schemas.openxmlformats.org/drawingml/2006/main">
-            <a:off x="3566160" y="3621024"/>
-            <a:ext cx="1417320" cy="219456"/>
-          </a:xfrm>
-          <a:prstGeom xmlns:a="http://schemas.openxmlformats.org/drawingml/2006/main" prst="rect">
-            <a:avLst/>
-          </a:prstGeom>
-          <a:noFill xmlns:a="http://schemas.openxmlformats.org/drawingml/2006/main"/>
-        </p:spPr>
-        <p:txBody>
-          <a:bodyPr xmlns:a="http://schemas.openxmlformats.org/drawingml/2006/main" wrap="square" lIns="0" tIns="0" rIns="0" bIns="0" anchor="ctr"/>
-          <a:lstStyle xmlns:a="http://schemas.openxmlformats.org/drawingml/2006/main"/>
-          <a:p xmlns:a="http://schemas.openxmlformats.org/drawingml/2006/main">
-            <a:pPr marL="0" indent="0" algn="ctr">
-              <a:buNone/>
-            </a:pPr>
-            <a:r>
-              <a:rPr sz="850" b="1" spc="60">
-                <a:solidFill>
-                  <a:srgbClr val="FFFFFF"/>
-                </a:solidFill>
-                <a:latin typeface="Calibri"/>
-                <a:ea typeface="Calibri"/>
-                <a:cs typeface="Calibri"/>
-              </a:rPr>
-              <a:t>CUP 150 Г · W/O OIL</a:t>
-            </a:r>
-            <a:endParaRPr sz="850"/>
-          </a:p>
-        </p:txBody>
-      </p:sp>
-      <p:sp>
-        <p:nvSpPr>
-          <p:cNvPr id="27" name="Text 23">
-            <a:extLst xmlns:a="http://schemas.openxmlformats.org/drawingml/2006/main">
-              <a:ext uri="{FF2B5EF4-FFF2-40B4-BE49-F238E27FC236}">
-                <a16:creationId xmlns:a16="http://schemas.microsoft.com/office/drawing/2014/main" id="{D623579F-4CF0-49CB-8419-DC085FE5D432}"/>
-              </a:ext>
-            </a:extLst>
-          </p:cNvPr>
-          <p:cNvSpPr>
-            <a:spLocks xmlns:a="http://schemas.openxmlformats.org/drawingml/2006/main" noGrp="1"/>
-          </p:cNvSpPr>
-          <p:nvPr/>
-        </p:nvSpPr>
-        <p:spPr>
-          <a:xfrm xmlns:a="http://schemas.openxmlformats.org/drawingml/2006/main">
-            <a:off x="3566160" y="3931920"/>
-            <a:ext cx="2340864" cy="548640"/>
-          </a:xfrm>
-          <a:prstGeom xmlns:a="http://schemas.openxmlformats.org/drawingml/2006/main" prst="rect">
-            <a:avLst/>
-          </a:prstGeom>
-          <a:noFill xmlns:a="http://schemas.openxmlformats.org/drawingml/2006/main"/>
-        </p:spPr>
-        <p:txBody>
-          <a:bodyPr xmlns:a="http://schemas.openxmlformats.org/drawingml/2006/main" wrap="square" lIns="0" tIns="0" rIns="0" bIns="0" anchor="t"/>
-          <a:lstStyle xmlns:a="http://schemas.openxmlformats.org/drawingml/2006/main"/>
-          <a:p xmlns:a="http://schemas.openxmlformats.org/drawingml/2006/main">
-            <a:pPr marL="0" indent="0">
-              <a:buNone/>
-            </a:pPr>
-            <a:r>
-              <a:rPr sz="1450" b="1">
-                <a:solidFill>
-                  <a:srgbClr val="FFFFFF"/>
+          <p:cNvPr id="26" name="Text 23">
+            <a:extLst xmlns:a="http://schemas.openxmlformats.org/drawingml/2006/main">
+              <a:ext uri="{FF2B5EF4-FFF2-40B4-BE49-F238E27FC236}">
+                <a16:creationId xmlns:a16="http://schemas.microsoft.com/office/drawing/2014/main" id="{3B99B33F-CA18-49F8-8EC9-D0A44AF63E2D}"/>
+              </a:ext>
+            </a:extLst>
+          </p:cNvPr>
+          <p:cNvSpPr>
+            <a:spLocks xmlns:a="http://schemas.openxmlformats.org/drawingml/2006/main" noGrp="1"/>
+          </p:cNvSpPr>
+          <p:nvPr/>
+        </p:nvSpPr>
+        <p:spPr>
+          <a:xfrm xmlns:a="http://schemas.openxmlformats.org/drawingml/2006/main">
+            <a:off x="7717536" y="4581144"/>
+            <a:ext cx="1371600" cy="365760"/>
+          </a:xfrm>
+          <a:prstGeom xmlns:a="http://schemas.openxmlformats.org/drawingml/2006/main" prst="rect">
+            <a:avLst/>
+          </a:prstGeom>
+          <a:noFill xmlns:a="http://schemas.openxmlformats.org/drawingml/2006/main"/>
+        </p:spPr>
+        <p:txBody>
+          <a:bodyPr xmlns:a="http://schemas.openxmlformats.org/drawingml/2006/main" wrap="square" lIns="0" tIns="0" rIns="0" bIns="0" anchor="ctr"/>
+          <a:lstStyle xmlns:a="http://schemas.openxmlformats.org/drawingml/2006/main"/>
+          <a:p xmlns:a="http://schemas.openxmlformats.org/drawingml/2006/main">
+            <a:pPr marL="0" indent="0">
+              <a:buNone/>
+            </a:pPr>
+            <a:r>
+              <a:rPr sz="1900" b="1">
+                <a:solidFill>
+                  <a:srgbClr val="F5CE76"/>
                 </a:solidFill>
                 <a:latin typeface="Cambria"/>
                 <a:ea typeface="Cambria"/>
                 <a:cs typeface="Cambria"/>
               </a:rPr>
-              <a:t>Jasmine Rice (Pathum)</a:t>
-            </a:r>
-            <a:endParaRPr sz="1450"/>
-          </a:p>
-        </p:txBody>
-      </p:sp>
-      <p:sp>
-        <p:nvSpPr>
-          <p:cNvPr id="28" name="Text 24">
-            <a:extLst xmlns:a="http://schemas.openxmlformats.org/drawingml/2006/main">
-              <a:ext uri="{FF2B5EF4-FFF2-40B4-BE49-F238E27FC236}">
-                <a16:creationId xmlns:a16="http://schemas.microsoft.com/office/drawing/2014/main" id="{34F13D1A-C3CC-4661-A13D-5D4192098AD7}"/>
-              </a:ext>
-            </a:extLst>
-          </p:cNvPr>
-          <p:cNvSpPr>
-            <a:spLocks xmlns:a="http://schemas.openxmlformats.org/drawingml/2006/main" noGrp="1"/>
-          </p:cNvSpPr>
-          <p:nvPr/>
-        </p:nvSpPr>
-        <p:spPr>
-          <a:xfrm xmlns:a="http://schemas.openxmlformats.org/drawingml/2006/main">
-            <a:off x="3566160" y="4498848"/>
-            <a:ext cx="2340864" cy="237744"/>
-          </a:xfrm>
-          <a:prstGeom xmlns:a="http://schemas.openxmlformats.org/drawingml/2006/main" prst="rect">
-            <a:avLst/>
-          </a:prstGeom>
-          <a:noFill xmlns:a="http://schemas.openxmlformats.org/drawingml/2006/main"/>
-        </p:spPr>
-        <p:txBody>
-          <a:bodyPr xmlns:a="http://schemas.openxmlformats.org/drawingml/2006/main" wrap="square" lIns="0" tIns="0" rIns="0" bIns="0" anchor="ctr"/>
-          <a:lstStyle xmlns:a="http://schemas.openxmlformats.org/drawingml/2006/main"/>
-          <a:p xmlns:a="http://schemas.openxmlformats.org/drawingml/2006/main">
-            <a:pPr marL="0" indent="0">
-              <a:buNone/>
-            </a:pPr>
-            <a:r>
-              <a:rPr sz="1000">
-                <a:solidFill>
-                  <a:srgbClr val="D2E4CE"/>
-                </a:solidFill>
-                <a:latin typeface="Calibri"/>
-                <a:ea typeface="Calibri"/>
-                <a:cs typeface="Calibri"/>
-              </a:rPr>
-              <a:t>Single Cup · Sleeve Box</a:t>
-            </a:r>
-            <a:endParaRPr sz="1000"/>
-          </a:p>
-        </p:txBody>
-      </p:sp>
-      <p:sp>
-        <p:nvSpPr>
-          <p:cNvPr id="29" name="Shape 25">
-            <a:extLst xmlns:a="http://schemas.openxmlformats.org/drawingml/2006/main">
-              <a:ext uri="{FF2B5EF4-FFF2-40B4-BE49-F238E27FC236}">
-                <a16:creationId xmlns:a16="http://schemas.microsoft.com/office/drawing/2014/main" id="{D49B14DE-CA73-4039-8430-FB42DBBD3991}"/>
-              </a:ext>
-            </a:extLst>
-          </p:cNvPr>
-          <p:cNvSpPr>
-            <a:spLocks xmlns:a="http://schemas.openxmlformats.org/drawingml/2006/main" noGrp="1"/>
-          </p:cNvSpPr>
-          <p:nvPr/>
-        </p:nvSpPr>
-        <p:spPr>
-          <a:xfrm xmlns:a="http://schemas.openxmlformats.org/drawingml/2006/main">
-            <a:off x="3566160" y="4791456"/>
-            <a:ext cx="2340864" cy="1170432"/>
+              <a:t>6 од.</a:t>
+            </a:r>
+            <a:r>
+              <a:rPr sz="1100">
+                <a:solidFill>
+                  <a:srgbClr val="F5CE76"/>
+                </a:solidFill>
+                <a:latin typeface="Cambria"/>
+                <a:ea typeface="Cambria"/>
+                <a:cs typeface="Cambria"/>
+              </a:rPr>
+              <a:t> у коробі</a:t>
+            </a:r>
+            <a:endParaRPr sz="1900"/>
+          </a:p>
+        </p:txBody>
+      </p:sp>
+      <p:sp>
+        <p:nvSpPr>
+          <p:cNvPr id="27" name="Text 24">
+            <a:extLst xmlns:a="http://schemas.openxmlformats.org/drawingml/2006/main">
+              <a:ext uri="{FF2B5EF4-FFF2-40B4-BE49-F238E27FC236}">
+                <a16:creationId xmlns:a16="http://schemas.microsoft.com/office/drawing/2014/main" id="{9254B401-36F1-4B46-897A-3CB2BDEB1BA4}"/>
+              </a:ext>
+            </a:extLst>
+          </p:cNvPr>
+          <p:cNvSpPr>
+            <a:spLocks xmlns:a="http://schemas.openxmlformats.org/drawingml/2006/main" noGrp="1"/>
+          </p:cNvSpPr>
+          <p:nvPr/>
+        </p:nvSpPr>
+        <p:spPr>
+          <a:xfrm xmlns:a="http://schemas.openxmlformats.org/drawingml/2006/main">
+            <a:off x="9098280" y="4581144"/>
+            <a:ext cx="2377440" cy="365760"/>
+          </a:xfrm>
+          <a:prstGeom xmlns:a="http://schemas.openxmlformats.org/drawingml/2006/main" prst="rect">
+            <a:avLst/>
+          </a:prstGeom>
+          <a:noFill xmlns:a="http://schemas.openxmlformats.org/drawingml/2006/main"/>
+        </p:spPr>
+        <p:txBody>
+          <a:bodyPr xmlns:a="http://schemas.openxmlformats.org/drawingml/2006/main" wrap="square" lIns="0" tIns="0" rIns="0" bIns="0" anchor="ctr"/>
+          <a:lstStyle xmlns:a="http://schemas.openxmlformats.org/drawingml/2006/main"/>
+          <a:p xmlns:a="http://schemas.openxmlformats.org/drawingml/2006/main">
+            <a:pPr marL="0" indent="0" algn="r">
+              <a:buNone/>
+            </a:pPr>
+            <a:r>
+              <a:rPr sz="1050">
+                <a:solidFill>
+                  <a:srgbClr val="FCF9F0"/>
+                </a:solidFill>
+                <a:latin typeface="Calibri"/>
+                <a:ea typeface="Calibri"/>
+                <a:cs typeface="Calibri"/>
+              </a:rPr>
+              <a:t>2 × 125 г = 250 г / уніт</a:t>
+            </a:r>
+            <a:endParaRPr sz="1050"/>
+          </a:p>
+        </p:txBody>
+      </p:sp>
+      <p:sp>
+        <p:nvSpPr>
+          <p:cNvPr id="28" name="Shape 25">
+            <a:extLst xmlns:a="http://schemas.openxmlformats.org/drawingml/2006/main">
+              <a:ext uri="{FF2B5EF4-FFF2-40B4-BE49-F238E27FC236}">
+                <a16:creationId xmlns:a16="http://schemas.microsoft.com/office/drawing/2014/main" id="{B6DB6DF8-9EDE-4700-B934-B2C5D27FD37C}"/>
+              </a:ext>
+            </a:extLst>
+          </p:cNvPr>
+          <p:cNvSpPr>
+            <a:spLocks xmlns:a="http://schemas.openxmlformats.org/drawingml/2006/main" noGrp="1"/>
+          </p:cNvSpPr>
+          <p:nvPr/>
+        </p:nvSpPr>
+        <p:spPr>
+          <a:xfrm xmlns:a="http://schemas.openxmlformats.org/drawingml/2006/main">
+            <a:off x="7534656" y="5093208"/>
+            <a:ext cx="4096512" cy="484632"/>
           </a:xfrm>
           <a:prstGeom xmlns:a="http://schemas.openxmlformats.org/drawingml/2006/main" prst="roundRect">
             <a:avLst>
-              <a:gd name="adj" fmla="val 5469"/>
-            </a:avLst>
-          </a:prstGeom>
-          <a:solidFill xmlns:a="http://schemas.openxmlformats.org/drawingml/2006/main">
-            <a:srgbClr val="1A5433">
-              <a:alpha val="92000"/>
-            </a:srgbClr>
-          </a:solidFill>
-          <a:ln xmlns:a="http://schemas.openxmlformats.org/drawingml/2006/main" w="9525">
-            <a:solidFill>
-              <a:srgbClr val="C89C40"/>
-            </a:solidFill>
-            <a:prstDash val="solid"/>
-          </a:ln>
-        </p:spPr>
-        <p:txBody>
-          <a:bodyPr xmlns:a="http://schemas.openxmlformats.org/drawingml/2006/main"/>
-          <a:lstStyle xmlns:a="http://schemas.openxmlformats.org/drawingml/2006/main"/>
-          <a:p xmlns:a="http://schemas.openxmlformats.org/drawingml/2006/main">
-            <a:endParaRPr/>
-          </a:p>
-        </p:txBody>
-      </p:sp>
-      <p:sp>
-        <p:nvSpPr>
-          <p:cNvPr id="30" name="Text 26">
-            <a:extLst xmlns:a="http://schemas.openxmlformats.org/drawingml/2006/main">
-              <a:ext uri="{FF2B5EF4-FFF2-40B4-BE49-F238E27FC236}">
-                <a16:creationId xmlns:a16="http://schemas.microsoft.com/office/drawing/2014/main" id="{D005C7CF-646A-4687-B1EA-E63F75D77D5C}"/>
-              </a:ext>
-            </a:extLst>
-          </p:cNvPr>
-          <p:cNvSpPr>
-            <a:spLocks xmlns:a="http://schemas.openxmlformats.org/drawingml/2006/main" noGrp="1"/>
-          </p:cNvSpPr>
-          <p:nvPr/>
-        </p:nvSpPr>
-        <p:spPr>
-          <a:xfrm xmlns:a="http://schemas.openxmlformats.org/drawingml/2006/main">
-            <a:off x="3675888" y="4855464"/>
-            <a:ext cx="2148840" cy="182880"/>
-          </a:xfrm>
-          <a:prstGeom xmlns:a="http://schemas.openxmlformats.org/drawingml/2006/main" prst="rect">
-            <a:avLst/>
-          </a:prstGeom>
-          <a:noFill xmlns:a="http://schemas.openxmlformats.org/drawingml/2006/main"/>
-        </p:spPr>
-        <p:txBody>
-          <a:bodyPr xmlns:a="http://schemas.openxmlformats.org/drawingml/2006/main" wrap="square" lIns="0" tIns="0" rIns="0" bIns="0" anchor="ctr"/>
-          <a:lstStyle xmlns:a="http://schemas.openxmlformats.org/drawingml/2006/main"/>
-          <a:p xmlns:a="http://schemas.openxmlformats.org/drawingml/2006/main">
-            <a:pPr marL="0" indent="0">
-              <a:buNone/>
-            </a:pPr>
-            <a:r>
-              <a:rPr sz="750" b="1" spc="100">
-                <a:solidFill>
-                  <a:srgbClr val="F5CE76"/>
-                </a:solidFill>
-                <a:latin typeface="Calibri"/>
-                <a:ea typeface="Calibri"/>
-                <a:cs typeface="Calibri"/>
-              </a:rPr>
-              <a:t>ПАРАМЕТРИ УПАКОВКИ</a:t>
-            </a:r>
-            <a:endParaRPr sz="750"/>
-          </a:p>
-        </p:txBody>
-      </p:sp>
-      <p:sp>
-        <p:nvSpPr>
-          <p:cNvPr id="31" name="Text 27">
-            <a:extLst xmlns:a="http://schemas.openxmlformats.org/drawingml/2006/main">
-              <a:ext uri="{FF2B5EF4-FFF2-40B4-BE49-F238E27FC236}">
-                <a16:creationId xmlns:a16="http://schemas.microsoft.com/office/drawing/2014/main" id="{793A1173-463D-43C7-AEA9-358CA2D92BA8}"/>
-              </a:ext>
-            </a:extLst>
-          </p:cNvPr>
-          <p:cNvSpPr>
-            <a:spLocks xmlns:a="http://schemas.openxmlformats.org/drawingml/2006/main" noGrp="1"/>
-          </p:cNvSpPr>
-          <p:nvPr/>
-        </p:nvSpPr>
-        <p:spPr>
-          <a:xfrm xmlns:a="http://schemas.openxmlformats.org/drawingml/2006/main">
-            <a:off x="3675888" y="5056632"/>
-            <a:ext cx="658368" cy="192024"/>
-          </a:xfrm>
-          <a:prstGeom xmlns:a="http://schemas.openxmlformats.org/drawingml/2006/main" prst="rect">
-            <a:avLst/>
-          </a:prstGeom>
-          <a:noFill xmlns:a="http://schemas.openxmlformats.org/drawingml/2006/main"/>
-        </p:spPr>
-        <p:txBody>
-          <a:bodyPr xmlns:a="http://schemas.openxmlformats.org/drawingml/2006/main" wrap="square" lIns="0" tIns="0" rIns="0" bIns="0" anchor="ctr"/>
-          <a:lstStyle xmlns:a="http://schemas.openxmlformats.org/drawingml/2006/main"/>
-          <a:p xmlns:a="http://schemas.openxmlformats.org/drawingml/2006/main">
-            <a:pPr marL="0" indent="0">
-              <a:buNone/>
-            </a:pPr>
-            <a:r>
-              <a:rPr sz="900">
-                <a:solidFill>
-                  <a:srgbClr val="D2E4CE"/>
-                </a:solidFill>
-                <a:latin typeface="Calibri"/>
-                <a:ea typeface="Calibri"/>
-                <a:cs typeface="Calibri"/>
-              </a:rPr>
-              <a:t>Формат</a:t>
-            </a:r>
-            <a:endParaRPr sz="900"/>
-          </a:p>
-        </p:txBody>
-      </p:sp>
-      <p:sp>
-        <p:nvSpPr>
-          <p:cNvPr id="32" name="Text 28">
-            <a:extLst xmlns:a="http://schemas.openxmlformats.org/drawingml/2006/main">
-              <a:ext uri="{FF2B5EF4-FFF2-40B4-BE49-F238E27FC236}">
-                <a16:creationId xmlns:a16="http://schemas.microsoft.com/office/drawing/2014/main" id="{7117FC0B-4F73-40B9-9BEC-953254E4BA9A}"/>
-              </a:ext>
-            </a:extLst>
-          </p:cNvPr>
-          <p:cNvSpPr>
-            <a:spLocks xmlns:a="http://schemas.openxmlformats.org/drawingml/2006/main" noGrp="1"/>
-          </p:cNvSpPr>
-          <p:nvPr/>
-        </p:nvSpPr>
-        <p:spPr>
-          <a:xfrm xmlns:a="http://schemas.openxmlformats.org/drawingml/2006/main">
-            <a:off x="4315968" y="5056632"/>
-            <a:ext cx="1508760" cy="192024"/>
-          </a:xfrm>
-          <a:prstGeom xmlns:a="http://schemas.openxmlformats.org/drawingml/2006/main" prst="rect">
-            <a:avLst/>
-          </a:prstGeom>
-          <a:noFill xmlns:a="http://schemas.openxmlformats.org/drawingml/2006/main"/>
-        </p:spPr>
-        <p:txBody>
-          <a:bodyPr xmlns:a="http://schemas.openxmlformats.org/drawingml/2006/main" wrap="square" lIns="0" tIns="0" rIns="0" bIns="0" anchor="ctr"/>
-          <a:lstStyle xmlns:a="http://schemas.openxmlformats.org/drawingml/2006/main"/>
-          <a:p xmlns:a="http://schemas.openxmlformats.org/drawingml/2006/main">
-            <a:pPr marL="0" indent="0" algn="r">
-              <a:buNone/>
-            </a:pPr>
-            <a:r>
-              <a:rPr sz="950">
-                <a:solidFill>
-                  <a:srgbClr val="FCF9F0"/>
-                </a:solidFill>
-                <a:latin typeface="Calibri"/>
-                <a:ea typeface="Calibri"/>
-                <a:cs typeface="Calibri"/>
-              </a:rPr>
-              <a:t>Single Cup</a:t>
-            </a:r>
-            <a:endParaRPr sz="950"/>
-          </a:p>
-        </p:txBody>
-      </p:sp>
-      <p:sp>
-        <p:nvSpPr>
-          <p:cNvPr id="33" name="Text 29">
-            <a:extLst xmlns:a="http://schemas.openxmlformats.org/drawingml/2006/main">
-              <a:ext uri="{FF2B5EF4-FFF2-40B4-BE49-F238E27FC236}">
-                <a16:creationId xmlns:a16="http://schemas.microsoft.com/office/drawing/2014/main" id="{48663418-84F8-4462-909D-711F0DD1DDD7}"/>
-              </a:ext>
-            </a:extLst>
-          </p:cNvPr>
-          <p:cNvSpPr>
-            <a:spLocks xmlns:a="http://schemas.openxmlformats.org/drawingml/2006/main" noGrp="1"/>
-          </p:cNvSpPr>
-          <p:nvPr/>
-        </p:nvSpPr>
-        <p:spPr>
-          <a:xfrm xmlns:a="http://schemas.openxmlformats.org/drawingml/2006/main">
-            <a:off x="3675888" y="5262372"/>
-            <a:ext cx="658368" cy="192024"/>
-          </a:xfrm>
-          <a:prstGeom xmlns:a="http://schemas.openxmlformats.org/drawingml/2006/main" prst="rect">
-            <a:avLst/>
-          </a:prstGeom>
-          <a:noFill xmlns:a="http://schemas.openxmlformats.org/drawingml/2006/main"/>
-        </p:spPr>
-        <p:txBody>
-          <a:bodyPr xmlns:a="http://schemas.openxmlformats.org/drawingml/2006/main" wrap="square" lIns="0" tIns="0" rIns="0" bIns="0" anchor="ctr"/>
-          <a:lstStyle xmlns:a="http://schemas.openxmlformats.org/drawingml/2006/main"/>
-          <a:p xmlns:a="http://schemas.openxmlformats.org/drawingml/2006/main">
-            <a:pPr marL="0" indent="0">
-              <a:buNone/>
-            </a:pPr>
-            <a:r>
-              <a:rPr sz="900" b="1">
-                <a:solidFill>
-                  <a:srgbClr val="F5CE76"/>
-                </a:solidFill>
-                <a:latin typeface="Calibri"/>
-                <a:ea typeface="Calibri"/>
-                <a:cs typeface="Calibri"/>
-              </a:rPr>
-              <a:t>Вага</a:t>
-            </a:r>
-            <a:endParaRPr sz="900"/>
-          </a:p>
-        </p:txBody>
-      </p:sp>
-      <p:sp>
-        <p:nvSpPr>
-          <p:cNvPr id="34" name="Text 30">
-            <a:extLst xmlns:a="http://schemas.openxmlformats.org/drawingml/2006/main">
-              <a:ext uri="{FF2B5EF4-FFF2-40B4-BE49-F238E27FC236}">
-                <a16:creationId xmlns:a16="http://schemas.microsoft.com/office/drawing/2014/main" id="{B09A954A-25C5-4C8C-BACC-D09A2CA513F0}"/>
-              </a:ext>
-            </a:extLst>
-          </p:cNvPr>
-          <p:cNvSpPr>
-            <a:spLocks xmlns:a="http://schemas.openxmlformats.org/drawingml/2006/main" noGrp="1"/>
-          </p:cNvSpPr>
-          <p:nvPr/>
-        </p:nvSpPr>
-        <p:spPr>
-          <a:xfrm xmlns:a="http://schemas.openxmlformats.org/drawingml/2006/main">
-            <a:off x="4315968" y="5262372"/>
-            <a:ext cx="1508760" cy="192024"/>
-          </a:xfrm>
-          <a:prstGeom xmlns:a="http://schemas.openxmlformats.org/drawingml/2006/main" prst="rect">
-            <a:avLst/>
-          </a:prstGeom>
-          <a:noFill xmlns:a="http://schemas.openxmlformats.org/drawingml/2006/main"/>
-        </p:spPr>
-        <p:txBody>
-          <a:bodyPr xmlns:a="http://schemas.openxmlformats.org/drawingml/2006/main" wrap="square" lIns="0" tIns="0" rIns="0" bIns="0" anchor="ctr"/>
-          <a:lstStyle xmlns:a="http://schemas.openxmlformats.org/drawingml/2006/main"/>
-          <a:p xmlns:a="http://schemas.openxmlformats.org/drawingml/2006/main">
-            <a:pPr marL="0" indent="0" algn="r">
-              <a:buNone/>
-            </a:pPr>
-            <a:r>
-              <a:rPr sz="950" b="1">
-                <a:solidFill>
-                  <a:srgbClr val="F5CE76"/>
-                </a:solidFill>
-                <a:latin typeface="Calibri"/>
-                <a:ea typeface="Calibri"/>
-                <a:cs typeface="Calibri"/>
-              </a:rPr>
-              <a:t>150 г</a:t>
-            </a:r>
-            <a:endParaRPr sz="950"/>
-          </a:p>
-        </p:txBody>
-      </p:sp>
-      <p:sp>
-        <p:nvSpPr>
-          <p:cNvPr id="35" name="Text 31">
-            <a:extLst xmlns:a="http://schemas.openxmlformats.org/drawingml/2006/main">
-              <a:ext uri="{FF2B5EF4-FFF2-40B4-BE49-F238E27FC236}">
-                <a16:creationId xmlns:a16="http://schemas.microsoft.com/office/drawing/2014/main" id="{1BD63ABA-2795-4167-B138-F7286363F43A}"/>
-              </a:ext>
-            </a:extLst>
-          </p:cNvPr>
-          <p:cNvSpPr>
-            <a:spLocks xmlns:a="http://schemas.openxmlformats.org/drawingml/2006/main" noGrp="1"/>
-          </p:cNvSpPr>
-          <p:nvPr/>
-        </p:nvSpPr>
-        <p:spPr>
-          <a:xfrm xmlns:a="http://schemas.openxmlformats.org/drawingml/2006/main">
-            <a:off x="3675888" y="5468112"/>
-            <a:ext cx="658368" cy="192024"/>
-          </a:xfrm>
-          <a:prstGeom xmlns:a="http://schemas.openxmlformats.org/drawingml/2006/main" prst="rect">
-            <a:avLst/>
-          </a:prstGeom>
-          <a:noFill xmlns:a="http://schemas.openxmlformats.org/drawingml/2006/main"/>
-        </p:spPr>
-        <p:txBody>
-          <a:bodyPr xmlns:a="http://schemas.openxmlformats.org/drawingml/2006/main" wrap="square" lIns="0" tIns="0" rIns="0" bIns="0" anchor="ctr"/>
-          <a:lstStyle xmlns:a="http://schemas.openxmlformats.org/drawingml/2006/main"/>
-          <a:p xmlns:a="http://schemas.openxmlformats.org/drawingml/2006/main">
-            <a:pPr marL="0" indent="0">
-              <a:buNone/>
-            </a:pPr>
-            <a:r>
-              <a:rPr sz="900">
-                <a:solidFill>
-                  <a:srgbClr val="D2E4CE"/>
-                </a:solidFill>
-                <a:latin typeface="Calibri"/>
-                <a:ea typeface="Calibri"/>
-                <a:cs typeface="Calibri"/>
-              </a:rPr>
-              <a:t>Короб</a:t>
-            </a:r>
-            <a:endParaRPr sz="900"/>
-          </a:p>
-        </p:txBody>
-      </p:sp>
-      <p:sp>
-        <p:nvSpPr>
-          <p:cNvPr id="36" name="Text 32">
-            <a:extLst xmlns:a="http://schemas.openxmlformats.org/drawingml/2006/main">
-              <a:ext uri="{FF2B5EF4-FFF2-40B4-BE49-F238E27FC236}">
-                <a16:creationId xmlns:a16="http://schemas.microsoft.com/office/drawing/2014/main" id="{995EAFC3-88FF-44CF-AFF4-614342C3B96D}"/>
-              </a:ext>
-            </a:extLst>
-          </p:cNvPr>
-          <p:cNvSpPr>
-            <a:spLocks xmlns:a="http://schemas.openxmlformats.org/drawingml/2006/main" noGrp="1"/>
-          </p:cNvSpPr>
-          <p:nvPr/>
-        </p:nvSpPr>
-        <p:spPr>
-          <a:xfrm xmlns:a="http://schemas.openxmlformats.org/drawingml/2006/main">
-            <a:off x="4315968" y="5468112"/>
-            <a:ext cx="1508760" cy="192024"/>
-          </a:xfrm>
-          <a:prstGeom xmlns:a="http://schemas.openxmlformats.org/drawingml/2006/main" prst="rect">
-            <a:avLst/>
-          </a:prstGeom>
-          <a:noFill xmlns:a="http://schemas.openxmlformats.org/drawingml/2006/main"/>
-        </p:spPr>
-        <p:txBody>
-          <a:bodyPr xmlns:a="http://schemas.openxmlformats.org/drawingml/2006/main" wrap="square" lIns="0" tIns="0" rIns="0" bIns="0" anchor="ctr"/>
-          <a:lstStyle xmlns:a="http://schemas.openxmlformats.org/drawingml/2006/main"/>
-          <a:p xmlns:a="http://schemas.openxmlformats.org/drawingml/2006/main">
-            <a:pPr marL="0" indent="0" algn="r">
-              <a:buNone/>
-            </a:pPr>
-            <a:r>
-              <a:rPr sz="950">
-                <a:solidFill>
-                  <a:srgbClr val="FCF9F0"/>
-                </a:solidFill>
-                <a:latin typeface="Calibri"/>
-                <a:ea typeface="Calibri"/>
-                <a:cs typeface="Calibri"/>
-              </a:rPr>
-              <a:t>12 шт.</a:t>
-            </a:r>
-            <a:endParaRPr sz="950"/>
-          </a:p>
-        </p:txBody>
-      </p:sp>
-      <p:sp>
-        <p:nvSpPr>
-          <p:cNvPr id="37" name="Text 33">
-            <a:extLst xmlns:a="http://schemas.openxmlformats.org/drawingml/2006/main">
-              <a:ext uri="{FF2B5EF4-FFF2-40B4-BE49-F238E27FC236}">
-                <a16:creationId xmlns:a16="http://schemas.microsoft.com/office/drawing/2014/main" id="{90133D29-79AD-41F7-AC4D-08F94F211A09}"/>
-              </a:ext>
-            </a:extLst>
-          </p:cNvPr>
-          <p:cNvSpPr>
-            <a:spLocks xmlns:a="http://schemas.openxmlformats.org/drawingml/2006/main" noGrp="1"/>
-          </p:cNvSpPr>
-          <p:nvPr/>
-        </p:nvSpPr>
-        <p:spPr>
-          <a:xfrm xmlns:a="http://schemas.openxmlformats.org/drawingml/2006/main">
-            <a:off x="3675888" y="5673852"/>
-            <a:ext cx="658368" cy="192024"/>
-          </a:xfrm>
-          <a:prstGeom xmlns:a="http://schemas.openxmlformats.org/drawingml/2006/main" prst="rect">
-            <a:avLst/>
-          </a:prstGeom>
-          <a:noFill xmlns:a="http://schemas.openxmlformats.org/drawingml/2006/main"/>
-        </p:spPr>
-        <p:txBody>
-          <a:bodyPr xmlns:a="http://schemas.openxmlformats.org/drawingml/2006/main" wrap="square" lIns="0" tIns="0" rIns="0" bIns="0" anchor="ctr"/>
-          <a:lstStyle xmlns:a="http://schemas.openxmlformats.org/drawingml/2006/main"/>
-          <a:p xmlns:a="http://schemas.openxmlformats.org/drawingml/2006/main">
-            <a:pPr marL="0" indent="0">
-              <a:buNone/>
-            </a:pPr>
-            <a:r>
-              <a:rPr sz="900">
-                <a:solidFill>
-                  <a:srgbClr val="D2E4CE"/>
-                </a:solidFill>
-                <a:latin typeface="Calibri"/>
-                <a:ea typeface="Calibri"/>
-                <a:cs typeface="Calibri"/>
-              </a:rPr>
-              <a:t>Статус</a:t>
-            </a:r>
-            <a:endParaRPr sz="900"/>
-          </a:p>
-        </p:txBody>
-      </p:sp>
-      <p:sp>
-        <p:nvSpPr>
-          <p:cNvPr id="38" name="Text 34">
-            <a:extLst xmlns:a="http://schemas.openxmlformats.org/drawingml/2006/main">
-              <a:ext uri="{FF2B5EF4-FFF2-40B4-BE49-F238E27FC236}">
-                <a16:creationId xmlns:a16="http://schemas.microsoft.com/office/drawing/2014/main" id="{48907D16-EC0C-4DB8-9E32-E30599EA1EE7}"/>
-              </a:ext>
-            </a:extLst>
-          </p:cNvPr>
-          <p:cNvSpPr>
-            <a:spLocks xmlns:a="http://schemas.openxmlformats.org/drawingml/2006/main" noGrp="1"/>
-          </p:cNvSpPr>
-          <p:nvPr/>
-        </p:nvSpPr>
-        <p:spPr>
-          <a:xfrm xmlns:a="http://schemas.openxmlformats.org/drawingml/2006/main">
-            <a:off x="4315968" y="5673852"/>
-            <a:ext cx="1508760" cy="192024"/>
-          </a:xfrm>
-          <a:prstGeom xmlns:a="http://schemas.openxmlformats.org/drawingml/2006/main" prst="rect">
-            <a:avLst/>
-          </a:prstGeom>
-          <a:noFill xmlns:a="http://schemas.openxmlformats.org/drawingml/2006/main"/>
-        </p:spPr>
-        <p:txBody>
-          <a:bodyPr xmlns:a="http://schemas.openxmlformats.org/drawingml/2006/main" wrap="square" lIns="0" tIns="0" rIns="0" bIns="0" anchor="ctr"/>
-          <a:lstStyle xmlns:a="http://schemas.openxmlformats.org/drawingml/2006/main"/>
-          <a:p xmlns:a="http://schemas.openxmlformats.org/drawingml/2006/main">
-            <a:pPr marL="0" indent="0" algn="r">
-              <a:buNone/>
-            </a:pPr>
-            <a:r>
-              <a:rPr sz="950">
-                <a:solidFill>
-                  <a:srgbClr val="FCF9F0"/>
-                </a:solidFill>
-                <a:latin typeface="Calibri"/>
-                <a:ea typeface="Calibri"/>
-                <a:cs typeface="Calibri"/>
-              </a:rPr>
-              <a:t>немає в PL</a:t>
-            </a:r>
-            <a:endParaRPr sz="950"/>
-          </a:p>
-        </p:txBody>
-      </p:sp>
-      <p:sp>
-        <p:nvSpPr>
-          <p:cNvPr id="39" name="Shape 35">
-            <a:extLst xmlns:a="http://schemas.openxmlformats.org/drawingml/2006/main">
-              <a:ext uri="{FF2B5EF4-FFF2-40B4-BE49-F238E27FC236}">
-                <a16:creationId xmlns:a16="http://schemas.microsoft.com/office/drawing/2014/main" id="{2259E21A-9C34-47EA-B3E9-E565B7940B3A}"/>
-              </a:ext>
-            </a:extLst>
-          </p:cNvPr>
-          <p:cNvSpPr>
-            <a:spLocks xmlns:a="http://schemas.openxmlformats.org/drawingml/2006/main" noGrp="1"/>
-          </p:cNvSpPr>
-          <p:nvPr/>
-        </p:nvSpPr>
-        <p:spPr>
-          <a:xfrm xmlns:a="http://schemas.openxmlformats.org/drawingml/2006/main">
-            <a:off x="6199632" y="1536192"/>
-            <a:ext cx="2706624" cy="4626864"/>
-          </a:xfrm>
-          <a:prstGeom xmlns:a="http://schemas.openxmlformats.org/drawingml/2006/main" prst="roundRect">
-            <a:avLst>
-              <a:gd name="adj" fmla="val 4054"/>
+              <a:gd name="adj" fmla="val 15094"/>
             </a:avLst>
           </a:prstGeom>
           <a:solidFill xmlns:a="http://schemas.openxmlformats.org/drawingml/2006/main">
@@ -16533,701 +16043,129 @@
       </p:sp>
       <p:sp>
         <p:nvSpPr>
-          <p:cNvPr id="41" name="Shape 36">
-            <a:extLst xmlns:a="http://schemas.openxmlformats.org/drawingml/2006/main">
-              <a:ext uri="{FF2B5EF4-FFF2-40B4-BE49-F238E27FC236}">
-                <a16:creationId xmlns:a16="http://schemas.microsoft.com/office/drawing/2014/main" id="{0711C6CE-DEDB-4DD0-8D53-429DE193BFFB}"/>
-              </a:ext>
-            </a:extLst>
-          </p:cNvPr>
-          <p:cNvSpPr>
-            <a:spLocks xmlns:a="http://schemas.openxmlformats.org/drawingml/2006/main" noGrp="1"/>
-          </p:cNvSpPr>
-          <p:nvPr/>
-        </p:nvSpPr>
-        <p:spPr>
-          <a:xfrm xmlns:a="http://schemas.openxmlformats.org/drawingml/2006/main">
-            <a:off x="6382512" y="1700784"/>
-            <a:ext cx="2340864" cy="1810512"/>
-          </a:xfrm>
-          <a:prstGeom xmlns:a="http://schemas.openxmlformats.org/drawingml/2006/main" prst="rect">
-            <a:avLst/>
-          </a:prstGeom>
-          <a:ln xmlns:a="http://schemas.openxmlformats.org/drawingml/2006/main" w="12700">
-            <a:solidFill>
-              <a:srgbClr val="C89C40"/>
-            </a:solidFill>
-            <a:prstDash val="solid"/>
-          </a:ln>
-        </p:spPr>
-        <p:txBody>
-          <a:bodyPr xmlns:a="http://schemas.openxmlformats.org/drawingml/2006/main"/>
-          <a:lstStyle xmlns:a="http://schemas.openxmlformats.org/drawingml/2006/main"/>
-          <a:p xmlns:a="http://schemas.openxmlformats.org/drawingml/2006/main">
-            <a:endParaRPr/>
-          </a:p>
-        </p:txBody>
-      </p:sp>
-      <p:sp>
-        <p:nvSpPr>
-          <p:cNvPr id="42" name="Shape 37">
-            <a:extLst xmlns:a="http://schemas.openxmlformats.org/drawingml/2006/main">
-              <a:ext uri="{FF2B5EF4-FFF2-40B4-BE49-F238E27FC236}">
-                <a16:creationId xmlns:a16="http://schemas.microsoft.com/office/drawing/2014/main" id="{DC7C47A5-93C4-467C-AF6A-51561B8A3AB4}"/>
-              </a:ext>
-            </a:extLst>
-          </p:cNvPr>
-          <p:cNvSpPr>
-            <a:spLocks xmlns:a="http://schemas.openxmlformats.org/drawingml/2006/main" noGrp="1"/>
-          </p:cNvSpPr>
-          <p:nvPr/>
-        </p:nvSpPr>
-        <p:spPr>
-          <a:xfrm xmlns:a="http://schemas.openxmlformats.org/drawingml/2006/main">
-            <a:off x="6382512" y="3611880"/>
-            <a:ext cx="1417320" cy="237744"/>
-          </a:xfrm>
-          <a:prstGeom xmlns:a="http://schemas.openxmlformats.org/drawingml/2006/main" prst="roundRect">
-            <a:avLst>
-              <a:gd name="adj" fmla="val 23077"/>
-            </a:avLst>
-          </a:prstGeom>
-          <a:solidFill xmlns:a="http://schemas.openxmlformats.org/drawingml/2006/main">
-            <a:srgbClr val="B0762A"/>
-          </a:solidFill>
-          <a:ln xmlns:a="http://schemas.openxmlformats.org/drawingml/2006/main" w="6350">
-            <a:solidFill>
-              <a:srgbClr val="C89C40"/>
-            </a:solidFill>
-            <a:prstDash val="solid"/>
-          </a:ln>
-        </p:spPr>
-        <p:txBody>
-          <a:bodyPr xmlns:a="http://schemas.openxmlformats.org/drawingml/2006/main"/>
-          <a:lstStyle xmlns:a="http://schemas.openxmlformats.org/drawingml/2006/main"/>
-          <a:p xmlns:a="http://schemas.openxmlformats.org/drawingml/2006/main">
-            <a:endParaRPr/>
-          </a:p>
-        </p:txBody>
-      </p:sp>
-      <p:sp>
-        <p:nvSpPr>
-          <p:cNvPr id="43" name="Text 38">
-            <a:extLst xmlns:a="http://schemas.openxmlformats.org/drawingml/2006/main">
-              <a:ext uri="{FF2B5EF4-FFF2-40B4-BE49-F238E27FC236}">
-                <a16:creationId xmlns:a16="http://schemas.microsoft.com/office/drawing/2014/main" id="{0596B2BA-8710-4E95-8365-1BF11E1890BF}"/>
-              </a:ext>
-            </a:extLst>
-          </p:cNvPr>
-          <p:cNvSpPr>
-            <a:spLocks xmlns:a="http://schemas.openxmlformats.org/drawingml/2006/main" noGrp="1"/>
-          </p:cNvSpPr>
-          <p:nvPr/>
-        </p:nvSpPr>
-        <p:spPr>
-          <a:xfrm xmlns:a="http://schemas.openxmlformats.org/drawingml/2006/main">
-            <a:off x="6382512" y="3621024"/>
-            <a:ext cx="1417320" cy="219456"/>
-          </a:xfrm>
-          <a:prstGeom xmlns:a="http://schemas.openxmlformats.org/drawingml/2006/main" prst="rect">
-            <a:avLst/>
-          </a:prstGeom>
-          <a:noFill xmlns:a="http://schemas.openxmlformats.org/drawingml/2006/main"/>
-        </p:spPr>
-        <p:txBody>
-          <a:bodyPr xmlns:a="http://schemas.openxmlformats.org/drawingml/2006/main" wrap="square" lIns="0" tIns="0" rIns="0" bIns="0" anchor="ctr"/>
-          <a:lstStyle xmlns:a="http://schemas.openxmlformats.org/drawingml/2006/main"/>
-          <a:p xmlns:a="http://schemas.openxmlformats.org/drawingml/2006/main">
-            <a:pPr marL="0" indent="0" algn="ctr">
-              <a:buNone/>
-            </a:pPr>
-            <a:r>
-              <a:rPr sz="850" b="1" spc="60">
-                <a:solidFill>
-                  <a:srgbClr val="FFFFFF"/>
-                </a:solidFill>
-                <a:latin typeface="Calibri"/>
-                <a:ea typeface="Calibri"/>
-                <a:cs typeface="Calibri"/>
-              </a:rPr>
-              <a:t>DOUBLE CUP · PL</a:t>
-            </a:r>
-            <a:endParaRPr sz="850"/>
-          </a:p>
-        </p:txBody>
-      </p:sp>
-      <p:sp>
-        <p:nvSpPr>
-          <p:cNvPr id="44" name="Text 39">
-            <a:extLst xmlns:a="http://schemas.openxmlformats.org/drawingml/2006/main">
-              <a:ext uri="{FF2B5EF4-FFF2-40B4-BE49-F238E27FC236}">
-                <a16:creationId xmlns:a16="http://schemas.microsoft.com/office/drawing/2014/main" id="{C06B8F32-5124-4A18-AC53-3481907D9192}"/>
-              </a:ext>
-            </a:extLst>
-          </p:cNvPr>
-          <p:cNvSpPr>
-            <a:spLocks xmlns:a="http://schemas.openxmlformats.org/drawingml/2006/main" noGrp="1"/>
-          </p:cNvSpPr>
-          <p:nvPr/>
-        </p:nvSpPr>
-        <p:spPr>
-          <a:xfrm xmlns:a="http://schemas.openxmlformats.org/drawingml/2006/main">
-            <a:off x="6382512" y="3931920"/>
-            <a:ext cx="2340864" cy="548640"/>
-          </a:xfrm>
-          <a:prstGeom xmlns:a="http://schemas.openxmlformats.org/drawingml/2006/main" prst="rect">
-            <a:avLst/>
-          </a:prstGeom>
-          <a:noFill xmlns:a="http://schemas.openxmlformats.org/drawingml/2006/main"/>
-        </p:spPr>
-        <p:txBody>
-          <a:bodyPr xmlns:a="http://schemas.openxmlformats.org/drawingml/2006/main" wrap="square" lIns="0" tIns="0" rIns="0" bIns="0" anchor="t"/>
-          <a:lstStyle xmlns:a="http://schemas.openxmlformats.org/drawingml/2006/main"/>
-          <a:p xmlns:a="http://schemas.openxmlformats.org/drawingml/2006/main">
-            <a:pPr marL="0" indent="0">
-              <a:buNone/>
-            </a:pPr>
-            <a:r>
-              <a:rPr sz="1450" b="1">
-                <a:solidFill>
-                  <a:srgbClr val="FFFFFF"/>
+          <p:cNvPr id="29" name="Text 26">
+            <a:extLst xmlns:a="http://schemas.openxmlformats.org/drawingml/2006/main">
+              <a:ext uri="{FF2B5EF4-FFF2-40B4-BE49-F238E27FC236}">
+                <a16:creationId xmlns:a16="http://schemas.microsoft.com/office/drawing/2014/main" id="{C0BEDDE1-3BA8-41C7-A18B-3458416DEE72}"/>
+              </a:ext>
+            </a:extLst>
+          </p:cNvPr>
+          <p:cNvSpPr>
+            <a:spLocks xmlns:a="http://schemas.openxmlformats.org/drawingml/2006/main" noGrp="1"/>
+          </p:cNvSpPr>
+          <p:nvPr/>
+        </p:nvSpPr>
+        <p:spPr>
+          <a:xfrm xmlns:a="http://schemas.openxmlformats.org/drawingml/2006/main">
+            <a:off x="7717536" y="5148072"/>
+            <a:ext cx="1371600" cy="365760"/>
+          </a:xfrm>
+          <a:prstGeom xmlns:a="http://schemas.openxmlformats.org/drawingml/2006/main" prst="rect">
+            <a:avLst/>
+          </a:prstGeom>
+          <a:noFill xmlns:a="http://schemas.openxmlformats.org/drawingml/2006/main"/>
+        </p:spPr>
+        <p:txBody>
+          <a:bodyPr xmlns:a="http://schemas.openxmlformats.org/drawingml/2006/main" wrap="square" lIns="0" tIns="0" rIns="0" bIns="0" anchor="ctr"/>
+          <a:lstStyle xmlns:a="http://schemas.openxmlformats.org/drawingml/2006/main"/>
+          <a:p xmlns:a="http://schemas.openxmlformats.org/drawingml/2006/main">
+            <a:pPr marL="0" indent="0">
+              <a:buNone/>
+            </a:pPr>
+            <a:r>
+              <a:rPr sz="1900" b="1">
+                <a:solidFill>
+                  <a:srgbClr val="F5CE76"/>
                 </a:solidFill>
                 <a:latin typeface="Cambria"/>
                 <a:ea typeface="Cambria"/>
                 <a:cs typeface="Cambria"/>
               </a:rPr>
-              <a:t>SPAR Jasmine Rice Cups</a:t>
-            </a:r>
-            <a:endParaRPr sz="1450"/>
-          </a:p>
-        </p:txBody>
-      </p:sp>
-      <p:sp>
-        <p:nvSpPr>
-          <p:cNvPr id="45" name="Text 40">
-            <a:extLst xmlns:a="http://schemas.openxmlformats.org/drawingml/2006/main">
-              <a:ext uri="{FF2B5EF4-FFF2-40B4-BE49-F238E27FC236}">
-                <a16:creationId xmlns:a16="http://schemas.microsoft.com/office/drawing/2014/main" id="{B818A736-226A-4409-9E84-13D21A31A265}"/>
-              </a:ext>
-            </a:extLst>
-          </p:cNvPr>
-          <p:cNvSpPr>
-            <a:spLocks xmlns:a="http://schemas.openxmlformats.org/drawingml/2006/main" noGrp="1"/>
-          </p:cNvSpPr>
-          <p:nvPr/>
-        </p:nvSpPr>
-        <p:spPr>
-          <a:xfrm xmlns:a="http://schemas.openxmlformats.org/drawingml/2006/main">
-            <a:off x="6382512" y="4498848"/>
-            <a:ext cx="2340864" cy="237744"/>
-          </a:xfrm>
-          <a:prstGeom xmlns:a="http://schemas.openxmlformats.org/drawingml/2006/main" prst="rect">
-            <a:avLst/>
-          </a:prstGeom>
-          <a:noFill xmlns:a="http://schemas.openxmlformats.org/drawingml/2006/main"/>
-        </p:spPr>
-        <p:txBody>
-          <a:bodyPr xmlns:a="http://schemas.openxmlformats.org/drawingml/2006/main" wrap="square" lIns="0" tIns="0" rIns="0" bIns="0" anchor="ctr"/>
-          <a:lstStyle xmlns:a="http://schemas.openxmlformats.org/drawingml/2006/main"/>
-          <a:p xmlns:a="http://schemas.openxmlformats.org/drawingml/2006/main">
-            <a:pPr marL="0" indent="0">
-              <a:buNone/>
-            </a:pPr>
-            <a:r>
-              <a:rPr sz="1000">
-                <a:solidFill>
-                  <a:srgbClr val="D2E4CE"/>
-                </a:solidFill>
-                <a:latin typeface="Calibri"/>
-                <a:ea typeface="Calibri"/>
-                <a:cs typeface="Calibri"/>
-              </a:rPr>
-              <a:t>Приклад Private Label</a:t>
-            </a:r>
-            <a:endParaRPr sz="1000"/>
-          </a:p>
-        </p:txBody>
-      </p:sp>
-      <p:sp>
-        <p:nvSpPr>
-          <p:cNvPr id="46" name="Shape 41">
-            <a:extLst xmlns:a="http://schemas.openxmlformats.org/drawingml/2006/main">
-              <a:ext uri="{FF2B5EF4-FFF2-40B4-BE49-F238E27FC236}">
-                <a16:creationId xmlns:a16="http://schemas.microsoft.com/office/drawing/2014/main" id="{74EB33FE-2A74-4110-9400-0929BAE7D070}"/>
-              </a:ext>
-            </a:extLst>
-          </p:cNvPr>
-          <p:cNvSpPr>
-            <a:spLocks xmlns:a="http://schemas.openxmlformats.org/drawingml/2006/main" noGrp="1"/>
-          </p:cNvSpPr>
-          <p:nvPr/>
-        </p:nvSpPr>
-        <p:spPr>
-          <a:xfrm xmlns:a="http://schemas.openxmlformats.org/drawingml/2006/main">
-            <a:off x="6382512" y="4791456"/>
-            <a:ext cx="2340864" cy="1170432"/>
+              <a:t>PL</a:t>
+            </a:r>
+            <a:r>
+              <a:rPr sz="1100">
+                <a:solidFill>
+                  <a:srgbClr val="F5CE76"/>
+                </a:solidFill>
+                <a:latin typeface="Cambria"/>
+                <a:ea typeface="Cambria"/>
+                <a:cs typeface="Cambria"/>
+              </a:rPr>
+              <a:t> бренд</a:t>
+            </a:r>
+            <a:endParaRPr sz="1900"/>
+          </a:p>
+        </p:txBody>
+      </p:sp>
+      <p:sp>
+        <p:nvSpPr>
+          <p:cNvPr id="30" name="Text 27">
+            <a:extLst xmlns:a="http://schemas.openxmlformats.org/drawingml/2006/main">
+              <a:ext uri="{FF2B5EF4-FFF2-40B4-BE49-F238E27FC236}">
+                <a16:creationId xmlns:a16="http://schemas.microsoft.com/office/drawing/2014/main" id="{218C4906-3F42-4BCF-AD90-A44D05606B4C}"/>
+              </a:ext>
+            </a:extLst>
+          </p:cNvPr>
+          <p:cNvSpPr>
+            <a:spLocks xmlns:a="http://schemas.openxmlformats.org/drawingml/2006/main" noGrp="1"/>
+          </p:cNvSpPr>
+          <p:nvPr/>
+        </p:nvSpPr>
+        <p:spPr>
+          <a:xfrm xmlns:a="http://schemas.openxmlformats.org/drawingml/2006/main">
+            <a:off x="9098280" y="5148072"/>
+            <a:ext cx="2377440" cy="365760"/>
+          </a:xfrm>
+          <a:prstGeom xmlns:a="http://schemas.openxmlformats.org/drawingml/2006/main" prst="rect">
+            <a:avLst/>
+          </a:prstGeom>
+          <a:noFill xmlns:a="http://schemas.openxmlformats.org/drawingml/2006/main"/>
+        </p:spPr>
+        <p:txBody>
+          <a:bodyPr xmlns:a="http://schemas.openxmlformats.org/drawingml/2006/main" wrap="square" lIns="0" tIns="0" rIns="0" bIns="0" anchor="ctr"/>
+          <a:lstStyle xmlns:a="http://schemas.openxmlformats.org/drawingml/2006/main"/>
+          <a:p xmlns:a="http://schemas.openxmlformats.org/drawingml/2006/main">
+            <a:pPr marL="0" indent="0" algn="r">
+              <a:buNone/>
+            </a:pPr>
+            <a:r>
+              <a:rPr sz="1050">
+                <a:solidFill>
+                  <a:srgbClr val="FCF9F0"/>
+                </a:solidFill>
+                <a:latin typeface="Calibri"/>
+                <a:ea typeface="Calibri"/>
+                <a:cs typeface="Calibri"/>
+              </a:rPr>
+              <a:t>тільки Private Label</a:t>
+            </a:r>
+            <a:endParaRPr sz="1050"/>
+          </a:p>
+        </p:txBody>
+      </p:sp>
+      <p:sp>
+        <p:nvSpPr>
+          <p:cNvPr id="31" name="Shape 28">
+            <a:extLst xmlns:a="http://schemas.openxmlformats.org/drawingml/2006/main">
+              <a:ext uri="{FF2B5EF4-FFF2-40B4-BE49-F238E27FC236}">
+                <a16:creationId xmlns:a16="http://schemas.microsoft.com/office/drawing/2014/main" id="{5F74166D-A4F2-4F13-9CD5-9980A3D4D94F}"/>
+              </a:ext>
+            </a:extLst>
+          </p:cNvPr>
+          <p:cNvSpPr>
+            <a:spLocks xmlns:a="http://schemas.openxmlformats.org/drawingml/2006/main" noGrp="1"/>
+          </p:cNvSpPr>
+          <p:nvPr/>
+        </p:nvSpPr>
+        <p:spPr>
+          <a:xfrm xmlns:a="http://schemas.openxmlformats.org/drawingml/2006/main">
+            <a:off x="7534656" y="5660136"/>
+            <a:ext cx="4096512" cy="484632"/>
           </a:xfrm>
           <a:prstGeom xmlns:a="http://schemas.openxmlformats.org/drawingml/2006/main" prst="roundRect">
             <a:avLst>
-              <a:gd name="adj" fmla="val 5469"/>
-            </a:avLst>
-          </a:prstGeom>
-          <a:solidFill xmlns:a="http://schemas.openxmlformats.org/drawingml/2006/main">
-            <a:srgbClr val="1A5433">
-              <a:alpha val="92000"/>
-            </a:srgbClr>
-          </a:solidFill>
-          <a:ln xmlns:a="http://schemas.openxmlformats.org/drawingml/2006/main" w="9525">
-            <a:solidFill>
-              <a:srgbClr val="C89C40"/>
-            </a:solidFill>
-            <a:prstDash val="solid"/>
-          </a:ln>
-        </p:spPr>
-        <p:txBody>
-          <a:bodyPr xmlns:a="http://schemas.openxmlformats.org/drawingml/2006/main"/>
-          <a:lstStyle xmlns:a="http://schemas.openxmlformats.org/drawingml/2006/main"/>
-          <a:p xmlns:a="http://schemas.openxmlformats.org/drawingml/2006/main">
-            <a:endParaRPr/>
-          </a:p>
-        </p:txBody>
-      </p:sp>
-      <p:sp>
-        <p:nvSpPr>
-          <p:cNvPr id="47" name="Text 42">
-            <a:extLst xmlns:a="http://schemas.openxmlformats.org/drawingml/2006/main">
-              <a:ext uri="{FF2B5EF4-FFF2-40B4-BE49-F238E27FC236}">
-                <a16:creationId xmlns:a16="http://schemas.microsoft.com/office/drawing/2014/main" id="{49EEB924-E332-4CCD-95A2-34608E9213B3}"/>
-              </a:ext>
-            </a:extLst>
-          </p:cNvPr>
-          <p:cNvSpPr>
-            <a:spLocks xmlns:a="http://schemas.openxmlformats.org/drawingml/2006/main" noGrp="1"/>
-          </p:cNvSpPr>
-          <p:nvPr/>
-        </p:nvSpPr>
-        <p:spPr>
-          <a:xfrm xmlns:a="http://schemas.openxmlformats.org/drawingml/2006/main">
-            <a:off x="6492240" y="4855464"/>
-            <a:ext cx="2148840" cy="182880"/>
-          </a:xfrm>
-          <a:prstGeom xmlns:a="http://schemas.openxmlformats.org/drawingml/2006/main" prst="rect">
-            <a:avLst/>
-          </a:prstGeom>
-          <a:noFill xmlns:a="http://schemas.openxmlformats.org/drawingml/2006/main"/>
-        </p:spPr>
-        <p:txBody>
-          <a:bodyPr xmlns:a="http://schemas.openxmlformats.org/drawingml/2006/main" wrap="square" lIns="0" tIns="0" rIns="0" bIns="0" anchor="ctr"/>
-          <a:lstStyle xmlns:a="http://schemas.openxmlformats.org/drawingml/2006/main"/>
-          <a:p xmlns:a="http://schemas.openxmlformats.org/drawingml/2006/main">
-            <a:pPr marL="0" indent="0">
-              <a:buNone/>
-            </a:pPr>
-            <a:r>
-              <a:rPr sz="750" b="1" spc="100">
-                <a:solidFill>
-                  <a:srgbClr val="F5CE76"/>
-                </a:solidFill>
-                <a:latin typeface="Calibri"/>
-                <a:ea typeface="Calibri"/>
-                <a:cs typeface="Calibri"/>
-              </a:rPr>
-              <a:t>ПАРАМЕТРИ УПАКОВКИ</a:t>
-            </a:r>
-            <a:endParaRPr sz="750"/>
-          </a:p>
-        </p:txBody>
-      </p:sp>
-      <p:sp>
-        <p:nvSpPr>
-          <p:cNvPr id="48" name="Text 43">
-            <a:extLst xmlns:a="http://schemas.openxmlformats.org/drawingml/2006/main">
-              <a:ext uri="{FF2B5EF4-FFF2-40B4-BE49-F238E27FC236}">
-                <a16:creationId xmlns:a16="http://schemas.microsoft.com/office/drawing/2014/main" id="{1233661C-E122-46E4-B4AF-2E989ADA051C}"/>
-              </a:ext>
-            </a:extLst>
-          </p:cNvPr>
-          <p:cNvSpPr>
-            <a:spLocks xmlns:a="http://schemas.openxmlformats.org/drawingml/2006/main" noGrp="1"/>
-          </p:cNvSpPr>
-          <p:nvPr/>
-        </p:nvSpPr>
-        <p:spPr>
-          <a:xfrm xmlns:a="http://schemas.openxmlformats.org/drawingml/2006/main">
-            <a:off x="6492240" y="5056632"/>
-            <a:ext cx="658368" cy="192024"/>
-          </a:xfrm>
-          <a:prstGeom xmlns:a="http://schemas.openxmlformats.org/drawingml/2006/main" prst="rect">
-            <a:avLst/>
-          </a:prstGeom>
-          <a:noFill xmlns:a="http://schemas.openxmlformats.org/drawingml/2006/main"/>
-        </p:spPr>
-        <p:txBody>
-          <a:bodyPr xmlns:a="http://schemas.openxmlformats.org/drawingml/2006/main" wrap="square" lIns="0" tIns="0" rIns="0" bIns="0" anchor="ctr"/>
-          <a:lstStyle xmlns:a="http://schemas.openxmlformats.org/drawingml/2006/main"/>
-          <a:p xmlns:a="http://schemas.openxmlformats.org/drawingml/2006/main">
-            <a:pPr marL="0" indent="0">
-              <a:buNone/>
-            </a:pPr>
-            <a:r>
-              <a:rPr sz="900">
-                <a:solidFill>
-                  <a:srgbClr val="D2E4CE"/>
-                </a:solidFill>
-                <a:latin typeface="Calibri"/>
-                <a:ea typeface="Calibri"/>
-                <a:cs typeface="Calibri"/>
-              </a:rPr>
-              <a:t>Формат</a:t>
-            </a:r>
-            <a:endParaRPr sz="900"/>
-          </a:p>
-        </p:txBody>
-      </p:sp>
-      <p:sp>
-        <p:nvSpPr>
-          <p:cNvPr id="49" name="Text 44">
-            <a:extLst xmlns:a="http://schemas.openxmlformats.org/drawingml/2006/main">
-              <a:ext uri="{FF2B5EF4-FFF2-40B4-BE49-F238E27FC236}">
-                <a16:creationId xmlns:a16="http://schemas.microsoft.com/office/drawing/2014/main" id="{BFF0E6A6-EE49-4AEB-B04B-23DA22BE286F}"/>
-              </a:ext>
-            </a:extLst>
-          </p:cNvPr>
-          <p:cNvSpPr>
-            <a:spLocks xmlns:a="http://schemas.openxmlformats.org/drawingml/2006/main" noGrp="1"/>
-          </p:cNvSpPr>
-          <p:nvPr/>
-        </p:nvSpPr>
-        <p:spPr>
-          <a:xfrm xmlns:a="http://schemas.openxmlformats.org/drawingml/2006/main">
-            <a:off x="7132320" y="5056632"/>
-            <a:ext cx="1508760" cy="192024"/>
-          </a:xfrm>
-          <a:prstGeom xmlns:a="http://schemas.openxmlformats.org/drawingml/2006/main" prst="rect">
-            <a:avLst/>
-          </a:prstGeom>
-          <a:noFill xmlns:a="http://schemas.openxmlformats.org/drawingml/2006/main"/>
-        </p:spPr>
-        <p:txBody>
-          <a:bodyPr xmlns:a="http://schemas.openxmlformats.org/drawingml/2006/main" wrap="square" lIns="0" tIns="0" rIns="0" bIns="0" anchor="ctr"/>
-          <a:lstStyle xmlns:a="http://schemas.openxmlformats.org/drawingml/2006/main"/>
-          <a:p xmlns:a="http://schemas.openxmlformats.org/drawingml/2006/main">
-            <a:pPr marL="0" indent="0" algn="r">
-              <a:buNone/>
-            </a:pPr>
-            <a:r>
-              <a:rPr sz="950">
-                <a:solidFill>
-                  <a:srgbClr val="FCF9F0"/>
-                </a:solidFill>
-                <a:latin typeface="Calibri"/>
-                <a:ea typeface="Calibri"/>
-                <a:cs typeface="Calibri"/>
-              </a:rPr>
-              <a:t>2 × 125 г</a:t>
-            </a:r>
-            <a:endParaRPr sz="950"/>
-          </a:p>
-        </p:txBody>
-      </p:sp>
-      <p:sp>
-        <p:nvSpPr>
-          <p:cNvPr id="50" name="Text 45">
-            <a:extLst xmlns:a="http://schemas.openxmlformats.org/drawingml/2006/main">
-              <a:ext uri="{FF2B5EF4-FFF2-40B4-BE49-F238E27FC236}">
-                <a16:creationId xmlns:a16="http://schemas.microsoft.com/office/drawing/2014/main" id="{0696E1FB-7D6D-40FC-AD7C-66FBBC12B10C}"/>
-              </a:ext>
-            </a:extLst>
-          </p:cNvPr>
-          <p:cNvSpPr>
-            <a:spLocks xmlns:a="http://schemas.openxmlformats.org/drawingml/2006/main" noGrp="1"/>
-          </p:cNvSpPr>
-          <p:nvPr/>
-        </p:nvSpPr>
-        <p:spPr>
-          <a:xfrm xmlns:a="http://schemas.openxmlformats.org/drawingml/2006/main">
-            <a:off x="6492240" y="5262372"/>
-            <a:ext cx="658368" cy="192024"/>
-          </a:xfrm>
-          <a:prstGeom xmlns:a="http://schemas.openxmlformats.org/drawingml/2006/main" prst="rect">
-            <a:avLst/>
-          </a:prstGeom>
-          <a:noFill xmlns:a="http://schemas.openxmlformats.org/drawingml/2006/main"/>
-        </p:spPr>
-        <p:txBody>
-          <a:bodyPr xmlns:a="http://schemas.openxmlformats.org/drawingml/2006/main" wrap="square" lIns="0" tIns="0" rIns="0" bIns="0" anchor="ctr"/>
-          <a:lstStyle xmlns:a="http://schemas.openxmlformats.org/drawingml/2006/main"/>
-          <a:p xmlns:a="http://schemas.openxmlformats.org/drawingml/2006/main">
-            <a:pPr marL="0" indent="0">
-              <a:buNone/>
-            </a:pPr>
-            <a:r>
-              <a:rPr sz="900" b="1">
-                <a:solidFill>
-                  <a:srgbClr val="F5CE76"/>
-                </a:solidFill>
-                <a:latin typeface="Calibri"/>
-                <a:ea typeface="Calibri"/>
-                <a:cs typeface="Calibri"/>
-              </a:rPr>
-              <a:t>Короб</a:t>
-            </a:r>
-            <a:endParaRPr sz="900"/>
-          </a:p>
-        </p:txBody>
-      </p:sp>
-      <p:sp>
-        <p:nvSpPr>
-          <p:cNvPr id="51" name="Text 46">
-            <a:extLst xmlns:a="http://schemas.openxmlformats.org/drawingml/2006/main">
-              <a:ext uri="{FF2B5EF4-FFF2-40B4-BE49-F238E27FC236}">
-                <a16:creationId xmlns:a16="http://schemas.microsoft.com/office/drawing/2014/main" id="{EEC05408-8F7F-4048-A172-AEF7DC75A581}"/>
-              </a:ext>
-            </a:extLst>
-          </p:cNvPr>
-          <p:cNvSpPr>
-            <a:spLocks xmlns:a="http://schemas.openxmlformats.org/drawingml/2006/main" noGrp="1"/>
-          </p:cNvSpPr>
-          <p:nvPr/>
-        </p:nvSpPr>
-        <p:spPr>
-          <a:xfrm xmlns:a="http://schemas.openxmlformats.org/drawingml/2006/main">
-            <a:off x="7132320" y="5262372"/>
-            <a:ext cx="1508760" cy="192024"/>
-          </a:xfrm>
-          <a:prstGeom xmlns:a="http://schemas.openxmlformats.org/drawingml/2006/main" prst="rect">
-            <a:avLst/>
-          </a:prstGeom>
-          <a:noFill xmlns:a="http://schemas.openxmlformats.org/drawingml/2006/main"/>
-        </p:spPr>
-        <p:txBody>
-          <a:bodyPr xmlns:a="http://schemas.openxmlformats.org/drawingml/2006/main" wrap="square" lIns="0" tIns="0" rIns="0" bIns="0" anchor="ctr"/>
-          <a:lstStyle xmlns:a="http://schemas.openxmlformats.org/drawingml/2006/main"/>
-          <a:p xmlns:a="http://schemas.openxmlformats.org/drawingml/2006/main">
-            <a:pPr marL="0" indent="0" algn="r">
-              <a:buNone/>
-            </a:pPr>
-            <a:r>
-              <a:rPr sz="950" b="1">
-                <a:solidFill>
-                  <a:srgbClr val="F5CE76"/>
-                </a:solidFill>
-                <a:latin typeface="Calibri"/>
-                <a:ea typeface="Calibri"/>
-                <a:cs typeface="Calibri"/>
-              </a:rPr>
-              <a:t>6 од.</a:t>
-            </a:r>
-            <a:endParaRPr sz="950"/>
-          </a:p>
-        </p:txBody>
-      </p:sp>
-      <p:sp>
-        <p:nvSpPr>
-          <p:cNvPr id="52" name="Text 47">
-            <a:extLst xmlns:a="http://schemas.openxmlformats.org/drawingml/2006/main">
-              <a:ext uri="{FF2B5EF4-FFF2-40B4-BE49-F238E27FC236}">
-                <a16:creationId xmlns:a16="http://schemas.microsoft.com/office/drawing/2014/main" id="{EDF78F8F-BC3B-4297-9AED-58144068050A}"/>
-              </a:ext>
-            </a:extLst>
-          </p:cNvPr>
-          <p:cNvSpPr>
-            <a:spLocks xmlns:a="http://schemas.openxmlformats.org/drawingml/2006/main" noGrp="1"/>
-          </p:cNvSpPr>
-          <p:nvPr/>
-        </p:nvSpPr>
-        <p:spPr>
-          <a:xfrm xmlns:a="http://schemas.openxmlformats.org/drawingml/2006/main">
-            <a:off x="6492240" y="5468112"/>
-            <a:ext cx="658368" cy="192024"/>
-          </a:xfrm>
-          <a:prstGeom xmlns:a="http://schemas.openxmlformats.org/drawingml/2006/main" prst="rect">
-            <a:avLst/>
-          </a:prstGeom>
-          <a:noFill xmlns:a="http://schemas.openxmlformats.org/drawingml/2006/main"/>
-        </p:spPr>
-        <p:txBody>
-          <a:bodyPr xmlns:a="http://schemas.openxmlformats.org/drawingml/2006/main" wrap="square" lIns="0" tIns="0" rIns="0" bIns="0" anchor="ctr"/>
-          <a:lstStyle xmlns:a="http://schemas.openxmlformats.org/drawingml/2006/main"/>
-          <a:p xmlns:a="http://schemas.openxmlformats.org/drawingml/2006/main">
-            <a:pPr marL="0" indent="0">
-              <a:buNone/>
-            </a:pPr>
-            <a:r>
-              <a:rPr sz="900">
-                <a:solidFill>
-                  <a:srgbClr val="D2E4CE"/>
-                </a:solidFill>
-                <a:latin typeface="Calibri"/>
-                <a:ea typeface="Calibri"/>
-                <a:cs typeface="Calibri"/>
-              </a:rPr>
-              <a:t>Бренд</a:t>
-            </a:r>
-            <a:endParaRPr sz="900"/>
-          </a:p>
-        </p:txBody>
-      </p:sp>
-      <p:sp>
-        <p:nvSpPr>
-          <p:cNvPr id="53" name="Text 48">
-            <a:extLst xmlns:a="http://schemas.openxmlformats.org/drawingml/2006/main">
-              <a:ext uri="{FF2B5EF4-FFF2-40B4-BE49-F238E27FC236}">
-                <a16:creationId xmlns:a16="http://schemas.microsoft.com/office/drawing/2014/main" id="{7A843F49-7C4D-43E2-9A00-CD7BED7D7EEF}"/>
-              </a:ext>
-            </a:extLst>
-          </p:cNvPr>
-          <p:cNvSpPr>
-            <a:spLocks xmlns:a="http://schemas.openxmlformats.org/drawingml/2006/main" noGrp="1"/>
-          </p:cNvSpPr>
-          <p:nvPr/>
-        </p:nvSpPr>
-        <p:spPr>
-          <a:xfrm xmlns:a="http://schemas.openxmlformats.org/drawingml/2006/main">
-            <a:off x="7132320" y="5468112"/>
-            <a:ext cx="1508760" cy="192024"/>
-          </a:xfrm>
-          <a:prstGeom xmlns:a="http://schemas.openxmlformats.org/drawingml/2006/main" prst="rect">
-            <a:avLst/>
-          </a:prstGeom>
-          <a:noFill xmlns:a="http://schemas.openxmlformats.org/drawingml/2006/main"/>
-        </p:spPr>
-        <p:txBody>
-          <a:bodyPr xmlns:a="http://schemas.openxmlformats.org/drawingml/2006/main" wrap="square" lIns="0" tIns="0" rIns="0" bIns="0" anchor="ctr"/>
-          <a:lstStyle xmlns:a="http://schemas.openxmlformats.org/drawingml/2006/main"/>
-          <a:p xmlns:a="http://schemas.openxmlformats.org/drawingml/2006/main">
-            <a:pPr marL="0" indent="0" algn="r">
-              <a:buNone/>
-            </a:pPr>
-            <a:r>
-              <a:rPr sz="950">
-                <a:solidFill>
-                  <a:srgbClr val="FCF9F0"/>
-                </a:solidFill>
-                <a:latin typeface="Calibri"/>
-                <a:ea typeface="Calibri"/>
-                <a:cs typeface="Calibri"/>
-              </a:rPr>
-              <a:t>Private Label</a:t>
-            </a:r>
-            <a:endParaRPr sz="950"/>
-          </a:p>
-        </p:txBody>
-      </p:sp>
-      <p:sp>
-        <p:nvSpPr>
-          <p:cNvPr id="54" name="Text 49">
-            <a:extLst xmlns:a="http://schemas.openxmlformats.org/drawingml/2006/main">
-              <a:ext uri="{FF2B5EF4-FFF2-40B4-BE49-F238E27FC236}">
-                <a16:creationId xmlns:a16="http://schemas.microsoft.com/office/drawing/2014/main" id="{2766A248-70B7-4C50-86DC-4743FDE08FED}"/>
-              </a:ext>
-            </a:extLst>
-          </p:cNvPr>
-          <p:cNvSpPr>
-            <a:spLocks xmlns:a="http://schemas.openxmlformats.org/drawingml/2006/main" noGrp="1"/>
-          </p:cNvSpPr>
-          <p:nvPr/>
-        </p:nvSpPr>
-        <p:spPr>
-          <a:xfrm xmlns:a="http://schemas.openxmlformats.org/drawingml/2006/main">
-            <a:off x="6492240" y="5673852"/>
-            <a:ext cx="658368" cy="192024"/>
-          </a:xfrm>
-          <a:prstGeom xmlns:a="http://schemas.openxmlformats.org/drawingml/2006/main" prst="rect">
-            <a:avLst/>
-          </a:prstGeom>
-          <a:noFill xmlns:a="http://schemas.openxmlformats.org/drawingml/2006/main"/>
-        </p:spPr>
-        <p:txBody>
-          <a:bodyPr xmlns:a="http://schemas.openxmlformats.org/drawingml/2006/main" wrap="square" lIns="0" tIns="0" rIns="0" bIns="0" anchor="ctr"/>
-          <a:lstStyle xmlns:a="http://schemas.openxmlformats.org/drawingml/2006/main"/>
-          <a:p xmlns:a="http://schemas.openxmlformats.org/drawingml/2006/main">
-            <a:pPr marL="0" indent="0">
-              <a:buNone/>
-            </a:pPr>
-            <a:r>
-              <a:rPr sz="900">
-                <a:solidFill>
-                  <a:srgbClr val="D2E4CE"/>
-                </a:solidFill>
-                <a:latin typeface="Calibri"/>
-                <a:ea typeface="Calibri"/>
-                <a:cs typeface="Calibri"/>
-              </a:rPr>
-              <a:t>Sleeve</a:t>
-            </a:r>
-            <a:endParaRPr sz="900"/>
-          </a:p>
-        </p:txBody>
-      </p:sp>
-      <p:sp>
-        <p:nvSpPr>
-          <p:cNvPr id="55" name="Text 50">
-            <a:extLst xmlns:a="http://schemas.openxmlformats.org/drawingml/2006/main">
-              <a:ext uri="{FF2B5EF4-FFF2-40B4-BE49-F238E27FC236}">
-                <a16:creationId xmlns:a16="http://schemas.microsoft.com/office/drawing/2014/main" id="{9C30AE53-0A95-413F-B9EF-82A330647E84}"/>
-              </a:ext>
-            </a:extLst>
-          </p:cNvPr>
-          <p:cNvSpPr>
-            <a:spLocks xmlns:a="http://schemas.openxmlformats.org/drawingml/2006/main" noGrp="1"/>
-          </p:cNvSpPr>
-          <p:nvPr/>
-        </p:nvSpPr>
-        <p:spPr>
-          <a:xfrm xmlns:a="http://schemas.openxmlformats.org/drawingml/2006/main">
-            <a:off x="7132320" y="5673852"/>
-            <a:ext cx="1508760" cy="192024"/>
-          </a:xfrm>
-          <a:prstGeom xmlns:a="http://schemas.openxmlformats.org/drawingml/2006/main" prst="rect">
-            <a:avLst/>
-          </a:prstGeom>
-          <a:noFill xmlns:a="http://schemas.openxmlformats.org/drawingml/2006/main"/>
-        </p:spPr>
-        <p:txBody>
-          <a:bodyPr xmlns:a="http://schemas.openxmlformats.org/drawingml/2006/main" wrap="square" lIns="0" tIns="0" rIns="0" bIns="0" anchor="ctr"/>
-          <a:lstStyle xmlns:a="http://schemas.openxmlformats.org/drawingml/2006/main"/>
-          <a:p xmlns:a="http://schemas.openxmlformats.org/drawingml/2006/main">
-            <a:pPr marL="0" indent="0" algn="r">
-              <a:buNone/>
-            </a:pPr>
-            <a:r>
-              <a:rPr sz="950">
-                <a:solidFill>
-                  <a:srgbClr val="FCF9F0"/>
-                </a:solidFill>
-                <a:latin typeface="Calibri"/>
-                <a:ea typeface="Calibri"/>
-                <a:cs typeface="Calibri"/>
-              </a:rPr>
-              <a:t>дизайн клієнта</a:t>
-            </a:r>
-            <a:endParaRPr sz="950"/>
-          </a:p>
-        </p:txBody>
-      </p:sp>
-      <p:sp>
-        <p:nvSpPr>
-          <p:cNvPr id="56" name="Shape 51">
-            <a:extLst xmlns:a="http://schemas.openxmlformats.org/drawingml/2006/main">
-              <a:ext uri="{FF2B5EF4-FFF2-40B4-BE49-F238E27FC236}">
-                <a16:creationId xmlns:a16="http://schemas.microsoft.com/office/drawing/2014/main" id="{BB65C8A4-36FE-4323-95C1-6CF79F6F2BD2}"/>
-              </a:ext>
-            </a:extLst>
-          </p:cNvPr>
-          <p:cNvSpPr>
-            <a:spLocks xmlns:a="http://schemas.openxmlformats.org/drawingml/2006/main" noGrp="1"/>
-          </p:cNvSpPr>
-          <p:nvPr/>
-        </p:nvSpPr>
-        <p:spPr>
-          <a:xfrm xmlns:a="http://schemas.openxmlformats.org/drawingml/2006/main">
-            <a:off x="9015984" y="1536192"/>
-            <a:ext cx="2706624" cy="4626864"/>
-          </a:xfrm>
-          <a:prstGeom xmlns:a="http://schemas.openxmlformats.org/drawingml/2006/main" prst="roundRect">
-            <a:avLst>
-              <a:gd name="adj" fmla="val 4054"/>
+              <a:gd name="adj" fmla="val 15094"/>
             </a:avLst>
           </a:prstGeom>
           <a:solidFill xmlns:a="http://schemas.openxmlformats.org/drawingml/2006/main">
@@ -17257,401 +16195,81 @@
           </a:p>
         </p:txBody>
       </p:sp>
-      <p:pic>
-        <p:nvPicPr>
-          <p:cNvPr id="133" name="Picture 76"/>
-          <p:cNvPicPr>
-            <a:picLocks xmlns:a="http://schemas.openxmlformats.org/drawingml/2006/main" noChangeAspect="1"/>
-          </p:cNvPicPr>
-          <p:nvPr/>
-        </p:nvPicPr>
-        <p:blipFill>
-          <a:blip xmlns:r="http://schemas.openxmlformats.org/officeDocument/2006/relationships" xmlns:a="http://schemas.openxmlformats.org/drawingml/2006/main" r:embed="Re33a6bf00cf54ef3"/>
-          <a:stretch xmlns:a="http://schemas.openxmlformats.org/drawingml/2006/main">
-            <a:fillRect l="0" t="0" r="0" b="0"/>
-          </a:stretch>
-        </p:blipFill>
-        <p:spPr>
-          <a:xfrm xmlns:a="http://schemas.openxmlformats.org/drawingml/2006/main">
-            <a:off x="9198864" y="1700784"/>
-            <a:ext cx="2340864" cy="1810512"/>
-          </a:xfrm>
-          <a:prstGeom xmlns:a="http://schemas.openxmlformats.org/drawingml/2006/main" prst="roundRect">
-            <a:avLst/>
-          </a:prstGeom>
-        </p:spPr>
-      </p:pic>
-      <p:sp>
-        <p:nvSpPr>
-          <p:cNvPr id="58" name="Shape 52">
-            <a:extLst xmlns:a="http://schemas.openxmlformats.org/drawingml/2006/main">
-              <a:ext uri="{FF2B5EF4-FFF2-40B4-BE49-F238E27FC236}">
-                <a16:creationId xmlns:a16="http://schemas.microsoft.com/office/drawing/2014/main" id="{A089A1B1-F6D0-4239-90A9-2A5FF4C2A16C}"/>
-              </a:ext>
-            </a:extLst>
-          </p:cNvPr>
-          <p:cNvSpPr>
-            <a:spLocks xmlns:a="http://schemas.openxmlformats.org/drawingml/2006/main" noGrp="1"/>
-          </p:cNvSpPr>
-          <p:nvPr/>
-        </p:nvSpPr>
-        <p:spPr>
-          <a:xfrm xmlns:a="http://schemas.openxmlformats.org/drawingml/2006/main">
-            <a:off x="9198864" y="1700784"/>
-            <a:ext cx="2340864" cy="1810512"/>
-          </a:xfrm>
-          <a:prstGeom xmlns:a="http://schemas.openxmlformats.org/drawingml/2006/main" prst="rect">
-            <a:avLst/>
-          </a:prstGeom>
-          <a:ln xmlns:a="http://schemas.openxmlformats.org/drawingml/2006/main" w="12700">
-            <a:solidFill>
-              <a:srgbClr val="C89C40"/>
-            </a:solidFill>
-            <a:prstDash val="solid"/>
-          </a:ln>
-        </p:spPr>
-        <p:txBody>
-          <a:bodyPr xmlns:a="http://schemas.openxmlformats.org/drawingml/2006/main"/>
-          <a:lstStyle xmlns:a="http://schemas.openxmlformats.org/drawingml/2006/main"/>
-          <a:p xmlns:a="http://schemas.openxmlformats.org/drawingml/2006/main">
-            <a:endParaRPr/>
-          </a:p>
-        </p:txBody>
-      </p:sp>
-      <p:sp>
-        <p:nvSpPr>
-          <p:cNvPr id="59" name="Shape 53">
-            <a:extLst xmlns:a="http://schemas.openxmlformats.org/drawingml/2006/main">
-              <a:ext uri="{FF2B5EF4-FFF2-40B4-BE49-F238E27FC236}">
-                <a16:creationId xmlns:a16="http://schemas.microsoft.com/office/drawing/2014/main" id="{102F35A9-F072-41A9-A5EF-E4FBAAA99241}"/>
-              </a:ext>
-            </a:extLst>
-          </p:cNvPr>
-          <p:cNvSpPr>
-            <a:spLocks xmlns:a="http://schemas.openxmlformats.org/drawingml/2006/main" noGrp="1"/>
-          </p:cNvSpPr>
-          <p:nvPr/>
-        </p:nvSpPr>
-        <p:spPr>
-          <a:xfrm xmlns:a="http://schemas.openxmlformats.org/drawingml/2006/main">
-            <a:off x="9198864" y="3611880"/>
-            <a:ext cx="1417320" cy="237744"/>
-          </a:xfrm>
-          <a:prstGeom xmlns:a="http://schemas.openxmlformats.org/drawingml/2006/main" prst="roundRect">
-            <a:avLst>
-              <a:gd name="adj" fmla="val 23077"/>
-            </a:avLst>
-          </a:prstGeom>
-          <a:solidFill xmlns:a="http://schemas.openxmlformats.org/drawingml/2006/main">
-            <a:srgbClr val="B0762A"/>
-          </a:solidFill>
-          <a:ln xmlns:a="http://schemas.openxmlformats.org/drawingml/2006/main" w="6350">
-            <a:solidFill>
-              <a:srgbClr val="C89C40"/>
-            </a:solidFill>
-            <a:prstDash val="solid"/>
-          </a:ln>
-        </p:spPr>
-        <p:txBody>
-          <a:bodyPr xmlns:a="http://schemas.openxmlformats.org/drawingml/2006/main"/>
-          <a:lstStyle xmlns:a="http://schemas.openxmlformats.org/drawingml/2006/main"/>
-          <a:p xmlns:a="http://schemas.openxmlformats.org/drawingml/2006/main">
-            <a:endParaRPr/>
-          </a:p>
-        </p:txBody>
-      </p:sp>
-      <p:sp>
-        <p:nvSpPr>
-          <p:cNvPr id="60" name="Text 54">
-            <a:extLst xmlns:a="http://schemas.openxmlformats.org/drawingml/2006/main">
-              <a:ext uri="{FF2B5EF4-FFF2-40B4-BE49-F238E27FC236}">
-                <a16:creationId xmlns:a16="http://schemas.microsoft.com/office/drawing/2014/main" id="{EA0F7E19-BC03-4457-BB96-38AB3991AB1A}"/>
-              </a:ext>
-            </a:extLst>
-          </p:cNvPr>
-          <p:cNvSpPr>
-            <a:spLocks xmlns:a="http://schemas.openxmlformats.org/drawingml/2006/main" noGrp="1"/>
-          </p:cNvSpPr>
-          <p:nvPr/>
-        </p:nvSpPr>
-        <p:spPr>
-          <a:xfrm xmlns:a="http://schemas.openxmlformats.org/drawingml/2006/main">
-            <a:off x="9198864" y="3621024"/>
-            <a:ext cx="1417320" cy="219456"/>
-          </a:xfrm>
-          <a:prstGeom xmlns:a="http://schemas.openxmlformats.org/drawingml/2006/main" prst="rect">
-            <a:avLst/>
-          </a:prstGeom>
-          <a:noFill xmlns:a="http://schemas.openxmlformats.org/drawingml/2006/main"/>
-        </p:spPr>
-        <p:txBody>
-          <a:bodyPr xmlns:a="http://schemas.openxmlformats.org/drawingml/2006/main" wrap="square" lIns="0" tIns="0" rIns="0" bIns="0" anchor="ctr"/>
-          <a:lstStyle xmlns:a="http://schemas.openxmlformats.org/drawingml/2006/main"/>
-          <a:p xmlns:a="http://schemas.openxmlformats.org/drawingml/2006/main">
-            <a:pPr marL="0" indent="0" algn="ctr">
-              <a:buNone/>
-            </a:pPr>
-            <a:r>
-              <a:rPr sz="850" b="1" spc="60">
-                <a:solidFill>
-                  <a:srgbClr val="FFFFFF"/>
-                </a:solidFill>
-                <a:latin typeface="Calibri"/>
-                <a:ea typeface="Calibri"/>
-                <a:cs typeface="Calibri"/>
-              </a:rPr>
-              <a:t>MIX CONTAINER</a:t>
-            </a:r>
-            <a:endParaRPr sz="850"/>
-          </a:p>
-        </p:txBody>
-      </p:sp>
-      <p:sp>
-        <p:nvSpPr>
-          <p:cNvPr id="61" name="Text 55">
-            <a:extLst xmlns:a="http://schemas.openxmlformats.org/drawingml/2006/main">
-              <a:ext uri="{FF2B5EF4-FFF2-40B4-BE49-F238E27FC236}">
-                <a16:creationId xmlns:a16="http://schemas.microsoft.com/office/drawing/2014/main" id="{53175901-99C3-41D7-9C1A-329684E5875E}"/>
-              </a:ext>
-            </a:extLst>
-          </p:cNvPr>
-          <p:cNvSpPr>
-            <a:spLocks xmlns:a="http://schemas.openxmlformats.org/drawingml/2006/main" noGrp="1"/>
-          </p:cNvSpPr>
-          <p:nvPr/>
-        </p:nvSpPr>
-        <p:spPr>
-          <a:xfrm xmlns:a="http://schemas.openxmlformats.org/drawingml/2006/main">
-            <a:off x="9198864" y="3931920"/>
-            <a:ext cx="2340864" cy="548640"/>
-          </a:xfrm>
-          <a:prstGeom xmlns:a="http://schemas.openxmlformats.org/drawingml/2006/main" prst="rect">
-            <a:avLst/>
-          </a:prstGeom>
-          <a:noFill xmlns:a="http://schemas.openxmlformats.org/drawingml/2006/main"/>
-        </p:spPr>
-        <p:txBody>
-          <a:bodyPr xmlns:a="http://schemas.openxmlformats.org/drawingml/2006/main" wrap="square" lIns="0" tIns="0" rIns="0" bIns="0" anchor="t"/>
-          <a:lstStyle xmlns:a="http://schemas.openxmlformats.org/drawingml/2006/main"/>
-          <a:p xmlns:a="http://schemas.openxmlformats.org/drawingml/2006/main">
-            <a:pPr marL="0" indent="0">
-              <a:buNone/>
-            </a:pPr>
-            <a:r>
-              <a:rPr sz="1450" b="1">
-                <a:solidFill>
-                  <a:srgbClr val="FFFFFF"/>
+      <p:sp>
+        <p:nvSpPr>
+          <p:cNvPr id="32" name="Text 29">
+            <a:extLst xmlns:a="http://schemas.openxmlformats.org/drawingml/2006/main">
+              <a:ext uri="{FF2B5EF4-FFF2-40B4-BE49-F238E27FC236}">
+                <a16:creationId xmlns:a16="http://schemas.microsoft.com/office/drawing/2014/main" id="{261A9ED7-0551-4B4E-B905-410FED97DEDE}"/>
+              </a:ext>
+            </a:extLst>
+          </p:cNvPr>
+          <p:cNvSpPr>
+            <a:spLocks xmlns:a="http://schemas.openxmlformats.org/drawingml/2006/main" noGrp="1"/>
+          </p:cNvSpPr>
+          <p:nvPr/>
+        </p:nvSpPr>
+        <p:spPr>
+          <a:xfrm xmlns:a="http://schemas.openxmlformats.org/drawingml/2006/main">
+            <a:off x="7717536" y="5715000"/>
+            <a:ext cx="1371600" cy="365760"/>
+          </a:xfrm>
+          <a:prstGeom xmlns:a="http://schemas.openxmlformats.org/drawingml/2006/main" prst="rect">
+            <a:avLst/>
+          </a:prstGeom>
+          <a:noFill xmlns:a="http://schemas.openxmlformats.org/drawingml/2006/main"/>
+        </p:spPr>
+        <p:txBody>
+          <a:bodyPr xmlns:a="http://schemas.openxmlformats.org/drawingml/2006/main" wrap="square" lIns="0" tIns="0" rIns="0" bIns="0" anchor="ctr"/>
+          <a:lstStyle xmlns:a="http://schemas.openxmlformats.org/drawingml/2006/main"/>
+          <a:p xmlns:a="http://schemas.openxmlformats.org/drawingml/2006/main">
+            <a:pPr marL="0" indent="0">
+              <a:buNone/>
+            </a:pPr>
+            <a:r>
+              <a:rPr sz="1900" b="1">
+                <a:solidFill>
+                  <a:srgbClr val="F5CE76"/>
                 </a:solidFill>
                 <a:latin typeface="Cambria"/>
                 <a:ea typeface="Cambria"/>
                 <a:cs typeface="Cambria"/>
               </a:rPr>
-              <a:t>Cup + Pouch</a:t>
-            </a:r>
-            <a:endParaRPr sz="1450"/>
-          </a:p>
-        </p:txBody>
-      </p:sp>
-      <p:sp>
-        <p:nvSpPr>
-          <p:cNvPr id="62" name="Text 56">
-            <a:extLst xmlns:a="http://schemas.openxmlformats.org/drawingml/2006/main">
-              <a:ext uri="{FF2B5EF4-FFF2-40B4-BE49-F238E27FC236}">
-                <a16:creationId xmlns:a16="http://schemas.microsoft.com/office/drawing/2014/main" id="{B27564B5-2E37-4E8E-B961-4CCD25190B86}"/>
-              </a:ext>
-            </a:extLst>
-          </p:cNvPr>
-          <p:cNvSpPr>
-            <a:spLocks xmlns:a="http://schemas.openxmlformats.org/drawingml/2006/main" noGrp="1"/>
-          </p:cNvSpPr>
-          <p:nvPr/>
-        </p:nvSpPr>
-        <p:spPr>
-          <a:xfrm xmlns:a="http://schemas.openxmlformats.org/drawingml/2006/main">
-            <a:off x="9198864" y="4498848"/>
-            <a:ext cx="2340864" cy="237744"/>
-          </a:xfrm>
-          <a:prstGeom xmlns:a="http://schemas.openxmlformats.org/drawingml/2006/main" prst="rect">
-            <a:avLst/>
-          </a:prstGeom>
-          <a:noFill xmlns:a="http://schemas.openxmlformats.org/drawingml/2006/main"/>
-        </p:spPr>
-        <p:txBody>
-          <a:bodyPr xmlns:a="http://schemas.openxmlformats.org/drawingml/2006/main" wrap="square" lIns="0" tIns="0" rIns="0" bIns="0" anchor="ctr"/>
-          <a:lstStyle xmlns:a="http://schemas.openxmlformats.org/drawingml/2006/main"/>
-          <a:p xmlns:a="http://schemas.openxmlformats.org/drawingml/2006/main">
-            <a:pPr marL="0" indent="0">
-              <a:buNone/>
-            </a:pPr>
-            <a:r>
-              <a:rPr sz="1000">
-                <a:solidFill>
-                  <a:srgbClr val="D2E4CE"/>
-                </a:solidFill>
-                <a:latin typeface="Calibri"/>
-                <a:ea typeface="Calibri"/>
-                <a:cs typeface="Calibri"/>
-              </a:rPr>
-              <a:t>FOB Bangkok · навалом</a:t>
-            </a:r>
-            <a:endParaRPr sz="1000"/>
-          </a:p>
-        </p:txBody>
-      </p:sp>
-      <p:sp>
-        <p:nvSpPr>
-          <p:cNvPr id="63" name="Shape 57">
-            <a:extLst xmlns:a="http://schemas.openxmlformats.org/drawingml/2006/main">
-              <a:ext uri="{FF2B5EF4-FFF2-40B4-BE49-F238E27FC236}">
-                <a16:creationId xmlns:a16="http://schemas.microsoft.com/office/drawing/2014/main" id="{FE01E20B-9EBB-4017-A8D9-C2567B2E5EC1}"/>
-              </a:ext>
-            </a:extLst>
-          </p:cNvPr>
-          <p:cNvSpPr>
-            <a:spLocks xmlns:a="http://schemas.openxmlformats.org/drawingml/2006/main" noGrp="1"/>
-          </p:cNvSpPr>
-          <p:nvPr/>
-        </p:nvSpPr>
-        <p:spPr>
-          <a:xfrm xmlns:a="http://schemas.openxmlformats.org/drawingml/2006/main">
-            <a:off x="9198864" y="4791456"/>
-            <a:ext cx="2340864" cy="1170432"/>
-          </a:xfrm>
-          <a:prstGeom xmlns:a="http://schemas.openxmlformats.org/drawingml/2006/main" prst="roundRect">
-            <a:avLst>
-              <a:gd name="adj" fmla="val 5469"/>
-            </a:avLst>
-          </a:prstGeom>
-          <a:solidFill xmlns:a="http://schemas.openxmlformats.org/drawingml/2006/main">
-            <a:srgbClr val="1A5433">
-              <a:alpha val="92000"/>
-            </a:srgbClr>
-          </a:solidFill>
-          <a:ln xmlns:a="http://schemas.openxmlformats.org/drawingml/2006/main" w="9525">
-            <a:solidFill>
-              <a:srgbClr val="C89C40"/>
-            </a:solidFill>
-            <a:prstDash val="solid"/>
-          </a:ln>
-        </p:spPr>
-        <p:txBody>
-          <a:bodyPr xmlns:a="http://schemas.openxmlformats.org/drawingml/2006/main"/>
-          <a:lstStyle xmlns:a="http://schemas.openxmlformats.org/drawingml/2006/main"/>
-          <a:p xmlns:a="http://schemas.openxmlformats.org/drawingml/2006/main">
-            <a:endParaRPr/>
-          </a:p>
-        </p:txBody>
-      </p:sp>
-      <p:sp>
-        <p:nvSpPr>
-          <p:cNvPr id="64" name="Text 58">
-            <a:extLst xmlns:a="http://schemas.openxmlformats.org/drawingml/2006/main">
-              <a:ext uri="{FF2B5EF4-FFF2-40B4-BE49-F238E27FC236}">
-                <a16:creationId xmlns:a16="http://schemas.microsoft.com/office/drawing/2014/main" id="{669B1082-8915-4983-B2B6-C14A6B449D5E}"/>
-              </a:ext>
-            </a:extLst>
-          </p:cNvPr>
-          <p:cNvSpPr>
-            <a:spLocks xmlns:a="http://schemas.openxmlformats.org/drawingml/2006/main" noGrp="1"/>
-          </p:cNvSpPr>
-          <p:nvPr/>
-        </p:nvSpPr>
-        <p:spPr>
-          <a:xfrm xmlns:a="http://schemas.openxmlformats.org/drawingml/2006/main">
-            <a:off x="9308592" y="4855464"/>
-            <a:ext cx="2148840" cy="182880"/>
-          </a:xfrm>
-          <a:prstGeom xmlns:a="http://schemas.openxmlformats.org/drawingml/2006/main" prst="rect">
-            <a:avLst/>
-          </a:prstGeom>
-          <a:noFill xmlns:a="http://schemas.openxmlformats.org/drawingml/2006/main"/>
-        </p:spPr>
-        <p:txBody>
-          <a:bodyPr xmlns:a="http://schemas.openxmlformats.org/drawingml/2006/main" wrap="square" lIns="0" tIns="0" rIns="0" bIns="0" anchor="ctr"/>
-          <a:lstStyle xmlns:a="http://schemas.openxmlformats.org/drawingml/2006/main"/>
-          <a:p xmlns:a="http://schemas.openxmlformats.org/drawingml/2006/main">
-            <a:pPr marL="0" indent="0">
-              <a:buNone/>
-            </a:pPr>
-            <a:r>
-              <a:rPr sz="750" b="1" spc="100">
+              <a:t>SPAR</a:t>
+            </a:r>
+            <a:r>
+              <a:rPr sz="1100">
                 <a:solidFill>
                   <a:srgbClr val="F5CE76"/>
                 </a:solidFill>
-                <a:latin typeface="Calibri"/>
-                <a:ea typeface="Calibri"/>
-                <a:cs typeface="Calibri"/>
-              </a:rPr>
-              <a:t>ПАРАМЕТРИ ЗАВАНТАЖЕННЯ</a:t>
-            </a:r>
-            <a:endParaRPr sz="750"/>
-          </a:p>
-        </p:txBody>
-      </p:sp>
-      <p:sp>
-        <p:nvSpPr>
-          <p:cNvPr id="65" name="Text 59">
-            <a:extLst xmlns:a="http://schemas.openxmlformats.org/drawingml/2006/main">
-              <a:ext uri="{FF2B5EF4-FFF2-40B4-BE49-F238E27FC236}">
-                <a16:creationId xmlns:a16="http://schemas.microsoft.com/office/drawing/2014/main" id="{BD1C138D-AD32-4415-A37B-0EEFBF070D1B}"/>
-              </a:ext>
-            </a:extLst>
-          </p:cNvPr>
-          <p:cNvSpPr>
-            <a:spLocks xmlns:a="http://schemas.openxmlformats.org/drawingml/2006/main" noGrp="1"/>
-          </p:cNvSpPr>
-          <p:nvPr/>
-        </p:nvSpPr>
-        <p:spPr>
-          <a:xfrm xmlns:a="http://schemas.openxmlformats.org/drawingml/2006/main">
-            <a:off x="9308592" y="5056632"/>
-            <a:ext cx="658368" cy="192024"/>
-          </a:xfrm>
-          <a:prstGeom xmlns:a="http://schemas.openxmlformats.org/drawingml/2006/main" prst="rect">
-            <a:avLst/>
-          </a:prstGeom>
-          <a:noFill xmlns:a="http://schemas.openxmlformats.org/drawingml/2006/main"/>
-        </p:spPr>
-        <p:txBody>
-          <a:bodyPr xmlns:a="http://schemas.openxmlformats.org/drawingml/2006/main" wrap="square" lIns="0" tIns="0" rIns="0" bIns="0" anchor="ctr"/>
-          <a:lstStyle xmlns:a="http://schemas.openxmlformats.org/drawingml/2006/main"/>
-          <a:p xmlns:a="http://schemas.openxmlformats.org/drawingml/2006/main">
-            <a:pPr marL="0" indent="0">
-              <a:buNone/>
-            </a:pPr>
-            <a:r>
-              <a:rPr sz="900">
-                <a:solidFill>
-                  <a:srgbClr val="D2E4CE"/>
-                </a:solidFill>
-                <a:latin typeface="Calibri"/>
-                <a:ea typeface="Calibri"/>
-                <a:cs typeface="Calibri"/>
-              </a:rPr>
-              <a:t>Мікс</a:t>
-            </a:r>
-            <a:endParaRPr sz="900"/>
-          </a:p>
-        </p:txBody>
-      </p:sp>
-      <p:sp>
-        <p:nvSpPr>
-          <p:cNvPr id="66" name="Text 60">
-            <a:extLst xmlns:a="http://schemas.openxmlformats.org/drawingml/2006/main">
-              <a:ext uri="{FF2B5EF4-FFF2-40B4-BE49-F238E27FC236}">
-                <a16:creationId xmlns:a16="http://schemas.microsoft.com/office/drawing/2014/main" id="{6AD7731F-A450-4B30-9B7A-DC5E48D9DC38}"/>
-              </a:ext>
-            </a:extLst>
-          </p:cNvPr>
-          <p:cNvSpPr>
-            <a:spLocks xmlns:a="http://schemas.openxmlformats.org/drawingml/2006/main" noGrp="1"/>
-          </p:cNvSpPr>
-          <p:nvPr/>
-        </p:nvSpPr>
-        <p:spPr>
-          <a:xfrm xmlns:a="http://schemas.openxmlformats.org/drawingml/2006/main">
-            <a:off x="9948672" y="5056632"/>
-            <a:ext cx="1508760" cy="192024"/>
+                <a:latin typeface="Cambria"/>
+                <a:ea typeface="Cambria"/>
+                <a:cs typeface="Cambria"/>
+              </a:rPr>
+              <a:t/>
+            </a:r>
+            <a:endParaRPr sz="1900"/>
+          </a:p>
+        </p:txBody>
+      </p:sp>
+      <p:sp>
+        <p:nvSpPr>
+          <p:cNvPr id="33" name="Text 30">
+            <a:extLst xmlns:a="http://schemas.openxmlformats.org/drawingml/2006/main">
+              <a:ext uri="{FF2B5EF4-FFF2-40B4-BE49-F238E27FC236}">
+                <a16:creationId xmlns:a16="http://schemas.microsoft.com/office/drawing/2014/main" id="{E99E232B-CE92-4C25-B546-D18CAEAE1AAC}"/>
+              </a:ext>
+            </a:extLst>
+          </p:cNvPr>
+          <p:cNvSpPr>
+            <a:spLocks xmlns:a="http://schemas.openxmlformats.org/drawingml/2006/main" noGrp="1"/>
+          </p:cNvSpPr>
+          <p:nvPr/>
+        </p:nvSpPr>
+        <p:spPr>
+          <a:xfrm xmlns:a="http://schemas.openxmlformats.org/drawingml/2006/main">
+            <a:off x="9098280" y="5715000"/>
+            <a:ext cx="2377440" cy="365760"/>
           </a:xfrm>
           <a:prstGeom xmlns:a="http://schemas.openxmlformats.org/drawingml/2006/main" prst="rect">
             <a:avLst/>
@@ -17666,7 +16284,7 @@
               <a:buNone/>
             </a:pPr>
             <a:r>
-              <a:rPr sz="950">
+              <a:rPr sz="1050">
                 <a:solidFill>
                   <a:srgbClr val="FCF9F0"/>
                 </a:solidFill>
@@ -17674,294 +16292,18 @@
                 <a:ea typeface="Calibri"/>
                 <a:cs typeface="Calibri"/>
               </a:rPr>
-              <a:t>Cup + Pouch</a:t>
-            </a:r>
-            <a:endParaRPr sz="950"/>
-          </a:p>
-        </p:txBody>
-      </p:sp>
-      <p:sp>
-        <p:nvSpPr>
-          <p:cNvPr id="67" name="Text 61">
-            <a:extLst xmlns:a="http://schemas.openxmlformats.org/drawingml/2006/main">
-              <a:ext uri="{FF2B5EF4-FFF2-40B4-BE49-F238E27FC236}">
-                <a16:creationId xmlns:a16="http://schemas.microsoft.com/office/drawing/2014/main" id="{5987284E-222D-491D-BC8B-596809AE17F5}"/>
-              </a:ext>
-            </a:extLst>
-          </p:cNvPr>
-          <p:cNvSpPr>
-            <a:spLocks xmlns:a="http://schemas.openxmlformats.org/drawingml/2006/main" noGrp="1"/>
-          </p:cNvSpPr>
-          <p:nvPr/>
-        </p:nvSpPr>
-        <p:spPr>
-          <a:xfrm xmlns:a="http://schemas.openxmlformats.org/drawingml/2006/main">
-            <a:off x="9308592" y="5262372"/>
-            <a:ext cx="658368" cy="192024"/>
-          </a:xfrm>
-          <a:prstGeom xmlns:a="http://schemas.openxmlformats.org/drawingml/2006/main" prst="rect">
-            <a:avLst/>
-          </a:prstGeom>
-          <a:noFill xmlns:a="http://schemas.openxmlformats.org/drawingml/2006/main"/>
-        </p:spPr>
-        <p:txBody>
-          <a:bodyPr xmlns:a="http://schemas.openxmlformats.org/drawingml/2006/main" wrap="square" lIns="0" tIns="0" rIns="0" bIns="0" anchor="ctr"/>
-          <a:lstStyle xmlns:a="http://schemas.openxmlformats.org/drawingml/2006/main"/>
-          <a:p xmlns:a="http://schemas.openxmlformats.org/drawingml/2006/main">
-            <a:pPr marL="0" indent="0">
-              <a:buNone/>
-            </a:pPr>
-            <a:r>
-              <a:rPr sz="900" b="1">
-                <a:solidFill>
-                  <a:srgbClr val="F5CE76"/>
-                </a:solidFill>
-                <a:latin typeface="Calibri"/>
-                <a:ea typeface="Calibri"/>
-                <a:cs typeface="Calibri"/>
-              </a:rPr>
-              <a:t>Умови</a:t>
-            </a:r>
-            <a:endParaRPr sz="900"/>
-          </a:p>
-        </p:txBody>
-      </p:sp>
-      <p:sp>
-        <p:nvSpPr>
-          <p:cNvPr id="68" name="Text 62">
-            <a:extLst xmlns:a="http://schemas.openxmlformats.org/drawingml/2006/main">
-              <a:ext uri="{FF2B5EF4-FFF2-40B4-BE49-F238E27FC236}">
-                <a16:creationId xmlns:a16="http://schemas.microsoft.com/office/drawing/2014/main" id="{1E079831-7D60-433F-857F-D392391EEAB4}"/>
-              </a:ext>
-            </a:extLst>
-          </p:cNvPr>
-          <p:cNvSpPr>
-            <a:spLocks xmlns:a="http://schemas.openxmlformats.org/drawingml/2006/main" noGrp="1"/>
-          </p:cNvSpPr>
-          <p:nvPr/>
-        </p:nvSpPr>
-        <p:spPr>
-          <a:xfrm xmlns:a="http://schemas.openxmlformats.org/drawingml/2006/main">
-            <a:off x="9948672" y="5262372"/>
-            <a:ext cx="1508760" cy="192024"/>
-          </a:xfrm>
-          <a:prstGeom xmlns:a="http://schemas.openxmlformats.org/drawingml/2006/main" prst="rect">
-            <a:avLst/>
-          </a:prstGeom>
-          <a:noFill xmlns:a="http://schemas.openxmlformats.org/drawingml/2006/main"/>
-        </p:spPr>
-        <p:txBody>
-          <a:bodyPr xmlns:a="http://schemas.openxmlformats.org/drawingml/2006/main" wrap="square" lIns="0" tIns="0" rIns="0" bIns="0" anchor="ctr"/>
-          <a:lstStyle xmlns:a="http://schemas.openxmlformats.org/drawingml/2006/main"/>
-          <a:p xmlns:a="http://schemas.openxmlformats.org/drawingml/2006/main">
-            <a:pPr marL="0" indent="0" algn="r">
-              <a:buNone/>
-            </a:pPr>
-            <a:r>
-              <a:rPr sz="950" b="1">
-                <a:solidFill>
-                  <a:srgbClr val="F5CE76"/>
-                </a:solidFill>
-                <a:latin typeface="Calibri"/>
-                <a:ea typeface="Calibri"/>
-                <a:cs typeface="Calibri"/>
-              </a:rPr>
-              <a:t>FOB Bangkok</a:t>
-            </a:r>
-            <a:endParaRPr sz="950"/>
-          </a:p>
-        </p:txBody>
-      </p:sp>
-      <p:sp>
-        <p:nvSpPr>
-          <p:cNvPr id="69" name="Text 63">
-            <a:extLst xmlns:a="http://schemas.openxmlformats.org/drawingml/2006/main">
-              <a:ext uri="{FF2B5EF4-FFF2-40B4-BE49-F238E27FC236}">
-                <a16:creationId xmlns:a16="http://schemas.microsoft.com/office/drawing/2014/main" id="{5D9ED1D0-06AB-4B43-A177-0B40947578D3}"/>
-              </a:ext>
-            </a:extLst>
-          </p:cNvPr>
-          <p:cNvSpPr>
-            <a:spLocks xmlns:a="http://schemas.openxmlformats.org/drawingml/2006/main" noGrp="1"/>
-          </p:cNvSpPr>
-          <p:nvPr/>
-        </p:nvSpPr>
-        <p:spPr>
-          <a:xfrm xmlns:a="http://schemas.openxmlformats.org/drawingml/2006/main">
-            <a:off x="9308592" y="5468112"/>
-            <a:ext cx="658368" cy="192024"/>
-          </a:xfrm>
-          <a:prstGeom xmlns:a="http://schemas.openxmlformats.org/drawingml/2006/main" prst="rect">
-            <a:avLst/>
-          </a:prstGeom>
-          <a:noFill xmlns:a="http://schemas.openxmlformats.org/drawingml/2006/main"/>
-        </p:spPr>
-        <p:txBody>
-          <a:bodyPr xmlns:a="http://schemas.openxmlformats.org/drawingml/2006/main" wrap="square" lIns="0" tIns="0" rIns="0" bIns="0" anchor="ctr"/>
-          <a:lstStyle xmlns:a="http://schemas.openxmlformats.org/drawingml/2006/main"/>
-          <a:p xmlns:a="http://schemas.openxmlformats.org/drawingml/2006/main">
-            <a:pPr marL="0" indent="0">
-              <a:buNone/>
-            </a:pPr>
-            <a:r>
-              <a:rPr sz="900">
-                <a:solidFill>
-                  <a:srgbClr val="D2E4CE"/>
-                </a:solidFill>
-                <a:latin typeface="Calibri"/>
-                <a:ea typeface="Calibri"/>
-                <a:cs typeface="Calibri"/>
-              </a:rPr>
-              <a:t>Формат</a:t>
-            </a:r>
-            <a:endParaRPr sz="900"/>
-          </a:p>
-        </p:txBody>
-      </p:sp>
-      <p:sp>
-        <p:nvSpPr>
-          <p:cNvPr id="70" name="Text 64">
-            <a:extLst xmlns:a="http://schemas.openxmlformats.org/drawingml/2006/main">
-              <a:ext uri="{FF2B5EF4-FFF2-40B4-BE49-F238E27FC236}">
-                <a16:creationId xmlns:a16="http://schemas.microsoft.com/office/drawing/2014/main" id="{4C05FFD0-DA43-4E50-A387-C4186B7E3DA8}"/>
-              </a:ext>
-            </a:extLst>
-          </p:cNvPr>
-          <p:cNvSpPr>
-            <a:spLocks xmlns:a="http://schemas.openxmlformats.org/drawingml/2006/main" noGrp="1"/>
-          </p:cNvSpPr>
-          <p:nvPr/>
-        </p:nvSpPr>
-        <p:spPr>
-          <a:xfrm xmlns:a="http://schemas.openxmlformats.org/drawingml/2006/main">
-            <a:off x="9948672" y="5468112"/>
-            <a:ext cx="1508760" cy="192024"/>
-          </a:xfrm>
-          <a:prstGeom xmlns:a="http://schemas.openxmlformats.org/drawingml/2006/main" prst="rect">
-            <a:avLst/>
-          </a:prstGeom>
-          <a:noFill xmlns:a="http://schemas.openxmlformats.org/drawingml/2006/main"/>
-        </p:spPr>
-        <p:txBody>
-          <a:bodyPr xmlns:a="http://schemas.openxmlformats.org/drawingml/2006/main" wrap="square" lIns="0" tIns="0" rIns="0" bIns="0" anchor="ctr"/>
-          <a:lstStyle xmlns:a="http://schemas.openxmlformats.org/drawingml/2006/main"/>
-          <a:p xmlns:a="http://schemas.openxmlformats.org/drawingml/2006/main">
-            <a:pPr marL="0" indent="0" algn="r">
-              <a:buNone/>
-            </a:pPr>
-            <a:r>
-              <a:rPr sz="950">
-                <a:solidFill>
-                  <a:srgbClr val="FCF9F0"/>
-                </a:solidFill>
-                <a:latin typeface="Calibri"/>
-                <a:ea typeface="Calibri"/>
-                <a:cs typeface="Calibri"/>
-              </a:rPr>
-              <a:t>навалом</a:t>
-            </a:r>
-            <a:endParaRPr sz="950"/>
-          </a:p>
-        </p:txBody>
-      </p:sp>
-      <p:sp>
-        <p:nvSpPr>
-          <p:cNvPr id="71" name="Text 65">
-            <a:extLst xmlns:a="http://schemas.openxmlformats.org/drawingml/2006/main">
-              <a:ext uri="{FF2B5EF4-FFF2-40B4-BE49-F238E27FC236}">
-                <a16:creationId xmlns:a16="http://schemas.microsoft.com/office/drawing/2014/main" id="{7FE64998-BF0F-49B6-9E76-DCEF0AF292A4}"/>
-              </a:ext>
-            </a:extLst>
-          </p:cNvPr>
-          <p:cNvSpPr>
-            <a:spLocks xmlns:a="http://schemas.openxmlformats.org/drawingml/2006/main" noGrp="1"/>
-          </p:cNvSpPr>
-          <p:nvPr/>
-        </p:nvSpPr>
-        <p:spPr>
-          <a:xfrm xmlns:a="http://schemas.openxmlformats.org/drawingml/2006/main">
-            <a:off x="9308592" y="5673852"/>
-            <a:ext cx="658368" cy="192024"/>
-          </a:xfrm>
-          <a:prstGeom xmlns:a="http://schemas.openxmlformats.org/drawingml/2006/main" prst="rect">
-            <a:avLst/>
-          </a:prstGeom>
-          <a:noFill xmlns:a="http://schemas.openxmlformats.org/drawingml/2006/main"/>
-        </p:spPr>
-        <p:txBody>
-          <a:bodyPr xmlns:a="http://schemas.openxmlformats.org/drawingml/2006/main" wrap="square" lIns="0" tIns="0" rIns="0" bIns="0" anchor="ctr"/>
-          <a:lstStyle xmlns:a="http://schemas.openxmlformats.org/drawingml/2006/main"/>
-          <a:p xmlns:a="http://schemas.openxmlformats.org/drawingml/2006/main">
-            <a:pPr marL="0" indent="0">
-              <a:buNone/>
-            </a:pPr>
-            <a:r>
-              <a:rPr sz="900">
-                <a:solidFill>
-                  <a:srgbClr val="D2E4CE"/>
-                </a:solidFill>
-                <a:latin typeface="Calibri"/>
-                <a:ea typeface="Calibri"/>
-                <a:cs typeface="Calibri"/>
-              </a:rPr>
-              <a:t>Статус</a:t>
-            </a:r>
-            <a:endParaRPr sz="900"/>
-          </a:p>
-        </p:txBody>
-      </p:sp>
-      <p:sp>
-        <p:nvSpPr>
-          <p:cNvPr id="72" name="Text 66">
-            <a:extLst xmlns:a="http://schemas.openxmlformats.org/drawingml/2006/main">
-              <a:ext uri="{FF2B5EF4-FFF2-40B4-BE49-F238E27FC236}">
-                <a16:creationId xmlns:a16="http://schemas.microsoft.com/office/drawing/2014/main" id="{D5AA0317-8C8E-4654-AB48-6EF530E5DEEB}"/>
-              </a:ext>
-            </a:extLst>
-          </p:cNvPr>
-          <p:cNvSpPr>
-            <a:spLocks xmlns:a="http://schemas.openxmlformats.org/drawingml/2006/main" noGrp="1"/>
-          </p:cNvSpPr>
-          <p:nvPr/>
-        </p:nvSpPr>
-        <p:spPr>
-          <a:xfrm xmlns:a="http://schemas.openxmlformats.org/drawingml/2006/main">
-            <a:off x="9948672" y="5673852"/>
-            <a:ext cx="1508760" cy="192024"/>
-          </a:xfrm>
-          <a:prstGeom xmlns:a="http://schemas.openxmlformats.org/drawingml/2006/main" prst="rect">
-            <a:avLst/>
-          </a:prstGeom>
-          <a:noFill xmlns:a="http://schemas.openxmlformats.org/drawingml/2006/main"/>
-        </p:spPr>
-        <p:txBody>
-          <a:bodyPr xmlns:a="http://schemas.openxmlformats.org/drawingml/2006/main" wrap="square" lIns="0" tIns="0" rIns="0" bIns="0" anchor="ctr"/>
-          <a:lstStyle xmlns:a="http://schemas.openxmlformats.org/drawingml/2006/main"/>
-          <a:p xmlns:a="http://schemas.openxmlformats.org/drawingml/2006/main">
-            <a:pPr marL="0" indent="0" algn="r">
-              <a:buNone/>
-            </a:pPr>
-            <a:r>
-              <a:rPr sz="950">
-                <a:solidFill>
-                  <a:srgbClr val="FCF9F0"/>
-                </a:solidFill>
-                <a:latin typeface="Calibri"/>
-                <a:ea typeface="Calibri"/>
-                <a:cs typeface="Calibri"/>
-              </a:rPr>
-              <a:t>доступно</a:t>
-            </a:r>
-            <a:endParaRPr sz="950"/>
-          </a:p>
-        </p:txBody>
-      </p:sp>
-      <p:sp>
-        <p:nvSpPr>
-          <p:cNvPr id="73" name="Text 67">
-            <a:extLst xmlns:a="http://schemas.openxmlformats.org/drawingml/2006/main">
-              <a:ext uri="{FF2B5EF4-FFF2-40B4-BE49-F238E27FC236}">
-                <a16:creationId xmlns:a16="http://schemas.microsoft.com/office/drawing/2014/main" id="{8A12195C-5F27-417B-939C-737A8C06AF0C}"/>
+              <a:t>приклад упаковки клієнта</a:t>
+            </a:r>
+            <a:endParaRPr sz="1050"/>
+          </a:p>
+        </p:txBody>
+      </p:sp>
+      <p:sp>
+        <p:nvSpPr>
+          <p:cNvPr id="34" name="Text 31">
+            <a:extLst xmlns:a="http://schemas.openxmlformats.org/drawingml/2006/main">
+              <a:ext uri="{FF2B5EF4-FFF2-40B4-BE49-F238E27FC236}">
+                <a16:creationId xmlns:a16="http://schemas.microsoft.com/office/drawing/2014/main" id="{536F47F1-10DF-4B38-8365-3317E620F8C6}"/>
               </a:ext>
             </a:extLst>
           </p:cNvPr>
@@ -17996,82 +16338,16 @@
                 <a:ea typeface="Calibri"/>
                 <a:cs typeface="Calibri"/>
               </a:rPr>
-              <a:t>Джерело: Cup-Photo of Products.pdf · фото SPAR надано користувачем.</a:t>
+              <a:t>Джерело: Cup-Photo of Products.pdf; фото SPAR Jasmine Rice Cups надано користувачем. * Basmati — за запитом постачальника.</a:t>
             </a:r>
             <a:endParaRPr sz="900"/>
           </a:p>
         </p:txBody>
       </p:sp>
-      <p:pic>
-        <p:nvPicPr>
-          <p:cNvPr id="150" name=""/>
-          <p:cNvPicPr>
-            <a:picLocks xmlns:a="http://schemas.openxmlformats.org/drawingml/2006/main" noChangeAspect="1"/>
-          </p:cNvPicPr>
-          <p:nvPr/>
-        </p:nvPicPr>
-        <p:blipFill>
-          <a:blip xmlns:r="http://schemas.openxmlformats.org/officeDocument/2006/relationships" xmlns:a="http://schemas.openxmlformats.org/drawingml/2006/main" r:embed="R91a9306d32f94de1"/>
-          <a:stretch xmlns:a="http://schemas.openxmlformats.org/drawingml/2006/main"/>
-        </p:blipFill>
-        <p:spPr>
-          <a:xfrm xmlns:a="http://schemas.openxmlformats.org/drawingml/2006/main" flipH="0" flipV="0">
-            <a:off x="749808" y="1700784"/>
-            <a:ext cx="2340864" cy="1810512"/>
-          </a:xfrm>
-          <a:prstGeom xmlns:a="http://schemas.openxmlformats.org/drawingml/2006/main" prst="roundRect">
-            <a:avLst/>
-          </a:prstGeom>
-        </p:spPr>
-      </p:pic>
-      <p:pic>
-        <p:nvPicPr>
-          <p:cNvPr id="151" name=""/>
-          <p:cNvPicPr>
-            <a:picLocks xmlns:a="http://schemas.openxmlformats.org/drawingml/2006/main" noChangeAspect="1"/>
-          </p:cNvPicPr>
-          <p:nvPr/>
-        </p:nvPicPr>
-        <p:blipFill>
-          <a:blip xmlns:r="http://schemas.openxmlformats.org/officeDocument/2006/relationships" xmlns:a="http://schemas.openxmlformats.org/drawingml/2006/main" r:embed="R3412426887fc459e"/>
-          <a:stretch xmlns:a="http://schemas.openxmlformats.org/drawingml/2006/main"/>
-        </p:blipFill>
-        <p:spPr>
-          <a:xfrm xmlns:a="http://schemas.openxmlformats.org/drawingml/2006/main" flipH="0" flipV="0">
-            <a:off x="3566160" y="1700784"/>
-            <a:ext cx="2340864" cy="1810512"/>
-          </a:xfrm>
-          <a:prstGeom xmlns:a="http://schemas.openxmlformats.org/drawingml/2006/main" prst="roundRect">
-            <a:avLst/>
-          </a:prstGeom>
-        </p:spPr>
-      </p:pic>
-      <p:pic>
-        <p:nvPicPr>
-          <p:cNvPr id="152" name=""/>
-          <p:cNvPicPr>
-            <a:picLocks xmlns:a="http://schemas.openxmlformats.org/drawingml/2006/main" noChangeAspect="1"/>
-          </p:cNvPicPr>
-          <p:nvPr/>
-        </p:nvPicPr>
-        <p:blipFill>
-          <a:blip xmlns:r="http://schemas.openxmlformats.org/officeDocument/2006/relationships" xmlns:a="http://schemas.openxmlformats.org/drawingml/2006/main" r:embed="R2844c0cd4dc14710"/>
-          <a:stretch xmlns:a="http://schemas.openxmlformats.org/drawingml/2006/main"/>
-        </p:blipFill>
-        <p:spPr>
-          <a:xfrm xmlns:a="http://schemas.openxmlformats.org/drawingml/2006/main" flipH="0" flipV="0">
-            <a:off x="6382512" y="1700784"/>
-            <a:ext cx="2340864" cy="1810512"/>
-          </a:xfrm>
-          <a:prstGeom xmlns:a="http://schemas.openxmlformats.org/drawingml/2006/main" prst="roundRect">
-            <a:avLst/>
-          </a:prstGeom>
-        </p:spPr>
-      </p:pic>
     </p:spTree>
     <p:extLst>
       <p:ext uri="{BB962C8B-B14F-4D97-AF65-F5344CB8AC3E}">
-        <p14:creationId xmlns:p14="http://schemas.microsoft.com/office/powerpoint/2010/main" val="1503426620"/>
+        <p14:creationId xmlns:p14="http://schemas.microsoft.com/office/powerpoint/2010/main" val="59807226"/>
       </p:ext>
     </p:extLst>
   </p:cSld>

</xml_diff>

<commit_message>
Add self-cost to the 4 Single Cup 150g SKUs on slide 6
Sourced from Self Cost Rice Brand.xlsx, sheet "BSCM(Bags+Cups) - Навалом",
final landed cost per unit (col 39/40) for all 4 shipping options - same
component as the pouch cards: FOB + tier line, cost box with 20'/40' FCL
and LCL 17/34 m³ rows, 40' FCL highlighted.

Two price tiers came out of the sheet: Thai Jasmine / Thai Brown Jasmine at
FOB $0.500 (базовий SKU), Thai Red Jasmine / Rice Berry at FOB $0.542
(спеціальний SKU) - identical figures within each pair, straight from the
workbook.

Dropped the per-card packaging parameters (Формат/Вага/Короб/Sleeve) to make
room - they were identical across all 4 cards and already stated once in the
slide's own subtitle.

Co-Authored-By: Claude Sonnet 5 <noreply@anthropic.com>
Claude-Session: https://claude.ai/code/session_01NDFDM6HpP3f8QTd8UUPgQV
</commit_message>
<xml_diff>
--- a/RTE_Rice_Suppliers.pptx
+++ b/RTE_Rice_Suppliers.pptx
@@ -11989,7 +11989,7 @@
                 <a:ea typeface="Calibri"/>
                 <a:cs typeface="Calibri"/>
               </a:rPr>
-              <a:t>Single Cup · Sleeve Box</a:t>
+              <a:t>FOB $0,500 · базовий SKU</a:t>
             </a:r>
             <a:endParaRPr sz="1000"/>
           </a:p>
@@ -12079,7 +12079,7 @@
                 <a:ea typeface="Calibri"/>
                 <a:cs typeface="Calibri"/>
               </a:rPr>
-              <a:t>ПАРАМЕТРИ УПАКОВКИ</a:t>
+              <a:t>СОБІВАРТІСТЬ, ЗА СТАКАНЧИК</a:t>
             </a:r>
             <a:endParaRPr sz="750"/>
           </a:p>
@@ -12125,7 +12125,7 @@
                 <a:ea typeface="Calibri"/>
                 <a:cs typeface="Calibri"/>
               </a:rPr>
-              <a:t>Формат</a:t>
+              <a:t>20′ FCL</a:t>
             </a:r>
             <a:endParaRPr sz="900"/>
           </a:p>
@@ -12171,7 +12171,7 @@
                 <a:ea typeface="Calibri"/>
                 <a:cs typeface="Calibri"/>
               </a:rPr>
-              <a:t>Single Cup</a:t>
+              <a:t>$0,871 / 39,18 ₴</a:t>
             </a:r>
             <a:endParaRPr sz="950"/>
           </a:p>
@@ -12217,7 +12217,7 @@
                 <a:ea typeface="Calibri"/>
                 <a:cs typeface="Calibri"/>
               </a:rPr>
-              <a:t>Вага</a:t>
+              <a:t>40′ FCL</a:t>
             </a:r>
             <a:endParaRPr sz="900"/>
           </a:p>
@@ -12263,7 +12263,7 @@
                 <a:ea typeface="Calibri"/>
                 <a:cs typeface="Calibri"/>
               </a:rPr>
-              <a:t>150 г</a:t>
+              <a:t>$0,772 / 34,72 ₴</a:t>
             </a:r>
             <a:endParaRPr sz="950"/>
           </a:p>
@@ -12309,7 +12309,7 @@
                 <a:ea typeface="Calibri"/>
                 <a:cs typeface="Calibri"/>
               </a:rPr>
-              <a:t>Короб</a:t>
+              <a:t>LCL 17 м³</a:t>
             </a:r>
             <a:endParaRPr sz="900"/>
           </a:p>
@@ -12355,7 +12355,7 @@
                 <a:ea typeface="Calibri"/>
                 <a:cs typeface="Calibri"/>
               </a:rPr>
-              <a:t>12 шт.</a:t>
+              <a:t>$0,878 / 39,49 ₴</a:t>
             </a:r>
             <a:endParaRPr sz="950"/>
           </a:p>
@@ -12401,7 +12401,7 @@
                 <a:ea typeface="Calibri"/>
                 <a:cs typeface="Calibri"/>
               </a:rPr>
-              <a:t>Sleeve</a:t>
+              <a:t>LCL 34 м³</a:t>
             </a:r>
             <a:endParaRPr sz="900"/>
           </a:p>
@@ -12447,7 +12447,7 @@
                 <a:ea typeface="Calibri"/>
                 <a:cs typeface="Calibri"/>
               </a:rPr>
-              <a:t>коробка</a:t>
+              <a:t>$0,808 / 36,38 ₴</a:t>
             </a:r>
             <a:endParaRPr sz="950"/>
           </a:p>
@@ -12715,7 +12715,7 @@
                 <a:ea typeface="Calibri"/>
                 <a:cs typeface="Calibri"/>
               </a:rPr>
-              <a:t>Single Cup · Sleeve Box</a:t>
+              <a:t>FOB $0,500 · базовий SKU</a:t>
             </a:r>
             <a:endParaRPr sz="1000"/>
           </a:p>
@@ -12805,7 +12805,7 @@
                 <a:ea typeface="Calibri"/>
                 <a:cs typeface="Calibri"/>
               </a:rPr>
-              <a:t>ПАРАМЕТРИ УПАКОВКИ</a:t>
+              <a:t>СОБІВАРТІСТЬ, ЗА СТАКАНЧИК</a:t>
             </a:r>
             <a:endParaRPr sz="750"/>
           </a:p>
@@ -12851,7 +12851,7 @@
                 <a:ea typeface="Calibri"/>
                 <a:cs typeface="Calibri"/>
               </a:rPr>
-              <a:t>Формат</a:t>
+              <a:t>20′ FCL</a:t>
             </a:r>
             <a:endParaRPr sz="900"/>
           </a:p>
@@ -12897,7 +12897,7 @@
                 <a:ea typeface="Calibri"/>
                 <a:cs typeface="Calibri"/>
               </a:rPr>
-              <a:t>Single Cup</a:t>
+              <a:t>$0,871 / 39,18 ₴</a:t>
             </a:r>
             <a:endParaRPr sz="950"/>
           </a:p>
@@ -12943,7 +12943,7 @@
                 <a:ea typeface="Calibri"/>
                 <a:cs typeface="Calibri"/>
               </a:rPr>
-              <a:t>Вага</a:t>
+              <a:t>40′ FCL</a:t>
             </a:r>
             <a:endParaRPr sz="900"/>
           </a:p>
@@ -12989,7 +12989,7 @@
                 <a:ea typeface="Calibri"/>
                 <a:cs typeface="Calibri"/>
               </a:rPr>
-              <a:t>150 г</a:t>
+              <a:t>$0,772 / 34,72 ₴</a:t>
             </a:r>
             <a:endParaRPr sz="950"/>
           </a:p>
@@ -13035,7 +13035,7 @@
                 <a:ea typeface="Calibri"/>
                 <a:cs typeface="Calibri"/>
               </a:rPr>
-              <a:t>Короб</a:t>
+              <a:t>LCL 17 м³</a:t>
             </a:r>
             <a:endParaRPr sz="900"/>
           </a:p>
@@ -13081,7 +13081,7 @@
                 <a:ea typeface="Calibri"/>
                 <a:cs typeface="Calibri"/>
               </a:rPr>
-              <a:t>12 шт.</a:t>
+              <a:t>$0,878 / 39,49 ₴</a:t>
             </a:r>
             <a:endParaRPr sz="950"/>
           </a:p>
@@ -13127,7 +13127,7 @@
                 <a:ea typeface="Calibri"/>
                 <a:cs typeface="Calibri"/>
               </a:rPr>
-              <a:t>Sleeve</a:t>
+              <a:t>LCL 34 м³</a:t>
             </a:r>
             <a:endParaRPr sz="900"/>
           </a:p>
@@ -13173,7 +13173,7 @@
                 <a:ea typeface="Calibri"/>
                 <a:cs typeface="Calibri"/>
               </a:rPr>
-              <a:t>коробка</a:t>
+              <a:t>$0,808 / 36,38 ₴</a:t>
             </a:r>
             <a:endParaRPr sz="950"/>
           </a:p>
@@ -13441,7 +13441,7 @@
                 <a:ea typeface="Calibri"/>
                 <a:cs typeface="Calibri"/>
               </a:rPr>
-              <a:t>Single Cup · Sleeve Box</a:t>
+              <a:t>FOB $0,542 · спеціальний SKU</a:t>
             </a:r>
             <a:endParaRPr sz="1000"/>
           </a:p>
@@ -13531,7 +13531,7 @@
                 <a:ea typeface="Calibri"/>
                 <a:cs typeface="Calibri"/>
               </a:rPr>
-              <a:t>ПАРАМЕТРИ УПАКОВКИ</a:t>
+              <a:t>СОБІВАРТІСТЬ, ЗА СТАКАНЧИК</a:t>
             </a:r>
             <a:endParaRPr sz="750"/>
           </a:p>
@@ -13577,7 +13577,7 @@
                 <a:ea typeface="Calibri"/>
                 <a:cs typeface="Calibri"/>
               </a:rPr>
-              <a:t>Формат</a:t>
+              <a:t>20′ FCL</a:t>
             </a:r>
             <a:endParaRPr sz="900"/>
           </a:p>
@@ -13623,7 +13623,7 @@
                 <a:ea typeface="Calibri"/>
                 <a:cs typeface="Calibri"/>
               </a:rPr>
-              <a:t>Single Cup</a:t>
+              <a:t>$0,943 / 42,45 ₴</a:t>
             </a:r>
             <a:endParaRPr sz="950"/>
           </a:p>
@@ -13669,7 +13669,7 @@
                 <a:ea typeface="Calibri"/>
                 <a:cs typeface="Calibri"/>
               </a:rPr>
-              <a:t>Вага</a:t>
+              <a:t>40′ FCL</a:t>
             </a:r>
             <a:endParaRPr sz="900"/>
           </a:p>
@@ -13715,7 +13715,7 @@
                 <a:ea typeface="Calibri"/>
                 <a:cs typeface="Calibri"/>
               </a:rPr>
-              <a:t>150 г</a:t>
+              <a:t>$0,836 / 37,61 ₴</a:t>
             </a:r>
             <a:endParaRPr sz="950"/>
           </a:p>
@@ -13761,7 +13761,7 @@
                 <a:ea typeface="Calibri"/>
                 <a:cs typeface="Calibri"/>
               </a:rPr>
-              <a:t>Короб</a:t>
+              <a:t>LCL 17 м³</a:t>
             </a:r>
             <a:endParaRPr sz="900"/>
           </a:p>
@@ -13807,7 +13807,7 @@
                 <a:ea typeface="Calibri"/>
                 <a:cs typeface="Calibri"/>
               </a:rPr>
-              <a:t>12 шт.</a:t>
+              <a:t>$0,951 / 42,78 ₴</a:t>
             </a:r>
             <a:endParaRPr sz="950"/>
           </a:p>
@@ -13853,7 +13853,7 @@
                 <a:ea typeface="Calibri"/>
                 <a:cs typeface="Calibri"/>
               </a:rPr>
-              <a:t>Sleeve</a:t>
+              <a:t>LCL 34 м³</a:t>
             </a:r>
             <a:endParaRPr sz="900"/>
           </a:p>
@@ -13899,7 +13899,7 @@
                 <a:ea typeface="Calibri"/>
                 <a:cs typeface="Calibri"/>
               </a:rPr>
-              <a:t>коробка</a:t>
+              <a:t>$0,876 / 39,41 ₴</a:t>
             </a:r>
             <a:endParaRPr sz="950"/>
           </a:p>
@@ -14167,7 +14167,7 @@
                 <a:ea typeface="Calibri"/>
                 <a:cs typeface="Calibri"/>
               </a:rPr>
-              <a:t>Single Cup · Sleeve Box</a:t>
+              <a:t>FOB $0,542 · спеціальний SKU</a:t>
             </a:r>
             <a:endParaRPr sz="1000"/>
           </a:p>
@@ -14257,7 +14257,7 @@
                 <a:ea typeface="Calibri"/>
                 <a:cs typeface="Calibri"/>
               </a:rPr>
-              <a:t>ПАРАМЕТРИ УПАКОВКИ</a:t>
+              <a:t>СОБІВАРТІСТЬ, ЗА СТАКАНЧИК</a:t>
             </a:r>
             <a:endParaRPr sz="750"/>
           </a:p>
@@ -14303,7 +14303,7 @@
                 <a:ea typeface="Calibri"/>
                 <a:cs typeface="Calibri"/>
               </a:rPr>
-              <a:t>Формат</a:t>
+              <a:t>20′ FCL</a:t>
             </a:r>
             <a:endParaRPr sz="900"/>
           </a:p>
@@ -14349,7 +14349,7 @@
                 <a:ea typeface="Calibri"/>
                 <a:cs typeface="Calibri"/>
               </a:rPr>
-              <a:t>Single Cup</a:t>
+              <a:t>$0,943 / 42,45 ₴</a:t>
             </a:r>
             <a:endParaRPr sz="950"/>
           </a:p>
@@ -14395,7 +14395,7 @@
                 <a:ea typeface="Calibri"/>
                 <a:cs typeface="Calibri"/>
               </a:rPr>
-              <a:t>Вага</a:t>
+              <a:t>40′ FCL</a:t>
             </a:r>
             <a:endParaRPr sz="900"/>
           </a:p>
@@ -14441,7 +14441,7 @@
                 <a:ea typeface="Calibri"/>
                 <a:cs typeface="Calibri"/>
               </a:rPr>
-              <a:t>150 г</a:t>
+              <a:t>$0,836 / 37,61 ₴</a:t>
             </a:r>
             <a:endParaRPr sz="950"/>
           </a:p>
@@ -14487,7 +14487,7 @@
                 <a:ea typeface="Calibri"/>
                 <a:cs typeface="Calibri"/>
               </a:rPr>
-              <a:t>Короб</a:t>
+              <a:t>LCL 17 м³</a:t>
             </a:r>
             <a:endParaRPr sz="900"/>
           </a:p>
@@ -14533,7 +14533,7 @@
                 <a:ea typeface="Calibri"/>
                 <a:cs typeface="Calibri"/>
               </a:rPr>
-              <a:t>12 шт.</a:t>
+              <a:t>$0,951 / 42,78 ₴</a:t>
             </a:r>
             <a:endParaRPr sz="950"/>
           </a:p>
@@ -14579,7 +14579,7 @@
                 <a:ea typeface="Calibri"/>
                 <a:cs typeface="Calibri"/>
               </a:rPr>
-              <a:t>Sleeve</a:t>
+              <a:t>LCL 34 м³</a:t>
             </a:r>
             <a:endParaRPr sz="900"/>
           </a:p>
@@ -14625,7 +14625,7 @@
                 <a:ea typeface="Calibri"/>
                 <a:cs typeface="Calibri"/>
               </a:rPr>
-              <a:t>коробка</a:t>
+              <a:t>$0,876 / 39,41 ₴</a:t>
             </a:r>
             <a:endParaRPr sz="950"/>
           </a:p>
@@ -14671,7 +14671,7 @@
                 <a:ea typeface="Calibri"/>
                 <a:cs typeface="Calibri"/>
               </a:rPr>
-              <a:t>Джерело: Cup-Photo of Products.pdf · нове виробництво BSCM Foods.</a:t>
+              <a:t>Джерело: Cup-Photo of Products.pdf, Self Cost Rice Brand.xlsx (BSCM(Bags+Cups) - Навалом) · курс 45,00 UAH/USD.</a:t>
             </a:r>
             <a:endParaRPr sz="900"/>
           </a:p>

</xml_diff>

<commit_message>
Deduplicate the Double Cup flavour list, simplify to plain bullets
Slide 8: the flavour list was label+status two-column rows ("доступно" on
6 of 7, one unavailable). Dropped the row that doesn't exist (Jasmine
Rice, no oil) and the status column entirely - what's listed is what's
offered, no extra words needed. Plain gold bullets, one column.

Slide 9 (appearance) was repeating that exact same list verbatim under an
identical header - removed it there; that slide's job is the photos. Its
"Про формат" paragraph is now shorter, framed for what's on that slide,
and points back to slide 8 for the full flavour list. Re-centered the card
now that it holds less text.

Co-Authored-By: Claude Sonnet 5 <noreply@anthropic.com>
Claude-Session: https://claude.ai/code/session_01NDFDM6HpP3f8QTd8UUPgQV
</commit_message>
<xml_diff>
--- a/RTE_Rice_Suppliers.pptx
+++ b/RTE_Rice_Suppliers.pptx
@@ -17065,10 +17065,10 @@
       </p:sp>
       <p:sp>
         <p:nvSpPr>
-          <p:cNvPr id="9" name="Text 7">
-            <a:extLst>
-              <a:ext uri="{FF2B5EF4-FFF2-40B4-BE49-F238E27FC236}">
-                <a16:creationId xmlns:a16="http://schemas.microsoft.com/office/drawing/2014/main" id="{7A91FA7F-CF81-4499-8A50-A7DEE4346D83}"/>
+          <p:cNvPr id="11" name="Text 9">
+            <a:extLst>
+              <a:ext uri="{FF2B5EF4-FFF2-40B4-BE49-F238E27FC236}">
+                <a16:creationId xmlns:a16="http://schemas.microsoft.com/office/drawing/2014/main" id="{FCACD5D8-D338-4EA5-B23F-C319A9D0F23D}"/>
               </a:ext>
             </a:extLst>
           </p:cNvPr>
@@ -17080,30 +17080,35 @@
         <p:spPr>
           <a:xfrm>
             <a:off x="841248" y="3383280"/>
-            <a:ext cx="2103120" cy="256032"/>
-          </a:xfrm>
-          <a:prstGeom prst="rect">
-            <a:avLst/>
-          </a:prstGeom>
-          <a:noFill/>
-        </p:spPr>
-        <p:txBody>
-          <a:bodyPr wrap="square" lIns="0" tIns="0" rIns="0" bIns="0" anchor="ctr"/>
-          <a:lstStyle/>
-          <a:p>
-            <a:pPr marL="0" indent="0">
-              <a:buNone/>
-            </a:pPr>
-            <a:r>
-              <a:rPr sz="1050">
-                <a:solidFill>
-                  <a:srgbClr val="D2E4CE"/>
-                </a:solidFill>
-                <a:latin typeface="Calibri"/>
-                <a:ea typeface="Calibri"/>
-                <a:cs typeface="Calibri"/>
-              </a:rPr>
-              <a:t>Jasmine Rice, no oil</a:t>
+            <a:ext cx="5486400" cy="256032"/>
+          </a:xfrm>
+          <a:prstGeom prst="rect">
+            <a:avLst/>
+          </a:prstGeom>
+          <a:noFill/>
+        </p:spPr>
+        <p:txBody>
+          <a:bodyPr wrap="square" lIns="0" tIns="0" rIns="0" bIns="0" anchor="ctr"/>
+          <a:lstStyle/>
+          <a:p>
+            <a:pPr marL="201168" indent="-201168">
+              <a:buNone/>
+              <a:buClr>
+                <a:srgbClr val="F5CE76"/>
+              </a:buClr>
+              <a:buFont typeface="Arial"/>
+              <a:buChar char="●"/>
+            </a:pPr>
+            <a:r>
+              <a:rPr sz="1400" b="0">
+                <a:solidFill>
+                  <a:srgbClr val="FCF9F0"/>
+                </a:solidFill>
+                <a:latin typeface="Calibri"/>
+                <a:ea typeface="Calibri"/>
+                <a:cs typeface="Calibri"/>
+              </a:rPr>
+              <a:t>Jasmine Rice</a:t>
             </a:r>
             <a:endParaRPr sz="1050"/>
           </a:p>
@@ -17111,37 +17116,42 @@
       </p:sp>
       <p:sp>
         <p:nvSpPr>
-          <p:cNvPr id="10" name="Text 8">
-            <a:extLst>
-              <a:ext uri="{FF2B5EF4-FFF2-40B4-BE49-F238E27FC236}">
-                <a16:creationId xmlns:a16="http://schemas.microsoft.com/office/drawing/2014/main" id="{BE8A5288-4469-45DA-BAD0-F665517C1E65}"/>
-              </a:ext>
-            </a:extLst>
-          </p:cNvPr>
-          <p:cNvSpPr>
-            <a:spLocks noGrp="1"/>
-          </p:cNvSpPr>
-          <p:nvPr/>
-        </p:nvSpPr>
-        <p:spPr>
-          <a:xfrm>
-            <a:off x="2971800" y="3383280"/>
-            <a:ext cx="4023360" cy="256032"/>
-          </a:xfrm>
-          <a:prstGeom prst="rect">
-            <a:avLst/>
-          </a:prstGeom>
-          <a:noFill/>
-        </p:spPr>
-        <p:txBody>
-          <a:bodyPr wrap="square" lIns="0" tIns="0" rIns="0" bIns="0" anchor="ctr"/>
-          <a:lstStyle/>
-          <a:p>
-            <a:pPr marL="0" indent="0">
-              <a:buNone/>
-            </a:pPr>
-            <a:r>
-              <a:rPr sz="1150" b="1">
+          <p:cNvPr id="13" name="Text 11">
+            <a:extLst>
+              <a:ext uri="{FF2B5EF4-FFF2-40B4-BE49-F238E27FC236}">
+                <a16:creationId xmlns:a16="http://schemas.microsoft.com/office/drawing/2014/main" id="{1B17E25C-EAC6-44DA-BED1-8DA3C384AB1F}"/>
+              </a:ext>
+            </a:extLst>
+          </p:cNvPr>
+          <p:cNvSpPr>
+            <a:spLocks noGrp="1"/>
+          </p:cNvSpPr>
+          <p:nvPr/>
+        </p:nvSpPr>
+        <p:spPr>
+          <a:xfrm>
+            <a:off x="841248" y="3749040"/>
+            <a:ext cx="5486400" cy="256032"/>
+          </a:xfrm>
+          <a:prstGeom prst="rect">
+            <a:avLst/>
+          </a:prstGeom>
+          <a:noFill/>
+        </p:spPr>
+        <p:txBody>
+          <a:bodyPr wrap="square" lIns="0" tIns="0" rIns="0" bIns="0" anchor="ctr"/>
+          <a:lstStyle/>
+          <a:p>
+            <a:pPr marL="201168" indent="-201168">
+              <a:buNone/>
+              <a:buClr>
+                <a:srgbClr val="F5CE76"/>
+              </a:buClr>
+              <a:buFont typeface="Arial"/>
+              <a:buChar char="●"/>
+            </a:pPr>
+            <a:r>
+              <a:rPr sz="1400" b="0">
                 <a:solidFill>
                   <a:srgbClr val="FCF9F0"/>
                 </a:solidFill>
@@ -17149,53 +17159,7 @@
                 <a:ea typeface="Calibri"/>
                 <a:cs typeface="Calibri"/>
               </a:rPr>
-              <a:t>немає в PL</a:t>
-            </a:r>
-            <a:endParaRPr sz="1150"/>
-          </a:p>
-        </p:txBody>
-      </p:sp>
-      <p:sp>
-        <p:nvSpPr>
-          <p:cNvPr id="11" name="Text 9">
-            <a:extLst>
-              <a:ext uri="{FF2B5EF4-FFF2-40B4-BE49-F238E27FC236}">
-                <a16:creationId xmlns:a16="http://schemas.microsoft.com/office/drawing/2014/main" id="{FCACD5D8-D338-4EA5-B23F-C319A9D0F23D}"/>
-              </a:ext>
-            </a:extLst>
-          </p:cNvPr>
-          <p:cNvSpPr>
-            <a:spLocks noGrp="1"/>
-          </p:cNvSpPr>
-          <p:nvPr/>
-        </p:nvSpPr>
-        <p:spPr>
-          <a:xfrm>
-            <a:off x="841248" y="3717036"/>
-            <a:ext cx="2103120" cy="256032"/>
-          </a:xfrm>
-          <a:prstGeom prst="rect">
-            <a:avLst/>
-          </a:prstGeom>
-          <a:noFill/>
-        </p:spPr>
-        <p:txBody>
-          <a:bodyPr wrap="square" lIns="0" tIns="0" rIns="0" bIns="0" anchor="ctr"/>
-          <a:lstStyle/>
-          <a:p>
-            <a:pPr marL="0" indent="0">
-              <a:buNone/>
-            </a:pPr>
-            <a:r>
-              <a:rPr sz="1050">
-                <a:solidFill>
-                  <a:srgbClr val="D2E4CE"/>
-                </a:solidFill>
-                <a:latin typeface="Calibri"/>
-                <a:ea typeface="Calibri"/>
-                <a:cs typeface="Calibri"/>
-              </a:rPr>
-              <a:t>Jasmine Rice, w oil</a:t>
+              <a:t>Jasmine Rice (Pathum)</a:t>
             </a:r>
             <a:endParaRPr sz="1050"/>
           </a:p>
@@ -17203,37 +17167,42 @@
       </p:sp>
       <p:sp>
         <p:nvSpPr>
-          <p:cNvPr id="12" name="Text 10">
-            <a:extLst>
-              <a:ext uri="{FF2B5EF4-FFF2-40B4-BE49-F238E27FC236}">
-                <a16:creationId xmlns:a16="http://schemas.microsoft.com/office/drawing/2014/main" id="{818D73A6-5619-40CD-864C-164E337887CE}"/>
-              </a:ext>
-            </a:extLst>
-          </p:cNvPr>
-          <p:cNvSpPr>
-            <a:spLocks noGrp="1"/>
-          </p:cNvSpPr>
-          <p:nvPr/>
-        </p:nvSpPr>
-        <p:spPr>
-          <a:xfrm>
-            <a:off x="2971800" y="3717036"/>
-            <a:ext cx="4023360" cy="256032"/>
-          </a:xfrm>
-          <a:prstGeom prst="rect">
-            <a:avLst/>
-          </a:prstGeom>
-          <a:noFill/>
-        </p:spPr>
-        <p:txBody>
-          <a:bodyPr wrap="square" lIns="0" tIns="0" rIns="0" bIns="0" anchor="ctr"/>
-          <a:lstStyle/>
-          <a:p>
-            <a:pPr marL="0" indent="0">
-              <a:buNone/>
-            </a:pPr>
-            <a:r>
-              <a:rPr sz="1150" b="1">
+          <p:cNvPr id="15" name="Text 13">
+            <a:extLst>
+              <a:ext uri="{FF2B5EF4-FFF2-40B4-BE49-F238E27FC236}">
+                <a16:creationId xmlns:a16="http://schemas.microsoft.com/office/drawing/2014/main" id="{61BC70C4-0C92-435A-9487-D75013A4A699}"/>
+              </a:ext>
+            </a:extLst>
+          </p:cNvPr>
+          <p:cNvSpPr>
+            <a:spLocks noGrp="1"/>
+          </p:cNvSpPr>
+          <p:nvPr/>
+        </p:nvSpPr>
+        <p:spPr>
+          <a:xfrm>
+            <a:off x="841248" y="4114800"/>
+            <a:ext cx="5486400" cy="256032"/>
+          </a:xfrm>
+          <a:prstGeom prst="rect">
+            <a:avLst/>
+          </a:prstGeom>
+          <a:noFill/>
+        </p:spPr>
+        <p:txBody>
+          <a:bodyPr wrap="square" lIns="0" tIns="0" rIns="0" bIns="0" anchor="ctr"/>
+          <a:lstStyle/>
+          <a:p>
+            <a:pPr marL="201168" indent="-201168">
+              <a:buNone/>
+              <a:buClr>
+                <a:srgbClr val="F5CE76"/>
+              </a:buClr>
+              <a:buFont typeface="Arial"/>
+              <a:buChar char="●"/>
+            </a:pPr>
+            <a:r>
+              <a:rPr sz="1400" b="0">
                 <a:solidFill>
                   <a:srgbClr val="FCF9F0"/>
                 </a:solidFill>
@@ -17241,53 +17210,7 @@
                 <a:ea typeface="Calibri"/>
                 <a:cs typeface="Calibri"/>
               </a:rPr>
-              <a:t>доступно</a:t>
-            </a:r>
-            <a:endParaRPr sz="1150"/>
-          </a:p>
-        </p:txBody>
-      </p:sp>
-      <p:sp>
-        <p:nvSpPr>
-          <p:cNvPr id="13" name="Text 11">
-            <a:extLst>
-              <a:ext uri="{FF2B5EF4-FFF2-40B4-BE49-F238E27FC236}">
-                <a16:creationId xmlns:a16="http://schemas.microsoft.com/office/drawing/2014/main" id="{1B17E25C-EAC6-44DA-BED1-8DA3C384AB1F}"/>
-              </a:ext>
-            </a:extLst>
-          </p:cNvPr>
-          <p:cNvSpPr>
-            <a:spLocks noGrp="1"/>
-          </p:cNvSpPr>
-          <p:nvPr/>
-        </p:nvSpPr>
-        <p:spPr>
-          <a:xfrm>
-            <a:off x="841248" y="4050792"/>
-            <a:ext cx="2103120" cy="256032"/>
-          </a:xfrm>
-          <a:prstGeom prst="rect">
-            <a:avLst/>
-          </a:prstGeom>
-          <a:noFill/>
-        </p:spPr>
-        <p:txBody>
-          <a:bodyPr wrap="square" lIns="0" tIns="0" rIns="0" bIns="0" anchor="ctr"/>
-          <a:lstStyle/>
-          <a:p>
-            <a:pPr marL="0" indent="0">
-              <a:buNone/>
-            </a:pPr>
-            <a:r>
-              <a:rPr sz="1050">
-                <a:solidFill>
-                  <a:srgbClr val="D2E4CE"/>
-                </a:solidFill>
-                <a:latin typeface="Calibri"/>
-                <a:ea typeface="Calibri"/>
-                <a:cs typeface="Calibri"/>
-              </a:rPr>
-              <a:t>Jasmine Rice (Pathum), w oil</a:t>
+              <a:t>Brown Jasmine Rice</a:t>
             </a:r>
             <a:endParaRPr sz="1050"/>
           </a:p>
@@ -17295,37 +17218,42 @@
       </p:sp>
       <p:sp>
         <p:nvSpPr>
-          <p:cNvPr id="14" name="Text 12">
-            <a:extLst>
-              <a:ext uri="{FF2B5EF4-FFF2-40B4-BE49-F238E27FC236}">
-                <a16:creationId xmlns:a16="http://schemas.microsoft.com/office/drawing/2014/main" id="{1ACB90C5-BF37-41D9-8DC3-D21E41BC119E}"/>
-              </a:ext>
-            </a:extLst>
-          </p:cNvPr>
-          <p:cNvSpPr>
-            <a:spLocks noGrp="1"/>
-          </p:cNvSpPr>
-          <p:nvPr/>
-        </p:nvSpPr>
-        <p:spPr>
-          <a:xfrm>
-            <a:off x="2971800" y="4050792"/>
-            <a:ext cx="4023360" cy="256032"/>
-          </a:xfrm>
-          <a:prstGeom prst="rect">
-            <a:avLst/>
-          </a:prstGeom>
-          <a:noFill/>
-        </p:spPr>
-        <p:txBody>
-          <a:bodyPr wrap="square" lIns="0" tIns="0" rIns="0" bIns="0" anchor="ctr"/>
-          <a:lstStyle/>
-          <a:p>
-            <a:pPr marL="0" indent="0">
-              <a:buNone/>
-            </a:pPr>
-            <a:r>
-              <a:rPr sz="1150" b="1">
+          <p:cNvPr id="17" name="Text 15">
+            <a:extLst>
+              <a:ext uri="{FF2B5EF4-FFF2-40B4-BE49-F238E27FC236}">
+                <a16:creationId xmlns:a16="http://schemas.microsoft.com/office/drawing/2014/main" id="{387B55C1-5453-4641-8FEE-2A2600E80415}"/>
+              </a:ext>
+            </a:extLst>
+          </p:cNvPr>
+          <p:cNvSpPr>
+            <a:spLocks noGrp="1"/>
+          </p:cNvSpPr>
+          <p:nvPr/>
+        </p:nvSpPr>
+        <p:spPr>
+          <a:xfrm>
+            <a:off x="841248" y="4480560"/>
+            <a:ext cx="5486400" cy="256032"/>
+          </a:xfrm>
+          <a:prstGeom prst="rect">
+            <a:avLst/>
+          </a:prstGeom>
+          <a:noFill/>
+        </p:spPr>
+        <p:txBody>
+          <a:bodyPr wrap="square" lIns="0" tIns="0" rIns="0" bIns="0" anchor="ctr"/>
+          <a:lstStyle/>
+          <a:p>
+            <a:pPr marL="201168" indent="-201168">
+              <a:buNone/>
+              <a:buClr>
+                <a:srgbClr val="F5CE76"/>
+              </a:buClr>
+              <a:buFont typeface="Arial"/>
+              <a:buChar char="●"/>
+            </a:pPr>
+            <a:r>
+              <a:rPr sz="1400" b="0">
                 <a:solidFill>
                   <a:srgbClr val="FCF9F0"/>
                 </a:solidFill>
@@ -17333,53 +17261,7 @@
                 <a:ea typeface="Calibri"/>
                 <a:cs typeface="Calibri"/>
               </a:rPr>
-              <a:t>доступно</a:t>
-            </a:r>
-            <a:endParaRPr sz="1150"/>
-          </a:p>
-        </p:txBody>
-      </p:sp>
-      <p:sp>
-        <p:nvSpPr>
-          <p:cNvPr id="15" name="Text 13">
-            <a:extLst>
-              <a:ext uri="{FF2B5EF4-FFF2-40B4-BE49-F238E27FC236}">
-                <a16:creationId xmlns:a16="http://schemas.microsoft.com/office/drawing/2014/main" id="{61BC70C4-0C92-435A-9487-D75013A4A699}"/>
-              </a:ext>
-            </a:extLst>
-          </p:cNvPr>
-          <p:cNvSpPr>
-            <a:spLocks noGrp="1"/>
-          </p:cNvSpPr>
-          <p:nvPr/>
-        </p:nvSpPr>
-        <p:spPr>
-          <a:xfrm>
-            <a:off x="841248" y="4384548"/>
-            <a:ext cx="2103120" cy="256032"/>
-          </a:xfrm>
-          <a:prstGeom prst="rect">
-            <a:avLst/>
-          </a:prstGeom>
-          <a:noFill/>
-        </p:spPr>
-        <p:txBody>
-          <a:bodyPr wrap="square" lIns="0" tIns="0" rIns="0" bIns="0" anchor="ctr"/>
-          <a:lstStyle/>
-          <a:p>
-            <a:pPr marL="0" indent="0">
-              <a:buNone/>
-            </a:pPr>
-            <a:r>
-              <a:rPr sz="1050">
-                <a:solidFill>
-                  <a:srgbClr val="D2E4CE"/>
-                </a:solidFill>
-                <a:latin typeface="Calibri"/>
-                <a:ea typeface="Calibri"/>
-                <a:cs typeface="Calibri"/>
-              </a:rPr>
-              <a:t>Brown Jasmine Rice, w oil</a:t>
+              <a:t>Brown Rice</a:t>
             </a:r>
             <a:endParaRPr sz="1050"/>
           </a:p>
@@ -17387,37 +17269,42 @@
       </p:sp>
       <p:sp>
         <p:nvSpPr>
-          <p:cNvPr id="16" name="Text 14">
-            <a:extLst>
-              <a:ext uri="{FF2B5EF4-FFF2-40B4-BE49-F238E27FC236}">
-                <a16:creationId xmlns:a16="http://schemas.microsoft.com/office/drawing/2014/main" id="{3F159060-DCDF-44CC-8B6D-02E8ED33BA8F}"/>
-              </a:ext>
-            </a:extLst>
-          </p:cNvPr>
-          <p:cNvSpPr>
-            <a:spLocks noGrp="1"/>
-          </p:cNvSpPr>
-          <p:nvPr/>
-        </p:nvSpPr>
-        <p:spPr>
-          <a:xfrm>
-            <a:off x="2971800" y="4384548"/>
-            <a:ext cx="4023360" cy="256032"/>
-          </a:xfrm>
-          <a:prstGeom prst="rect">
-            <a:avLst/>
-          </a:prstGeom>
-          <a:noFill/>
-        </p:spPr>
-        <p:txBody>
-          <a:bodyPr wrap="square" lIns="0" tIns="0" rIns="0" bIns="0" anchor="ctr"/>
-          <a:lstStyle/>
-          <a:p>
-            <a:pPr marL="0" indent="0">
-              <a:buNone/>
-            </a:pPr>
-            <a:r>
-              <a:rPr sz="1150" b="1">
+          <p:cNvPr id="19" name="Text 17">
+            <a:extLst>
+              <a:ext uri="{FF2B5EF4-FFF2-40B4-BE49-F238E27FC236}">
+                <a16:creationId xmlns:a16="http://schemas.microsoft.com/office/drawing/2014/main" id="{9CD79870-7EED-40F1-B03F-865D47193057}"/>
+              </a:ext>
+            </a:extLst>
+          </p:cNvPr>
+          <p:cNvSpPr>
+            <a:spLocks noGrp="1"/>
+          </p:cNvSpPr>
+          <p:nvPr/>
+        </p:nvSpPr>
+        <p:spPr>
+          <a:xfrm>
+            <a:off x="841248" y="4846320"/>
+            <a:ext cx="5486400" cy="256032"/>
+          </a:xfrm>
+          <a:prstGeom prst="rect">
+            <a:avLst/>
+          </a:prstGeom>
+          <a:noFill/>
+        </p:spPr>
+        <p:txBody>
+          <a:bodyPr wrap="square" lIns="0" tIns="0" rIns="0" bIns="0" anchor="ctr"/>
+          <a:lstStyle/>
+          <a:p>
+            <a:pPr marL="201168" indent="-201168">
+              <a:buNone/>
+              <a:buClr>
+                <a:srgbClr val="F5CE76"/>
+              </a:buClr>
+              <a:buFont typeface="Arial"/>
+              <a:buChar char="●"/>
+            </a:pPr>
+            <a:r>
+              <a:rPr sz="1400" b="0">
                 <a:solidFill>
                   <a:srgbClr val="FCF9F0"/>
                 </a:solidFill>
@@ -17425,53 +17312,7 @@
                 <a:ea typeface="Calibri"/>
                 <a:cs typeface="Calibri"/>
               </a:rPr>
-              <a:t>доступно</a:t>
-            </a:r>
-            <a:endParaRPr sz="1150"/>
-          </a:p>
-        </p:txBody>
-      </p:sp>
-      <p:sp>
-        <p:nvSpPr>
-          <p:cNvPr id="17" name="Text 15">
-            <a:extLst>
-              <a:ext uri="{FF2B5EF4-FFF2-40B4-BE49-F238E27FC236}">
-                <a16:creationId xmlns:a16="http://schemas.microsoft.com/office/drawing/2014/main" id="{387B55C1-5453-4641-8FEE-2A2600E80415}"/>
-              </a:ext>
-            </a:extLst>
-          </p:cNvPr>
-          <p:cNvSpPr>
-            <a:spLocks noGrp="1"/>
-          </p:cNvSpPr>
-          <p:nvPr/>
-        </p:nvSpPr>
-        <p:spPr>
-          <a:xfrm>
-            <a:off x="841248" y="4718304"/>
-            <a:ext cx="2103120" cy="256032"/>
-          </a:xfrm>
-          <a:prstGeom prst="rect">
-            <a:avLst/>
-          </a:prstGeom>
-          <a:noFill/>
-        </p:spPr>
-        <p:txBody>
-          <a:bodyPr wrap="square" lIns="0" tIns="0" rIns="0" bIns="0" anchor="ctr"/>
-          <a:lstStyle/>
-          <a:p>
-            <a:pPr marL="0" indent="0">
-              <a:buNone/>
-            </a:pPr>
-            <a:r>
-              <a:rPr sz="1050">
-                <a:solidFill>
-                  <a:srgbClr val="D2E4CE"/>
-                </a:solidFill>
-                <a:latin typeface="Calibri"/>
-                <a:ea typeface="Calibri"/>
-                <a:cs typeface="Calibri"/>
-              </a:rPr>
-              <a:t>Brown Rice, w oil</a:t>
+              <a:t>Basmati Rice*</a:t>
             </a:r>
             <a:endParaRPr sz="1050"/>
           </a:p>
@@ -17479,37 +17320,42 @@
       </p:sp>
       <p:sp>
         <p:nvSpPr>
-          <p:cNvPr id="18" name="Text 16">
-            <a:extLst>
-              <a:ext uri="{FF2B5EF4-FFF2-40B4-BE49-F238E27FC236}">
-                <a16:creationId xmlns:a16="http://schemas.microsoft.com/office/drawing/2014/main" id="{E5BCD84D-F4E9-40F7-AA7D-85E5A9A7C865}"/>
-              </a:ext>
-            </a:extLst>
-          </p:cNvPr>
-          <p:cNvSpPr>
-            <a:spLocks noGrp="1"/>
-          </p:cNvSpPr>
-          <p:nvPr/>
-        </p:nvSpPr>
-        <p:spPr>
-          <a:xfrm>
-            <a:off x="2971800" y="4718304"/>
-            <a:ext cx="4023360" cy="256032"/>
-          </a:xfrm>
-          <a:prstGeom prst="rect">
-            <a:avLst/>
-          </a:prstGeom>
-          <a:noFill/>
-        </p:spPr>
-        <p:txBody>
-          <a:bodyPr wrap="square" lIns="0" tIns="0" rIns="0" bIns="0" anchor="ctr"/>
-          <a:lstStyle/>
-          <a:p>
-            <a:pPr marL="0" indent="0">
-              <a:buNone/>
-            </a:pPr>
-            <a:r>
-              <a:rPr sz="1150" b="1">
+          <p:cNvPr id="21" name="Text 19">
+            <a:extLst>
+              <a:ext uri="{FF2B5EF4-FFF2-40B4-BE49-F238E27FC236}">
+                <a16:creationId xmlns:a16="http://schemas.microsoft.com/office/drawing/2014/main" id="{13A8E69A-5D22-455F-8007-BE2ECE9342F0}"/>
+              </a:ext>
+            </a:extLst>
+          </p:cNvPr>
+          <p:cNvSpPr>
+            <a:spLocks noGrp="1"/>
+          </p:cNvSpPr>
+          <p:nvPr/>
+        </p:nvSpPr>
+        <p:spPr>
+          <a:xfrm>
+            <a:off x="841248" y="5212080"/>
+            <a:ext cx="5486400" cy="256032"/>
+          </a:xfrm>
+          <a:prstGeom prst="rect">
+            <a:avLst/>
+          </a:prstGeom>
+          <a:noFill/>
+        </p:spPr>
+        <p:txBody>
+          <a:bodyPr wrap="square" lIns="0" tIns="0" rIns="0" bIns="0" anchor="ctr"/>
+          <a:lstStyle/>
+          <a:p>
+            <a:pPr marL="201168" indent="-201168">
+              <a:buNone/>
+              <a:buClr>
+                <a:srgbClr val="F5CE76"/>
+              </a:buClr>
+              <a:buFont typeface="Arial"/>
+              <a:buChar char="●"/>
+            </a:pPr>
+            <a:r>
+              <a:rPr sz="1400" b="0">
                 <a:solidFill>
                   <a:srgbClr val="FCF9F0"/>
                 </a:solidFill>
@@ -17517,193 +17363,9 @@
                 <a:ea typeface="Calibri"/>
                 <a:cs typeface="Calibri"/>
               </a:rPr>
-              <a:t>доступно</a:t>
-            </a:r>
-            <a:endParaRPr sz="1150"/>
-          </a:p>
-        </p:txBody>
-      </p:sp>
-      <p:sp>
-        <p:nvSpPr>
-          <p:cNvPr id="19" name="Text 17">
-            <a:extLst>
-              <a:ext uri="{FF2B5EF4-FFF2-40B4-BE49-F238E27FC236}">
-                <a16:creationId xmlns:a16="http://schemas.microsoft.com/office/drawing/2014/main" id="{9CD79870-7EED-40F1-B03F-865D47193057}"/>
-              </a:ext>
-            </a:extLst>
-          </p:cNvPr>
-          <p:cNvSpPr>
-            <a:spLocks noGrp="1"/>
-          </p:cNvSpPr>
-          <p:nvPr/>
-        </p:nvSpPr>
-        <p:spPr>
-          <a:xfrm>
-            <a:off x="841248" y="5052060"/>
-            <a:ext cx="2103120" cy="256032"/>
-          </a:xfrm>
-          <a:prstGeom prst="rect">
-            <a:avLst/>
-          </a:prstGeom>
-          <a:noFill/>
-        </p:spPr>
-        <p:txBody>
-          <a:bodyPr wrap="square" lIns="0" tIns="0" rIns="0" bIns="0" anchor="ctr"/>
-          <a:lstStyle/>
-          <a:p>
-            <a:pPr marL="0" indent="0">
-              <a:buNone/>
-            </a:pPr>
-            <a:r>
-              <a:rPr sz="1050">
-                <a:solidFill>
-                  <a:srgbClr val="D2E4CE"/>
-                </a:solidFill>
-                <a:latin typeface="Calibri"/>
-                <a:ea typeface="Calibri"/>
-                <a:cs typeface="Calibri"/>
-              </a:rPr>
-              <a:t>Basmati Rice*, w oil</a:t>
+              <a:t>Long Grain</a:t>
             </a:r>
             <a:endParaRPr sz="1050"/>
-          </a:p>
-        </p:txBody>
-      </p:sp>
-      <p:sp>
-        <p:nvSpPr>
-          <p:cNvPr id="20" name="Text 18">
-            <a:extLst>
-              <a:ext uri="{FF2B5EF4-FFF2-40B4-BE49-F238E27FC236}">
-                <a16:creationId xmlns:a16="http://schemas.microsoft.com/office/drawing/2014/main" id="{9696F0F8-6388-458A-9A6E-BD09F3ACBA30}"/>
-              </a:ext>
-            </a:extLst>
-          </p:cNvPr>
-          <p:cNvSpPr>
-            <a:spLocks noGrp="1"/>
-          </p:cNvSpPr>
-          <p:nvPr/>
-        </p:nvSpPr>
-        <p:spPr>
-          <a:xfrm>
-            <a:off x="2971800" y="5052060"/>
-            <a:ext cx="4023360" cy="256032"/>
-          </a:xfrm>
-          <a:prstGeom prst="rect">
-            <a:avLst/>
-          </a:prstGeom>
-          <a:noFill/>
-        </p:spPr>
-        <p:txBody>
-          <a:bodyPr wrap="square" lIns="0" tIns="0" rIns="0" bIns="0" anchor="ctr"/>
-          <a:lstStyle/>
-          <a:p>
-            <a:pPr marL="0" indent="0">
-              <a:buNone/>
-            </a:pPr>
-            <a:r>
-              <a:rPr sz="1150" b="1">
-                <a:solidFill>
-                  <a:srgbClr val="FCF9F0"/>
-                </a:solidFill>
-                <a:latin typeface="Calibri"/>
-                <a:ea typeface="Calibri"/>
-                <a:cs typeface="Calibri"/>
-              </a:rPr>
-              <a:t>доступно</a:t>
-            </a:r>
-            <a:endParaRPr sz="1150"/>
-          </a:p>
-        </p:txBody>
-      </p:sp>
-      <p:sp>
-        <p:nvSpPr>
-          <p:cNvPr id="21" name="Text 19">
-            <a:extLst>
-              <a:ext uri="{FF2B5EF4-FFF2-40B4-BE49-F238E27FC236}">
-                <a16:creationId xmlns:a16="http://schemas.microsoft.com/office/drawing/2014/main" id="{13A8E69A-5D22-455F-8007-BE2ECE9342F0}"/>
-              </a:ext>
-            </a:extLst>
-          </p:cNvPr>
-          <p:cNvSpPr>
-            <a:spLocks noGrp="1"/>
-          </p:cNvSpPr>
-          <p:nvPr/>
-        </p:nvSpPr>
-        <p:spPr>
-          <a:xfrm>
-            <a:off x="841248" y="5385816"/>
-            <a:ext cx="2103120" cy="256032"/>
-          </a:xfrm>
-          <a:prstGeom prst="rect">
-            <a:avLst/>
-          </a:prstGeom>
-          <a:noFill/>
-        </p:spPr>
-        <p:txBody>
-          <a:bodyPr wrap="square" lIns="0" tIns="0" rIns="0" bIns="0" anchor="ctr"/>
-          <a:lstStyle/>
-          <a:p>
-            <a:pPr marL="0" indent="0">
-              <a:buNone/>
-            </a:pPr>
-            <a:r>
-              <a:rPr sz="1050">
-                <a:solidFill>
-                  <a:srgbClr val="D2E4CE"/>
-                </a:solidFill>
-                <a:latin typeface="Calibri"/>
-                <a:ea typeface="Calibri"/>
-                <a:cs typeface="Calibri"/>
-              </a:rPr>
-              <a:t>Long Grain, w oil</a:t>
-            </a:r>
-            <a:endParaRPr sz="1050"/>
-          </a:p>
-        </p:txBody>
-      </p:sp>
-      <p:sp>
-        <p:nvSpPr>
-          <p:cNvPr id="22" name="Text 20">
-            <a:extLst>
-              <a:ext uri="{FF2B5EF4-FFF2-40B4-BE49-F238E27FC236}">
-                <a16:creationId xmlns:a16="http://schemas.microsoft.com/office/drawing/2014/main" id="{0F71CE83-5380-4313-A831-A097BEC1C816}"/>
-              </a:ext>
-            </a:extLst>
-          </p:cNvPr>
-          <p:cNvSpPr>
-            <a:spLocks noGrp="1"/>
-          </p:cNvSpPr>
-          <p:nvPr/>
-        </p:nvSpPr>
-        <p:spPr>
-          <a:xfrm>
-            <a:off x="2971800" y="5385816"/>
-            <a:ext cx="4023360" cy="256032"/>
-          </a:xfrm>
-          <a:prstGeom prst="rect">
-            <a:avLst/>
-          </a:prstGeom>
-          <a:noFill/>
-        </p:spPr>
-        <p:txBody>
-          <a:bodyPr wrap="square" lIns="0" tIns="0" rIns="0" bIns="0" anchor="ctr"/>
-          <a:lstStyle/>
-          <a:p>
-            <a:pPr marL="0" indent="0">
-              <a:buNone/>
-            </a:pPr>
-            <a:r>
-              <a:rPr sz="1150" b="1">
-                <a:solidFill>
-                  <a:srgbClr val="FCF9F0"/>
-                </a:solidFill>
-                <a:latin typeface="Calibri"/>
-                <a:ea typeface="Calibri"/>
-                <a:cs typeface="Calibri"/>
-              </a:rPr>
-              <a:t>доступно</a:t>
-            </a:r>
-            <a:endParaRPr sz="1150"/>
           </a:p>
         </p:txBody>
       </p:sp>
@@ -18527,7 +18189,7 @@
                 <a:ea typeface="Cambria"/>
                 <a:cs typeface="Cambria"/>
               </a:rPr>
-              <a:t>Про формат</a:t>
+              <a:t>Як це виглядає</a:t>
             </a:r>
             <a:endParaRPr sz="1700"/>
           </a:p>
@@ -18549,8 +18211,8 @@
         </p:nvSpPr>
         <p:spPr>
           <a:xfrm>
-            <a:off x="841248" y="2103120"/>
-            <a:ext cx="6126480" cy="868680"/>
+            <a:off x="841248" y="3200400"/>
+            <a:ext cx="6126480" cy="1645920"/>
           </a:xfrm>
           <a:prstGeom prst="rect">
             <a:avLst/>
@@ -18568,7 +18230,7 @@
               <a:buNone/>
             </a:pPr>
             <a:r>
-              <a:rPr sz="1200">
+              <a:rPr sz="1500">
                 <a:solidFill>
                   <a:srgbClr val="FCF9F0"/>
                 </a:solidFill>
@@ -18576,699 +18238,9 @@
                 <a:ea typeface="Calibri"/>
                 <a:cs typeface="Calibri"/>
               </a:rPr>
-              <a:t>Власного бренду BSCM у форматі double cup немає — цей формат постачальник випускає виключно під приватною маркою замовника. Sleeve-бокс друкується під дизайн клієнта; приклад нижче — Jasmine Rice Cups для мережі SPAR.</a:t>
+              <a:t>Один sleeve-дизайн друкується під усі смаки лінійки — окремих фото пакування для кожного смаку постачальник не надає. Нижче показано сам бокс і приклад друку для мережі SPAR; повний перелік смаків — на попередньому слайді.</a:t>
             </a:r>
             <a:endParaRPr sz="1200"/>
-          </a:p>
-        </p:txBody>
-      </p:sp>
-      <p:sp>
-        <p:nvSpPr>
-          <p:cNvPr id="8" name="Text 6">
-            <a:extLst>
-              <a:ext uri="{FF2B5EF4-FFF2-40B4-BE49-F238E27FC236}">
-                <a16:creationId xmlns:a16="http://schemas.microsoft.com/office/drawing/2014/main" id="{650D0EC9-3F48-4B23-B62F-2DC20F4CB1E3}"/>
-              </a:ext>
-            </a:extLst>
-          </p:cNvPr>
-          <p:cNvSpPr>
-            <a:spLocks noGrp="1"/>
-          </p:cNvSpPr>
-          <p:nvPr/>
-        </p:nvSpPr>
-        <p:spPr>
-          <a:xfrm>
-            <a:off x="841248" y="3017520"/>
-            <a:ext cx="6126480" cy="310896"/>
-          </a:xfrm>
-          <a:prstGeom prst="rect">
-            <a:avLst/>
-          </a:prstGeom>
-          <a:noFill/>
-        </p:spPr>
-        <p:txBody>
-          <a:bodyPr wrap="square" lIns="0" tIns="0" rIns="0" bIns="0" anchor="ctr"/>
-          <a:lstStyle/>
-          <a:p>
-            <a:pPr marL="0" indent="0">
-              <a:buNone/>
-            </a:pPr>
-            <a:r>
-              <a:rPr sz="1700" b="1">
-                <a:solidFill>
-                  <a:srgbClr val="F5CE76"/>
-                </a:solidFill>
-                <a:latin typeface="Cambria"/>
-                <a:ea typeface="Cambria"/>
-                <a:cs typeface="Cambria"/>
-              </a:rPr>
-              <a:t>Смаки в офері</a:t>
-            </a:r>
-            <a:endParaRPr sz="1700"/>
-          </a:p>
-        </p:txBody>
-      </p:sp>
-      <p:sp>
-        <p:nvSpPr>
-          <p:cNvPr id="9" name="Text 7">
-            <a:extLst>
-              <a:ext uri="{FF2B5EF4-FFF2-40B4-BE49-F238E27FC236}">
-                <a16:creationId xmlns:a16="http://schemas.microsoft.com/office/drawing/2014/main" id="{7A91FA7F-CF81-4499-8A50-A7DEE4346D83}"/>
-              </a:ext>
-            </a:extLst>
-          </p:cNvPr>
-          <p:cNvSpPr>
-            <a:spLocks noGrp="1"/>
-          </p:cNvSpPr>
-          <p:nvPr/>
-        </p:nvSpPr>
-        <p:spPr>
-          <a:xfrm>
-            <a:off x="841248" y="3383280"/>
-            <a:ext cx="2103120" cy="256032"/>
-          </a:xfrm>
-          <a:prstGeom prst="rect">
-            <a:avLst/>
-          </a:prstGeom>
-          <a:noFill/>
-        </p:spPr>
-        <p:txBody>
-          <a:bodyPr wrap="square" lIns="0" tIns="0" rIns="0" bIns="0" anchor="ctr"/>
-          <a:lstStyle/>
-          <a:p>
-            <a:pPr marL="0" indent="0">
-              <a:buNone/>
-            </a:pPr>
-            <a:r>
-              <a:rPr sz="1050">
-                <a:solidFill>
-                  <a:srgbClr val="D2E4CE"/>
-                </a:solidFill>
-                <a:latin typeface="Calibri"/>
-                <a:ea typeface="Calibri"/>
-                <a:cs typeface="Calibri"/>
-              </a:rPr>
-              <a:t>Jasmine Rice, no oil</a:t>
-            </a:r>
-            <a:endParaRPr sz="1050"/>
-          </a:p>
-        </p:txBody>
-      </p:sp>
-      <p:sp>
-        <p:nvSpPr>
-          <p:cNvPr id="10" name="Text 8">
-            <a:extLst>
-              <a:ext uri="{FF2B5EF4-FFF2-40B4-BE49-F238E27FC236}">
-                <a16:creationId xmlns:a16="http://schemas.microsoft.com/office/drawing/2014/main" id="{BE8A5288-4469-45DA-BAD0-F665517C1E65}"/>
-              </a:ext>
-            </a:extLst>
-          </p:cNvPr>
-          <p:cNvSpPr>
-            <a:spLocks noGrp="1"/>
-          </p:cNvSpPr>
-          <p:nvPr/>
-        </p:nvSpPr>
-        <p:spPr>
-          <a:xfrm>
-            <a:off x="2971800" y="3383280"/>
-            <a:ext cx="4023360" cy="256032"/>
-          </a:xfrm>
-          <a:prstGeom prst="rect">
-            <a:avLst/>
-          </a:prstGeom>
-          <a:noFill/>
-        </p:spPr>
-        <p:txBody>
-          <a:bodyPr wrap="square" lIns="0" tIns="0" rIns="0" bIns="0" anchor="ctr"/>
-          <a:lstStyle/>
-          <a:p>
-            <a:pPr marL="0" indent="0">
-              <a:buNone/>
-            </a:pPr>
-            <a:r>
-              <a:rPr sz="1150" b="1">
-                <a:solidFill>
-                  <a:srgbClr val="FCF9F0"/>
-                </a:solidFill>
-                <a:latin typeface="Calibri"/>
-                <a:ea typeface="Calibri"/>
-                <a:cs typeface="Calibri"/>
-              </a:rPr>
-              <a:t>немає в PL</a:t>
-            </a:r>
-            <a:endParaRPr sz="1150"/>
-          </a:p>
-        </p:txBody>
-      </p:sp>
-      <p:sp>
-        <p:nvSpPr>
-          <p:cNvPr id="11" name="Text 9">
-            <a:extLst>
-              <a:ext uri="{FF2B5EF4-FFF2-40B4-BE49-F238E27FC236}">
-                <a16:creationId xmlns:a16="http://schemas.microsoft.com/office/drawing/2014/main" id="{FCACD5D8-D338-4EA5-B23F-C319A9D0F23D}"/>
-              </a:ext>
-            </a:extLst>
-          </p:cNvPr>
-          <p:cNvSpPr>
-            <a:spLocks noGrp="1"/>
-          </p:cNvSpPr>
-          <p:nvPr/>
-        </p:nvSpPr>
-        <p:spPr>
-          <a:xfrm>
-            <a:off x="841248" y="3717036"/>
-            <a:ext cx="2103120" cy="256032"/>
-          </a:xfrm>
-          <a:prstGeom prst="rect">
-            <a:avLst/>
-          </a:prstGeom>
-          <a:noFill/>
-        </p:spPr>
-        <p:txBody>
-          <a:bodyPr wrap="square" lIns="0" tIns="0" rIns="0" bIns="0" anchor="ctr"/>
-          <a:lstStyle/>
-          <a:p>
-            <a:pPr marL="0" indent="0">
-              <a:buNone/>
-            </a:pPr>
-            <a:r>
-              <a:rPr sz="1050">
-                <a:solidFill>
-                  <a:srgbClr val="D2E4CE"/>
-                </a:solidFill>
-                <a:latin typeface="Calibri"/>
-                <a:ea typeface="Calibri"/>
-                <a:cs typeface="Calibri"/>
-              </a:rPr>
-              <a:t>Jasmine Rice, w oil</a:t>
-            </a:r>
-            <a:endParaRPr sz="1050"/>
-          </a:p>
-        </p:txBody>
-      </p:sp>
-      <p:sp>
-        <p:nvSpPr>
-          <p:cNvPr id="12" name="Text 10">
-            <a:extLst>
-              <a:ext uri="{FF2B5EF4-FFF2-40B4-BE49-F238E27FC236}">
-                <a16:creationId xmlns:a16="http://schemas.microsoft.com/office/drawing/2014/main" id="{818D73A6-5619-40CD-864C-164E337887CE}"/>
-              </a:ext>
-            </a:extLst>
-          </p:cNvPr>
-          <p:cNvSpPr>
-            <a:spLocks noGrp="1"/>
-          </p:cNvSpPr>
-          <p:nvPr/>
-        </p:nvSpPr>
-        <p:spPr>
-          <a:xfrm>
-            <a:off x="2971800" y="3717036"/>
-            <a:ext cx="4023360" cy="256032"/>
-          </a:xfrm>
-          <a:prstGeom prst="rect">
-            <a:avLst/>
-          </a:prstGeom>
-          <a:noFill/>
-        </p:spPr>
-        <p:txBody>
-          <a:bodyPr wrap="square" lIns="0" tIns="0" rIns="0" bIns="0" anchor="ctr"/>
-          <a:lstStyle/>
-          <a:p>
-            <a:pPr marL="0" indent="0">
-              <a:buNone/>
-            </a:pPr>
-            <a:r>
-              <a:rPr sz="1150" b="1">
-                <a:solidFill>
-                  <a:srgbClr val="FCF9F0"/>
-                </a:solidFill>
-                <a:latin typeface="Calibri"/>
-                <a:ea typeface="Calibri"/>
-                <a:cs typeface="Calibri"/>
-              </a:rPr>
-              <a:t>доступно</a:t>
-            </a:r>
-            <a:endParaRPr sz="1150"/>
-          </a:p>
-        </p:txBody>
-      </p:sp>
-      <p:sp>
-        <p:nvSpPr>
-          <p:cNvPr id="13" name="Text 11">
-            <a:extLst>
-              <a:ext uri="{FF2B5EF4-FFF2-40B4-BE49-F238E27FC236}">
-                <a16:creationId xmlns:a16="http://schemas.microsoft.com/office/drawing/2014/main" id="{1B17E25C-EAC6-44DA-BED1-8DA3C384AB1F}"/>
-              </a:ext>
-            </a:extLst>
-          </p:cNvPr>
-          <p:cNvSpPr>
-            <a:spLocks noGrp="1"/>
-          </p:cNvSpPr>
-          <p:nvPr/>
-        </p:nvSpPr>
-        <p:spPr>
-          <a:xfrm>
-            <a:off x="841248" y="4050792"/>
-            <a:ext cx="2103120" cy="256032"/>
-          </a:xfrm>
-          <a:prstGeom prst="rect">
-            <a:avLst/>
-          </a:prstGeom>
-          <a:noFill/>
-        </p:spPr>
-        <p:txBody>
-          <a:bodyPr wrap="square" lIns="0" tIns="0" rIns="0" bIns="0" anchor="ctr"/>
-          <a:lstStyle/>
-          <a:p>
-            <a:pPr marL="0" indent="0">
-              <a:buNone/>
-            </a:pPr>
-            <a:r>
-              <a:rPr sz="1050">
-                <a:solidFill>
-                  <a:srgbClr val="D2E4CE"/>
-                </a:solidFill>
-                <a:latin typeface="Calibri"/>
-                <a:ea typeface="Calibri"/>
-                <a:cs typeface="Calibri"/>
-              </a:rPr>
-              <a:t>Jasmine Rice (Pathum), w oil</a:t>
-            </a:r>
-            <a:endParaRPr sz="1050"/>
-          </a:p>
-        </p:txBody>
-      </p:sp>
-      <p:sp>
-        <p:nvSpPr>
-          <p:cNvPr id="14" name="Text 12">
-            <a:extLst>
-              <a:ext uri="{FF2B5EF4-FFF2-40B4-BE49-F238E27FC236}">
-                <a16:creationId xmlns:a16="http://schemas.microsoft.com/office/drawing/2014/main" id="{1ACB90C5-BF37-41D9-8DC3-D21E41BC119E}"/>
-              </a:ext>
-            </a:extLst>
-          </p:cNvPr>
-          <p:cNvSpPr>
-            <a:spLocks noGrp="1"/>
-          </p:cNvSpPr>
-          <p:nvPr/>
-        </p:nvSpPr>
-        <p:spPr>
-          <a:xfrm>
-            <a:off x="2971800" y="4050792"/>
-            <a:ext cx="4023360" cy="256032"/>
-          </a:xfrm>
-          <a:prstGeom prst="rect">
-            <a:avLst/>
-          </a:prstGeom>
-          <a:noFill/>
-        </p:spPr>
-        <p:txBody>
-          <a:bodyPr wrap="square" lIns="0" tIns="0" rIns="0" bIns="0" anchor="ctr"/>
-          <a:lstStyle/>
-          <a:p>
-            <a:pPr marL="0" indent="0">
-              <a:buNone/>
-            </a:pPr>
-            <a:r>
-              <a:rPr sz="1150" b="1">
-                <a:solidFill>
-                  <a:srgbClr val="FCF9F0"/>
-                </a:solidFill>
-                <a:latin typeface="Calibri"/>
-                <a:ea typeface="Calibri"/>
-                <a:cs typeface="Calibri"/>
-              </a:rPr>
-              <a:t>доступно</a:t>
-            </a:r>
-            <a:endParaRPr sz="1150"/>
-          </a:p>
-        </p:txBody>
-      </p:sp>
-      <p:sp>
-        <p:nvSpPr>
-          <p:cNvPr id="15" name="Text 13">
-            <a:extLst>
-              <a:ext uri="{FF2B5EF4-FFF2-40B4-BE49-F238E27FC236}">
-                <a16:creationId xmlns:a16="http://schemas.microsoft.com/office/drawing/2014/main" id="{61BC70C4-0C92-435A-9487-D75013A4A699}"/>
-              </a:ext>
-            </a:extLst>
-          </p:cNvPr>
-          <p:cNvSpPr>
-            <a:spLocks noGrp="1"/>
-          </p:cNvSpPr>
-          <p:nvPr/>
-        </p:nvSpPr>
-        <p:spPr>
-          <a:xfrm>
-            <a:off x="841248" y="4384548"/>
-            <a:ext cx="2103120" cy="256032"/>
-          </a:xfrm>
-          <a:prstGeom prst="rect">
-            <a:avLst/>
-          </a:prstGeom>
-          <a:noFill/>
-        </p:spPr>
-        <p:txBody>
-          <a:bodyPr wrap="square" lIns="0" tIns="0" rIns="0" bIns="0" anchor="ctr"/>
-          <a:lstStyle/>
-          <a:p>
-            <a:pPr marL="0" indent="0">
-              <a:buNone/>
-            </a:pPr>
-            <a:r>
-              <a:rPr sz="1050">
-                <a:solidFill>
-                  <a:srgbClr val="D2E4CE"/>
-                </a:solidFill>
-                <a:latin typeface="Calibri"/>
-                <a:ea typeface="Calibri"/>
-                <a:cs typeface="Calibri"/>
-              </a:rPr>
-              <a:t>Brown Jasmine Rice, w oil</a:t>
-            </a:r>
-            <a:endParaRPr sz="1050"/>
-          </a:p>
-        </p:txBody>
-      </p:sp>
-      <p:sp>
-        <p:nvSpPr>
-          <p:cNvPr id="16" name="Text 14">
-            <a:extLst>
-              <a:ext uri="{FF2B5EF4-FFF2-40B4-BE49-F238E27FC236}">
-                <a16:creationId xmlns:a16="http://schemas.microsoft.com/office/drawing/2014/main" id="{3F159060-DCDF-44CC-8B6D-02E8ED33BA8F}"/>
-              </a:ext>
-            </a:extLst>
-          </p:cNvPr>
-          <p:cNvSpPr>
-            <a:spLocks noGrp="1"/>
-          </p:cNvSpPr>
-          <p:nvPr/>
-        </p:nvSpPr>
-        <p:spPr>
-          <a:xfrm>
-            <a:off x="2971800" y="4384548"/>
-            <a:ext cx="4023360" cy="256032"/>
-          </a:xfrm>
-          <a:prstGeom prst="rect">
-            <a:avLst/>
-          </a:prstGeom>
-          <a:noFill/>
-        </p:spPr>
-        <p:txBody>
-          <a:bodyPr wrap="square" lIns="0" tIns="0" rIns="0" bIns="0" anchor="ctr"/>
-          <a:lstStyle/>
-          <a:p>
-            <a:pPr marL="0" indent="0">
-              <a:buNone/>
-            </a:pPr>
-            <a:r>
-              <a:rPr sz="1150" b="1">
-                <a:solidFill>
-                  <a:srgbClr val="FCF9F0"/>
-                </a:solidFill>
-                <a:latin typeface="Calibri"/>
-                <a:ea typeface="Calibri"/>
-                <a:cs typeface="Calibri"/>
-              </a:rPr>
-              <a:t>доступно</a:t>
-            </a:r>
-            <a:endParaRPr sz="1150"/>
-          </a:p>
-        </p:txBody>
-      </p:sp>
-      <p:sp>
-        <p:nvSpPr>
-          <p:cNvPr id="17" name="Text 15">
-            <a:extLst>
-              <a:ext uri="{FF2B5EF4-FFF2-40B4-BE49-F238E27FC236}">
-                <a16:creationId xmlns:a16="http://schemas.microsoft.com/office/drawing/2014/main" id="{387B55C1-5453-4641-8FEE-2A2600E80415}"/>
-              </a:ext>
-            </a:extLst>
-          </p:cNvPr>
-          <p:cNvSpPr>
-            <a:spLocks noGrp="1"/>
-          </p:cNvSpPr>
-          <p:nvPr/>
-        </p:nvSpPr>
-        <p:spPr>
-          <a:xfrm>
-            <a:off x="841248" y="4718304"/>
-            <a:ext cx="2103120" cy="256032"/>
-          </a:xfrm>
-          <a:prstGeom prst="rect">
-            <a:avLst/>
-          </a:prstGeom>
-          <a:noFill/>
-        </p:spPr>
-        <p:txBody>
-          <a:bodyPr wrap="square" lIns="0" tIns="0" rIns="0" bIns="0" anchor="ctr"/>
-          <a:lstStyle/>
-          <a:p>
-            <a:pPr marL="0" indent="0">
-              <a:buNone/>
-            </a:pPr>
-            <a:r>
-              <a:rPr sz="1050">
-                <a:solidFill>
-                  <a:srgbClr val="D2E4CE"/>
-                </a:solidFill>
-                <a:latin typeface="Calibri"/>
-                <a:ea typeface="Calibri"/>
-                <a:cs typeface="Calibri"/>
-              </a:rPr>
-              <a:t>Brown Rice, w oil</a:t>
-            </a:r>
-            <a:endParaRPr sz="1050"/>
-          </a:p>
-        </p:txBody>
-      </p:sp>
-      <p:sp>
-        <p:nvSpPr>
-          <p:cNvPr id="18" name="Text 16">
-            <a:extLst>
-              <a:ext uri="{FF2B5EF4-FFF2-40B4-BE49-F238E27FC236}">
-                <a16:creationId xmlns:a16="http://schemas.microsoft.com/office/drawing/2014/main" id="{E5BCD84D-F4E9-40F7-AA7D-85E5A9A7C865}"/>
-              </a:ext>
-            </a:extLst>
-          </p:cNvPr>
-          <p:cNvSpPr>
-            <a:spLocks noGrp="1"/>
-          </p:cNvSpPr>
-          <p:nvPr/>
-        </p:nvSpPr>
-        <p:spPr>
-          <a:xfrm>
-            <a:off x="2971800" y="4718304"/>
-            <a:ext cx="4023360" cy="256032"/>
-          </a:xfrm>
-          <a:prstGeom prst="rect">
-            <a:avLst/>
-          </a:prstGeom>
-          <a:noFill/>
-        </p:spPr>
-        <p:txBody>
-          <a:bodyPr wrap="square" lIns="0" tIns="0" rIns="0" bIns="0" anchor="ctr"/>
-          <a:lstStyle/>
-          <a:p>
-            <a:pPr marL="0" indent="0">
-              <a:buNone/>
-            </a:pPr>
-            <a:r>
-              <a:rPr sz="1150" b="1">
-                <a:solidFill>
-                  <a:srgbClr val="FCF9F0"/>
-                </a:solidFill>
-                <a:latin typeface="Calibri"/>
-                <a:ea typeface="Calibri"/>
-                <a:cs typeface="Calibri"/>
-              </a:rPr>
-              <a:t>доступно</a:t>
-            </a:r>
-            <a:endParaRPr sz="1150"/>
-          </a:p>
-        </p:txBody>
-      </p:sp>
-      <p:sp>
-        <p:nvSpPr>
-          <p:cNvPr id="19" name="Text 17">
-            <a:extLst>
-              <a:ext uri="{FF2B5EF4-FFF2-40B4-BE49-F238E27FC236}">
-                <a16:creationId xmlns:a16="http://schemas.microsoft.com/office/drawing/2014/main" id="{9CD79870-7EED-40F1-B03F-865D47193057}"/>
-              </a:ext>
-            </a:extLst>
-          </p:cNvPr>
-          <p:cNvSpPr>
-            <a:spLocks noGrp="1"/>
-          </p:cNvSpPr>
-          <p:nvPr/>
-        </p:nvSpPr>
-        <p:spPr>
-          <a:xfrm>
-            <a:off x="841248" y="5052060"/>
-            <a:ext cx="2103120" cy="256032"/>
-          </a:xfrm>
-          <a:prstGeom prst="rect">
-            <a:avLst/>
-          </a:prstGeom>
-          <a:noFill/>
-        </p:spPr>
-        <p:txBody>
-          <a:bodyPr wrap="square" lIns="0" tIns="0" rIns="0" bIns="0" anchor="ctr"/>
-          <a:lstStyle/>
-          <a:p>
-            <a:pPr marL="0" indent="0">
-              <a:buNone/>
-            </a:pPr>
-            <a:r>
-              <a:rPr sz="1050">
-                <a:solidFill>
-                  <a:srgbClr val="D2E4CE"/>
-                </a:solidFill>
-                <a:latin typeface="Calibri"/>
-                <a:ea typeface="Calibri"/>
-                <a:cs typeface="Calibri"/>
-              </a:rPr>
-              <a:t>Basmati Rice*, w oil</a:t>
-            </a:r>
-            <a:endParaRPr sz="1050"/>
-          </a:p>
-        </p:txBody>
-      </p:sp>
-      <p:sp>
-        <p:nvSpPr>
-          <p:cNvPr id="20" name="Text 18">
-            <a:extLst>
-              <a:ext uri="{FF2B5EF4-FFF2-40B4-BE49-F238E27FC236}">
-                <a16:creationId xmlns:a16="http://schemas.microsoft.com/office/drawing/2014/main" id="{9696F0F8-6388-458A-9A6E-BD09F3ACBA30}"/>
-              </a:ext>
-            </a:extLst>
-          </p:cNvPr>
-          <p:cNvSpPr>
-            <a:spLocks noGrp="1"/>
-          </p:cNvSpPr>
-          <p:nvPr/>
-        </p:nvSpPr>
-        <p:spPr>
-          <a:xfrm>
-            <a:off x="2971800" y="5052060"/>
-            <a:ext cx="4023360" cy="256032"/>
-          </a:xfrm>
-          <a:prstGeom prst="rect">
-            <a:avLst/>
-          </a:prstGeom>
-          <a:noFill/>
-        </p:spPr>
-        <p:txBody>
-          <a:bodyPr wrap="square" lIns="0" tIns="0" rIns="0" bIns="0" anchor="ctr"/>
-          <a:lstStyle/>
-          <a:p>
-            <a:pPr marL="0" indent="0">
-              <a:buNone/>
-            </a:pPr>
-            <a:r>
-              <a:rPr sz="1150" b="1">
-                <a:solidFill>
-                  <a:srgbClr val="FCF9F0"/>
-                </a:solidFill>
-                <a:latin typeface="Calibri"/>
-                <a:ea typeface="Calibri"/>
-                <a:cs typeface="Calibri"/>
-              </a:rPr>
-              <a:t>доступно</a:t>
-            </a:r>
-            <a:endParaRPr sz="1150"/>
-          </a:p>
-        </p:txBody>
-      </p:sp>
-      <p:sp>
-        <p:nvSpPr>
-          <p:cNvPr id="21" name="Text 19">
-            <a:extLst>
-              <a:ext uri="{FF2B5EF4-FFF2-40B4-BE49-F238E27FC236}">
-                <a16:creationId xmlns:a16="http://schemas.microsoft.com/office/drawing/2014/main" id="{13A8E69A-5D22-455F-8007-BE2ECE9342F0}"/>
-              </a:ext>
-            </a:extLst>
-          </p:cNvPr>
-          <p:cNvSpPr>
-            <a:spLocks noGrp="1"/>
-          </p:cNvSpPr>
-          <p:nvPr/>
-        </p:nvSpPr>
-        <p:spPr>
-          <a:xfrm>
-            <a:off x="841248" y="5385816"/>
-            <a:ext cx="2103120" cy="256032"/>
-          </a:xfrm>
-          <a:prstGeom prst="rect">
-            <a:avLst/>
-          </a:prstGeom>
-          <a:noFill/>
-        </p:spPr>
-        <p:txBody>
-          <a:bodyPr wrap="square" lIns="0" tIns="0" rIns="0" bIns="0" anchor="ctr"/>
-          <a:lstStyle/>
-          <a:p>
-            <a:pPr marL="0" indent="0">
-              <a:buNone/>
-            </a:pPr>
-            <a:r>
-              <a:rPr sz="1050">
-                <a:solidFill>
-                  <a:srgbClr val="D2E4CE"/>
-                </a:solidFill>
-                <a:latin typeface="Calibri"/>
-                <a:ea typeface="Calibri"/>
-                <a:cs typeface="Calibri"/>
-              </a:rPr>
-              <a:t>Long Grain, w oil</a:t>
-            </a:r>
-            <a:endParaRPr sz="1050"/>
-          </a:p>
-        </p:txBody>
-      </p:sp>
-      <p:sp>
-        <p:nvSpPr>
-          <p:cNvPr id="22" name="Text 20">
-            <a:extLst>
-              <a:ext uri="{FF2B5EF4-FFF2-40B4-BE49-F238E27FC236}">
-                <a16:creationId xmlns:a16="http://schemas.microsoft.com/office/drawing/2014/main" id="{0F71CE83-5380-4313-A831-A097BEC1C816}"/>
-              </a:ext>
-            </a:extLst>
-          </p:cNvPr>
-          <p:cNvSpPr>
-            <a:spLocks noGrp="1"/>
-          </p:cNvSpPr>
-          <p:nvPr/>
-        </p:nvSpPr>
-        <p:spPr>
-          <a:xfrm>
-            <a:off x="2971800" y="5385816"/>
-            <a:ext cx="4023360" cy="256032"/>
-          </a:xfrm>
-          <a:prstGeom prst="rect">
-            <a:avLst/>
-          </a:prstGeom>
-          <a:noFill/>
-        </p:spPr>
-        <p:txBody>
-          <a:bodyPr wrap="square" lIns="0" tIns="0" rIns="0" bIns="0" anchor="ctr"/>
-          <a:lstStyle/>
-          <a:p>
-            <a:pPr marL="0" indent="0">
-              <a:buNone/>
-            </a:pPr>
-            <a:r>
-              <a:rPr sz="1150" b="1">
-                <a:solidFill>
-                  <a:srgbClr val="FCF9F0"/>
-                </a:solidFill>
-                <a:latin typeface="Calibri"/>
-                <a:ea typeface="Calibri"/>
-                <a:cs typeface="Calibri"/>
-              </a:rPr>
-              <a:t>доступно</a:t>
-            </a:r>
-            <a:endParaRPr sz="1150"/>
           </a:p>
         </p:txBody>
       </p:sp>

</xml_diff>

<commit_message>
Update Single Cup 40' FCL self-cost to match revised workbook
The user raised the 40' container FOB unit price for the Single Cup SKUs
(BSCM(Bags+Cups) - Навалом sheet) to match the other three shipping
blocks, which changes only the "40' FCL" row on all 5 Single Cup cost
cards:
- Thai Jasmine / Brown Jasmine Rice: $0,700/31,51 UAH -> $0,777/34,95 UAH
- Thai Red Jasmine / Rice Berry / Quinoa: $0,759/34,14 UAH -> $0,841/37,86 UAH

Diffed the old and new workbooks cell-by-cell: the 240g pouch, 150g/200g
special-production, and Double Cup figures are all unchanged.

Co-Authored-By: Claude Sonnet 5 <noreply@anthropic.com>
Claude-Session: https://claude.ai/code/session_01NDFDM6HpP3f8QTd8UUPgQV
</commit_message>
<xml_diff>
--- a/RTE_Rice_Suppliers.pptx
+++ b/RTE_Rice_Suppliers.pptx
@@ -25064,7 +25064,7 @@
                 <a:ea typeface="Calibri"/>
                 <a:cs typeface="Calibri"/>
               </a:rPr>
-              <a:t>$0,700 / 31,51 ₴</a:t>
+              <a:t>$0,777 / 34,95 ₴</a:t>
             </a:r>
             <a:endParaRPr sz="950"/>
           </a:p>
@@ -25790,7 +25790,7 @@
                 <a:ea typeface="Calibri"/>
                 <a:cs typeface="Calibri"/>
               </a:rPr>
-              <a:t>$0,700 / 31,51 ₴</a:t>
+              <a:t>$0,777 / 34,95 ₴</a:t>
             </a:r>
             <a:endParaRPr sz="950"/>
           </a:p>
@@ -26516,7 +26516,7 @@
                 <a:ea typeface="Calibri"/>
                 <a:cs typeface="Calibri"/>
               </a:rPr>
-              <a:t>$0,759 / 34,14 ₴</a:t>
+              <a:t>$0,841 / 37,86 ₴</a:t>
             </a:r>
             <a:endParaRPr sz="950"/>
           </a:p>
@@ -27762,7 +27762,7 @@
                 <a:ea typeface="Calibri"/>
                 <a:cs typeface="Calibri"/>
               </a:rPr>
-              <a:t>$0,759 / 34,14 ₴</a:t>
+              <a:t>$0,841 / 37,86 ₴</a:t>
             </a:r>
             <a:endParaRPr sz="950"/>
           </a:p>
@@ -27808,7 +27808,7 @@
                 <a:ea typeface="Calibri"/>
                 <a:cs typeface="Calibri"/>
               </a:rPr>
-              <a:t>$0,759 / 34,14 ₴</a:t>
+              <a:t>$0,841 / 37,86 ₴</a:t>
             </a:r>
             <a:endParaRPr sz="950"/>
           </a:p>

</xml_diff>

<commit_message>
Fill Double Cup self-cost, fix oversized photo and SKU list on Special production slide
- Slide 12 (Double Cup, 7 SKU): the "cost pending" placeholders are
  replaced with real self-cost figures from the new
  "BSCM(Double cup) - Навалом" sheet, for all 7 SKUs across all 4
  shipping blocks.
- Slide 6 (Special production): the pouch photo was displayed at ~1.9x
  the size its native 512x396 resolution supports elsewhere in this same
  deck (slide 5 shows the identical image at roughly half the size),
  which read as soft/blurry; shrunk it back down and added the same
  thin gold border-frame overlay used on every other product photo in
  the deck. The named 4-SKU list is replaced with a generic line, since
  more than those 4 products are actually available in the special
  150g/200g runs.

Co-Authored-By: Claude Sonnet 5 <noreply@anthropic.com>
Claude-Session: https://claude.ai/code/session_01NDFDM6HpP3f8QTd8UUPgQV
</commit_message>
<xml_diff>
--- a/RTE_Rice_Suppliers.pptx
+++ b/RTE_Rice_Suppliers.pptx
@@ -4825,7 +4825,7 @@
                 <a:ea typeface="Calibri"/>
                 <a:cs typeface="Calibri"/>
               </a:rPr>
-              <a:t>Собівартість буде додано після розрахунку.</a:t>
+              <a:t>Джерело: Self_Cost_Rice_Brand..xlsx, аркуш «BSCM(Double cup) - Навалом».</a:t>
             </a:r>
             <a:endParaRPr sz="1200"/>
           </a:p>
@@ -5220,7 +5220,7 @@
                 </a:solidFill>
                 <a:latin typeface="Calibri"/>
               </a:rPr>
-              <a:t>—</a:t>
+              <a:t>$1,628 / 73,24 ₴</a:t>
             </a:r>
           </a:p>
         </p:txBody>
@@ -5255,7 +5255,7 @@
                 </a:solidFill>
                 <a:latin typeface="Calibri"/>
               </a:rPr>
-              <a:t>—</a:t>
+              <a:t>$1,434 / 64,51 ₴</a:t>
             </a:r>
           </a:p>
         </p:txBody>
@@ -5290,7 +5290,7 @@
                 </a:solidFill>
                 <a:latin typeface="Calibri"/>
               </a:rPr>
-              <a:t>—</a:t>
+              <a:t>$1,633 / 73,51 ₴</a:t>
             </a:r>
           </a:p>
         </p:txBody>
@@ -5325,7 +5325,7 @@
                 </a:solidFill>
                 <a:latin typeface="Calibri"/>
               </a:rPr>
-              <a:t>—</a:t>
+              <a:t>$1,499 / 67,44 ₴</a:t>
             </a:r>
           </a:p>
         </p:txBody>
@@ -5440,7 +5440,7 @@
                 </a:solidFill>
                 <a:latin typeface="Calibri"/>
               </a:rPr>
-              <a:t>—</a:t>
+              <a:t>$1,628 / 73,24 ₴</a:t>
             </a:r>
           </a:p>
         </p:txBody>
@@ -5475,7 +5475,7 @@
                 </a:solidFill>
                 <a:latin typeface="Calibri"/>
               </a:rPr>
-              <a:t>—</a:t>
+              <a:t>$1,434 / 64,51 ₴</a:t>
             </a:r>
           </a:p>
         </p:txBody>
@@ -5510,7 +5510,7 @@
                 </a:solidFill>
                 <a:latin typeface="Calibri"/>
               </a:rPr>
-              <a:t>—</a:t>
+              <a:t>$1,633 / 73,51 ₴</a:t>
             </a:r>
           </a:p>
         </p:txBody>
@@ -5545,7 +5545,7 @@
                 </a:solidFill>
                 <a:latin typeface="Calibri"/>
               </a:rPr>
-              <a:t>—</a:t>
+              <a:t>$1,499 / 67,44 ₴</a:t>
             </a:r>
           </a:p>
         </p:txBody>
@@ -5660,7 +5660,7 @@
                 </a:solidFill>
                 <a:latin typeface="Calibri"/>
               </a:rPr>
-              <a:t>—</a:t>
+              <a:t>$1,480 / 66,58 ₴</a:t>
             </a:r>
           </a:p>
         </p:txBody>
@@ -5695,7 +5695,7 @@
                 </a:solidFill>
                 <a:latin typeface="Calibri"/>
               </a:rPr>
-              <a:t>—</a:t>
+              <a:t>$1,303 / 58,65 ₴</a:t>
             </a:r>
           </a:p>
         </p:txBody>
@@ -5730,7 +5730,7 @@
                 </a:solidFill>
                 <a:latin typeface="Calibri"/>
               </a:rPr>
-              <a:t>—</a:t>
+              <a:t>$1,485 / 66,82 ₴</a:t>
             </a:r>
           </a:p>
         </p:txBody>
@@ -5765,7 +5765,7 @@
                 </a:solidFill>
                 <a:latin typeface="Calibri"/>
               </a:rPr>
-              <a:t>—</a:t>
+              <a:t>$1,362 / 61,31 ₴</a:t>
             </a:r>
           </a:p>
         </p:txBody>
@@ -5880,7 +5880,7 @@
                 </a:solidFill>
                 <a:latin typeface="Calibri"/>
               </a:rPr>
-              <a:t>—</a:t>
+              <a:t>$1,628 / 73,24 ₴</a:t>
             </a:r>
           </a:p>
         </p:txBody>
@@ -5915,7 +5915,7 @@
                 </a:solidFill>
                 <a:latin typeface="Calibri"/>
               </a:rPr>
-              <a:t>—</a:t>
+              <a:t>$1,434 / 64,51 ₴</a:t>
             </a:r>
           </a:p>
         </p:txBody>
@@ -5950,7 +5950,7 @@
                 </a:solidFill>
                 <a:latin typeface="Calibri"/>
               </a:rPr>
-              <a:t>—</a:t>
+              <a:t>$1,633 / 75,14 ₴</a:t>
             </a:r>
           </a:p>
         </p:txBody>
@@ -5985,7 +5985,7 @@
                 </a:solidFill>
                 <a:latin typeface="Calibri"/>
               </a:rPr>
-              <a:t>—</a:t>
+              <a:t>$1,499 / 68,94 ₴</a:t>
             </a:r>
           </a:p>
         </p:txBody>
@@ -6100,7 +6100,7 @@
                 </a:solidFill>
                 <a:latin typeface="Calibri"/>
               </a:rPr>
-              <a:t>—</a:t>
+              <a:t>$1,628 / 73,24 ₴</a:t>
             </a:r>
           </a:p>
         </p:txBody>
@@ -6135,7 +6135,7 @@
                 </a:solidFill>
                 <a:latin typeface="Calibri"/>
               </a:rPr>
-              <a:t>—</a:t>
+              <a:t>$1,434 / 64,51 ₴</a:t>
             </a:r>
           </a:p>
         </p:txBody>
@@ -6170,7 +6170,7 @@
                 </a:solidFill>
                 <a:latin typeface="Calibri"/>
               </a:rPr>
-              <a:t>—</a:t>
+              <a:t>$1,633 / 73,51 ₴</a:t>
             </a:r>
           </a:p>
         </p:txBody>
@@ -6205,7 +6205,7 @@
                 </a:solidFill>
                 <a:latin typeface="Calibri"/>
               </a:rPr>
-              <a:t>—</a:t>
+              <a:t>$1,499 / 67,44 ₴</a:t>
             </a:r>
           </a:p>
         </p:txBody>
@@ -6320,7 +6320,7 @@
                 </a:solidFill>
                 <a:latin typeface="Calibri"/>
               </a:rPr>
-              <a:t>—</a:t>
+              <a:t>$1,776 / 79,90 ₴</a:t>
             </a:r>
           </a:p>
         </p:txBody>
@@ -6355,7 +6355,7 @@
                 </a:solidFill>
                 <a:latin typeface="Calibri"/>
               </a:rPr>
-              <a:t>—</a:t>
+              <a:t>$1,564 / 70,38 ₴</a:t>
             </a:r>
           </a:p>
         </p:txBody>
@@ -6390,7 +6390,7 @@
                 </a:solidFill>
                 <a:latin typeface="Calibri"/>
               </a:rPr>
-              <a:t>—</a:t>
+              <a:t>$1,782 / 80,19 ₴</a:t>
             </a:r>
           </a:p>
         </p:txBody>
@@ -6425,7 +6425,7 @@
                 </a:solidFill>
                 <a:latin typeface="Calibri"/>
               </a:rPr>
-              <a:t>—</a:t>
+              <a:t>$1,635 / 73,57 ₴</a:t>
             </a:r>
           </a:p>
         </p:txBody>
@@ -6540,7 +6540,7 @@
                 </a:solidFill>
                 <a:latin typeface="Calibri"/>
               </a:rPr>
-              <a:t>—</a:t>
+              <a:t>$1,391 / 62,59 ₴</a:t>
             </a:r>
           </a:p>
         </p:txBody>
@@ -6575,7 +6575,7 @@
                 </a:solidFill>
                 <a:latin typeface="Calibri"/>
               </a:rPr>
-              <a:t>—</a:t>
+              <a:t>$1,225 / 55,13 ₴</a:t>
             </a:r>
           </a:p>
         </p:txBody>
@@ -6610,7 +6610,7 @@
                 </a:solidFill>
                 <a:latin typeface="Calibri"/>
               </a:rPr>
-              <a:t>—</a:t>
+              <a:t>$1,396 / 62,82 ₴</a:t>
             </a:r>
           </a:p>
         </p:txBody>
@@ -6645,7 +6645,7 @@
                 </a:solidFill>
                 <a:latin typeface="Calibri"/>
               </a:rPr>
-              <a:t>—</a:t>
+              <a:t>$1,281 / 57,63 ₴</a:t>
             </a:r>
           </a:p>
         </p:txBody>
@@ -17428,7 +17428,7 @@
                 <a:ea typeface="Calibri"/>
                 <a:cs typeface="Calibri"/>
               </a:rPr>
-              <a:t>Доступні позиції</a:t>
+              <a:t>Гнучкий асортимент</a:t>
             </a:r>
             <a:endParaRPr sz="1200"/>
           </a:p>
@@ -17796,8 +17796,8 @@
         </p:blipFill>
         <p:spPr>
           <a:xfrm xmlns:a="http://schemas.openxmlformats.org/drawingml/2006/main">
-            <a:off x="571500" y="2248942"/>
-            <a:ext cx="4381500" cy="3388816"/>
+            <a:off x="979322" y="2554191"/>
+            <a:ext cx="3566160" cy="2758202"/>
           </a:xfrm>
           <a:prstGeom xmlns:a="http://schemas.openxmlformats.org/drawingml/2006/main" prst="roundRect">
             <a:avLst>
@@ -17814,8 +17814,8 @@
         </p:nvSpPr>
         <p:spPr>
           <a:xfrm>
-            <a:off x="5924580" y="5505450"/>
-            <a:ext cx="5695950" cy="1298448"/>
+            <a:off x="5924398" y="5505450"/>
+            <a:ext cx="5695950" cy="1097280"/>
           </a:xfrm>
           <a:prstGeom prst="rect">
             <a:avLst/>
@@ -17823,97 +17823,81 @@
           <a:noFill/>
         </p:spPr>
         <p:txBody>
-          <a:bodyPr wrap="none" lIns="0" rIns="0" tIns="0" bIns="0" anchor="t">
+          <a:bodyPr wrap="square" lIns="0" rIns="0" tIns="0" bIns="0">
             <a:spAutoFit/>
           </a:bodyPr>
           <a:lstStyle/>
           <a:p>
-            <a:pPr algn="l" marL="219456" indent="-219456">
-              <a:buClr>
-                <a:srgbClr val="F5CE76"/>
-              </a:buClr>
-              <a:buFont typeface="Arial"/>
-              <a:buChar char="●"/>
-            </a:pPr>
-            <a:r>
-              <a:rPr sz="1500" b="0">
+            <a:pPr algn="l"/>
+            <a:r>
+              <a:rPr sz="1500">
                 <a:solidFill>
                   <a:srgbClr val="FCF9F0"/>
                 </a:solidFill>
                 <a:latin typeface="Calibri"/>
               </a:rPr>
-              <a:t>Jasmine Rice</a:t>
-            </a:r>
-          </a:p>
-          <a:p>
-            <a:pPr algn="l" marL="219456" indent="-219456">
-              <a:buClr>
-                <a:srgbClr val="F5CE76"/>
-              </a:buClr>
-              <a:buFont typeface="Arial"/>
-              <a:buChar char="●"/>
-            </a:pPr>
-            <a:r>
-              <a:rPr sz="1500" b="0">
-                <a:solidFill>
-                  <a:srgbClr val="FCF9F0"/>
-                </a:solidFill>
-                <a:latin typeface="Calibri"/>
-              </a:rPr>
-              <a:t>Mexican Rice</a:t>
-            </a:r>
-          </a:p>
-          <a:p>
-            <a:pPr algn="l" marL="219456" indent="-219456">
-              <a:buClr>
-                <a:srgbClr val="F5CE76"/>
-              </a:buClr>
-              <a:buFont typeface="Arial"/>
-              <a:buChar char="●"/>
-            </a:pPr>
-            <a:r>
-              <a:rPr sz="1500" b="0">
-                <a:solidFill>
-                  <a:srgbClr val="FCF9F0"/>
-                </a:solidFill>
-                <a:latin typeface="Calibri"/>
-              </a:rPr>
-              <a:t>Japanese Style Rice</a:t>
-            </a:r>
-          </a:p>
-          <a:p>
-            <a:pPr algn="l" marL="219456" indent="-219456">
-              <a:buClr>
-                <a:srgbClr val="F5CE76"/>
-              </a:buClr>
-              <a:buFont typeface="Arial"/>
-              <a:buChar char="●"/>
-            </a:pPr>
-            <a:r>
-              <a:rPr sz="1500" b="0">
-                <a:solidFill>
-                  <a:srgbClr val="FCF9F0"/>
-                </a:solidFill>
-                <a:latin typeface="Calibri"/>
-              </a:rPr>
-              <a:t>Hot and Spicy Rice</a:t>
+              <a:t>Доступно для будь-якої позиції лінійки Ready Rice — конкретний асортимент і формат погоджуємо під замовлення.</a:t>
             </a:r>
           </a:p>
           <a:p>
             <a:pPr algn="l">
               <a:spcBef>
-                <a:spcPts val="800"/>
+                <a:spcPts val="1000"/>
               </a:spcBef>
             </a:pPr>
             <a:r>
-              <a:rPr sz="1100" b="0">
+              <a:rPr sz="1100">
                 <a:solidFill>
                   <a:srgbClr val="D2E4CE"/>
                 </a:solidFill>
                 <a:latin typeface="Calibri"/>
               </a:rPr>
-              <a:t>Собівартість для 150 г та 200 г — на наступних двох слайдах.</a:t>
-            </a:r>
+              <a:t>Собівартість для 150 г та 200 г — на попередніх двох слайдах.</a:t>
+            </a:r>
+          </a:p>
+        </p:txBody>
+      </p:sp>
+      <p:sp xmlns:a="http://schemas.openxmlformats.org/drawingml/2006/main">
+        <p:nvSpPr>
+          <p:cNvPr id="78" name="Rectangle 77"/>
+          <p:cNvSpPr/>
+          <p:nvPr/>
+        </p:nvSpPr>
+        <p:spPr>
+          <a:xfrm>
+            <a:off x="979322" y="2554191"/>
+            <a:ext cx="3566160" cy="2758202"/>
+          </a:xfrm>
+          <a:prstGeom prst="rect">
+            <a:avLst/>
+          </a:prstGeom>
+          <a:noFill/>
+          <a:ln w="12700">
+            <a:solidFill>
+              <a:srgbClr val="C89C40"/>
+            </a:solidFill>
+          </a:ln>
+          <a:effectLst/>
+        </p:spPr>
+        <p:style>
+          <a:lnRef idx="1">
+            <a:schemeClr val="accent1"/>
+          </a:lnRef>
+          <a:fillRef idx="3">
+            <a:schemeClr val="accent1"/>
+          </a:fillRef>
+          <a:effectRef idx="2">
+            <a:schemeClr val="accent1"/>
+          </a:effectRef>
+          <a:fontRef idx="minor">
+            <a:schemeClr val="lt1"/>
+          </a:fontRef>
+        </p:style>
+        <p:txBody>
+          <a:bodyPr rtlCol="0" anchor="ctr"/>
+          <a:lstStyle/>
+          <a:p>
+            <a:pPr algn="ctr"/>
           </a:p>
         </p:txBody>
       </p:sp>

</xml_diff>

<commit_message>
Make Double Cup's Private-Label-only status unambiguous
The "Виробництво під Private Label" line on the Double Cup format slide
was plain, unbold body text, easy to miss next to the bold gold stat
lines around it. Restyled it as its own bold gold headline ("Тільки
Private Label") with a plain-language follow-up making clear the
manufacturer has no own-brand version of this format at all.

Co-Authored-By: Claude Sonnet 5 <noreply@anthropic.com>
Claude-Session: https://claude.ai/code/session_01NDFDM6HpP3f8QTd8UUPgQV
</commit_message>
<xml_diff>
--- a/RTE_Rice_Suppliers.pptx
+++ b/RTE_Rice_Suppliers.pptx
@@ -4478,7 +4478,7 @@
         <p:spPr>
           <a:xfrm xmlns:a="http://schemas.openxmlformats.org/drawingml/2006/main">
             <a:off x="6191250" y="5210175"/>
-            <a:ext cx="5429250" cy="723900"/>
+            <a:ext cx="5429250" cy="914400"/>
           </a:xfrm>
           <a:prstGeom xmlns:a="http://schemas.openxmlformats.org/drawingml/2006/main" prst="rect">
             <a:avLst/>
@@ -4503,39 +4503,53 @@
               </a:defRPr>
             </a:pPr>
             <a:r>
-              <a:rPr sz="1800" b="0" i="0">
+              <a:rPr sz="1800" b="1" i="0">
+                <a:solidFill>
+                  <a:srgbClr val="F5CE76"/>
+                </a:solidFill>
+                <a:latin typeface="Calibri"/>
+                <a:ea typeface="Calibri"/>
+                <a:cs typeface="Calibri"/>
+              </a:rPr>
+              <a:t>Тільки Private Label</a:t>
+            </a:r>
+          </a:p>
+          <a:p xmlns:a="http://schemas.openxmlformats.org/drawingml/2006/main">
+            <a:pPr algn="l">
+              <a:buNone/>
+              <a:defRPr sz="1800" b="0" i="0">
                 <a:solidFill>
                   <a:srgbClr val="FCF9F0"/>
                 </a:solidFill>
                 <a:latin typeface="Calibri"/>
                 <a:ea typeface="Calibri"/>
                 <a:cs typeface="Calibri"/>
-              </a:rPr>
-              <a:t>Виробництво під Private Label.</a:t>
+              </a:defRPr>
+            </a:pPr>
+            <a:r>
+              <a:rPr sz="1500" b="0" i="0">
+                <a:solidFill>
+                  <a:srgbClr val="FCF9F0"/>
+                </a:solidFill>
+                <a:latin typeface="Calibri"/>
+                <a:ea typeface="Calibri"/>
+                <a:cs typeface="Calibri"/>
+              </a:rPr>
+              <a:t>Власного бренду в цьому форматі немає.</a:t>
             </a:r>
           </a:p>
           <a:p xmlns:a="http://schemas.openxmlformats.org/drawingml/2006/main">
             <a:pPr algn="l">
               <a:buNone/>
-              <a:defRPr sz="1800" b="0" i="0">
+            </a:pPr>
+            <a:r>
+              <a:rPr sz="1500" b="0">
                 <a:solidFill>
                   <a:srgbClr val="FCF9F0"/>
                 </a:solidFill>
                 <a:latin typeface="Calibri"/>
-                <a:ea typeface="Calibri"/>
-                <a:cs typeface="Calibri"/>
-              </a:defRPr>
-            </a:pPr>
-            <a:r>
-              <a:rPr sz="1800" b="0" i="0">
-                <a:solidFill>
-                  <a:srgbClr val="FCF9F0"/>
-                </a:solidFill>
-                <a:latin typeface="Calibri"/>
-                <a:ea typeface="Calibri"/>
-                <a:cs typeface="Calibri"/>
-              </a:rPr>
-              <a:t>Дизайн — під нашу торгову марку.</a:t>
+              </a:rPr>
+              <a:t>Тільки під торговою маркою замовника.</a:t>
             </a:r>
           </a:p>
         </p:txBody>

</xml_diff>

<commit_message>
Drop the MOQ stat tile from the One's International profile
The "200 ctn / мінімальне замовлення, SKU" tile was redundant. Removing
it would have left a hole between the hero photo and the remaining
tiles, so the two survivors move down one pitch to stay flush with the
bottom of the profile card, and the product collage grows into the
freed space (3.10 -> 3.72in), re-rendered at the new aspect so the trays
keep their proportions.

Co-Authored-By: Claude Opus 5 <noreply@anthropic.com>
Claude-Session: https://claude.ai/code/session_01NDFDM6HpP3f8QTd8UUPgQV
</commit_message>
<xml_diff>
--- a/RTE_Rice_Suppliers.pptx
+++ b/RTE_Rice_Suppliers.pptx
@@ -8346,14 +8346,14 @@
       </p:sp>
       <p:pic>
         <p:nvPicPr>
-          <p:cNvPr id="37" name="Picture 36" descr="hero_collage.jpg"/>
+          <p:cNvPr id="37" name="Picture 36" descr="hero_collage_tall.jpg"/>
           <p:cNvPicPr>
             <a:picLocks noChangeAspect="1"/>
           </p:cNvPicPr>
           <p:nvPr/>
         </p:nvPicPr>
         <p:blipFill>
-          <a:blip r:embed="rId2"/>
+          <a:blip r:embed="rId5"/>
           <a:stretch>
             <a:fillRect/>
           </a:stretch>
@@ -8361,7 +8361,7 @@
         <p:spPr>
           <a:xfrm>
             <a:off x="7534656" y="1536192"/>
-            <a:ext cx="4096512" cy="2834640"/>
+            <a:ext cx="4096512" cy="3401568"/>
           </a:xfrm>
           <a:prstGeom prst="roundRect">
             <a:avLst/>
@@ -8385,7 +8385,7 @@
         <p:spPr>
           <a:xfrm>
             <a:off x="7534656" y="1536192"/>
-            <a:ext cx="4096512" cy="2834640"/>
+            <a:ext cx="4096512" cy="3401568"/>
           </a:xfrm>
           <a:prstGeom prst="rect">
             <a:avLst/>
@@ -8421,7 +8421,7 @@
         </p:nvSpPr>
         <p:spPr>
           <a:xfrm>
-            <a:off x="7534656" y="4526280"/>
+            <a:off x="7534656" y="5093208"/>
             <a:ext cx="4096512" cy="484632"/>
           </a:xfrm>
           <a:prstGeom prst="roundRect">
@@ -8472,7 +8472,7 @@
         </p:nvSpPr>
         <p:spPr>
           <a:xfrm>
-            <a:off x="7717536" y="4581144"/>
+            <a:off x="7717536" y="5148072"/>
             <a:ext cx="1737360" cy="365760"/>
           </a:xfrm>
           <a:prstGeom prst="rect">
@@ -8529,7 +8529,7 @@
         </p:nvSpPr>
         <p:spPr>
           <a:xfrm>
-            <a:off x="9418320" y="4581144"/>
+            <a:off x="9418320" y="5148072"/>
             <a:ext cx="2057400" cy="365760"/>
           </a:xfrm>
           <a:prstGeom prst="rect">
@@ -8575,7 +8575,7 @@
         </p:nvSpPr>
         <p:spPr>
           <a:xfrm>
-            <a:off x="7534656" y="5093208"/>
+            <a:off x="7534656" y="5660136"/>
             <a:ext cx="4096512" cy="484632"/>
           </a:xfrm>
           <a:prstGeom prst="roundRect">
@@ -8626,7 +8626,7 @@
         </p:nvSpPr>
         <p:spPr>
           <a:xfrm>
-            <a:off x="7717536" y="5148072"/>
+            <a:off x="7717536" y="5715000"/>
             <a:ext cx="1737360" cy="365760"/>
           </a:xfrm>
           <a:prstGeom prst="rect">
@@ -8683,160 +8683,6 @@
         </p:nvSpPr>
         <p:spPr>
           <a:xfrm>
-            <a:off x="9418320" y="5148072"/>
-            <a:ext cx="2057400" cy="365760"/>
-          </a:xfrm>
-          <a:prstGeom prst="rect">
-            <a:avLst/>
-          </a:prstGeom>
-          <a:noFill/>
-        </p:spPr>
-        <p:txBody>
-          <a:bodyPr wrap="square" lIns="0" tIns="0" rIns="0" bIns="0" anchor="ctr"/>
-          <a:lstStyle/>
-          <a:p>
-            <a:pPr marL="0" indent="0" algn="r">
-              <a:buNone/>
-            </a:pPr>
-            <a:r>
-              <a:rPr sz="1050">
-                <a:solidFill>
-                  <a:srgbClr val="FCF9F0"/>
-                </a:solidFill>
-                <a:latin typeface="Calibri"/>
-                <a:ea typeface="Calibri"/>
-                <a:cs typeface="Calibri"/>
-              </a:rPr>
-              <a:t>розігрів у мікрохвильовці</a:t>
-            </a:r>
-            <a:endParaRPr sz="1050"/>
-          </a:p>
-        </p:txBody>
-      </p:sp>
-      <p:sp>
-        <p:nvSpPr>
-          <p:cNvPr id="31" name="Shape 28">
-            <a:extLst>
-              <a:ext uri="{FF2B5EF4-FFF2-40B4-BE49-F238E27FC236}">
-                <a16:creationId xmlns:a16="http://schemas.microsoft.com/office/drawing/2014/main" id="{E9455139-65F1-448B-8A7C-86FFA827F351}"/>
-              </a:ext>
-            </a:extLst>
-          </p:cNvPr>
-          <p:cNvSpPr>
-            <a:spLocks noGrp="1"/>
-          </p:cNvSpPr>
-          <p:nvPr/>
-        </p:nvSpPr>
-        <p:spPr>
-          <a:xfrm>
-            <a:off x="7534656" y="5660136"/>
-            <a:ext cx="4096512" cy="484632"/>
-          </a:xfrm>
-          <a:prstGeom prst="roundRect">
-            <a:avLst>
-              <a:gd name="adj" fmla="val 15094"/>
-            </a:avLst>
-          </a:prstGeom>
-          <a:solidFill>
-            <a:srgbClr val="12452B">
-              <a:alpha val="90000"/>
-            </a:srgbClr>
-          </a:solidFill>
-          <a:ln w="15875">
-            <a:solidFill>
-              <a:srgbClr val="C89C40"/>
-            </a:solidFill>
-            <a:prstDash val="solid"/>
-          </a:ln>
-          <a:effectLst>
-            <a:outerShdw blurRad="177800" dist="38100" dir="5400000" algn="bl" rotWithShape="0">
-              <a:srgbClr val="000000">
-                <a:alpha val="45000"/>
-              </a:srgbClr>
-            </a:outerShdw>
-          </a:effectLst>
-        </p:spPr>
-        <p:txBody>
-          <a:bodyPr/>
-          <a:lstStyle/>
-          <a:p>
-            <a:endParaRPr/>
-          </a:p>
-        </p:txBody>
-      </p:sp>
-      <p:sp>
-        <p:nvSpPr>
-          <p:cNvPr id="32" name="Text 29">
-            <a:extLst>
-              <a:ext uri="{FF2B5EF4-FFF2-40B4-BE49-F238E27FC236}">
-                <a16:creationId xmlns:a16="http://schemas.microsoft.com/office/drawing/2014/main" id="{D40C00FA-3D9E-4C88-BA29-ECBF4916B185}"/>
-              </a:ext>
-            </a:extLst>
-          </p:cNvPr>
-          <p:cNvSpPr>
-            <a:spLocks noGrp="1"/>
-          </p:cNvSpPr>
-          <p:nvPr/>
-        </p:nvSpPr>
-        <p:spPr>
-          <a:xfrm>
-            <a:off x="7717536" y="5715000"/>
-            <a:ext cx="1737360" cy="365760"/>
-          </a:xfrm>
-          <a:prstGeom prst="rect">
-            <a:avLst/>
-          </a:prstGeom>
-          <a:noFill/>
-        </p:spPr>
-        <p:txBody>
-          <a:bodyPr wrap="square" lIns="0" tIns="0" rIns="0" bIns="0" anchor="ctr"/>
-          <a:lstStyle/>
-          <a:p>
-            <a:pPr marL="0" indent="0">
-              <a:buNone/>
-            </a:pPr>
-            <a:r>
-              <a:rPr sz="1900" b="1">
-                <a:solidFill>
-                  <a:srgbClr val="F5CE76"/>
-                </a:solidFill>
-                <a:latin typeface="Cambria"/>
-                <a:ea typeface="Cambria"/>
-                <a:cs typeface="Cambria"/>
-              </a:rPr>
-              <a:t>200</a:t>
-            </a:r>
-            <a:r>
-              <a:rPr sz="1100">
-                <a:solidFill>
-                  <a:srgbClr val="F5CE76"/>
-                </a:solidFill>
-                <a:latin typeface="Cambria"/>
-                <a:ea typeface="Cambria"/>
-                <a:cs typeface="Cambria"/>
-              </a:rPr>
-              <a:t> ctn</a:t>
-            </a:r>
-            <a:endParaRPr sz="1900"/>
-          </a:p>
-        </p:txBody>
-      </p:sp>
-      <p:sp>
-        <p:nvSpPr>
-          <p:cNvPr id="33" name="Text 30">
-            <a:extLst>
-              <a:ext uri="{FF2B5EF4-FFF2-40B4-BE49-F238E27FC236}">
-                <a16:creationId xmlns:a16="http://schemas.microsoft.com/office/drawing/2014/main" id="{5324D476-C6D4-42C7-BAFD-4CF0E84F17CB}"/>
-              </a:ext>
-            </a:extLst>
-          </p:cNvPr>
-          <p:cNvSpPr>
-            <a:spLocks noGrp="1"/>
-          </p:cNvSpPr>
-          <p:nvPr/>
-        </p:nvSpPr>
-        <p:spPr>
-          <a:xfrm>
             <a:off x="9418320" y="5715000"/>
             <a:ext cx="2057400" cy="365760"/>
           </a:xfrm>
@@ -8861,7 +8707,7 @@
                 <a:ea typeface="Calibri"/>
                 <a:cs typeface="Calibri"/>
               </a:rPr>
-              <a:t>мінімальне замовлення, SKU</a:t>
+              <a:t>розігрів у мікрохвильовці</a:t>
             </a:r>
             <a:endParaRPr sz="1050"/>
           </a:p>

</xml_diff>

<commit_message>
Re-sync Double Cup UAH figures after the exchange-rate fix
The user corrected the two cells that converted at 46 UAH/USD instead of
45 (Brown Jasmine Rice, LCL 17 and LCL 34 on the Double Cup sheet), so
those two figures on slide 12 come down:
  LCL 17 м³  75,14 -> 73,51 ₴
  LCL 34 м³  68,94 -> 67,44 ₴

Rather than patch the two cells, every cost figure on all seven cost
slides was rewritten from the workbook; only these two differed, which
confirms the rest was already in sync. Card-to-product mapping is
resolved by product name, not row position.

Co-Authored-By: Claude Opus 5 <noreply@anthropic.com>
Claude-Session: https://claude.ai/code/session_01NDFDM6HpP3f8QTd8UUPgQV
</commit_message>
<xml_diff>
--- a/RTE_Rice_Suppliers.pptx
+++ b/RTE_Rice_Suppliers.pptx
@@ -5888,7 +5888,7 @@
                 </a:solidFill>
                 <a:latin typeface="Calibri"/>
               </a:rPr>
-              <a:t>$1,633 / 75,14 ₴</a:t>
+              <a:t>$1,633 / 73,51 ₴</a:t>
             </a:r>
           </a:p>
         </p:txBody>
@@ -5923,7 +5923,7 @@
                 </a:solidFill>
                 <a:latin typeface="Calibri"/>
               </a:rPr>
-              <a:t>$1,499 / 68,94 ₴</a:t>
+              <a:t>$1,499 / 67,44 ₴</a:t>
             </a:r>
           </a:p>
         </p:txBody>

</xml_diff>